<commit_message>
docs: add research report and presentation slides for Apart Research sprint
</commit_message>
<xml_diff>
--- a/Apart Research/slides.pptx
+++ b/Apart Research/slides.pptx
@@ -4,6 +4,9 @@
   <p:sldMasterIdLst>
     <p:sldMasterId id="2147483648" r:id="rId1"/>
   </p:sldMasterIdLst>
+  <p:notesMasterIdLst>
+    <p:notesMasterId r:id="rId12"/>
+  </p:notesMasterIdLst>
   <p:sldIdLst>
     <p:sldId id="256" r:id="rId2"/>
     <p:sldId id="257" r:id="rId3"/>
@@ -16,9 +19,6 @@
     <p:sldId id="264" r:id="rId10"/>
     <p:sldId id="265" r:id="rId11"/>
   </p:sldIdLst>
-  <p:notesMasterIdLst>
-    <p:notesMasterId r:id="rId12"/>
-  </p:notesMasterIdLst>
   <p:sldSz cx="12192000" cy="6858000"/>
   <p:notesSz cx="6858000" cy="12192000"/>
   <p:defaultTextStyle>
@@ -113,13 +113,20 @@
       </a:defRPr>
     </a:lvl9pPr>
   </p:defaultTextStyle>
+  <p:extLst>
+    <p:ext uri="{EFAFB233-063F-42B5-8137-9DF3F51BA10A}">
+      <p15:sldGuideLst xmlns:p15="http://schemas.microsoft.com/office/powerpoint/2012/main"/>
+    </p:ext>
+  </p:extLst>
 </p:presentation>
 </file>
 
 <file path=ppt/charts/chart1.xml><?xml version="1.0" encoding="utf-8"?>
-<c:chartSpace xmlns:c="http://schemas.openxmlformats.org/drawingml/2006/chart" xmlns:a="http://schemas.openxmlformats.org/drawingml/2006/main" xmlns:r="http://schemas.openxmlformats.org/officeDocument/2006/relationships">
+<c:chartSpace xmlns:c="http://schemas.openxmlformats.org/drawingml/2006/chart" xmlns:a="http://schemas.openxmlformats.org/drawingml/2006/main" xmlns:r="http://schemas.openxmlformats.org/officeDocument/2006/relationships" xmlns:c16r2="http://schemas.microsoft.com/office/drawing/2015/06/chart">
   <c:date1904 val="0"/>
+  <c:lang val="en-US"/>
   <c:roundedCorners val="1"/>
+  <c:style val="2"/>
   <c:chart>
     <c:title>
       <c:tx>
@@ -136,7 +143,7 @@
               </a:defRPr>
             </a:pPr>
             <a:r>
-              <a:rPr sz="1500" b="0" i="0" u="none" strike="noStrike">
+              <a:rPr lang="en-US" sz="1500" b="0" i="0" u="none" strike="noStrike">
                 <a:solidFill>
                   <a:srgbClr val="16202B"/>
                 </a:solidFill>
@@ -147,7 +154,6 @@
           </a:p>
         </c:rich>
       </c:tx>
-      <c:layout/>
       <c:overlay val="0"/>
     </c:title>
     <c:autoTitleDeleted val="0"/>
@@ -178,51 +184,25 @@
             <a:effectLst/>
           </c:spPr>
           <c:invertIfNegative val="0"/>
-          <c:dLbls>
-            <c:numFmt formatCode="0.000" sourceLinked="0"/>
-            <c:txPr>
-              <a:bodyPr/>
-              <a:lstStyle/>
-              <a:p>
-                <a:pPr>
-                  <a:defRPr b="0" i="0" strike="noStrike" sz="1300" u="none">
-                    <a:solidFill>
-                      <a:srgbClr val="16202B"/>
-                    </a:solidFill>
-                    <a:latin typeface="+mn-lt"/>
-                  </a:defRPr>
-                </a:pPr>
-              </a:p>
-            </c:txPr>
-            <c:showLegendKey val="0"/>
-            <c:showVal val="1"/>
-            <c:showCatName val="0"/>
-            <c:showSerName val="0"/>
-            <c:showPercent val="0"/>
-            <c:showBubbleSize val="0"/>
-            <c:showLeaderLines val="0"/>
-          </c:dLbls>
           <c:dPt>
             <c:idx val="0"/>
             <c:invertIfNegative val="0"/>
             <c:bubble3D val="0"/>
-            <c:spPr>
-              <a:solidFill>
-                <a:srgbClr val="2E3A46"/>
-              </a:solidFill>
-              <a:effectLst/>
-            </c:spPr>
+            <c:extLst>
+              <c:ext xmlns:c16="http://schemas.microsoft.com/office/drawing/2014/chart" uri="{C3380CC4-5D6E-409C-BE32-E72D297353CC}">
+                <c16:uniqueId val="{00000001-FA4F-47A2-9D3E-A558FBC35EF2}"/>
+              </c:ext>
+            </c:extLst>
           </c:dPt>
           <c:dPt>
             <c:idx val="1"/>
             <c:invertIfNegative val="0"/>
             <c:bubble3D val="0"/>
-            <c:spPr>
-              <a:solidFill>
-                <a:srgbClr val="2E3A46"/>
-              </a:solidFill>
-              <a:effectLst/>
-            </c:spPr>
+            <c:extLst>
+              <c:ext xmlns:c16="http://schemas.microsoft.com/office/drawing/2014/chart" uri="{C3380CC4-5D6E-409C-BE32-E72D297353CC}">
+                <c16:uniqueId val="{00000003-FA4F-47A2-9D3E-A558FBC35EF2}"/>
+              </c:ext>
+            </c:extLst>
           </c:dPt>
           <c:dPt>
             <c:idx val="2"/>
@@ -234,6 +214,11 @@
               </a:solidFill>
               <a:effectLst/>
             </c:spPr>
+            <c:extLst>
+              <c:ext xmlns:c16="http://schemas.microsoft.com/office/drawing/2014/chart" uri="{C3380CC4-5D6E-409C-BE32-E72D297353CC}">
+                <c16:uniqueId val="{00000005-FA4F-47A2-9D3E-A558FBC35EF2}"/>
+              </c:ext>
+            </c:extLst>
           </c:dPt>
           <c:dPt>
             <c:idx val="3"/>
@@ -245,6 +230,11 @@
               </a:solidFill>
               <a:effectLst/>
             </c:spPr>
+            <c:extLst>
+              <c:ext xmlns:c16="http://schemas.microsoft.com/office/drawing/2014/chart" uri="{C3380CC4-5D6E-409C-BE32-E72D297353CC}">
+                <c16:uniqueId val="{00000007-FA4F-47A2-9D3E-A558FBC35EF2}"/>
+              </c:ext>
+            </c:extLst>
           </c:dPt>
           <c:dPt>
             <c:idx val="4"/>
@@ -256,6 +246,11 @@
               </a:solidFill>
               <a:effectLst/>
             </c:spPr>
+            <c:extLst>
+              <c:ext xmlns:c16="http://schemas.microsoft.com/office/drawing/2014/chart" uri="{C3380CC4-5D6E-409C-BE32-E72D297353CC}">
+                <c16:uniqueId val="{00000009-FA4F-47A2-9D3E-A558FBC35EF2}"/>
+              </c:ext>
+            </c:extLst>
           </c:dPt>
           <c:dPt>
             <c:idx val="5"/>
@@ -267,6 +262,11 @@
               </a:solidFill>
               <a:effectLst/>
             </c:spPr>
+            <c:extLst>
+              <c:ext xmlns:c16="http://schemas.microsoft.com/office/drawing/2014/chart" uri="{C3380CC4-5D6E-409C-BE32-E72D297353CC}">
+                <c16:uniqueId val="{0000000B-FA4F-47A2-9D3E-A558FBC35EF2}"/>
+              </c:ext>
+            </c:extLst>
           </c:dPt>
           <c:dPt>
             <c:idx val="6"/>
@@ -278,6 +278,11 @@
               </a:solidFill>
               <a:effectLst/>
             </c:spPr>
+            <c:extLst>
+              <c:ext xmlns:c16="http://schemas.microsoft.com/office/drawing/2014/chart" uri="{C3380CC4-5D6E-409C-BE32-E72D297353CC}">
+                <c16:uniqueId val="{0000000D-FA4F-47A2-9D3E-A558FBC35EF2}"/>
+              </c:ext>
+            </c:extLst>
           </c:dPt>
           <c:dPt>
             <c:idx val="7"/>
@@ -289,40 +294,80 @@
               </a:solidFill>
               <a:effectLst/>
             </c:spPr>
+            <c:extLst>
+              <c:ext xmlns:c16="http://schemas.microsoft.com/office/drawing/2014/chart" uri="{C3380CC4-5D6E-409C-BE32-E72D297353CC}">
+                <c16:uniqueId val="{0000000F-FA4F-47A2-9D3E-A558FBC35EF2}"/>
+              </c:ext>
+            </c:extLst>
           </c:dPt>
+          <c:dLbls>
+            <c:numFmt formatCode="0.000" sourceLinked="0"/>
+            <c:spPr>
+              <a:noFill/>
+              <a:ln>
+                <a:noFill/>
+              </a:ln>
+              <a:effectLst/>
+            </c:spPr>
+            <c:txPr>
+              <a:bodyPr/>
+              <a:lstStyle/>
+              <a:p>
+                <a:pPr>
+                  <a:defRPr sz="1300" b="0" i="0" u="none" strike="noStrike">
+                    <a:solidFill>
+                      <a:srgbClr val="16202B"/>
+                    </a:solidFill>
+                    <a:latin typeface="+mn-lt"/>
+                  </a:defRPr>
+                </a:pPr>
+                <a:endParaRPr lang="en-US"/>
+              </a:p>
+            </c:txPr>
+            <c:showLegendKey val="0"/>
+            <c:showVal val="1"/>
+            <c:showCatName val="0"/>
+            <c:showSerName val="0"/>
+            <c:showPercent val="0"/>
+            <c:showBubbleSize val="0"/>
+            <c:showLeaderLines val="0"/>
+            <c:extLst>
+              <c:ext xmlns:c15="http://schemas.microsoft.com/office/drawing/2012/chart" uri="{CE6537A1-D6FC-4f65-9D91-7224C49458BB}">
+                <c15:showLeaderLines val="0"/>
+              </c:ext>
+            </c:extLst>
+          </c:dLbls>
           <c:cat>
-            <c:multiLvlStrRef>
+            <c:strRef>
               <c:f>Sheet1!$A$2:$A$9</c:f>
-              <c:multiLvlStrCache>
+              <c:strCache>
                 <c:ptCount val="8"/>
-                <c:lvl>
-                  <c:pt idx="0">
-                    <c:v>Control</c:v>
-                  </c:pt>
-                  <c:pt idx="1">
-                    <c:v>Placebo</c:v>
-                  </c:pt>
-                  <c:pt idx="2">
-                    <c:v>Same + history</c:v>
-                  </c:pt>
-                  <c:pt idx="3">
-                    <c:v>Same, notes only</c:v>
-                  </c:pt>
-                  <c:pt idx="4">
-                    <c:v>Same, no history</c:v>
-                  </c:pt>
-                  <c:pt idx="5">
-                    <c:v>Other + history</c:v>
-                  </c:pt>
-                  <c:pt idx="6">
-                    <c:v>Other, no history</c:v>
-                  </c:pt>
-                  <c:pt idx="7">
-                    <c:v>Best-response bot</c:v>
-                  </c:pt>
-                </c:lvl>
-              </c:multiLvlStrCache>
-            </c:multiLvlStrRef>
+                <c:pt idx="0">
+                  <c:v>Control</c:v>
+                </c:pt>
+                <c:pt idx="1">
+                  <c:v>Placebo</c:v>
+                </c:pt>
+                <c:pt idx="2">
+                  <c:v>Same + history</c:v>
+                </c:pt>
+                <c:pt idx="3">
+                  <c:v>Same, notes only</c:v>
+                </c:pt>
+                <c:pt idx="4">
+                  <c:v>Same, no history</c:v>
+                </c:pt>
+                <c:pt idx="5">
+                  <c:v>Other + history</c:v>
+                </c:pt>
+                <c:pt idx="6">
+                  <c:v>Other, no history</c:v>
+                </c:pt>
+                <c:pt idx="7">
+                  <c:v>Best-response bot</c:v>
+                </c:pt>
+              </c:strCache>
+            </c:strRef>
           </c:cat>
           <c:val>
             <c:numRef>
@@ -334,7 +379,7 @@
                   <c:v>0.9</c:v>
                 </c:pt>
                 <c:pt idx="1">
-                  <c:v>0.884</c:v>
+                  <c:v>0.88400000000000001</c:v>
                 </c:pt>
                 <c:pt idx="2">
                   <c:v>0.876</c:v>
@@ -343,50 +388,37 @@
                   <c:v>0.63</c:v>
                 </c:pt>
                 <c:pt idx="4">
-                  <c:v>0.289</c:v>
+                  <c:v>0.28899999999999998</c:v>
                 </c:pt>
                 <c:pt idx="5">
-                  <c:v>0.199</c:v>
+                  <c:v>0.19900000000000001</c:v>
                 </c:pt>
                 <c:pt idx="6">
-                  <c:v>0.039</c:v>
+                  <c:v>3.9E-2</c:v>
                 </c:pt>
                 <c:pt idx="7">
-                  <c:v>0.023</c:v>
+                  <c:v>2.3E-2</c:v>
                 </c:pt>
               </c:numCache>
             </c:numRef>
           </c:val>
+          <c:extLst>
+            <c:ext xmlns:c16="http://schemas.microsoft.com/office/drawing/2014/chart" uri="{C3380CC4-5D6E-409C-BE32-E72D297353CC}">
+              <c16:uniqueId val="{00000010-FA4F-47A2-9D3E-A558FBC35EF2}"/>
+            </c:ext>
+          </c:extLst>
         </c:ser>
         <c:dLbls>
-          <c:numFmt formatCode="0.000" sourceLinked="0"/>
-          <c:txPr>
-            <a:bodyPr/>
-            <a:lstStyle/>
-            <a:p>
-              <a:pPr>
-                <a:defRPr b="0" i="0" strike="noStrike" sz="1300" u="none">
-                  <a:solidFill>
-                    <a:srgbClr val="16202B"/>
-                  </a:solidFill>
-                  <a:latin typeface="+mn-lt"/>
-                </a:defRPr>
-              </a:pPr>
-            </a:p>
-          </c:txPr>
           <c:showLegendKey val="0"/>
           <c:showVal val="1"/>
           <c:showCatName val="0"/>
           <c:showSerName val="0"/>
           <c:showPercent val="0"/>
           <c:showBubbleSize val="0"/>
-          <c:showLeaderLines val="0"/>
         </c:dLbls>
         <c:gapWidth val="150"/>
-        <c:overlap val="0"/>
         <c:axId val="2094734554"/>
         <c:axId val="2094734552"/>
-        <c:axId val="2094734556"/>
       </c:barChart>
       <c:catAx>
         <c:axId val="2094734554"/>
@@ -427,6 +459,7 @@
         <c:crosses val="autoZero"/>
         <c:auto val="1"/>
         <c:lblAlgn val="ctr"/>
+        <c:lblOffset val="100"/>
         <c:noMultiLvlLbl val="1"/>
       </c:catAx>
       <c:valAx>
@@ -437,7 +470,7 @@
           <c:min val="0"/>
         </c:scaling>
         <c:delete val="0"/>
-        <c:axPos val="b"/>
+        <c:axPos val="t"/>
         <c:majorGridlines>
           <c:spPr>
             <a:ln w="9525" cap="flat">
@@ -491,6 +524,7 @@
     </c:plotArea>
     <c:plotVisOnly val="1"/>
     <c:dispBlanksAs val="span"/>
+    <c:showDLblsOverMax val="1"/>
   </c:chart>
   <c:spPr>
     <a:noFill/>
@@ -527,234 +561,10 @@
           <a:chExt cx="0" cy="0"/>
         </a:xfrm>
       </p:grpSpPr>
-      <p:sp>
-        <p:nvSpPr>
-          <p:cNvPr id="2" name="Header Placeholder 1"/>
-          <p:cNvSpPr>
-            <a:spLocks noGrp="1"/>
-          </p:cNvSpPr>
-          <p:nvPr>
-            <p:ph type="hdr" sz="quarter"/>
-          </p:nvPr>
-        </p:nvSpPr>
-        <p:spPr>
-          <a:xfrm>
-            <a:off x="0" y="0"/>
-            <a:ext cx="2971800" cy="458788"/>
-          </a:xfrm>
-          <a:prstGeom prst="rect">
-            <a:avLst/>
-          </a:prstGeom>
-        </p:spPr>
-        <p:txBody>
-          <a:bodyPr vert="horz" lIns="91440" tIns="45720" rIns="91440" bIns="45720" rtlCol="0"/>
-          <a:lstStyle>
-            <a:lvl1pPr algn="l">
-              <a:defRPr sz="1200"/>
-            </a:lvl1pPr>
-          </a:lstStyle>
-          <a:p>
-            <a:endParaRPr lang="en-US"/>
-          </a:p>
-        </p:txBody>
-      </p:sp>
-      <p:sp>
-        <p:nvSpPr>
-          <p:cNvPr id="3" name="Date Placeholder 2"/>
-          <p:cNvSpPr>
-            <a:spLocks noGrp="1"/>
-          </p:cNvSpPr>
-          <p:nvPr>
-            <p:ph type="dt" idx="1"/>
-          </p:nvPr>
-        </p:nvSpPr>
-        <p:spPr>
-          <a:xfrm>
-            <a:off x="3884613" y="0"/>
-            <a:ext cx="2971800" cy="458788"/>
-          </a:xfrm>
-          <a:prstGeom prst="rect">
-            <a:avLst/>
-          </a:prstGeom>
-        </p:spPr>
-        <p:txBody>
-          <a:bodyPr vert="horz" lIns="91440" tIns="45720" rIns="91440" bIns="45720" rtlCol="0"/>
-          <a:lstStyle>
-            <a:lvl1pPr algn="r">
-              <a:defRPr sz="1200"/>
-            </a:lvl1pPr>
-          </a:lstStyle>
-          <a:p>
-            <a:fld id="{5282F153-3F37-0F45-9E97-73ACFA13230C}" type="datetimeFigureOut">
-              <a:rPr lang="en-US"/>
-              <a:t>7/23/19</a:t>
-            </a:fld>
-            <a:endParaRPr lang="en-US"/>
-          </a:p>
-        </p:txBody>
-      </p:sp>
-      <p:sp>
-        <p:nvSpPr>
-          <p:cNvPr id="4" name="Slide Image Placeholder 3"/>
-          <p:cNvSpPr>
-            <a:spLocks noGrp="1" noRot="1" noChangeAspect="1"/>
-          </p:cNvSpPr>
-          <p:nvPr>
-            <p:ph type="sldImg" idx="2"/>
-          </p:nvPr>
-        </p:nvSpPr>
-        <p:spPr>
-          <a:xfrm>
-            <a:off x="685800" y="1143000"/>
-            <a:ext cx="5486400" cy="3086100"/>
-          </a:xfrm>
-          <a:prstGeom prst="rect">
-            <a:avLst/>
-          </a:prstGeom>
-          <a:noFill/>
-          <a:ln w="12700">
-            <a:solidFill>
-              <a:prstClr val="black"/>
-            </a:solidFill>
-          </a:ln>
-        </p:spPr>
-        <p:txBody>
-          <a:bodyPr vert="horz" lIns="91440" tIns="45720" rIns="91440" bIns="45720" rtlCol="0" anchor="ctr"/>
-          <a:lstStyle/>
-          <a:p>
-            <a:endParaRPr lang="en-US"/>
-          </a:p>
-        </p:txBody>
-      </p:sp>
-      <p:sp>
-        <p:nvSpPr>
-          <p:cNvPr id="5" name="Notes Placeholder 4"/>
-          <p:cNvSpPr>
-            <a:spLocks noGrp="1"/>
-          </p:cNvSpPr>
-          <p:nvPr>
-            <p:ph type="body" sz="quarter" idx="3"/>
-          </p:nvPr>
-        </p:nvSpPr>
-        <p:spPr>
-          <a:xfrm>
-            <a:off x="685800" y="4400550"/>
-            <a:ext cx="5486400" cy="3600450"/>
-          </a:xfrm>
-          <a:prstGeom prst="rect">
-            <a:avLst/>
-          </a:prstGeom>
-        </p:spPr>
-        <p:txBody>
-          <a:bodyPr vert="horz" lIns="91440" tIns="45720" rIns="91440" bIns="45720" rtlCol="0"/>
-          <a:lstStyle/>
-          <a:p>
-            <a:pPr lvl="0"/>
-            <a:r>
-              <a:rPr lang="en-US"/>
-              <a:t>Click to edit Master text styles</a:t>
-            </a:r>
-          </a:p>
-          <a:p>
-            <a:pPr lvl="1"/>
-            <a:r>
-              <a:rPr lang="en-US"/>
-              <a:t>Second level</a:t>
-            </a:r>
-          </a:p>
-          <a:p>
-            <a:pPr lvl="2"/>
-            <a:r>
-              <a:rPr lang="en-US"/>
-              <a:t>Third level</a:t>
-            </a:r>
-          </a:p>
-          <a:p>
-            <a:pPr lvl="3"/>
-            <a:r>
-              <a:rPr lang="en-US"/>
-              <a:t>Fourth level</a:t>
-            </a:r>
-          </a:p>
-          <a:p>
-            <a:pPr lvl="4"/>
-            <a:r>
-              <a:rPr lang="en-US"/>
-              <a:t>Fifth level</a:t>
-            </a:r>
-          </a:p>
-        </p:txBody>
-      </p:sp>
-      <p:sp>
-        <p:nvSpPr>
-          <p:cNvPr id="6" name="Footer Placeholder 5"/>
-          <p:cNvSpPr>
-            <a:spLocks noGrp="1"/>
-          </p:cNvSpPr>
-          <p:nvPr>
-            <p:ph type="ftr" sz="quarter" idx="4"/>
-          </p:nvPr>
-        </p:nvSpPr>
-        <p:spPr>
-          <a:xfrm>
-            <a:off x="0" y="8685213"/>
-            <a:ext cx="2971800" cy="458787"/>
-          </a:xfrm>
-          <a:prstGeom prst="rect">
-            <a:avLst/>
-          </a:prstGeom>
-        </p:spPr>
-        <p:txBody>
-          <a:bodyPr vert="horz" lIns="91440" tIns="45720" rIns="91440" bIns="45720" rtlCol="0" anchor="b"/>
-          <a:lstStyle>
-            <a:lvl1pPr algn="l">
-              <a:defRPr sz="1200"/>
-            </a:lvl1pPr>
-          </a:lstStyle>
-          <a:p>
-            <a:endParaRPr lang="en-US"/>
-          </a:p>
-        </p:txBody>
-      </p:sp>
-      <p:sp>
-        <p:nvSpPr>
-          <p:cNvPr id="7" name="Slide Number Placeholder 6"/>
-          <p:cNvSpPr>
-            <a:spLocks noGrp="1"/>
-          </p:cNvSpPr>
-          <p:nvPr>
-            <p:ph type="sldNum" sz="quarter" idx="5"/>
-          </p:nvPr>
-        </p:nvSpPr>
-        <p:spPr>
-          <a:xfrm>
-            <a:off x="3884613" y="8685213"/>
-            <a:ext cx="2971800" cy="458787"/>
-          </a:xfrm>
-          <a:prstGeom prst="rect">
-            <a:avLst/>
-          </a:prstGeom>
-        </p:spPr>
-        <p:txBody>
-          <a:bodyPr vert="horz" lIns="91440" tIns="45720" rIns="91440" bIns="45720" rtlCol="0" anchor="b"/>
-          <a:lstStyle>
-            <a:lvl1pPr algn="r">
-              <a:defRPr sz="1200"/>
-            </a:lvl1pPr>
-          </a:lstStyle>
-          <a:p>
-            <a:fld id="{CE5E9CC1-C706-0F49-92D6-E571CC5EEA8F}" type="slidenum">
-              <a:rPr lang="en-US"/>
-              <a:t>‹#›</a:t>
-            </a:fld>
-            <a:endParaRPr lang="en-US"/>
-          </a:p>
-        </p:txBody>
-      </p:sp>
     </p:spTree>
     <p:extLst>
       <p:ext uri="{BB962C8B-B14F-4D97-AF65-F5344CB8AC3E}">
-        <p14:creationId xmlns:p14="http://schemas.microsoft.com/office/powerpoint/2010/main" val="1024086991"/>
+        <p14:creationId xmlns:p14="http://schemas.microsoft.com/office/powerpoint/2010/main" val="1300070587"/>
       </p:ext>
     </p:extLst>
   </p:cSld>
@@ -902,7 +712,6 @@
               <a:rPr lang="en-US" dirty="0"/>
               <a:t>Two AI agents that set prices for two competing firms often learn to keep prices high without being told to. We ask what happens when one of them is replaced. Short answer: the cartel survives if the new agent reads the old price history.</a:t>
             </a:r>
-            <a:endParaRPr lang="en-US" dirty="0"/>
           </a:p>
         </p:txBody>
       </p:sp>
@@ -990,7 +799,6 @@
               <a:rPr lang="en-US" dirty="0"/>
               <a:t>All numbers come from stored run data through the analysis code in the repository. The report lists every run, null results and failures.</a:t>
             </a:r>
-            <a:endParaRPr lang="en-US" dirty="0"/>
           </a:p>
         </p:txBody>
       </p:sp>
@@ -1078,7 +886,6 @@
               <a:rPr lang="en-US" dirty="0"/>
               <a:t>The answer tells a regulator which item a remedy must change: the agent, the data it inherits, or its memory.</a:t>
             </a:r>
-            <a:endParaRPr lang="en-US" dirty="0"/>
           </a:p>
         </p:txBody>
       </p:sp>
@@ -1166,7 +973,6 @@
               <a:rPr lang="en-US" dirty="0"/>
               <a:t>A profit index near 1 means the two agents behave like a cartel. We report both indices because they disagree when prices overshoot the monopoly price.</a:t>
             </a:r>
-            <a:endParaRPr lang="en-US" dirty="0"/>
           </a:p>
         </p:txBody>
       </p:sp>
@@ -1254,7 +1060,6 @@
               <a:rPr lang="en-US" dirty="0"/>
               <a:t>Six independent runs, hypotheses fixed in advance, 95% bootstrap intervals over markets. Runs without a stable cartel are reported too.</a:t>
             </a:r>
-            <a:endParaRPr lang="en-US" dirty="0"/>
           </a:p>
         </p:txBody>
       </p:sp>
@@ -1342,7 +1147,6 @@
               <a:rPr lang="en-US" dirty="0"/>
               <a:t>Profit index 0 = competitive, 1 = monopoly. 'Same + history' differs from no replacement by between -0.025 and +0.213 across the six runs.</a:t>
             </a:r>
-            <a:endParaRPr lang="en-US" dirty="0"/>
           </a:p>
         </p:txBody>
       </p:sp>
@@ -1430,7 +1234,6 @@
               <a:rPr lang="en-US" dirty="0"/>
               <a:t>The blank entrant has no anchor. It starts high and stays above the monopoly price, so both firms sell less. Only the best-response bot and the Mistral entrant reach competitive prices.</a:t>
             </a:r>
-            <a:endParaRPr lang="en-US" dirty="0"/>
           </a:p>
         </p:txBody>
       </p:sp>
@@ -1518,7 +1321,6 @@
               <a:rPr lang="en-US" dirty="0"/>
               <a:t>'A different model' is not one treatment. A sticky model keeps the inherited prices by inertia; an exploring model drifts to competition.</a:t>
             </a:r>
-            <a:endParaRPr lang="en-US" dirty="0"/>
           </a:p>
         </p:txBody>
       </p:sp>
@@ -1606,7 +1408,6 @@
               <a:rPr lang="en-US" dirty="0"/>
               <a:t>The inherited high prices persist because the agents anchor on what they see, not because they threaten a price war.</a:t>
             </a:r>
-            <a:endParaRPr lang="en-US" dirty="0"/>
           </a:p>
         </p:txBody>
       </p:sp>
@@ -1694,7 +1495,6 @@
               <a:rPr lang="en-US" dirty="0"/>
               <a:t>The unit of analysis moves from the agent to the agent and its context.</a:t>
             </a:r>
-            <a:endParaRPr lang="en-US" dirty="0"/>
           </a:p>
         </p:txBody>
       </p:sp>
@@ -1772,6 +1572,7 @@
         <a:solidFill>
           <a:srgbClr val="FFFFFF"/>
         </a:solidFill>
+        <a:effectLst/>
       </p:bgPr>
     </p:bg>
     <p:spTree>
@@ -1809,7 +1610,7 @@
           <a:bodyPr wrap="square" rtlCol="0" anchor="ctr"/>
           <a:lstStyle/>
           <a:p>
-            <a:pPr indent="0" marL="0">
+            <a:pPr marL="0" indent="0">
               <a:buNone/>
             </a:pPr>
             <a:r>
@@ -1830,9 +1631,11 @@
       <p:sp>
         <p:nvSpPr>
           <p:cNvPr id="3" name="Text 1"/>
-          <p:cNvSpPr/>
+          <p:cNvSpPr>
+            <a:spLocks noGrp="1"/>
+          </p:cNvSpPr>
           <p:nvPr>
-            <p:ph idx="101" type="title" hasCustomPrompt="1"/>
+            <p:ph type="title" idx="101" hasCustomPrompt="1"/>
           </p:nvPr>
         </p:nvSpPr>
         <p:spPr>
@@ -1849,7 +1652,7 @@
         <p:txBody>
           <a:bodyPr wrap="square" rtlCol="0"/>
           <a:lstStyle>
-            <a:lvl1pPr algn="l" indent="0" marL="0">
+            <a:lvl1pPr marL="0" indent="0" algn="l">
               <a:buNone/>
               <a:defRPr lang="en-US" sz="3000" b="1" dirty="0">
                 <a:solidFill>
@@ -1862,7 +1665,7 @@
             </a:lvl1pPr>
           </a:lstStyle>
           <a:p>
-            <a:pPr algn="l" indent="0" marL="0">
+            <a:pPr marL="0" indent="0" algn="l">
               <a:buNone/>
             </a:pPr>
             <a:endParaRPr lang="en-US" sz="3000" dirty="0"/>
@@ -1889,7 +1692,7 @@
           </a:prstGeom>
           <a:extLst>
             <a:ext uri="{C572A759-6A51-4108-AA02-DFA0A04FC94B}">
-              <ma14:wrappingTextBoxFlag xmlns:ma14="http://schemas.microsoft.com/office/mac/drawingml/2011/main" val="0"/>
+              <ma14:wrappingTextBoxFlag xmlns:ma14="http://schemas.microsoft.com/office/mac/drawingml/2011/main" xmlns="" val="0"/>
             </a:ext>
           </a:extLst>
         </p:spPr>
@@ -1910,8 +1713,8 @@
           <a:p>
             <a:pPr algn="l"/>
             <a:fld id="{F7021451-1387-4CA6-816F-3879F97B5CBC}" type="slidenum">
-              <a:rPr b="0" lang="en-US"/>
-              <a:t>1002</a:t>
+              <a:rPr lang="en-US" b="0"/>
+              <a:t>‹#›</a:t>
             </a:fld>
             <a:endParaRPr lang="en-US"/>
           </a:p>
@@ -1933,6 +1736,7 @@
         <a:solidFill>
           <a:srgbClr val="16202B"/>
         </a:solidFill>
+        <a:effectLst/>
       </p:bgPr>
     </p:bg>
     <p:spTree>
@@ -1952,9 +1756,11 @@
       <p:sp>
         <p:nvSpPr>
           <p:cNvPr id="2" name="Text 0"/>
-          <p:cNvSpPr/>
+          <p:cNvSpPr>
+            <a:spLocks noGrp="1"/>
+          </p:cNvSpPr>
           <p:nvPr>
-            <p:ph idx="100" type="title" hasCustomPrompt="1"/>
+            <p:ph type="title" idx="100" hasCustomPrompt="1"/>
           </p:nvPr>
         </p:nvSpPr>
         <p:spPr>
@@ -1971,7 +1777,7 @@
         <p:txBody>
           <a:bodyPr wrap="square" rtlCol="0"/>
           <a:lstStyle>
-            <a:lvl1pPr algn="l" indent="0" marL="0">
+            <a:lvl1pPr marL="0" indent="0" algn="l">
               <a:buNone/>
               <a:defRPr lang="en-US" sz="3000" b="1" dirty="0">
                 <a:solidFill>
@@ -1984,7 +1790,7 @@
             </a:lvl1pPr>
           </a:lstStyle>
           <a:p>
-            <a:pPr algn="l" indent="0" marL="0">
+            <a:pPr marL="0" indent="0" algn="l">
               <a:buNone/>
             </a:pPr>
             <a:endParaRPr lang="en-US" sz="3000" dirty="0"/>
@@ -2011,7 +1817,7 @@
           </a:prstGeom>
           <a:extLst>
             <a:ext uri="{C572A759-6A51-4108-AA02-DFA0A04FC94B}">
-              <ma14:wrappingTextBoxFlag xmlns:ma14="http://schemas.microsoft.com/office/mac/drawingml/2011/main" val="0"/>
+              <ma14:wrappingTextBoxFlag xmlns:ma14="http://schemas.microsoft.com/office/mac/drawingml/2011/main" xmlns="" val="0"/>
             </a:ext>
           </a:extLst>
         </p:spPr>
@@ -2032,8 +1838,8 @@
           <a:p>
             <a:pPr algn="l"/>
             <a:fld id="{F7021451-1387-4CA6-816F-3879F97B5CBC}" type="slidenum">
-              <a:rPr b="0" lang="en-US"/>
-              <a:t>1003</a:t>
+              <a:rPr lang="en-US" b="0"/>
+              <a:t>‹#›</a:t>
             </a:fld>
             <a:endParaRPr lang="en-US"/>
           </a:p>
@@ -2050,6 +1856,11 @@
 <file path=ppt/slideMasters/slideMaster1.xml><?xml version="1.0" encoding="utf-8"?>
 <p:sldMaster xmlns:a="http://schemas.openxmlformats.org/drawingml/2006/main" xmlns:r="http://schemas.openxmlformats.org/officeDocument/2006/relationships" xmlns:p="http://schemas.openxmlformats.org/presentationml/2006/main">
   <p:cSld>
+    <p:bg>
+      <p:bgRef idx="1001">
+        <a:schemeClr val="bg1"/>
+      </p:bgRef>
+    </p:bg>
     <p:spTree>
       <p:nvGrpSpPr>
         <p:cNvPr id="1" name=""/>
@@ -2084,7 +1895,7 @@
           </a:prstGeom>
           <a:extLst>
             <a:ext uri="{C572A759-6A51-4108-AA02-DFA0A04FC94B}">
-              <ma14:wrappingTextBoxFlag xmlns:ma14="http://schemas.microsoft.com/office/mac/drawingml/2011/main" val="0"/>
+              <ma14:wrappingTextBoxFlag xmlns:ma14="http://schemas.microsoft.com/office/mac/drawingml/2011/main" xmlns="" val="0"/>
             </a:ext>
           </a:extLst>
         </p:spPr>
@@ -2105,8 +1916,8 @@
           <a:p>
             <a:pPr algn="l"/>
             <a:fld id="{F7021451-1387-4CA6-816F-3879F97B5CBC}" type="slidenum">
-              <a:rPr b="0" lang="en-US"/>
-              <a:t>null</a:t>
+              <a:rPr lang="en-US" b="0"/>
+              <a:t>‹#›</a:t>
             </a:fld>
             <a:endParaRPr lang="en-US"/>
           </a:p>
@@ -2412,7 +2223,7 @@
           <a:bodyPr wrap="square" lIns="0" tIns="0" rIns="0" bIns="0" rtlCol="0" anchor="t"/>
           <a:lstStyle/>
           <a:p>
-            <a:pPr indent="0" marL="0">
+            <a:pPr marL="0" indent="0">
               <a:buNone/>
             </a:pPr>
             <a:r>
@@ -2451,7 +2262,7 @@
           <a:bodyPr wrap="square" lIns="0" tIns="0" rIns="0" bIns="0" rtlCol="0" anchor="t"/>
           <a:lstStyle/>
           <a:p>
-            <a:pPr indent="0" marL="0">
+            <a:pPr marL="0" indent="0">
               <a:buNone/>
             </a:pPr>
             <a:r>
@@ -2490,7 +2301,7 @@
           <a:bodyPr wrap="square" lIns="0" tIns="0" rIns="0" bIns="0" rtlCol="0" anchor="t"/>
           <a:lstStyle/>
           <a:p>
-            <a:pPr indent="0" marL="0">
+            <a:pPr marL="0" indent="0">
               <a:buNone/>
             </a:pPr>
             <a:r>
@@ -2529,7 +2340,7 @@
           <a:bodyPr wrap="square" lIns="0" tIns="0" rIns="0" bIns="0" rtlCol="0" anchor="t"/>
           <a:lstStyle/>
           <a:p>
-            <a:pPr indent="0" marL="0">
+            <a:pPr marL="0" indent="0">
               <a:buNone/>
             </a:pPr>
             <a:r>
@@ -2568,7 +2379,7 @@
           <a:bodyPr wrap="square" lIns="0" tIns="0" rIns="0" bIns="0" rtlCol="0" anchor="t"/>
           <a:lstStyle/>
           <a:p>
-            <a:pPr indent="0" marL="0">
+            <a:pPr marL="0" indent="0">
               <a:buNone/>
             </a:pPr>
             <a:r>
@@ -2607,7 +2418,7 @@
           <a:bodyPr wrap="square" lIns="0" tIns="0" rIns="0" bIns="0" rtlCol="0" anchor="t"/>
           <a:lstStyle/>
           <a:p>
-            <a:pPr indent="0" marL="0">
+            <a:pPr marL="0" indent="0">
               <a:buNone/>
             </a:pPr>
             <a:r>
@@ -2646,7 +2457,7 @@
           <a:bodyPr wrap="square" lIns="0" tIns="0" rIns="0" bIns="0" rtlCol="0" anchor="t"/>
           <a:lstStyle/>
           <a:p>
-            <a:pPr indent="0" marL="0">
+            <a:pPr marL="0" indent="0">
               <a:buNone/>
             </a:pPr>
             <a:r>
@@ -2685,7 +2496,7 @@
           <a:bodyPr wrap="square" lIns="0" tIns="0" rIns="0" bIns="0" rtlCol="0" anchor="t"/>
           <a:lstStyle/>
           <a:p>
-            <a:pPr indent="0" marL="0">
+            <a:pPr marL="0" indent="0">
               <a:buNone/>
             </a:pPr>
             <a:r>
@@ -2724,7 +2535,7 @@
           <a:bodyPr wrap="square" lIns="0" tIns="0" rIns="0" bIns="0" rtlCol="0" anchor="t"/>
           <a:lstStyle/>
           <a:p>
-            <a:pPr indent="0" marL="0">
+            <a:pPr marL="0" indent="0">
               <a:buNone/>
             </a:pPr>
             <a:r>
@@ -2763,7 +2574,7 @@
           <a:bodyPr wrap="square" lIns="0" tIns="0" rIns="0" bIns="0" rtlCol="0" anchor="t"/>
           <a:lstStyle/>
           <a:p>
-            <a:pPr indent="0" marL="0">
+            <a:pPr marL="0" indent="0">
               <a:buNone/>
             </a:pPr>
             <a:r>
@@ -2778,36 +2589,6 @@
               <a:t>Supratik Bhowal  ·  IEM Kolkata  ·  with Apart Research</a:t>
             </a:r>
             <a:endParaRPr lang="en-US" sz="1500" dirty="0"/>
-          </a:p>
-        </p:txBody>
-      </p:sp>
-      <p:sp>
-        <p:nvSpPr>
-          <p:cNvPr id="13" name="Text 0"/>
-          <p:cNvSpPr/>
-          <p:nvPr>
-            <p:ph idx="100" type="title" hasCustomPrompt="1"/>
-          </p:nvPr>
-        </p:nvSpPr>
-        <p:spPr>
-          <a:xfrm>
-            <a:off x="548640" y="320040"/>
-            <a:ext cx="11064240" cy="822960"/>
-          </a:xfrm>
-          <a:prstGeom prst="rect">
-            <a:avLst/>
-          </a:prstGeom>
-          <a:noFill/>
-          <a:ln/>
-        </p:spPr>
-        <p:txBody>
-          <a:bodyPr wrap="square" rtlCol="0" anchor="ctr"/>
-          <a:lstStyle/>
-          <a:p>
-            <a:pPr algn="l" indent="0" marL="0">
-              <a:buNone/>
-            </a:pPr>
-            <a:endParaRPr lang="en-US" sz="3000" dirty="0"/>
           </a:p>
         </p:txBody>
       </p:sp>
@@ -2831,7 +2612,7 @@
           </a:prstGeom>
           <a:extLst>
             <a:ext uri="{C572A759-6A51-4108-AA02-DFA0A04FC94B}">
-              <ma14:wrappingTextBoxFlag xmlns:ma14="http://schemas.microsoft.com/office/mac/drawingml/2011/main" val="0"/>
+              <ma14:wrappingTextBoxFlag xmlns:ma14="http://schemas.microsoft.com/office/mac/drawingml/2011/main" xmlns="" val="0"/>
             </a:ext>
           </a:extLst>
         </p:spPr>
@@ -2852,7 +2633,7 @@
           <a:p>
             <a:pPr algn="l"/>
             <a:fld id="{F7021451-1387-4CA6-816F-3879F97B5CBC}" type="slidenum">
-              <a:rPr b="0" lang="en-US"/>
+              <a:rPr lang="en-US" b="0"/>
               <a:t>1</a:t>
             </a:fld>
             <a:endParaRPr lang="en-US"/>
@@ -2887,9 +2668,11 @@
       <p:sp>
         <p:nvSpPr>
           <p:cNvPr id="2" name="Text 1"/>
-          <p:cNvSpPr/>
+          <p:cNvSpPr>
+            <a:spLocks noGrp="1"/>
+          </p:cNvSpPr>
           <p:nvPr>
-            <p:ph idx="101" type="title" hasCustomPrompt="1"/>
+            <p:ph type="title" idx="101" hasCustomPrompt="1"/>
           </p:nvPr>
         </p:nvSpPr>
         <p:spPr>
@@ -2907,7 +2690,7 @@
           <a:bodyPr wrap="square" rtlCol="0" anchor="ctr"/>
           <a:lstStyle/>
           <a:p>
-            <a:pPr algn="l" indent="0" marL="0">
+            <a:pPr marL="0" indent="0" algn="l">
               <a:buNone/>
             </a:pPr>
             <a:r>
@@ -2973,7 +2756,7 @@
           <a:bodyPr wrap="square" lIns="0" tIns="0" rIns="0" bIns="0" rtlCol="0" anchor="t"/>
           <a:lstStyle/>
           <a:p>
-            <a:pPr indent="0" marL="0">
+            <a:pPr marL="0" indent="0">
               <a:buNone/>
             </a:pPr>
             <a:r>
@@ -3145,7 +2928,7 @@
           <a:bodyPr wrap="square" lIns="0" tIns="0" rIns="0" bIns="0" rtlCol="0" anchor="t"/>
           <a:lstStyle/>
           <a:p>
-            <a:pPr indent="0" marL="0">
+            <a:pPr marL="0" indent="0">
               <a:buNone/>
             </a:pPr>
             <a:r>
@@ -3269,7 +3052,7 @@
           <a:bodyPr wrap="square" lIns="0" tIns="0" rIns="0" bIns="0" rtlCol="0" anchor="t"/>
           <a:lstStyle/>
           <a:p>
-            <a:pPr indent="0" marL="0">
+            <a:pPr marL="0" indent="0">
               <a:buNone/>
             </a:pPr>
             <a:r>
@@ -3308,7 +3091,7 @@
           <a:bodyPr wrap="square" lIns="0" tIns="0" rIns="0" bIns="0" rtlCol="0" anchor="t"/>
           <a:lstStyle/>
           <a:p>
-            <a:pPr indent="0" marL="0">
+            <a:pPr marL="0" indent="0">
               <a:buNone/>
             </a:pPr>
             <a:r>
@@ -3319,7 +3102,7 @@
                 <a:latin typeface="Calibri" pitchFamily="34" charset="0"/>
                 <a:ea typeface="Calibri" pitchFamily="34" charset="-122"/>
                 <a:cs typeface="Calibri" pitchFamily="34" charset="-120"/>
-                <a:hlinkClick r:id="rId1" invalidUrl="" action="" tgtFrame="" tooltip="" history="1" highlightClick="0" endSnd="0">
+                <a:hlinkClick r:id="rId3">
                   <a:extLst>
                     <a:ext uri="{A12FA001-AC4F-418D-AE19-62706E023703}">
                       <ahyp:hlinkClr xmlns:ahyp="http://schemas.microsoft.com/office/drawing/2018/hyperlinkcolor" val="tx"/>
@@ -3353,7 +3136,7 @@
           </a:prstGeom>
           <a:extLst>
             <a:ext uri="{C572A759-6A51-4108-AA02-DFA0A04FC94B}">
-              <ma14:wrappingTextBoxFlag xmlns:ma14="http://schemas.microsoft.com/office/mac/drawingml/2011/main" val="0"/>
+              <ma14:wrappingTextBoxFlag xmlns:ma14="http://schemas.microsoft.com/office/mac/drawingml/2011/main" xmlns="" val="0"/>
             </a:ext>
           </a:extLst>
         </p:spPr>
@@ -3374,7 +3157,7 @@
           <a:p>
             <a:pPr algn="l"/>
             <a:fld id="{F7021451-1387-4CA6-816F-3879F97B5CBC}" type="slidenum">
-              <a:rPr b="0" lang="en-US"/>
+              <a:rPr lang="en-US" b="0"/>
               <a:t>10</a:t>
             </a:fld>
             <a:endParaRPr lang="en-US"/>
@@ -3409,9 +3192,11 @@
       <p:sp>
         <p:nvSpPr>
           <p:cNvPr id="2" name="Text 1"/>
-          <p:cNvSpPr/>
+          <p:cNvSpPr>
+            <a:spLocks noGrp="1"/>
+          </p:cNvSpPr>
           <p:nvPr>
-            <p:ph idx="101" type="title" hasCustomPrompt="1"/>
+            <p:ph type="title" idx="101" hasCustomPrompt="1"/>
           </p:nvPr>
         </p:nvSpPr>
         <p:spPr>
@@ -3429,7 +3214,7 @@
           <a:bodyPr wrap="square" rtlCol="0" anchor="ctr"/>
           <a:lstStyle/>
           <a:p>
-            <a:pPr algn="l" indent="0" marL="0">
+            <a:pPr marL="0" indent="0" algn="l">
               <a:buNone/>
             </a:pPr>
             <a:r>
@@ -3468,7 +3253,7 @@
           <a:bodyPr wrap="square" lIns="0" tIns="0" rIns="0" bIns="0" rtlCol="0" anchor="t"/>
           <a:lstStyle/>
           <a:p>
-            <a:pPr indent="0" marL="0">
+            <a:pPr marL="0" indent="0">
               <a:buNone/>
             </a:pPr>
             <a:r>
@@ -3485,7 +3270,7 @@
             <a:endParaRPr lang="en-US" sz="1800" dirty="0"/>
           </a:p>
           <a:p>
-            <a:pPr indent="0" marL="0">
+            <a:pPr marL="0" indent="0">
               <a:buNone/>
             </a:pPr>
             <a:r>
@@ -3502,7 +3287,7 @@
             <a:endParaRPr lang="en-US" sz="1800" dirty="0"/>
           </a:p>
           <a:p>
-            <a:pPr indent="0" marL="0">
+            <a:pPr marL="0" indent="0">
               <a:buNone/>
             </a:pPr>
             <a:r>
@@ -3519,7 +3304,7 @@
             <a:endParaRPr lang="en-US" sz="1800" dirty="0"/>
           </a:p>
           <a:p>
-            <a:pPr indent="0" marL="0">
+            <a:pPr marL="0" indent="0">
               <a:buNone/>
             </a:pPr>
             <a:r>
@@ -3536,7 +3321,7 @@
             <a:endParaRPr lang="en-US" sz="1800" dirty="0"/>
           </a:p>
           <a:p>
-            <a:pPr indent="0" marL="0">
+            <a:pPr marL="0" indent="0">
               <a:buNone/>
             </a:pPr>
             <a:r>
@@ -3627,7 +3412,7 @@
           <a:bodyPr wrap="square" lIns="0" tIns="0" rIns="0" bIns="0" rtlCol="0" anchor="ctr"/>
           <a:lstStyle/>
           <a:p>
-            <a:pPr algn="ctr" indent="0" marL="0">
+            <a:pPr marL="0" indent="0" algn="ctr">
               <a:buNone/>
             </a:pPr>
             <a:r>
@@ -3666,7 +3451,7 @@
           <a:bodyPr wrap="square" lIns="0" tIns="0" rIns="0" bIns="0" rtlCol="0" anchor="t"/>
           <a:lstStyle/>
           <a:p>
-            <a:pPr indent="0" marL="0">
+            <a:pPr marL="0" indent="0">
               <a:buNone/>
             </a:pPr>
             <a:r>
@@ -3705,7 +3490,7 @@
           <a:bodyPr wrap="square" lIns="0" tIns="0" rIns="0" bIns="0" rtlCol="0" anchor="t"/>
           <a:lstStyle/>
           <a:p>
-            <a:pPr indent="0" marL="0">
+            <a:pPr marL="0" indent="0">
               <a:buNone/>
             </a:pPr>
             <a:r>
@@ -3796,7 +3581,7 @@
           <a:bodyPr wrap="square" lIns="0" tIns="0" rIns="0" bIns="0" rtlCol="0" anchor="ctr"/>
           <a:lstStyle/>
           <a:p>
-            <a:pPr algn="ctr" indent="0" marL="0">
+            <a:pPr marL="0" indent="0" algn="ctr">
               <a:buNone/>
             </a:pPr>
             <a:r>
@@ -3835,7 +3620,7 @@
           <a:bodyPr wrap="square" lIns="0" tIns="0" rIns="0" bIns="0" rtlCol="0" anchor="t"/>
           <a:lstStyle/>
           <a:p>
-            <a:pPr indent="0" marL="0">
+            <a:pPr marL="0" indent="0">
               <a:buNone/>
             </a:pPr>
             <a:r>
@@ -3874,7 +3659,7 @@
           <a:bodyPr wrap="square" lIns="0" tIns="0" rIns="0" bIns="0" rtlCol="0" anchor="t"/>
           <a:lstStyle/>
           <a:p>
-            <a:pPr indent="0" marL="0">
+            <a:pPr marL="0" indent="0">
               <a:buNone/>
             </a:pPr>
             <a:r>
@@ -3965,7 +3750,7 @@
           <a:bodyPr wrap="square" lIns="0" tIns="0" rIns="0" bIns="0" rtlCol="0" anchor="ctr"/>
           <a:lstStyle/>
           <a:p>
-            <a:pPr algn="ctr" indent="0" marL="0">
+            <a:pPr marL="0" indent="0" algn="ctr">
               <a:buNone/>
             </a:pPr>
             <a:r>
@@ -4004,7 +3789,7 @@
           <a:bodyPr wrap="square" lIns="0" tIns="0" rIns="0" bIns="0" rtlCol="0" anchor="t"/>
           <a:lstStyle/>
           <a:p>
-            <a:pPr indent="0" marL="0">
+            <a:pPr marL="0" indent="0">
               <a:buNone/>
             </a:pPr>
             <a:r>
@@ -4043,7 +3828,7 @@
           <a:bodyPr wrap="square" lIns="0" tIns="0" rIns="0" bIns="0" rtlCol="0" anchor="t"/>
           <a:lstStyle/>
           <a:p>
-            <a:pPr indent="0" marL="0">
+            <a:pPr marL="0" indent="0">
               <a:buNone/>
             </a:pPr>
             <a:r>
@@ -4081,7 +3866,7 @@
           </a:prstGeom>
           <a:extLst>
             <a:ext uri="{C572A759-6A51-4108-AA02-DFA0A04FC94B}">
-              <ma14:wrappingTextBoxFlag xmlns:ma14="http://schemas.microsoft.com/office/mac/drawingml/2011/main" val="0"/>
+              <ma14:wrappingTextBoxFlag xmlns:ma14="http://schemas.microsoft.com/office/mac/drawingml/2011/main" xmlns="" val="0"/>
             </a:ext>
           </a:extLst>
         </p:spPr>
@@ -4102,7 +3887,7 @@
           <a:p>
             <a:pPr algn="l"/>
             <a:fld id="{F7021451-1387-4CA6-816F-3879F97B5CBC}" type="slidenum">
-              <a:rPr b="0" lang="en-US"/>
+              <a:rPr lang="en-US" b="0"/>
               <a:t>2</a:t>
             </a:fld>
             <a:endParaRPr lang="en-US"/>
@@ -4137,9 +3922,11 @@
       <p:sp>
         <p:nvSpPr>
           <p:cNvPr id="2" name="Text 1"/>
-          <p:cNvSpPr/>
+          <p:cNvSpPr>
+            <a:spLocks noGrp="1"/>
+          </p:cNvSpPr>
           <p:nvPr>
-            <p:ph idx="101" type="title" hasCustomPrompt="1"/>
+            <p:ph type="title" idx="101" hasCustomPrompt="1"/>
           </p:nvPr>
         </p:nvSpPr>
         <p:spPr>
@@ -4157,7 +3944,7 @@
           <a:bodyPr wrap="square" rtlCol="0" anchor="ctr"/>
           <a:lstStyle/>
           <a:p>
-            <a:pPr algn="l" indent="0" marL="0">
+            <a:pPr marL="0" indent="0" algn="l">
               <a:buNone/>
             </a:pPr>
             <a:r>
@@ -4196,7 +3983,7 @@
           <a:bodyPr wrap="square" lIns="0" tIns="0" rIns="0" bIns="0" rtlCol="0" anchor="t"/>
           <a:lstStyle/>
           <a:p>
-            <a:pPr indent="0" marL="0">
+            <a:pPr marL="0" indent="0">
               <a:spcAft>
                 <a:spcPts val="600"/>
               </a:spcAft>
@@ -4213,14 +4000,28 @@
               </a:rPr>
               <a:t>Market: </a:t>
             </a:r>
-            <a:pPr indent="0" marL="0">
+            <a:r>
+              <a:rPr lang="en-US" sz="1800" dirty="0">
+                <a:solidFill>
+                  <a:srgbClr val="2E3A46"/>
+                </a:solidFill>
+                <a:latin typeface="Calibri" pitchFamily="34" charset="0"/>
+                <a:ea typeface="Calibri" pitchFamily="34" charset="-122"/>
+                <a:cs typeface="Calibri" pitchFamily="34" charset="-120"/>
+              </a:rPr>
+              <a:t>two firms sell similar products; buyers choose by price (logit Bertrand duopoly, Calvano et al. 2020).</a:t>
+            </a:r>
+            <a:endParaRPr lang="en-US" sz="1800" dirty="0"/>
+          </a:p>
+          <a:p>
+            <a:pPr marL="0" indent="0">
               <a:spcAft>
                 <a:spcPts val="600"/>
               </a:spcAft>
               <a:buNone/>
             </a:pPr>
             <a:r>
-              <a:rPr lang="en-US" sz="1800" dirty="0">
+              <a:rPr lang="en-US" sz="800" dirty="0">
                 <a:solidFill>
                   <a:srgbClr val="2E3A46"/>
                 </a:solidFill>
@@ -4228,19 +4029,19 @@
                 <a:ea typeface="Calibri" pitchFamily="34" charset="-122"/>
                 <a:cs typeface="Calibri" pitchFamily="34" charset="-120"/>
               </a:rPr>
-              <a:t>two firms sell similar products; buyers choose by price (logit Bertrand duopoly, Calvano et al. 2020).</a:t>
+              <a:t> </a:t>
             </a:r>
             <a:endParaRPr lang="en-US" sz="1800" dirty="0"/>
           </a:p>
           <a:p>
-            <a:pPr indent="0" marL="0">
+            <a:pPr marL="0" indent="0">
               <a:spcAft>
                 <a:spcPts val="600"/>
               </a:spcAft>
               <a:buNone/>
             </a:pPr>
             <a:r>
-              <a:rPr lang="en-US" sz="800" dirty="0">
+              <a:rPr lang="en-US" sz="1800" b="1" dirty="0">
                 <a:solidFill>
                   <a:srgbClr val="2E3A46"/>
                 </a:solidFill>
@@ -4248,19 +4049,30 @@
                 <a:ea typeface="Calibri" pitchFamily="34" charset="-122"/>
                 <a:cs typeface="Calibri" pitchFamily="34" charset="-120"/>
               </a:rPr>
-              <a:t> </a:t>
+              <a:t>Agents: </a:t>
+            </a:r>
+            <a:r>
+              <a:rPr lang="en-US" sz="1800" dirty="0">
+                <a:solidFill>
+                  <a:srgbClr val="2E3A46"/>
+                </a:solidFill>
+                <a:latin typeface="Calibri" pitchFamily="34" charset="0"/>
+                <a:ea typeface="Calibri" pitchFamily="34" charset="-122"/>
+                <a:cs typeface="Calibri" pitchFamily="34" charset="-120"/>
+              </a:rPr>
+              <a:t>each firm is an open LLM. Each round it sees the rules, its last 30 rounds and its notes, and answers with a price and new notes. The prompt never mentions collusion.</a:t>
             </a:r>
             <a:endParaRPr lang="en-US" sz="1800" dirty="0"/>
           </a:p>
           <a:p>
-            <a:pPr indent="0" marL="0">
+            <a:pPr marL="0" indent="0">
               <a:spcAft>
                 <a:spcPts val="600"/>
               </a:spcAft>
               <a:buNone/>
             </a:pPr>
             <a:r>
-              <a:rPr lang="en-US" sz="1800" b="1" dirty="0">
+              <a:rPr lang="en-US" sz="800" dirty="0">
                 <a:solidFill>
                   <a:srgbClr val="2E3A46"/>
                 </a:solidFill>
@@ -4268,16 +4080,19 @@
                 <a:ea typeface="Calibri" pitchFamily="34" charset="-122"/>
                 <a:cs typeface="Calibri" pitchFamily="34" charset="-120"/>
               </a:rPr>
-              <a:t>Agents: </a:t>
-            </a:r>
-            <a:pPr indent="0" marL="0">
+              <a:t> </a:t>
+            </a:r>
+            <a:endParaRPr lang="en-US" sz="1800" dirty="0"/>
+          </a:p>
+          <a:p>
+            <a:pPr marL="0" indent="0">
               <a:spcAft>
                 <a:spcPts val="600"/>
               </a:spcAft>
               <a:buNone/>
             </a:pPr>
             <a:r>
-              <a:rPr lang="en-US" sz="1800" dirty="0">
+              <a:rPr lang="en-US" sz="1800" b="1" dirty="0">
                 <a:solidFill>
                   <a:srgbClr val="2E3A46"/>
                 </a:solidFill>
@@ -4285,54 +4100,8 @@
                 <a:ea typeface="Calibri" pitchFamily="34" charset="-122"/>
                 <a:cs typeface="Calibri" pitchFamily="34" charset="-120"/>
               </a:rPr>
-              <a:t>each firm is an open LLM. Each round it sees the rules, its last 30 rounds and its notes, and answers with a price and new notes. The prompt never mentions collusion.</a:t>
-            </a:r>
-            <a:endParaRPr lang="en-US" sz="1800" dirty="0"/>
-          </a:p>
-          <a:p>
-            <a:pPr indent="0" marL="0">
-              <a:spcAft>
-                <a:spcPts val="600"/>
-              </a:spcAft>
-              <a:buNone/>
-            </a:pPr>
-            <a:r>
-              <a:rPr lang="en-US" sz="800" dirty="0">
-                <a:solidFill>
-                  <a:srgbClr val="2E3A46"/>
-                </a:solidFill>
-                <a:latin typeface="Calibri" pitchFamily="34" charset="0"/>
-                <a:ea typeface="Calibri" pitchFamily="34" charset="-122"/>
-                <a:cs typeface="Calibri" pitchFamily="34" charset="-120"/>
-              </a:rPr>
-              <a:t> </a:t>
-            </a:r>
-            <a:endParaRPr lang="en-US" sz="1800" dirty="0"/>
-          </a:p>
-          <a:p>
-            <a:pPr indent="0" marL="0">
-              <a:spcAft>
-                <a:spcPts val="600"/>
-              </a:spcAft>
-              <a:buNone/>
-            </a:pPr>
-            <a:r>
-              <a:rPr lang="en-US" sz="1800" b="1" dirty="0">
-                <a:solidFill>
-                  <a:srgbClr val="2E3A46"/>
-                </a:solidFill>
-                <a:latin typeface="Calibri" pitchFamily="34" charset="0"/>
-                <a:ea typeface="Calibri" pitchFamily="34" charset="-122"/>
-                <a:cs typeface="Calibri" pitchFamily="34" charset="-120"/>
-              </a:rPr>
               <a:t>Models: </a:t>
             </a:r>
-            <a:pPr indent="0" marL="0">
-              <a:spcAft>
-                <a:spcPts val="600"/>
-              </a:spcAft>
-              <a:buNone/>
-            </a:pPr>
             <a:r>
               <a:rPr lang="en-US" sz="1800" dirty="0">
                 <a:solidFill>
@@ -4396,7 +4165,7 @@
           <a:bodyPr wrap="square" lIns="0" tIns="0" rIns="0" bIns="0" rtlCol="0" anchor="t"/>
           <a:lstStyle/>
           <a:p>
-            <a:pPr indent="0" marL="0">
+            <a:pPr marL="0" indent="0">
               <a:buNone/>
             </a:pPr>
             <a:r>
@@ -4510,7 +4279,7 @@
           <a:bodyPr wrap="square" lIns="0" tIns="0" rIns="0" bIns="0" rtlCol="0" anchor="t"/>
           <a:lstStyle/>
           <a:p>
-            <a:pPr indent="0" marL="0">
+            <a:pPr marL="0" indent="0">
               <a:buNone/>
             </a:pPr>
             <a:r>
@@ -4527,7 +4296,7 @@
             <a:endParaRPr lang="en-US" sz="1400" dirty="0"/>
           </a:p>
           <a:p>
-            <a:pPr indent="0" marL="0">
+            <a:pPr marL="0" indent="0">
               <a:buNone/>
             </a:pPr>
             <a:r>
@@ -4566,7 +4335,7 @@
           <a:bodyPr wrap="square" lIns="0" tIns="0" rIns="0" bIns="0" rtlCol="0" anchor="t"/>
           <a:lstStyle/>
           <a:p>
-            <a:pPr algn="r" indent="0" marL="0">
+            <a:pPr marL="0" indent="0" algn="r">
               <a:buNone/>
             </a:pPr>
             <a:r>
@@ -4583,7 +4352,7 @@
             <a:endParaRPr lang="en-US" sz="1400" dirty="0"/>
           </a:p>
           <a:p>
-            <a:pPr algn="r" indent="0" marL="0">
+            <a:pPr marL="0" indent="0" algn="r">
               <a:buNone/>
             </a:pPr>
             <a:r>
@@ -4622,7 +4391,7 @@
           <a:bodyPr wrap="square" lIns="0" tIns="0" rIns="0" bIns="0" rtlCol="0" anchor="t"/>
           <a:lstStyle/>
           <a:p>
-            <a:pPr indent="0" marL="0">
+            <a:pPr marL="0" indent="0">
               <a:buNone/>
             </a:pPr>
             <a:r>
@@ -4660,7 +4429,7 @@
           </a:prstGeom>
           <a:extLst>
             <a:ext uri="{C572A759-6A51-4108-AA02-DFA0A04FC94B}">
-              <ma14:wrappingTextBoxFlag xmlns:ma14="http://schemas.microsoft.com/office/mac/drawingml/2011/main" val="0"/>
+              <ma14:wrappingTextBoxFlag xmlns:ma14="http://schemas.microsoft.com/office/mac/drawingml/2011/main" xmlns="" val="0"/>
             </a:ext>
           </a:extLst>
         </p:spPr>
@@ -4681,7 +4450,7 @@
           <a:p>
             <a:pPr algn="l"/>
             <a:fld id="{F7021451-1387-4CA6-816F-3879F97B5CBC}" type="slidenum">
-              <a:rPr b="0" lang="en-US"/>
+              <a:rPr lang="en-US" b="0"/>
               <a:t>3</a:t>
             </a:fld>
             <a:endParaRPr lang="en-US"/>
@@ -4716,9 +4485,11 @@
       <p:sp>
         <p:nvSpPr>
           <p:cNvPr id="2" name="Text 1"/>
-          <p:cNvSpPr/>
+          <p:cNvSpPr>
+            <a:spLocks noGrp="1"/>
+          </p:cNvSpPr>
           <p:nvPr>
-            <p:ph idx="101" type="title" hasCustomPrompt="1"/>
+            <p:ph type="title" idx="101" hasCustomPrompt="1"/>
           </p:nvPr>
         </p:nvSpPr>
         <p:spPr>
@@ -4736,7 +4507,7 @@
           <a:bodyPr wrap="square" rtlCol="0" anchor="ctr"/>
           <a:lstStyle/>
           <a:p>
-            <a:pPr algn="l" indent="0" marL="0">
+            <a:pPr marL="0" indent="0" algn="l">
               <a:buNone/>
             </a:pPr>
             <a:r>
@@ -4827,7 +4598,7 @@
           <a:bodyPr wrap="square" lIns="0" tIns="0" rIns="0" bIns="0" rtlCol="0" anchor="ctr"/>
           <a:lstStyle/>
           <a:p>
-            <a:pPr algn="ctr" indent="0" marL="0">
+            <a:pPr marL="0" indent="0" algn="ctr">
               <a:buNone/>
             </a:pPr>
             <a:r>
@@ -4866,7 +4637,7 @@
           <a:bodyPr wrap="square" lIns="0" tIns="0" rIns="0" bIns="0" rtlCol="0" anchor="t"/>
           <a:lstStyle/>
           <a:p>
-            <a:pPr indent="0" marL="0">
+            <a:pPr marL="0" indent="0">
               <a:buNone/>
             </a:pPr>
             <a:r>
@@ -4905,7 +4676,7 @@
           <a:bodyPr wrap="square" lIns="0" tIns="0" rIns="0" bIns="0" rtlCol="0" anchor="t"/>
           <a:lstStyle/>
           <a:p>
-            <a:pPr indent="0" marL="0">
+            <a:pPr marL="0" indent="0">
               <a:buNone/>
             </a:pPr>
             <a:r>
@@ -4996,7 +4767,7 @@
           <a:bodyPr wrap="square" lIns="0" tIns="0" rIns="0" bIns="0" rtlCol="0" anchor="ctr"/>
           <a:lstStyle/>
           <a:p>
-            <a:pPr algn="ctr" indent="0" marL="0">
+            <a:pPr marL="0" indent="0" algn="ctr">
               <a:buNone/>
             </a:pPr>
             <a:r>
@@ -5035,7 +4806,7 @@
           <a:bodyPr wrap="square" lIns="0" tIns="0" rIns="0" bIns="0" rtlCol="0" anchor="t"/>
           <a:lstStyle/>
           <a:p>
-            <a:pPr indent="0" marL="0">
+            <a:pPr marL="0" indent="0">
               <a:buNone/>
             </a:pPr>
             <a:r>
@@ -5074,7 +4845,7 @@
           <a:bodyPr wrap="square" lIns="0" tIns="0" rIns="0" bIns="0" rtlCol="0" anchor="t"/>
           <a:lstStyle/>
           <a:p>
-            <a:pPr indent="0" marL="0">
+            <a:pPr marL="0" indent="0">
               <a:buNone/>
             </a:pPr>
             <a:r>
@@ -5165,7 +4936,7 @@
           <a:bodyPr wrap="square" lIns="0" tIns="0" rIns="0" bIns="0" rtlCol="0" anchor="ctr"/>
           <a:lstStyle/>
           <a:p>
-            <a:pPr algn="ctr" indent="0" marL="0">
+            <a:pPr marL="0" indent="0" algn="ctr">
               <a:buNone/>
             </a:pPr>
             <a:r>
@@ -5204,7 +4975,7 @@
           <a:bodyPr wrap="square" lIns="0" tIns="0" rIns="0" bIns="0" rtlCol="0" anchor="t"/>
           <a:lstStyle/>
           <a:p>
-            <a:pPr indent="0" marL="0">
+            <a:pPr marL="0" indent="0">
               <a:buNone/>
             </a:pPr>
             <a:r>
@@ -5243,7 +5014,7 @@
           <a:bodyPr wrap="square" lIns="0" tIns="0" rIns="0" bIns="0" rtlCol="0" anchor="t"/>
           <a:lstStyle/>
           <a:p>
-            <a:pPr indent="0" marL="0">
+            <a:pPr marL="0" indent="0">
               <a:buNone/>
             </a:pPr>
             <a:r>
@@ -5334,7 +5105,7 @@
           <a:bodyPr wrap="square" lIns="0" tIns="0" rIns="0" bIns="0" rtlCol="0" anchor="ctr"/>
           <a:lstStyle/>
           <a:p>
-            <a:pPr algn="ctr" indent="0" marL="0">
+            <a:pPr marL="0" indent="0" algn="ctr">
               <a:buNone/>
             </a:pPr>
             <a:r>
@@ -5373,7 +5144,7 @@
           <a:bodyPr wrap="square" lIns="0" tIns="0" rIns="0" bIns="0" rtlCol="0" anchor="t"/>
           <a:lstStyle/>
           <a:p>
-            <a:pPr indent="0" marL="0">
+            <a:pPr marL="0" indent="0">
               <a:buNone/>
             </a:pPr>
             <a:r>
@@ -5412,7 +5183,7 @@
           <a:bodyPr wrap="square" lIns="0" tIns="0" rIns="0" bIns="0" rtlCol="0" anchor="t"/>
           <a:lstStyle/>
           <a:p>
-            <a:pPr indent="0" marL="0">
+            <a:pPr marL="0" indent="0">
               <a:buNone/>
             </a:pPr>
             <a:r>
@@ -5478,7 +5249,7 @@
           <a:bodyPr wrap="square" lIns="0" tIns="0" rIns="0" bIns="0" rtlCol="0" anchor="t"/>
           <a:lstStyle/>
           <a:p>
-            <a:pPr indent="0" marL="0">
+            <a:pPr marL="0" indent="0">
               <a:buNone/>
             </a:pPr>
             <a:r>
@@ -5517,7 +5288,7 @@
           <a:bodyPr wrap="square" lIns="0" tIns="0" rIns="0" bIns="0" rtlCol="0" anchor="t"/>
           <a:lstStyle/>
           <a:p>
-            <a:pPr indent="0" marL="0">
+            <a:pPr marL="0" indent="0">
               <a:buNone/>
             </a:pPr>
             <a:r>
@@ -5583,7 +5354,7 @@
           <a:bodyPr wrap="square" lIns="0" tIns="0" rIns="0" bIns="0" rtlCol="0" anchor="t"/>
           <a:lstStyle/>
           <a:p>
-            <a:pPr indent="0" marL="0">
+            <a:pPr marL="0" indent="0">
               <a:buNone/>
             </a:pPr>
             <a:r>
@@ -5622,7 +5393,7 @@
           <a:bodyPr wrap="square" lIns="0" tIns="0" rIns="0" bIns="0" rtlCol="0" anchor="t"/>
           <a:lstStyle/>
           <a:p>
-            <a:pPr indent="0" marL="0">
+            <a:pPr marL="0" indent="0">
               <a:buNone/>
             </a:pPr>
             <a:r>
@@ -5688,7 +5459,7 @@
           <a:bodyPr wrap="square" lIns="0" tIns="0" rIns="0" bIns="0" rtlCol="0" anchor="t"/>
           <a:lstStyle/>
           <a:p>
-            <a:pPr indent="0" marL="0">
+            <a:pPr marL="0" indent="0">
               <a:buNone/>
             </a:pPr>
             <a:r>
@@ -5727,7 +5498,7 @@
           <a:bodyPr wrap="square" lIns="0" tIns="0" rIns="0" bIns="0" rtlCol="0" anchor="t"/>
           <a:lstStyle/>
           <a:p>
-            <a:pPr indent="0" marL="0">
+            <a:pPr marL="0" indent="0">
               <a:buNone/>
             </a:pPr>
             <a:r>
@@ -5793,7 +5564,7 @@
           <a:bodyPr wrap="square" lIns="0" tIns="0" rIns="0" bIns="0" rtlCol="0" anchor="t"/>
           <a:lstStyle/>
           <a:p>
-            <a:pPr indent="0" marL="0">
+            <a:pPr marL="0" indent="0">
               <a:buNone/>
             </a:pPr>
             <a:r>
@@ -5832,7 +5603,7 @@
           <a:bodyPr wrap="square" lIns="0" tIns="0" rIns="0" bIns="0" rtlCol="0" anchor="t"/>
           <a:lstStyle/>
           <a:p>
-            <a:pPr indent="0" marL="0">
+            <a:pPr marL="0" indent="0">
               <a:buNone/>
             </a:pPr>
             <a:r>
@@ -5898,7 +5669,7 @@
           <a:bodyPr wrap="square" lIns="0" tIns="0" rIns="0" bIns="0" rtlCol="0" anchor="t"/>
           <a:lstStyle/>
           <a:p>
-            <a:pPr indent="0" marL="0">
+            <a:pPr marL="0" indent="0">
               <a:buNone/>
             </a:pPr>
             <a:r>
@@ -5937,7 +5708,7 @@
           <a:bodyPr wrap="square" lIns="0" tIns="0" rIns="0" bIns="0" rtlCol="0" anchor="t"/>
           <a:lstStyle/>
           <a:p>
-            <a:pPr indent="0" marL="0">
+            <a:pPr marL="0" indent="0">
               <a:buNone/>
             </a:pPr>
             <a:r>
@@ -6003,7 +5774,7 @@
           <a:bodyPr wrap="square" lIns="0" tIns="0" rIns="0" bIns="0" rtlCol="0" anchor="t"/>
           <a:lstStyle/>
           <a:p>
-            <a:pPr indent="0" marL="0">
+            <a:pPr marL="0" indent="0">
               <a:buNone/>
             </a:pPr>
             <a:r>
@@ -6042,7 +5813,7 @@
           <a:bodyPr wrap="square" lIns="0" tIns="0" rIns="0" bIns="0" rtlCol="0" anchor="t"/>
           <a:lstStyle/>
           <a:p>
-            <a:pPr indent="0" marL="0">
+            <a:pPr marL="0" indent="0">
               <a:buNone/>
             </a:pPr>
             <a:r>
@@ -6108,7 +5879,7 @@
           <a:bodyPr wrap="square" lIns="0" tIns="0" rIns="0" bIns="0" rtlCol="0" anchor="t"/>
           <a:lstStyle/>
           <a:p>
-            <a:pPr indent="0" marL="0">
+            <a:pPr marL="0" indent="0">
               <a:buNone/>
             </a:pPr>
             <a:r>
@@ -6147,7 +5918,7 @@
           <a:bodyPr wrap="square" lIns="0" tIns="0" rIns="0" bIns="0" rtlCol="0" anchor="t"/>
           <a:lstStyle/>
           <a:p>
-            <a:pPr indent="0" marL="0">
+            <a:pPr marL="0" indent="0">
               <a:buNone/>
             </a:pPr>
             <a:r>
@@ -6213,7 +5984,7 @@
           <a:bodyPr wrap="square" lIns="0" tIns="0" rIns="0" bIns="0" rtlCol="0" anchor="t"/>
           <a:lstStyle/>
           <a:p>
-            <a:pPr indent="0" marL="0">
+            <a:pPr marL="0" indent="0">
               <a:buNone/>
             </a:pPr>
             <a:r>
@@ -6252,7 +6023,7 @@
           <a:bodyPr wrap="square" lIns="0" tIns="0" rIns="0" bIns="0" rtlCol="0" anchor="t"/>
           <a:lstStyle/>
           <a:p>
-            <a:pPr indent="0" marL="0">
+            <a:pPr marL="0" indent="0">
               <a:buNone/>
             </a:pPr>
             <a:r>
@@ -6272,7 +6043,7 @@
       </p:sp>
       <p:sp>
         <p:nvSpPr>
-          <p:cNvPr id="25" name="Slide Number Placeholder 0"/>
+          <p:cNvPr id="47" name="Slide Number Placeholder 0"/>
           <p:cNvSpPr>
             <a:spLocks noGrp="1"/>
           </p:cNvSpPr>
@@ -6290,7 +6061,7 @@
           </a:prstGeom>
           <a:extLst>
             <a:ext uri="{C572A759-6A51-4108-AA02-DFA0A04FC94B}">
-              <ma14:wrappingTextBoxFlag xmlns:ma14="http://schemas.microsoft.com/office/mac/drawingml/2011/main" val="0"/>
+              <ma14:wrappingTextBoxFlag xmlns:ma14="http://schemas.microsoft.com/office/mac/drawingml/2011/main" xmlns="" val="0"/>
             </a:ext>
           </a:extLst>
         </p:spPr>
@@ -6311,7 +6082,7 @@
           <a:p>
             <a:pPr algn="l"/>
             <a:fld id="{F7021451-1387-4CA6-816F-3879F97B5CBC}" type="slidenum">
-              <a:rPr b="0" lang="en-US"/>
+              <a:rPr lang="en-US" b="0"/>
               <a:t>4</a:t>
             </a:fld>
             <a:endParaRPr lang="en-US"/>
@@ -6346,9 +6117,11 @@
       <p:sp>
         <p:nvSpPr>
           <p:cNvPr id="2" name="Text 1"/>
-          <p:cNvSpPr/>
+          <p:cNvSpPr>
+            <a:spLocks noGrp="1"/>
+          </p:cNvSpPr>
           <p:nvPr>
-            <p:ph idx="101" type="title" hasCustomPrompt="1"/>
+            <p:ph type="title" idx="101" hasCustomPrompt="1"/>
           </p:nvPr>
         </p:nvSpPr>
         <p:spPr>
@@ -6366,7 +6139,7 @@
           <a:bodyPr wrap="square" rtlCol="0" anchor="ctr"/>
           <a:lstStyle/>
           <a:p>
-            <a:pPr algn="l" indent="0" marL="0">
+            <a:pPr marL="0" indent="0" algn="l">
               <a:buNone/>
             </a:pPr>
             <a:r>
@@ -6386,7 +6159,7 @@
       </p:sp>
       <p:graphicFrame>
         <p:nvGraphicFramePr>
-          <p:cNvPr id="3" name="Chart 0" descr=""/>
+          <p:cNvPr id="3" name="Chart 0"/>
           <p:cNvGraphicFramePr/>
           <p:nvPr/>
         </p:nvGraphicFramePr>
@@ -6394,9 +6167,9 @@
           <a:off x="548640" y="1325880"/>
           <a:ext cx="6949440" cy="4846320"/>
         </p:xfrm>
-        <a:graphic xmlns:a="http://schemas.openxmlformats.org/drawingml/2006/main">
+        <a:graphic>
           <a:graphicData uri="http://schemas.openxmlformats.org/drawingml/2006/chart">
-            <c:chart xmlns:c="http://schemas.openxmlformats.org/drawingml/2006/chart" r:id="rId1"/>
+            <c:chart xmlns:c="http://schemas.openxmlformats.org/drawingml/2006/chart" xmlns:r="http://schemas.openxmlformats.org/officeDocument/2006/relationships" r:id="rId3"/>
           </a:graphicData>
         </a:graphic>
       </p:graphicFrame>
@@ -6448,7 +6221,7 @@
           <a:bodyPr wrap="square" lIns="0" tIns="0" rIns="0" bIns="0" rtlCol="0" anchor="t"/>
           <a:lstStyle/>
           <a:p>
-            <a:pPr indent="0" marL="0">
+            <a:pPr marL="0" indent="0">
               <a:buNone/>
             </a:pPr>
             <a:r>
@@ -6487,7 +6260,7 @@
           <a:bodyPr wrap="square" lIns="0" tIns="0" rIns="0" bIns="0" rtlCol="0" anchor="t"/>
           <a:lstStyle/>
           <a:p>
-            <a:pPr indent="0" marL="0">
+            <a:pPr marL="0" indent="0">
               <a:buNone/>
             </a:pPr>
             <a:r>
@@ -6553,7 +6326,7 @@
           <a:bodyPr wrap="square" lIns="0" tIns="0" rIns="0" bIns="0" rtlCol="0" anchor="t"/>
           <a:lstStyle/>
           <a:p>
-            <a:pPr indent="0" marL="0">
+            <a:pPr marL="0" indent="0">
               <a:buNone/>
             </a:pPr>
             <a:r>
@@ -6592,7 +6365,7 @@
           <a:bodyPr wrap="square" lIns="0" tIns="0" rIns="0" bIns="0" rtlCol="0" anchor="t"/>
           <a:lstStyle/>
           <a:p>
-            <a:pPr indent="0" marL="0">
+            <a:pPr marL="0" indent="0">
               <a:buNone/>
             </a:pPr>
             <a:r>
@@ -6630,7 +6403,7 @@
           </a:prstGeom>
           <a:extLst>
             <a:ext uri="{C572A759-6A51-4108-AA02-DFA0A04FC94B}">
-              <ma14:wrappingTextBoxFlag xmlns:ma14="http://schemas.microsoft.com/office/mac/drawingml/2011/main" val="0"/>
+              <ma14:wrappingTextBoxFlag xmlns:ma14="http://schemas.microsoft.com/office/mac/drawingml/2011/main" xmlns="" val="0"/>
             </a:ext>
           </a:extLst>
         </p:spPr>
@@ -6651,7 +6424,7 @@
           <a:p>
             <a:pPr algn="l"/>
             <a:fld id="{F7021451-1387-4CA6-816F-3879F97B5CBC}" type="slidenum">
-              <a:rPr b="0" lang="en-US"/>
+              <a:rPr lang="en-US" b="0"/>
               <a:t>5</a:t>
             </a:fld>
             <a:endParaRPr lang="en-US"/>
@@ -6686,9 +6459,11 @@
       <p:sp>
         <p:nvSpPr>
           <p:cNvPr id="2" name="Text 1"/>
-          <p:cNvSpPr/>
+          <p:cNvSpPr>
+            <a:spLocks noGrp="1"/>
+          </p:cNvSpPr>
           <p:nvPr>
-            <p:ph idx="101" type="title" hasCustomPrompt="1"/>
+            <p:ph type="title" idx="101" hasCustomPrompt="1"/>
           </p:nvPr>
         </p:nvSpPr>
         <p:spPr>
@@ -6706,7 +6481,7 @@
           <a:bodyPr wrap="square" rtlCol="0" anchor="ctr"/>
           <a:lstStyle/>
           <a:p>
-            <a:pPr algn="l" indent="0" marL="0">
+            <a:pPr marL="0" indent="0" algn="l">
               <a:buNone/>
             </a:pPr>
             <a:r>
@@ -6726,14 +6501,14 @@
       </p:sp>
       <p:pic>
         <p:nvPicPr>
-          <p:cNvPr id="3" name="Image 0" descr="/home/user/AI-Collusion-Research-Sprint/Apart Research/figures/fig_trajectories.png">    </p:cNvPr>
+          <p:cNvPr id="3" name="Image 0" descr="/home/user/AI-Collusion-Research-Sprint/Apart Research/figures/fig_trajectories.png"/>
           <p:cNvPicPr>
             <a:picLocks noChangeAspect="1"/>
           </p:cNvPicPr>
           <p:nvPr/>
         </p:nvPicPr>
         <p:blipFill>
-          <a:blip r:embed="rId1"/>
+          <a:blip r:embed="rId3"/>
           <a:stretch>
             <a:fillRect/>
           </a:stretch>
@@ -6769,7 +6544,7 @@
           <a:bodyPr wrap="square" lIns="0" tIns="0" rIns="0" bIns="0" rtlCol="0" anchor="t"/>
           <a:lstStyle/>
           <a:p>
-            <a:pPr indent="0" marL="0">
+            <a:pPr marL="0" indent="0">
               <a:buNone/>
             </a:pPr>
             <a:r>
@@ -6835,7 +6610,7 @@
           <a:bodyPr wrap="square" lIns="0" tIns="0" rIns="0" bIns="0" rtlCol="0" anchor="t"/>
           <a:lstStyle/>
           <a:p>
-            <a:pPr indent="0" marL="0">
+            <a:pPr marL="0" indent="0">
               <a:buNone/>
             </a:pPr>
             <a:r>
@@ -6874,7 +6649,7 @@
           <a:bodyPr wrap="square" lIns="0" tIns="0" rIns="0" bIns="0" rtlCol="0" anchor="t"/>
           <a:lstStyle/>
           <a:p>
-            <a:pPr indent="0" marL="0">
+            <a:pPr marL="0" indent="0">
               <a:buNone/>
             </a:pPr>
             <a:r>
@@ -6913,7 +6688,7 @@
           <a:bodyPr wrap="square" lIns="0" tIns="0" rIns="0" bIns="0" rtlCol="0" anchor="t"/>
           <a:lstStyle/>
           <a:p>
-            <a:pPr indent="0" marL="0">
+            <a:pPr marL="0" indent="0">
               <a:buNone/>
             </a:pPr>
             <a:r>
@@ -6952,7 +6727,7 @@
           <a:bodyPr wrap="square" lIns="0" tIns="0" rIns="0" bIns="0" rtlCol="0" anchor="t"/>
           <a:lstStyle/>
           <a:p>
-            <a:pPr indent="0" marL="0">
+            <a:pPr marL="0" indent="0">
               <a:buNone/>
             </a:pPr>
             <a:r>
@@ -6990,7 +6765,7 @@
           </a:prstGeom>
           <a:extLst>
             <a:ext uri="{C572A759-6A51-4108-AA02-DFA0A04FC94B}">
-              <ma14:wrappingTextBoxFlag xmlns:ma14="http://schemas.microsoft.com/office/mac/drawingml/2011/main" val="0"/>
+              <ma14:wrappingTextBoxFlag xmlns:ma14="http://schemas.microsoft.com/office/mac/drawingml/2011/main" xmlns="" val="0"/>
             </a:ext>
           </a:extLst>
         </p:spPr>
@@ -7011,7 +6786,7 @@
           <a:p>
             <a:pPr algn="l"/>
             <a:fld id="{F7021451-1387-4CA6-816F-3879F97B5CBC}" type="slidenum">
-              <a:rPr b="0" lang="en-US"/>
+              <a:rPr lang="en-US" b="0"/>
               <a:t>6</a:t>
             </a:fld>
             <a:endParaRPr lang="en-US"/>
@@ -7046,9 +6821,11 @@
       <p:sp>
         <p:nvSpPr>
           <p:cNvPr id="2" name="Text 1"/>
-          <p:cNvSpPr/>
+          <p:cNvSpPr>
+            <a:spLocks noGrp="1"/>
+          </p:cNvSpPr>
           <p:nvPr>
-            <p:ph idx="101" type="title" hasCustomPrompt="1"/>
+            <p:ph type="title" idx="101" hasCustomPrompt="1"/>
           </p:nvPr>
         </p:nvSpPr>
         <p:spPr>
@@ -7066,7 +6843,7 @@
           <a:bodyPr wrap="square" rtlCol="0" anchor="ctr"/>
           <a:lstStyle/>
           <a:p>
-            <a:pPr algn="l" indent="0" marL="0">
+            <a:pPr marL="0" indent="0" algn="l">
               <a:buNone/>
             </a:pPr>
             <a:r>
@@ -7132,7 +6909,7 @@
           <a:bodyPr wrap="square" lIns="0" tIns="0" rIns="0" bIns="0" rtlCol="0" anchor="t"/>
           <a:lstStyle/>
           <a:p>
-            <a:pPr indent="0" marL="0">
+            <a:pPr marL="0" indent="0">
               <a:buNone/>
             </a:pPr>
             <a:r>
@@ -7171,7 +6948,7 @@
           <a:bodyPr wrap="square" lIns="0" tIns="0" rIns="0" bIns="0" rtlCol="0" anchor="t"/>
           <a:lstStyle/>
           <a:p>
-            <a:pPr indent="0" marL="0">
+            <a:pPr marL="0" indent="0">
               <a:buNone/>
             </a:pPr>
             <a:r>
@@ -7210,7 +6987,7 @@
           <a:bodyPr wrap="square" lIns="0" tIns="0" rIns="0" bIns="0" rtlCol="0" anchor="t"/>
           <a:lstStyle/>
           <a:p>
-            <a:pPr indent="0" marL="0">
+            <a:pPr marL="0" indent="0">
               <a:buNone/>
             </a:pPr>
             <a:r>
@@ -7249,7 +7026,7 @@
           <a:bodyPr wrap="square" lIns="0" tIns="0" rIns="0" bIns="0" rtlCol="0" anchor="t"/>
           <a:lstStyle/>
           <a:p>
-            <a:pPr indent="0" marL="0">
+            <a:pPr marL="0" indent="0">
               <a:buNone/>
             </a:pPr>
             <a:r>
@@ -7315,7 +7092,7 @@
           <a:bodyPr wrap="square" lIns="0" tIns="0" rIns="0" bIns="0" rtlCol="0" anchor="t"/>
           <a:lstStyle/>
           <a:p>
-            <a:pPr indent="0" marL="0">
+            <a:pPr marL="0" indent="0">
               <a:buNone/>
             </a:pPr>
             <a:r>
@@ -7354,7 +7131,7 @@
           <a:bodyPr wrap="square" lIns="0" tIns="0" rIns="0" bIns="0" rtlCol="0" anchor="t"/>
           <a:lstStyle/>
           <a:p>
-            <a:pPr indent="0" marL="0">
+            <a:pPr marL="0" indent="0">
               <a:buNone/>
             </a:pPr>
             <a:r>
@@ -7393,7 +7170,7 @@
           <a:bodyPr wrap="square" lIns="0" tIns="0" rIns="0" bIns="0" rtlCol="0" anchor="t"/>
           <a:lstStyle/>
           <a:p>
-            <a:pPr indent="0" marL="0">
+            <a:pPr marL="0" indent="0">
               <a:buNone/>
             </a:pPr>
             <a:r>
@@ -7432,7 +7209,7 @@
           <a:bodyPr wrap="square" lIns="0" tIns="0" rIns="0" bIns="0" rtlCol="0" anchor="t"/>
           <a:lstStyle/>
           <a:p>
-            <a:pPr indent="0" marL="0">
+            <a:pPr marL="0" indent="0">
               <a:buNone/>
             </a:pPr>
             <a:r>
@@ -7471,7 +7248,7 @@
           <a:bodyPr wrap="square" lIns="0" tIns="0" rIns="0" bIns="0" rtlCol="0" anchor="t"/>
           <a:lstStyle/>
           <a:p>
-            <a:pPr indent="0" marL="0">
+            <a:pPr marL="0" indent="0">
               <a:buNone/>
             </a:pPr>
             <a:r>
@@ -7509,7 +7286,7 @@
           </a:prstGeom>
           <a:extLst>
             <a:ext uri="{C572A759-6A51-4108-AA02-DFA0A04FC94B}">
-              <ma14:wrappingTextBoxFlag xmlns:ma14="http://schemas.microsoft.com/office/mac/drawingml/2011/main" val="0"/>
+              <ma14:wrappingTextBoxFlag xmlns:ma14="http://schemas.microsoft.com/office/mac/drawingml/2011/main" xmlns="" val="0"/>
             </a:ext>
           </a:extLst>
         </p:spPr>
@@ -7530,7 +7307,7 @@
           <a:p>
             <a:pPr algn="l"/>
             <a:fld id="{F7021451-1387-4CA6-816F-3879F97B5CBC}" type="slidenum">
-              <a:rPr b="0" lang="en-US"/>
+              <a:rPr lang="en-US" b="0"/>
               <a:t>7</a:t>
             </a:fld>
             <a:endParaRPr lang="en-US"/>
@@ -7565,9 +7342,11 @@
       <p:sp>
         <p:nvSpPr>
           <p:cNvPr id="2" name="Text 1"/>
-          <p:cNvSpPr/>
+          <p:cNvSpPr>
+            <a:spLocks noGrp="1"/>
+          </p:cNvSpPr>
           <p:nvPr>
-            <p:ph idx="101" type="title" hasCustomPrompt="1"/>
+            <p:ph type="title" idx="101" hasCustomPrompt="1"/>
           </p:nvPr>
         </p:nvSpPr>
         <p:spPr>
@@ -7585,7 +7364,7 @@
           <a:bodyPr wrap="square" rtlCol="0" anchor="ctr"/>
           <a:lstStyle/>
           <a:p>
-            <a:pPr algn="l" indent="0" marL="0">
+            <a:pPr marL="0" indent="0" algn="l">
               <a:buNone/>
             </a:pPr>
             <a:r>
@@ -7676,7 +7455,7 @@
           <a:bodyPr wrap="square" lIns="0" tIns="0" rIns="0" bIns="0" rtlCol="0" anchor="ctr"/>
           <a:lstStyle/>
           <a:p>
-            <a:pPr algn="ctr" indent="0" marL="0">
+            <a:pPr marL="0" indent="0" algn="ctr">
               <a:buNone/>
             </a:pPr>
             <a:r>
@@ -7715,7 +7494,7 @@
           <a:bodyPr wrap="square" lIns="0" tIns="0" rIns="0" bIns="0" rtlCol="0" anchor="t"/>
           <a:lstStyle/>
           <a:p>
-            <a:pPr indent="0" marL="0">
+            <a:pPr marL="0" indent="0">
               <a:buNone/>
             </a:pPr>
             <a:r>
@@ -7754,7 +7533,7 @@
           <a:bodyPr wrap="square" lIns="0" tIns="0" rIns="0" bIns="0" rtlCol="0" anchor="t"/>
           <a:lstStyle/>
           <a:p>
-            <a:pPr indent="0" marL="0">
+            <a:pPr marL="0" indent="0">
               <a:buNone/>
             </a:pPr>
             <a:r>
@@ -7845,7 +7624,7 @@
           <a:bodyPr wrap="square" lIns="0" tIns="0" rIns="0" bIns="0" rtlCol="0" anchor="ctr"/>
           <a:lstStyle/>
           <a:p>
-            <a:pPr algn="ctr" indent="0" marL="0">
+            <a:pPr marL="0" indent="0" algn="ctr">
               <a:buNone/>
             </a:pPr>
             <a:r>
@@ -7884,7 +7663,7 @@
           <a:bodyPr wrap="square" lIns="0" tIns="0" rIns="0" bIns="0" rtlCol="0" anchor="t"/>
           <a:lstStyle/>
           <a:p>
-            <a:pPr indent="0" marL="0">
+            <a:pPr marL="0" indent="0">
               <a:buNone/>
             </a:pPr>
             <a:r>
@@ -7923,7 +7702,7 @@
           <a:bodyPr wrap="square" lIns="0" tIns="0" rIns="0" bIns="0" rtlCol="0" anchor="t"/>
           <a:lstStyle/>
           <a:p>
-            <a:pPr indent="0" marL="0">
+            <a:pPr marL="0" indent="0">
               <a:buNone/>
             </a:pPr>
             <a:r>
@@ -8014,7 +7793,7 @@
           <a:bodyPr wrap="square" lIns="0" tIns="0" rIns="0" bIns="0" rtlCol="0" anchor="ctr"/>
           <a:lstStyle/>
           <a:p>
-            <a:pPr algn="ctr" indent="0" marL="0">
+            <a:pPr marL="0" indent="0" algn="ctr">
               <a:buNone/>
             </a:pPr>
             <a:r>
@@ -8053,7 +7832,7 @@
           <a:bodyPr wrap="square" lIns="0" tIns="0" rIns="0" bIns="0" rtlCol="0" anchor="t"/>
           <a:lstStyle/>
           <a:p>
-            <a:pPr indent="0" marL="0">
+            <a:pPr marL="0" indent="0">
               <a:buNone/>
             </a:pPr>
             <a:r>
@@ -8092,7 +7871,7 @@
           <a:bodyPr wrap="square" lIns="0" tIns="0" rIns="0" bIns="0" rtlCol="0" anchor="t"/>
           <a:lstStyle/>
           <a:p>
-            <a:pPr indent="0" marL="0">
+            <a:pPr marL="0" indent="0">
               <a:buNone/>
             </a:pPr>
             <a:r>
@@ -8158,7 +7937,7 @@
           <a:bodyPr wrap="square" lIns="0" tIns="0" rIns="0" bIns="0" rtlCol="0" anchor="t"/>
           <a:lstStyle/>
           <a:p>
-            <a:pPr indent="0" marL="0">
+            <a:pPr marL="0" indent="0">
               <a:buNone/>
             </a:pPr>
             <a:r>
@@ -8197,7 +7976,7 @@
           <a:bodyPr wrap="square" lIns="0" tIns="0" rIns="0" bIns="0" rtlCol="0" anchor="t"/>
           <a:lstStyle/>
           <a:p>
-            <a:pPr indent="0" marL="0">
+            <a:pPr marL="0" indent="0">
               <a:buNone/>
             </a:pPr>
             <a:r>
@@ -8236,7 +8015,7 @@
           <a:bodyPr wrap="square" lIns="0" tIns="0" rIns="0" bIns="0" rtlCol="0" anchor="t"/>
           <a:lstStyle/>
           <a:p>
-            <a:pPr indent="0" marL="0">
+            <a:pPr marL="0" indent="0">
               <a:buNone/>
             </a:pPr>
             <a:r>
@@ -8275,7 +8054,7 @@
           <a:bodyPr wrap="square" lIns="0" tIns="0" rIns="0" bIns="0" rtlCol="0" anchor="t"/>
           <a:lstStyle/>
           <a:p>
-            <a:pPr indent="0" marL="0">
+            <a:pPr marL="0" indent="0">
               <a:buNone/>
             </a:pPr>
             <a:r>
@@ -8314,7 +8093,7 @@
           <a:bodyPr wrap="square" lIns="0" tIns="0" rIns="0" bIns="0" rtlCol="0" anchor="t"/>
           <a:lstStyle/>
           <a:p>
-            <a:pPr indent="0" marL="0">
+            <a:pPr marL="0" indent="0">
               <a:buNone/>
             </a:pPr>
             <a:r>
@@ -8353,7 +8132,7 @@
           <a:bodyPr wrap="square" lIns="0" tIns="0" rIns="0" bIns="0" rtlCol="0" anchor="t"/>
           <a:lstStyle/>
           <a:p>
-            <a:pPr indent="0" marL="0">
+            <a:pPr marL="0" indent="0">
               <a:buNone/>
             </a:pPr>
             <a:r>
@@ -8391,7 +8170,7 @@
           </a:prstGeom>
           <a:extLst>
             <a:ext uri="{C572A759-6A51-4108-AA02-DFA0A04FC94B}">
-              <ma14:wrappingTextBoxFlag xmlns:ma14="http://schemas.microsoft.com/office/mac/drawingml/2011/main" val="0"/>
+              <ma14:wrappingTextBoxFlag xmlns:ma14="http://schemas.microsoft.com/office/mac/drawingml/2011/main" xmlns="" val="0"/>
             </a:ext>
           </a:extLst>
         </p:spPr>
@@ -8412,7 +8191,7 @@
           <a:p>
             <a:pPr algn="l"/>
             <a:fld id="{F7021451-1387-4CA6-816F-3879F97B5CBC}" type="slidenum">
-              <a:rPr b="0" lang="en-US"/>
+              <a:rPr lang="en-US" b="0"/>
               <a:t>8</a:t>
             </a:fld>
             <a:endParaRPr lang="en-US"/>
@@ -8447,9 +8226,11 @@
       <p:sp>
         <p:nvSpPr>
           <p:cNvPr id="2" name="Text 0"/>
-          <p:cNvSpPr/>
+          <p:cNvSpPr>
+            <a:spLocks noGrp="1"/>
+          </p:cNvSpPr>
           <p:nvPr>
-            <p:ph idx="100" type="title" hasCustomPrompt="1"/>
+            <p:ph type="title" idx="100" hasCustomPrompt="1"/>
           </p:nvPr>
         </p:nvSpPr>
         <p:spPr>
@@ -8467,7 +8248,7 @@
           <a:bodyPr wrap="square" rtlCol="0" anchor="ctr"/>
           <a:lstStyle/>
           <a:p>
-            <a:pPr algn="l" indent="0" marL="0">
+            <a:pPr marL="0" indent="0" algn="l">
               <a:buNone/>
             </a:pPr>
             <a:r>
@@ -8533,7 +8314,7 @@
           <a:bodyPr wrap="square" lIns="0" tIns="0" rIns="0" bIns="0" rtlCol="0" anchor="t"/>
           <a:lstStyle/>
           <a:p>
-            <a:pPr indent="0" marL="0">
+            <a:pPr marL="0" indent="0">
               <a:buNone/>
             </a:pPr>
             <a:r>
@@ -8572,7 +8353,7 @@
           <a:bodyPr wrap="square" lIns="0" tIns="0" rIns="0" bIns="0" rtlCol="0" anchor="t"/>
           <a:lstStyle/>
           <a:p>
-            <a:pPr indent="0" marL="0">
+            <a:pPr marL="0" indent="0">
               <a:buNone/>
             </a:pPr>
             <a:r>
@@ -8638,7 +8419,7 @@
           <a:bodyPr wrap="square" lIns="0" tIns="0" rIns="0" bIns="0" rtlCol="0" anchor="t"/>
           <a:lstStyle/>
           <a:p>
-            <a:pPr indent="0" marL="0">
+            <a:pPr marL="0" indent="0">
               <a:buNone/>
             </a:pPr>
             <a:r>
@@ -8677,7 +8458,7 @@
           <a:bodyPr wrap="square" lIns="0" tIns="0" rIns="0" bIns="0" rtlCol="0" anchor="t"/>
           <a:lstStyle/>
           <a:p>
-            <a:pPr indent="0" marL="0">
+            <a:pPr marL="0" indent="0">
               <a:buNone/>
             </a:pPr>
             <a:r>
@@ -8743,7 +8524,7 @@
           <a:bodyPr wrap="square" lIns="0" tIns="0" rIns="0" bIns="0" rtlCol="0" anchor="t"/>
           <a:lstStyle/>
           <a:p>
-            <a:pPr indent="0" marL="0">
+            <a:pPr marL="0" indent="0">
               <a:buNone/>
             </a:pPr>
             <a:r>
@@ -8782,7 +8563,7 @@
           <a:bodyPr wrap="square" lIns="0" tIns="0" rIns="0" bIns="0" rtlCol="0" anchor="t"/>
           <a:lstStyle/>
           <a:p>
-            <a:pPr indent="0" marL="0">
+            <a:pPr marL="0" indent="0">
               <a:buNone/>
             </a:pPr>
             <a:r>
@@ -8848,7 +8629,7 @@
           <a:bodyPr wrap="square" lIns="0" tIns="0" rIns="0" bIns="0" rtlCol="0" anchor="t"/>
           <a:lstStyle/>
           <a:p>
-            <a:pPr indent="0" marL="0">
+            <a:pPr marL="0" indent="0">
               <a:buNone/>
             </a:pPr>
             <a:r>
@@ -8887,7 +8668,7 @@
           <a:bodyPr wrap="square" lIns="0" tIns="0" rIns="0" bIns="0" rtlCol="0" anchor="t"/>
           <a:lstStyle/>
           <a:p>
-            <a:pPr indent="0" marL="0">
+            <a:pPr marL="0" indent="0">
               <a:buNone/>
             </a:pPr>
             <a:r>
@@ -8925,7 +8706,7 @@
           </a:prstGeom>
           <a:extLst>
             <a:ext uri="{C572A759-6A51-4108-AA02-DFA0A04FC94B}">
-              <ma14:wrappingTextBoxFlag xmlns:ma14="http://schemas.microsoft.com/office/mac/drawingml/2011/main" val="0"/>
+              <ma14:wrappingTextBoxFlag xmlns:ma14="http://schemas.microsoft.com/office/mac/drawingml/2011/main" xmlns="" val="0"/>
             </a:ext>
           </a:extLst>
         </p:spPr>
@@ -8946,7 +8727,7 @@
           <a:p>
             <a:pPr algn="l"/>
             <a:fld id="{F7021451-1387-4CA6-816F-3879F97B5CBC}" type="slidenum">
-              <a:rPr b="0" lang="en-US"/>
+              <a:rPr lang="en-US" b="0"/>
               <a:t>9</a:t>
             </a:fld>
             <a:endParaRPr lang="en-US"/>
@@ -9254,4 +9035,299 @@
     </a:ext>
   </a:extLst>
 </a:theme>
+</file>
+
+<file path=ppt/theme/theme2.xml><?xml version="1.0" encoding="utf-8"?>
+<a:theme xmlns:a="http://schemas.openxmlformats.org/drawingml/2006/main" name="Office Theme">
+  <a:themeElements>
+    <a:clrScheme name="Office">
+      <a:dk1>
+        <a:sysClr val="windowText" lastClr="000000"/>
+      </a:dk1>
+      <a:lt1>
+        <a:sysClr val="window" lastClr="FFFFFF"/>
+      </a:lt1>
+      <a:dk2>
+        <a:srgbClr val="44546A"/>
+      </a:dk2>
+      <a:lt2>
+        <a:srgbClr val="E7E6E6"/>
+      </a:lt2>
+      <a:accent1>
+        <a:srgbClr val="4472C4"/>
+      </a:accent1>
+      <a:accent2>
+        <a:srgbClr val="ED7D31"/>
+      </a:accent2>
+      <a:accent3>
+        <a:srgbClr val="A5A5A5"/>
+      </a:accent3>
+      <a:accent4>
+        <a:srgbClr val="FFC000"/>
+      </a:accent4>
+      <a:accent5>
+        <a:srgbClr val="5B9BD5"/>
+      </a:accent5>
+      <a:accent6>
+        <a:srgbClr val="70AD47"/>
+      </a:accent6>
+      <a:hlink>
+        <a:srgbClr val="0563C1"/>
+      </a:hlink>
+      <a:folHlink>
+        <a:srgbClr val="954F72"/>
+      </a:folHlink>
+    </a:clrScheme>
+    <a:fontScheme name="Office">
+      <a:majorFont>
+        <a:latin typeface="Calibri Light" panose="020F0302020204030204"/>
+        <a:ea typeface=""/>
+        <a:cs typeface=""/>
+        <a:font script="Jpan" typeface="游ゴシック Light"/>
+        <a:font script="Hang" typeface="맑은 고딕"/>
+        <a:font script="Hans" typeface="等线 Light"/>
+        <a:font script="Hant" typeface="新細明體"/>
+        <a:font script="Arab" typeface="Times New Roman"/>
+        <a:font script="Hebr" typeface="Times New Roman"/>
+        <a:font script="Thai" typeface="Angsana New"/>
+        <a:font script="Ethi" typeface="Nyala"/>
+        <a:font script="Beng" typeface="Vrinda"/>
+        <a:font script="Gujr" typeface="Shruti"/>
+        <a:font script="Khmr" typeface="MoolBoran"/>
+        <a:font script="Knda" typeface="Tunga"/>
+        <a:font script="Guru" typeface="Raavi"/>
+        <a:font script="Cans" typeface="Euphemia"/>
+        <a:font script="Cher" typeface="Plantagenet Cherokee"/>
+        <a:font script="Yiii" typeface="Microsoft Yi Baiti"/>
+        <a:font script="Tibt" typeface="Microsoft Himalaya"/>
+        <a:font script="Thaa" typeface="MV Boli"/>
+        <a:font script="Deva" typeface="Mangal"/>
+        <a:font script="Telu" typeface="Gautami"/>
+        <a:font script="Taml" typeface="Latha"/>
+        <a:font script="Syrc" typeface="Estrangelo Edessa"/>
+        <a:font script="Orya" typeface="Kalinga"/>
+        <a:font script="Mlym" typeface="Kartika"/>
+        <a:font script="Laoo" typeface="DokChampa"/>
+        <a:font script="Sinh" typeface="Iskoola Pota"/>
+        <a:font script="Mong" typeface="Mongolian Baiti"/>
+        <a:font script="Viet" typeface="Times New Roman"/>
+        <a:font script="Uigh" typeface="Microsoft Uighur"/>
+        <a:font script="Geor" typeface="Sylfaen"/>
+        <a:font script="Armn" typeface="Arial"/>
+        <a:font script="Bugi" typeface="Leelawadee UI"/>
+        <a:font script="Bopo" typeface="Microsoft JhengHei"/>
+        <a:font script="Java" typeface="Javanese Text"/>
+        <a:font script="Lisu" typeface="Segoe UI"/>
+        <a:font script="Mymr" typeface="Myanmar Text"/>
+        <a:font script="Nkoo" typeface="Ebrima"/>
+        <a:font script="Olck" typeface="Nirmala UI"/>
+        <a:font script="Osma" typeface="Ebrima"/>
+        <a:font script="Phag" typeface="Phagspa"/>
+        <a:font script="Syrn" typeface="Estrangelo Edessa"/>
+        <a:font script="Syrj" typeface="Estrangelo Edessa"/>
+        <a:font script="Syre" typeface="Estrangelo Edessa"/>
+        <a:font script="Sora" typeface="Nirmala UI"/>
+        <a:font script="Tale" typeface="Microsoft Tai Le"/>
+        <a:font script="Talu" typeface="Microsoft New Tai Lue"/>
+        <a:font script="Tfng" typeface="Ebrima"/>
+      </a:majorFont>
+      <a:minorFont>
+        <a:latin typeface="Calibri" panose="020F0502020204030204"/>
+        <a:ea typeface=""/>
+        <a:cs typeface=""/>
+        <a:font script="Jpan" typeface="游ゴシック"/>
+        <a:font script="Hang" typeface="맑은 고딕"/>
+        <a:font script="Hans" typeface="等线"/>
+        <a:font script="Hant" typeface="新細明體"/>
+        <a:font script="Arab" typeface="Arial"/>
+        <a:font script="Hebr" typeface="Arial"/>
+        <a:font script="Thai" typeface="Cordia New"/>
+        <a:font script="Ethi" typeface="Nyala"/>
+        <a:font script="Beng" typeface="Vrinda"/>
+        <a:font script="Gujr" typeface="Shruti"/>
+        <a:font script="Khmr" typeface="DaunPenh"/>
+        <a:font script="Knda" typeface="Tunga"/>
+        <a:font script="Guru" typeface="Raavi"/>
+        <a:font script="Cans" typeface="Euphemia"/>
+        <a:font script="Cher" typeface="Plantagenet Cherokee"/>
+        <a:font script="Yiii" typeface="Microsoft Yi Baiti"/>
+        <a:font script="Tibt" typeface="Microsoft Himalaya"/>
+        <a:font script="Thaa" typeface="MV Boli"/>
+        <a:font script="Deva" typeface="Mangal"/>
+        <a:font script="Telu" typeface="Gautami"/>
+        <a:font script="Taml" typeface="Latha"/>
+        <a:font script="Syrc" typeface="Estrangelo Edessa"/>
+        <a:font script="Orya" typeface="Kalinga"/>
+        <a:font script="Mlym" typeface="Kartika"/>
+        <a:font script="Laoo" typeface="DokChampa"/>
+        <a:font script="Sinh" typeface="Iskoola Pota"/>
+        <a:font script="Mong" typeface="Mongolian Baiti"/>
+        <a:font script="Viet" typeface="Arial"/>
+        <a:font script="Uigh" typeface="Microsoft Uighur"/>
+        <a:font script="Geor" typeface="Sylfaen"/>
+        <a:font script="Armn" typeface="Arial"/>
+        <a:font script="Bugi" typeface="Leelawadee UI"/>
+        <a:font script="Bopo" typeface="Microsoft JhengHei"/>
+        <a:font script="Java" typeface="Javanese Text"/>
+        <a:font script="Lisu" typeface="Segoe UI"/>
+        <a:font script="Mymr" typeface="Myanmar Text"/>
+        <a:font script="Nkoo" typeface="Ebrima"/>
+        <a:font script="Olck" typeface="Nirmala UI"/>
+        <a:font script="Osma" typeface="Ebrima"/>
+        <a:font script="Phag" typeface="Phagspa"/>
+        <a:font script="Syrn" typeface="Estrangelo Edessa"/>
+        <a:font script="Syrj" typeface="Estrangelo Edessa"/>
+        <a:font script="Syre" typeface="Estrangelo Edessa"/>
+        <a:font script="Sora" typeface="Nirmala UI"/>
+        <a:font script="Tale" typeface="Microsoft Tai Le"/>
+        <a:font script="Talu" typeface="Microsoft New Tai Lue"/>
+        <a:font script="Tfng" typeface="Ebrima"/>
+      </a:minorFont>
+    </a:fontScheme>
+    <a:fmtScheme name="Office">
+      <a:fillStyleLst>
+        <a:solidFill>
+          <a:schemeClr val="phClr"/>
+        </a:solidFill>
+        <a:gradFill rotWithShape="1">
+          <a:gsLst>
+            <a:gs pos="0">
+              <a:schemeClr val="phClr">
+                <a:lumMod val="110000"/>
+                <a:satMod val="105000"/>
+                <a:tint val="67000"/>
+              </a:schemeClr>
+            </a:gs>
+            <a:gs pos="50000">
+              <a:schemeClr val="phClr">
+                <a:lumMod val="105000"/>
+                <a:satMod val="103000"/>
+                <a:tint val="73000"/>
+              </a:schemeClr>
+            </a:gs>
+            <a:gs pos="100000">
+              <a:schemeClr val="phClr">
+                <a:lumMod val="105000"/>
+                <a:satMod val="109000"/>
+                <a:tint val="81000"/>
+              </a:schemeClr>
+            </a:gs>
+          </a:gsLst>
+          <a:lin ang="5400000" scaled="0"/>
+        </a:gradFill>
+        <a:gradFill rotWithShape="1">
+          <a:gsLst>
+            <a:gs pos="0">
+              <a:schemeClr val="phClr">
+                <a:satMod val="103000"/>
+                <a:lumMod val="102000"/>
+                <a:tint val="94000"/>
+              </a:schemeClr>
+            </a:gs>
+            <a:gs pos="50000">
+              <a:schemeClr val="phClr">
+                <a:satMod val="110000"/>
+                <a:lumMod val="100000"/>
+                <a:shade val="100000"/>
+              </a:schemeClr>
+            </a:gs>
+            <a:gs pos="100000">
+              <a:schemeClr val="phClr">
+                <a:lumMod val="99000"/>
+                <a:satMod val="120000"/>
+                <a:shade val="78000"/>
+              </a:schemeClr>
+            </a:gs>
+          </a:gsLst>
+          <a:lin ang="5400000" scaled="0"/>
+        </a:gradFill>
+      </a:fillStyleLst>
+      <a:lnStyleLst>
+        <a:ln w="6350" cap="flat" cmpd="sng" algn="ctr">
+          <a:solidFill>
+            <a:schemeClr val="phClr"/>
+          </a:solidFill>
+          <a:prstDash val="solid"/>
+          <a:miter lim="800000"/>
+        </a:ln>
+        <a:ln w="12700" cap="flat" cmpd="sng" algn="ctr">
+          <a:solidFill>
+            <a:schemeClr val="phClr"/>
+          </a:solidFill>
+          <a:prstDash val="solid"/>
+          <a:miter lim="800000"/>
+        </a:ln>
+        <a:ln w="19050" cap="flat" cmpd="sng" algn="ctr">
+          <a:solidFill>
+            <a:schemeClr val="phClr"/>
+          </a:solidFill>
+          <a:prstDash val="solid"/>
+          <a:miter lim="800000"/>
+        </a:ln>
+      </a:lnStyleLst>
+      <a:effectStyleLst>
+        <a:effectStyle>
+          <a:effectLst/>
+        </a:effectStyle>
+        <a:effectStyle>
+          <a:effectLst/>
+        </a:effectStyle>
+        <a:effectStyle>
+          <a:effectLst>
+            <a:outerShdw blurRad="57150" dist="19050" dir="5400000" algn="ctr" rotWithShape="0">
+              <a:srgbClr val="000000">
+                <a:alpha val="63000"/>
+              </a:srgbClr>
+            </a:outerShdw>
+          </a:effectLst>
+        </a:effectStyle>
+      </a:effectStyleLst>
+      <a:bgFillStyleLst>
+        <a:solidFill>
+          <a:schemeClr val="phClr"/>
+        </a:solidFill>
+        <a:solidFill>
+          <a:schemeClr val="phClr">
+            <a:tint val="95000"/>
+            <a:satMod val="170000"/>
+          </a:schemeClr>
+        </a:solidFill>
+        <a:gradFill rotWithShape="1">
+          <a:gsLst>
+            <a:gs pos="0">
+              <a:schemeClr val="phClr">
+                <a:tint val="93000"/>
+                <a:satMod val="150000"/>
+                <a:shade val="98000"/>
+                <a:lumMod val="102000"/>
+              </a:schemeClr>
+            </a:gs>
+            <a:gs pos="50000">
+              <a:schemeClr val="phClr">
+                <a:tint val="98000"/>
+                <a:satMod val="130000"/>
+                <a:shade val="90000"/>
+                <a:lumMod val="103000"/>
+              </a:schemeClr>
+            </a:gs>
+            <a:gs pos="100000">
+              <a:schemeClr val="phClr">
+                <a:shade val="63000"/>
+                <a:satMod val="120000"/>
+              </a:schemeClr>
+            </a:gs>
+          </a:gsLst>
+          <a:lin ang="5400000" scaled="0"/>
+        </a:gradFill>
+      </a:bgFillStyleLst>
+    </a:fmtScheme>
+  </a:themeElements>
+  <a:objectDefaults/>
+  <a:extraClrSchemeLst/>
+  <a:extLst>
+    <a:ext uri="{05A4C25C-085E-4340-85A3-A5531E510DB2}">
+      <thm15:themeFamily xmlns:thm15="http://schemas.microsoft.com/office/thememl/2012/main" name="Office Theme" id="{62F939B6-93AF-4DB8-9C6B-D6C7DFDC589F}" vid="{4A3C46E8-61CC-4603-A589-7422A47A8E4A}"/>
+    </a:ext>
+  </a:extLst>
+</a:theme>
 </file>
</xml_diff>

<commit_message>
feat: add initial report and presentation slides for Apart Research sprint
</commit_message>
<xml_diff>
--- a/Apart Research/slides.pptx
+++ b/Apart Research/slides.pptx
@@ -4,6 +4,9 @@
   <p:sldMasterIdLst>
     <p:sldMasterId id="2147483648" r:id="rId1"/>
   </p:sldMasterIdLst>
+  <p:notesMasterIdLst>
+    <p:notesMasterId r:id="rId12"/>
+  </p:notesMasterIdLst>
   <p:sldIdLst>
     <p:sldId id="256" r:id="rId2"/>
     <p:sldId id="257" r:id="rId3"/>
@@ -16,9 +19,6 @@
     <p:sldId id="264" r:id="rId10"/>
     <p:sldId id="265" r:id="rId11"/>
   </p:sldIdLst>
-  <p:notesMasterIdLst>
-    <p:notesMasterId r:id="rId12"/>
-  </p:notesMasterIdLst>
   <p:sldSz cx="12192000" cy="6858000"/>
   <p:notesSz cx="6858000" cy="12192000"/>
   <p:defaultTextStyle>
@@ -113,13 +113,20 @@
       </a:defRPr>
     </a:lvl9pPr>
   </p:defaultTextStyle>
+  <p:extLst>
+    <p:ext uri="{EFAFB233-063F-42B5-8137-9DF3F51BA10A}">
+      <p15:sldGuideLst xmlns:p15="http://schemas.microsoft.com/office/powerpoint/2012/main"/>
+    </p:ext>
+  </p:extLst>
 </p:presentation>
 </file>
 
 <file path=ppt/charts/chart1.xml><?xml version="1.0" encoding="utf-8"?>
-<c:chartSpace xmlns:c="http://schemas.openxmlformats.org/drawingml/2006/chart" xmlns:a="http://schemas.openxmlformats.org/drawingml/2006/main" xmlns:r="http://schemas.openxmlformats.org/officeDocument/2006/relationships">
+<c:chartSpace xmlns:c="http://schemas.openxmlformats.org/drawingml/2006/chart" xmlns:a="http://schemas.openxmlformats.org/drawingml/2006/main" xmlns:r="http://schemas.openxmlformats.org/officeDocument/2006/relationships" xmlns:c16r2="http://schemas.microsoft.com/office/drawing/2015/06/chart">
   <c:date1904 val="0"/>
+  <c:lang val="en-US"/>
   <c:roundedCorners val="1"/>
+  <c:style val="2"/>
   <c:chart>
     <c:title>
       <c:tx>
@@ -136,7 +143,7 @@
               </a:defRPr>
             </a:pPr>
             <a:r>
-              <a:rPr sz="1500" b="0" i="0" u="none" strike="noStrike">
+              <a:rPr lang="en-US" sz="1500" b="0" i="0" u="none" strike="noStrike">
                 <a:solidFill>
                   <a:srgbClr val="2B2F36"/>
                 </a:solidFill>
@@ -147,7 +154,6 @@
           </a:p>
         </c:rich>
       </c:tx>
-      <c:layout/>
       <c:overlay val="0"/>
     </c:title>
     <c:autoTitleDeleted val="0"/>
@@ -178,40 +184,15 @@
             <a:effectLst/>
           </c:spPr>
           <c:invertIfNegative val="0"/>
-          <c:dLbls>
-            <c:numFmt formatCode="0.000" sourceLinked="0"/>
-            <c:txPr>
-              <a:bodyPr/>
-              <a:lstStyle/>
-              <a:p>
-                <a:pPr>
-                  <a:defRPr b="0" i="0" strike="noStrike" sz="1300" u="none">
-                    <a:solidFill>
-                      <a:srgbClr val="2B2F36"/>
-                    </a:solidFill>
-                    <a:latin typeface="+mn-lt"/>
-                  </a:defRPr>
-                </a:pPr>
-              </a:p>
-            </c:txPr>
-            <c:showLegendKey val="0"/>
-            <c:showVal val="1"/>
-            <c:showCatName val="0"/>
-            <c:showSerName val="0"/>
-            <c:showPercent val="0"/>
-            <c:showBubbleSize val="0"/>
-            <c:showLeaderLines val="0"/>
-          </c:dLbls>
           <c:dPt>
             <c:idx val="0"/>
             <c:invertIfNegative val="0"/>
             <c:bubble3D val="0"/>
-            <c:spPr>
-              <a:solidFill>
-                <a:srgbClr val="2B2F36"/>
-              </a:solidFill>
-              <a:effectLst/>
-            </c:spPr>
+            <c:extLst>
+              <c:ext xmlns:c16="http://schemas.microsoft.com/office/drawing/2014/chart" uri="{C3380CC4-5D6E-409C-BE32-E72D297353CC}">
+                <c16:uniqueId val="{00000001-1203-43C0-A483-3AC5DC55E42C}"/>
+              </c:ext>
+            </c:extLst>
           </c:dPt>
           <c:dPt>
             <c:idx val="1"/>
@@ -223,6 +204,11 @@
               </a:solidFill>
               <a:effectLst/>
             </c:spPr>
+            <c:extLst>
+              <c:ext xmlns:c16="http://schemas.microsoft.com/office/drawing/2014/chart" uri="{C3380CC4-5D6E-409C-BE32-E72D297353CC}">
+                <c16:uniqueId val="{00000003-1203-43C0-A483-3AC5DC55E42C}"/>
+              </c:ext>
+            </c:extLst>
           </c:dPt>
           <c:dPt>
             <c:idx val="2"/>
@@ -234,6 +220,11 @@
               </a:solidFill>
               <a:effectLst/>
             </c:spPr>
+            <c:extLst>
+              <c:ext xmlns:c16="http://schemas.microsoft.com/office/drawing/2014/chart" uri="{C3380CC4-5D6E-409C-BE32-E72D297353CC}">
+                <c16:uniqueId val="{00000005-1203-43C0-A483-3AC5DC55E42C}"/>
+              </c:ext>
+            </c:extLst>
           </c:dPt>
           <c:dPt>
             <c:idx val="3"/>
@@ -245,6 +236,11 @@
               </a:solidFill>
               <a:effectLst/>
             </c:spPr>
+            <c:extLst>
+              <c:ext xmlns:c16="http://schemas.microsoft.com/office/drawing/2014/chart" uri="{C3380CC4-5D6E-409C-BE32-E72D297353CC}">
+                <c16:uniqueId val="{00000007-1203-43C0-A483-3AC5DC55E42C}"/>
+              </c:ext>
+            </c:extLst>
           </c:dPt>
           <c:dPt>
             <c:idx val="4"/>
@@ -256,6 +252,11 @@
               </a:solidFill>
               <a:effectLst/>
             </c:spPr>
+            <c:extLst>
+              <c:ext xmlns:c16="http://schemas.microsoft.com/office/drawing/2014/chart" uri="{C3380CC4-5D6E-409C-BE32-E72D297353CC}">
+                <c16:uniqueId val="{00000009-1203-43C0-A483-3AC5DC55E42C}"/>
+              </c:ext>
+            </c:extLst>
           </c:dPt>
           <c:dPt>
             <c:idx val="5"/>
@@ -267,6 +268,11 @@
               </a:solidFill>
               <a:effectLst/>
             </c:spPr>
+            <c:extLst>
+              <c:ext xmlns:c16="http://schemas.microsoft.com/office/drawing/2014/chart" uri="{C3380CC4-5D6E-409C-BE32-E72D297353CC}">
+                <c16:uniqueId val="{0000000B-1203-43C0-A483-3AC5DC55E42C}"/>
+              </c:ext>
+            </c:extLst>
           </c:dPt>
           <c:dPt>
             <c:idx val="6"/>
@@ -278,6 +284,11 @@
               </a:solidFill>
               <a:effectLst/>
             </c:spPr>
+            <c:extLst>
+              <c:ext xmlns:c16="http://schemas.microsoft.com/office/drawing/2014/chart" uri="{C3380CC4-5D6E-409C-BE32-E72D297353CC}">
+                <c16:uniqueId val="{0000000D-1203-43C0-A483-3AC5DC55E42C}"/>
+              </c:ext>
+            </c:extLst>
           </c:dPt>
           <c:dPt>
             <c:idx val="7"/>
@@ -289,40 +300,80 @@
               </a:solidFill>
               <a:effectLst/>
             </c:spPr>
+            <c:extLst>
+              <c:ext xmlns:c16="http://schemas.microsoft.com/office/drawing/2014/chart" uri="{C3380CC4-5D6E-409C-BE32-E72D297353CC}">
+                <c16:uniqueId val="{0000000F-1203-43C0-A483-3AC5DC55E42C}"/>
+              </c:ext>
+            </c:extLst>
           </c:dPt>
+          <c:dLbls>
+            <c:numFmt formatCode="0.000" sourceLinked="0"/>
+            <c:spPr>
+              <a:noFill/>
+              <a:ln>
+                <a:noFill/>
+              </a:ln>
+              <a:effectLst/>
+            </c:spPr>
+            <c:txPr>
+              <a:bodyPr/>
+              <a:lstStyle/>
+              <a:p>
+                <a:pPr>
+                  <a:defRPr sz="1300" b="0" i="0" u="none" strike="noStrike">
+                    <a:solidFill>
+                      <a:srgbClr val="2B2F36"/>
+                    </a:solidFill>
+                    <a:latin typeface="+mn-lt"/>
+                  </a:defRPr>
+                </a:pPr>
+                <a:endParaRPr lang="en-US"/>
+              </a:p>
+            </c:txPr>
+            <c:showLegendKey val="0"/>
+            <c:showVal val="1"/>
+            <c:showCatName val="0"/>
+            <c:showSerName val="0"/>
+            <c:showPercent val="0"/>
+            <c:showBubbleSize val="0"/>
+            <c:showLeaderLines val="0"/>
+            <c:extLst>
+              <c:ext xmlns:c15="http://schemas.microsoft.com/office/drawing/2012/chart" uri="{CE6537A1-D6FC-4f65-9D91-7224C49458BB}">
+                <c15:showLeaderLines val="0"/>
+              </c:ext>
+            </c:extLst>
+          </c:dLbls>
           <c:cat>
-            <c:multiLvlStrRef>
+            <c:strRef>
               <c:f>Sheet1!$A$2:$A$9</c:f>
-              <c:multiLvlStrCache>
+              <c:strCache>
                 <c:ptCount val="8"/>
-                <c:lvl>
-                  <c:pt idx="0">
-                    <c:v>Control</c:v>
-                  </c:pt>
-                  <c:pt idx="1">
-                    <c:v>Placebo</c:v>
-                  </c:pt>
-                  <c:pt idx="2">
-                    <c:v>Same + history</c:v>
-                  </c:pt>
-                  <c:pt idx="3">
-                    <c:v>Same, notes only</c:v>
-                  </c:pt>
-                  <c:pt idx="4">
-                    <c:v>Same, no history</c:v>
-                  </c:pt>
-                  <c:pt idx="5">
-                    <c:v>Other + history</c:v>
-                  </c:pt>
-                  <c:pt idx="6">
-                    <c:v>Other, no history</c:v>
-                  </c:pt>
-                  <c:pt idx="7">
-                    <c:v>Best-response bot</c:v>
-                  </c:pt>
-                </c:lvl>
-              </c:multiLvlStrCache>
-            </c:multiLvlStrRef>
+                <c:pt idx="0">
+                  <c:v>Control</c:v>
+                </c:pt>
+                <c:pt idx="1">
+                  <c:v>Placebo</c:v>
+                </c:pt>
+                <c:pt idx="2">
+                  <c:v>Same + history</c:v>
+                </c:pt>
+                <c:pt idx="3">
+                  <c:v>Same, notes only</c:v>
+                </c:pt>
+                <c:pt idx="4">
+                  <c:v>Same, no history</c:v>
+                </c:pt>
+                <c:pt idx="5">
+                  <c:v>Other + history</c:v>
+                </c:pt>
+                <c:pt idx="6">
+                  <c:v>Other, no history</c:v>
+                </c:pt>
+                <c:pt idx="7">
+                  <c:v>Best-response bot</c:v>
+                </c:pt>
+              </c:strCache>
+            </c:strRef>
           </c:cat>
           <c:val>
             <c:numRef>
@@ -334,7 +385,7 @@
                   <c:v>0.9</c:v>
                 </c:pt>
                 <c:pt idx="1">
-                  <c:v>0.884</c:v>
+                  <c:v>0.88400000000000001</c:v>
                 </c:pt>
                 <c:pt idx="2">
                   <c:v>0.876</c:v>
@@ -343,50 +394,37 @@
                   <c:v>0.63</c:v>
                 </c:pt>
                 <c:pt idx="4">
-                  <c:v>0.289</c:v>
+                  <c:v>0.28899999999999998</c:v>
                 </c:pt>
                 <c:pt idx="5">
-                  <c:v>0.199</c:v>
+                  <c:v>0.19900000000000001</c:v>
                 </c:pt>
                 <c:pt idx="6">
-                  <c:v>0.039</c:v>
+                  <c:v>3.9E-2</c:v>
                 </c:pt>
                 <c:pt idx="7">
-                  <c:v>0.023</c:v>
+                  <c:v>2.3E-2</c:v>
                 </c:pt>
               </c:numCache>
             </c:numRef>
           </c:val>
+          <c:extLst>
+            <c:ext xmlns:c16="http://schemas.microsoft.com/office/drawing/2014/chart" uri="{C3380CC4-5D6E-409C-BE32-E72D297353CC}">
+              <c16:uniqueId val="{00000010-1203-43C0-A483-3AC5DC55E42C}"/>
+            </c:ext>
+          </c:extLst>
         </c:ser>
         <c:dLbls>
-          <c:numFmt formatCode="0.000" sourceLinked="0"/>
-          <c:txPr>
-            <a:bodyPr/>
-            <a:lstStyle/>
-            <a:p>
-              <a:pPr>
-                <a:defRPr b="0" i="0" strike="noStrike" sz="1300" u="none">
-                  <a:solidFill>
-                    <a:srgbClr val="2B2F36"/>
-                  </a:solidFill>
-                  <a:latin typeface="+mn-lt"/>
-                </a:defRPr>
-              </a:pPr>
-            </a:p>
-          </c:txPr>
           <c:showLegendKey val="0"/>
           <c:showVal val="1"/>
           <c:showCatName val="0"/>
           <c:showSerName val="0"/>
           <c:showPercent val="0"/>
           <c:showBubbleSize val="0"/>
-          <c:showLeaderLines val="0"/>
         </c:dLbls>
         <c:gapWidth val="150"/>
-        <c:overlap val="0"/>
         <c:axId val="2094734554"/>
         <c:axId val="2094734552"/>
-        <c:axId val="2094734556"/>
       </c:barChart>
       <c:catAx>
         <c:axId val="2094734554"/>
@@ -427,6 +465,7 @@
         <c:crosses val="autoZero"/>
         <c:auto val="1"/>
         <c:lblAlgn val="ctr"/>
+        <c:lblOffset val="100"/>
         <c:noMultiLvlLbl val="1"/>
       </c:catAx>
       <c:valAx>
@@ -437,7 +476,7 @@
           <c:min val="0"/>
         </c:scaling>
         <c:delete val="0"/>
-        <c:axPos val="b"/>
+        <c:axPos val="t"/>
         <c:majorGridlines>
           <c:spPr>
             <a:ln w="9525" cap="flat">
@@ -491,6 +530,7 @@
     </c:plotArea>
     <c:plotVisOnly val="1"/>
     <c:dispBlanksAs val="span"/>
+    <c:showDLblsOverMax val="1"/>
   </c:chart>
   <c:spPr>
     <a:noFill/>
@@ -527,234 +567,10 @@
           <a:chExt cx="0" cy="0"/>
         </a:xfrm>
       </p:grpSpPr>
-      <p:sp>
-        <p:nvSpPr>
-          <p:cNvPr id="2" name="Header Placeholder 1"/>
-          <p:cNvSpPr>
-            <a:spLocks noGrp="1"/>
-          </p:cNvSpPr>
-          <p:nvPr>
-            <p:ph type="hdr" sz="quarter"/>
-          </p:nvPr>
-        </p:nvSpPr>
-        <p:spPr>
-          <a:xfrm>
-            <a:off x="0" y="0"/>
-            <a:ext cx="2971800" cy="458788"/>
-          </a:xfrm>
-          <a:prstGeom prst="rect">
-            <a:avLst/>
-          </a:prstGeom>
-        </p:spPr>
-        <p:txBody>
-          <a:bodyPr vert="horz" lIns="91440" tIns="45720" rIns="91440" bIns="45720" rtlCol="0"/>
-          <a:lstStyle>
-            <a:lvl1pPr algn="l">
-              <a:defRPr sz="1200"/>
-            </a:lvl1pPr>
-          </a:lstStyle>
-          <a:p>
-            <a:endParaRPr lang="en-US"/>
-          </a:p>
-        </p:txBody>
-      </p:sp>
-      <p:sp>
-        <p:nvSpPr>
-          <p:cNvPr id="3" name="Date Placeholder 2"/>
-          <p:cNvSpPr>
-            <a:spLocks noGrp="1"/>
-          </p:cNvSpPr>
-          <p:nvPr>
-            <p:ph type="dt" idx="1"/>
-          </p:nvPr>
-        </p:nvSpPr>
-        <p:spPr>
-          <a:xfrm>
-            <a:off x="3884613" y="0"/>
-            <a:ext cx="2971800" cy="458788"/>
-          </a:xfrm>
-          <a:prstGeom prst="rect">
-            <a:avLst/>
-          </a:prstGeom>
-        </p:spPr>
-        <p:txBody>
-          <a:bodyPr vert="horz" lIns="91440" tIns="45720" rIns="91440" bIns="45720" rtlCol="0"/>
-          <a:lstStyle>
-            <a:lvl1pPr algn="r">
-              <a:defRPr sz="1200"/>
-            </a:lvl1pPr>
-          </a:lstStyle>
-          <a:p>
-            <a:fld id="{5282F153-3F37-0F45-9E97-73ACFA13230C}" type="datetimeFigureOut">
-              <a:rPr lang="en-US"/>
-              <a:t>7/23/19</a:t>
-            </a:fld>
-            <a:endParaRPr lang="en-US"/>
-          </a:p>
-        </p:txBody>
-      </p:sp>
-      <p:sp>
-        <p:nvSpPr>
-          <p:cNvPr id="4" name="Slide Image Placeholder 3"/>
-          <p:cNvSpPr>
-            <a:spLocks noGrp="1" noRot="1" noChangeAspect="1"/>
-          </p:cNvSpPr>
-          <p:nvPr>
-            <p:ph type="sldImg" idx="2"/>
-          </p:nvPr>
-        </p:nvSpPr>
-        <p:spPr>
-          <a:xfrm>
-            <a:off x="685800" y="1143000"/>
-            <a:ext cx="5486400" cy="3086100"/>
-          </a:xfrm>
-          <a:prstGeom prst="rect">
-            <a:avLst/>
-          </a:prstGeom>
-          <a:noFill/>
-          <a:ln w="12700">
-            <a:solidFill>
-              <a:prstClr val="black"/>
-            </a:solidFill>
-          </a:ln>
-        </p:spPr>
-        <p:txBody>
-          <a:bodyPr vert="horz" lIns="91440" tIns="45720" rIns="91440" bIns="45720" rtlCol="0" anchor="ctr"/>
-          <a:lstStyle/>
-          <a:p>
-            <a:endParaRPr lang="en-US"/>
-          </a:p>
-        </p:txBody>
-      </p:sp>
-      <p:sp>
-        <p:nvSpPr>
-          <p:cNvPr id="5" name="Notes Placeholder 4"/>
-          <p:cNvSpPr>
-            <a:spLocks noGrp="1"/>
-          </p:cNvSpPr>
-          <p:nvPr>
-            <p:ph type="body" sz="quarter" idx="3"/>
-          </p:nvPr>
-        </p:nvSpPr>
-        <p:spPr>
-          <a:xfrm>
-            <a:off x="685800" y="4400550"/>
-            <a:ext cx="5486400" cy="3600450"/>
-          </a:xfrm>
-          <a:prstGeom prst="rect">
-            <a:avLst/>
-          </a:prstGeom>
-        </p:spPr>
-        <p:txBody>
-          <a:bodyPr vert="horz" lIns="91440" tIns="45720" rIns="91440" bIns="45720" rtlCol="0"/>
-          <a:lstStyle/>
-          <a:p>
-            <a:pPr lvl="0"/>
-            <a:r>
-              <a:rPr lang="en-US"/>
-              <a:t>Click to edit Master text styles</a:t>
-            </a:r>
-          </a:p>
-          <a:p>
-            <a:pPr lvl="1"/>
-            <a:r>
-              <a:rPr lang="en-US"/>
-              <a:t>Second level</a:t>
-            </a:r>
-          </a:p>
-          <a:p>
-            <a:pPr lvl="2"/>
-            <a:r>
-              <a:rPr lang="en-US"/>
-              <a:t>Third level</a:t>
-            </a:r>
-          </a:p>
-          <a:p>
-            <a:pPr lvl="3"/>
-            <a:r>
-              <a:rPr lang="en-US"/>
-              <a:t>Fourth level</a:t>
-            </a:r>
-          </a:p>
-          <a:p>
-            <a:pPr lvl="4"/>
-            <a:r>
-              <a:rPr lang="en-US"/>
-              <a:t>Fifth level</a:t>
-            </a:r>
-          </a:p>
-        </p:txBody>
-      </p:sp>
-      <p:sp>
-        <p:nvSpPr>
-          <p:cNvPr id="6" name="Footer Placeholder 5"/>
-          <p:cNvSpPr>
-            <a:spLocks noGrp="1"/>
-          </p:cNvSpPr>
-          <p:nvPr>
-            <p:ph type="ftr" sz="quarter" idx="4"/>
-          </p:nvPr>
-        </p:nvSpPr>
-        <p:spPr>
-          <a:xfrm>
-            <a:off x="0" y="8685213"/>
-            <a:ext cx="2971800" cy="458787"/>
-          </a:xfrm>
-          <a:prstGeom prst="rect">
-            <a:avLst/>
-          </a:prstGeom>
-        </p:spPr>
-        <p:txBody>
-          <a:bodyPr vert="horz" lIns="91440" tIns="45720" rIns="91440" bIns="45720" rtlCol="0" anchor="b"/>
-          <a:lstStyle>
-            <a:lvl1pPr algn="l">
-              <a:defRPr sz="1200"/>
-            </a:lvl1pPr>
-          </a:lstStyle>
-          <a:p>
-            <a:endParaRPr lang="en-US"/>
-          </a:p>
-        </p:txBody>
-      </p:sp>
-      <p:sp>
-        <p:nvSpPr>
-          <p:cNvPr id="7" name="Slide Number Placeholder 6"/>
-          <p:cNvSpPr>
-            <a:spLocks noGrp="1"/>
-          </p:cNvSpPr>
-          <p:nvPr>
-            <p:ph type="sldNum" sz="quarter" idx="5"/>
-          </p:nvPr>
-        </p:nvSpPr>
-        <p:spPr>
-          <a:xfrm>
-            <a:off x="3884613" y="8685213"/>
-            <a:ext cx="2971800" cy="458787"/>
-          </a:xfrm>
-          <a:prstGeom prst="rect">
-            <a:avLst/>
-          </a:prstGeom>
-        </p:spPr>
-        <p:txBody>
-          <a:bodyPr vert="horz" lIns="91440" tIns="45720" rIns="91440" bIns="45720" rtlCol="0" anchor="b"/>
-          <a:lstStyle>
-            <a:lvl1pPr algn="r">
-              <a:defRPr sz="1200"/>
-            </a:lvl1pPr>
-          </a:lstStyle>
-          <a:p>
-            <a:fld id="{CE5E9CC1-C706-0F49-92D6-E571CC5EEA8F}" type="slidenum">
-              <a:rPr lang="en-US"/>
-              <a:t>‹#›</a:t>
-            </a:fld>
-            <a:endParaRPr lang="en-US"/>
-          </a:p>
-        </p:txBody>
-      </p:sp>
     </p:spTree>
     <p:extLst>
       <p:ext uri="{BB962C8B-B14F-4D97-AF65-F5344CB8AC3E}">
-        <p14:creationId xmlns:p14="http://schemas.microsoft.com/office/powerpoint/2010/main" val="1024086991"/>
+        <p14:creationId xmlns:p14="http://schemas.microsoft.com/office/powerpoint/2010/main" val="1393504906"/>
       </p:ext>
     </p:extLst>
   </p:cSld>
@@ -902,7 +718,6 @@
               <a:rPr lang="en-US" dirty="0"/>
               <a:t>Two AI agents that set prices for two competing firms often learn to keep prices high without being told to. We ask what happens when one of them is replaced. Short answer: the cartel survives if the new agent reads the old price history.</a:t>
             </a:r>
-            <a:endParaRPr lang="en-US" dirty="0"/>
           </a:p>
         </p:txBody>
       </p:sp>
@@ -990,7 +805,6 @@
               <a:rPr lang="en-US" dirty="0"/>
               <a:t>All numbers come from stored run data through the analysis code in the repository. The report lists every run, null results and failures.</a:t>
             </a:r>
-            <a:endParaRPr lang="en-US" dirty="0"/>
           </a:p>
         </p:txBody>
       </p:sp>
@@ -1078,7 +892,6 @@
               <a:rPr lang="en-US" dirty="0"/>
               <a:t>The answer tells a regulator which item a remedy must change: the agent, the data it inherits, or its memory.</a:t>
             </a:r>
-            <a:endParaRPr lang="en-US" dirty="0"/>
           </a:p>
         </p:txBody>
       </p:sp>
@@ -1166,7 +979,6 @@
               <a:rPr lang="en-US" dirty="0"/>
               <a:t>A profit index near 1 means the two agents behave like a cartel. We report both indices because they disagree when prices overshoot the monopoly price.</a:t>
             </a:r>
-            <a:endParaRPr lang="en-US" dirty="0"/>
           </a:p>
         </p:txBody>
       </p:sp>
@@ -1254,7 +1066,6 @@
               <a:rPr lang="en-US" dirty="0"/>
               <a:t>Six independent runs, hypotheses fixed in advance, 95% bootstrap intervals over markets. Runs without a stable cartel are reported too.</a:t>
             </a:r>
-            <a:endParaRPr lang="en-US" dirty="0"/>
           </a:p>
         </p:txBody>
       </p:sp>
@@ -1342,7 +1153,6 @@
               <a:rPr lang="en-US" dirty="0"/>
               <a:t>Profit index 0 = competitive, 1 = monopoly. 'Same + history' differs from no replacement by between -0.025 and +0.213 across the six runs.</a:t>
             </a:r>
-            <a:endParaRPr lang="en-US" dirty="0"/>
           </a:p>
         </p:txBody>
       </p:sp>
@@ -1430,7 +1240,6 @@
               <a:rPr lang="en-US" dirty="0"/>
               <a:t>The blank entrant has no anchor. It starts high and stays above the monopoly price, so both firms sell less. Only the best-response bot and the Mistral entrant reach competitive prices.</a:t>
             </a:r>
-            <a:endParaRPr lang="en-US" dirty="0"/>
           </a:p>
         </p:txBody>
       </p:sp>
@@ -1518,7 +1327,6 @@
               <a:rPr lang="en-US" dirty="0"/>
               <a:t>'A different model' is not one treatment. A sticky model keeps the inherited prices by inertia; an exploring model drifts to competition.</a:t>
             </a:r>
-            <a:endParaRPr lang="en-US" dirty="0"/>
           </a:p>
         </p:txBody>
       </p:sp>
@@ -1606,7 +1414,6 @@
               <a:rPr lang="en-US" dirty="0"/>
               <a:t>The inherited high prices persist because the agents anchor on what they see, not because they threaten a price war.</a:t>
             </a:r>
-            <a:endParaRPr lang="en-US" dirty="0"/>
           </a:p>
         </p:txBody>
       </p:sp>
@@ -1694,7 +1501,6 @@
               <a:rPr lang="en-US" dirty="0"/>
               <a:t>The unit of analysis moves from the agent to the agent and its context.</a:t>
             </a:r>
-            <a:endParaRPr lang="en-US" dirty="0"/>
           </a:p>
         </p:txBody>
       </p:sp>
@@ -1772,6 +1578,7 @@
         <a:solidFill>
           <a:srgbClr val="FFFFFF"/>
         </a:solidFill>
+        <a:effectLst/>
       </p:bgPr>
     </p:bg>
     <p:spTree>
@@ -1809,7 +1616,7 @@
           <a:bodyPr wrap="square" rtlCol="0" anchor="ctr"/>
           <a:lstStyle/>
           <a:p>
-            <a:pPr indent="0" marL="0">
+            <a:pPr marL="0" indent="0">
               <a:buNone/>
             </a:pPr>
             <a:r>
@@ -1830,9 +1637,11 @@
       <p:sp>
         <p:nvSpPr>
           <p:cNvPr id="3" name="Text 1"/>
-          <p:cNvSpPr/>
+          <p:cNvSpPr>
+            <a:spLocks noGrp="1"/>
+          </p:cNvSpPr>
           <p:nvPr>
-            <p:ph idx="101" type="title" hasCustomPrompt="1"/>
+            <p:ph type="title" idx="101" hasCustomPrompt="1"/>
           </p:nvPr>
         </p:nvSpPr>
         <p:spPr>
@@ -1849,7 +1658,7 @@
         <p:txBody>
           <a:bodyPr wrap="square" rtlCol="0"/>
           <a:lstStyle>
-            <a:lvl1pPr algn="l" indent="0" marL="0">
+            <a:lvl1pPr marL="0" indent="0" algn="l">
               <a:buNone/>
               <a:defRPr lang="en-US" sz="3000" b="1" dirty="0">
                 <a:solidFill>
@@ -1862,7 +1671,7 @@
             </a:lvl1pPr>
           </a:lstStyle>
           <a:p>
-            <a:pPr algn="l" indent="0" marL="0">
+            <a:pPr marL="0" indent="0" algn="l">
               <a:buNone/>
             </a:pPr>
             <a:endParaRPr lang="en-US" sz="3000" dirty="0"/>
@@ -1889,7 +1698,7 @@
           </a:prstGeom>
           <a:extLst>
             <a:ext uri="{C572A759-6A51-4108-AA02-DFA0A04FC94B}">
-              <ma14:wrappingTextBoxFlag xmlns:ma14="http://schemas.microsoft.com/office/mac/drawingml/2011/main" val="0"/>
+              <ma14:wrappingTextBoxFlag xmlns:ma14="http://schemas.microsoft.com/office/mac/drawingml/2011/main" xmlns="" val="0"/>
             </a:ext>
           </a:extLst>
         </p:spPr>
@@ -1910,8 +1719,8 @@
           <a:p>
             <a:pPr algn="l"/>
             <a:fld id="{F7021451-1387-4CA6-816F-3879F97B5CBC}" type="slidenum">
-              <a:rPr b="0" lang="en-US"/>
-              <a:t>1002</a:t>
+              <a:rPr lang="en-US" b="0"/>
+              <a:t>‹#›</a:t>
             </a:fld>
             <a:endParaRPr lang="en-US"/>
           </a:p>
@@ -1933,6 +1742,7 @@
         <a:solidFill>
           <a:srgbClr val="FFFFFF"/>
         </a:solidFill>
+        <a:effectLst/>
       </p:bgPr>
     </p:bg>
     <p:spTree>
@@ -1952,9 +1762,11 @@
       <p:sp>
         <p:nvSpPr>
           <p:cNvPr id="2" name="Text 0"/>
-          <p:cNvSpPr/>
+          <p:cNvSpPr>
+            <a:spLocks noGrp="1"/>
+          </p:cNvSpPr>
           <p:nvPr>
-            <p:ph idx="100" type="title" hasCustomPrompt="1"/>
+            <p:ph type="title" idx="100" hasCustomPrompt="1"/>
           </p:nvPr>
         </p:nvSpPr>
         <p:spPr>
@@ -1971,7 +1783,7 @@
         <p:txBody>
           <a:bodyPr wrap="square" rtlCol="0"/>
           <a:lstStyle>
-            <a:lvl1pPr algn="l" indent="0" marL="0">
+            <a:lvl1pPr marL="0" indent="0" algn="l">
               <a:buNone/>
               <a:defRPr lang="en-US" sz="3000" b="1" dirty="0">
                 <a:solidFill>
@@ -1984,7 +1796,7 @@
             </a:lvl1pPr>
           </a:lstStyle>
           <a:p>
-            <a:pPr algn="l" indent="0" marL="0">
+            <a:pPr marL="0" indent="0" algn="l">
               <a:buNone/>
             </a:pPr>
             <a:endParaRPr lang="en-US" sz="3000" dirty="0"/>
@@ -2011,7 +1823,7 @@
           </a:prstGeom>
           <a:extLst>
             <a:ext uri="{C572A759-6A51-4108-AA02-DFA0A04FC94B}">
-              <ma14:wrappingTextBoxFlag xmlns:ma14="http://schemas.microsoft.com/office/mac/drawingml/2011/main" val="0"/>
+              <ma14:wrappingTextBoxFlag xmlns:ma14="http://schemas.microsoft.com/office/mac/drawingml/2011/main" xmlns="" val="0"/>
             </a:ext>
           </a:extLst>
         </p:spPr>
@@ -2032,8 +1844,8 @@
           <a:p>
             <a:pPr algn="l"/>
             <a:fld id="{F7021451-1387-4CA6-816F-3879F97B5CBC}" type="slidenum">
-              <a:rPr b="0" lang="en-US"/>
-              <a:t>1003</a:t>
+              <a:rPr lang="en-US" b="0"/>
+              <a:t>‹#›</a:t>
             </a:fld>
             <a:endParaRPr lang="en-US"/>
           </a:p>
@@ -2050,6 +1862,11 @@
 <file path=ppt/slideMasters/slideMaster1.xml><?xml version="1.0" encoding="utf-8"?>
 <p:sldMaster xmlns:a="http://schemas.openxmlformats.org/drawingml/2006/main" xmlns:r="http://schemas.openxmlformats.org/officeDocument/2006/relationships" xmlns:p="http://schemas.openxmlformats.org/presentationml/2006/main">
   <p:cSld>
+    <p:bg>
+      <p:bgRef idx="1001">
+        <a:schemeClr val="bg1"/>
+      </p:bgRef>
+    </p:bg>
     <p:spTree>
       <p:nvGrpSpPr>
         <p:cNvPr id="1" name=""/>
@@ -2084,7 +1901,7 @@
           </a:prstGeom>
           <a:extLst>
             <a:ext uri="{C572A759-6A51-4108-AA02-DFA0A04FC94B}">
-              <ma14:wrappingTextBoxFlag xmlns:ma14="http://schemas.microsoft.com/office/mac/drawingml/2011/main" val="0"/>
+              <ma14:wrappingTextBoxFlag xmlns:ma14="http://schemas.microsoft.com/office/mac/drawingml/2011/main" xmlns="" val="0"/>
             </a:ext>
           </a:extLst>
         </p:spPr>
@@ -2105,8 +1922,8 @@
           <a:p>
             <a:pPr algn="l"/>
             <a:fld id="{F7021451-1387-4CA6-816F-3879F97B5CBC}" type="slidenum">
-              <a:rPr b="0" lang="en-US"/>
-              <a:t>null</a:t>
+              <a:rPr lang="en-US" b="0"/>
+              <a:t>‹#›</a:t>
             </a:fld>
             <a:endParaRPr lang="en-US"/>
           </a:p>
@@ -2412,7 +2229,7 @@
           <a:bodyPr wrap="square" lIns="0" tIns="0" rIns="0" bIns="0" rtlCol="0" anchor="t"/>
           <a:lstStyle/>
           <a:p>
-            <a:pPr indent="0" marL="0">
+            <a:pPr marL="0" indent="0">
               <a:buNone/>
             </a:pPr>
             <a:r>
@@ -2451,7 +2268,7 @@
           <a:bodyPr wrap="square" lIns="0" tIns="0" rIns="0" bIns="0" rtlCol="0" anchor="t"/>
           <a:lstStyle/>
           <a:p>
-            <a:pPr indent="0" marL="0">
+            <a:pPr marL="0" indent="0">
               <a:buNone/>
             </a:pPr>
             <a:r>
@@ -2490,7 +2307,7 @@
           <a:bodyPr wrap="square" lIns="0" tIns="0" rIns="0" bIns="0" rtlCol="0" anchor="t"/>
           <a:lstStyle/>
           <a:p>
-            <a:pPr indent="0" marL="0">
+            <a:pPr marL="0" indent="0">
               <a:buNone/>
             </a:pPr>
             <a:r>
@@ -2529,7 +2346,7 @@
           <a:bodyPr wrap="square" lIns="0" tIns="0" rIns="0" bIns="0" rtlCol="0" anchor="t"/>
           <a:lstStyle/>
           <a:p>
-            <a:pPr indent="0" marL="0">
+            <a:pPr marL="0" indent="0">
               <a:buNone/>
             </a:pPr>
             <a:r>
@@ -2568,7 +2385,7 @@
           <a:bodyPr wrap="square" lIns="0" tIns="0" rIns="0" bIns="0" rtlCol="0" anchor="t"/>
           <a:lstStyle/>
           <a:p>
-            <a:pPr indent="0" marL="0">
+            <a:pPr marL="0" indent="0">
               <a:buNone/>
             </a:pPr>
             <a:r>
@@ -2607,7 +2424,7 @@
           <a:bodyPr wrap="square" lIns="0" tIns="0" rIns="0" bIns="0" rtlCol="0" anchor="t"/>
           <a:lstStyle/>
           <a:p>
-            <a:pPr indent="0" marL="0">
+            <a:pPr marL="0" indent="0">
               <a:buNone/>
             </a:pPr>
             <a:r>
@@ -2646,7 +2463,7 @@
           <a:bodyPr wrap="square" lIns="0" tIns="0" rIns="0" bIns="0" rtlCol="0" anchor="t"/>
           <a:lstStyle/>
           <a:p>
-            <a:pPr indent="0" marL="0">
+            <a:pPr marL="0" indent="0">
               <a:buNone/>
             </a:pPr>
             <a:r>
@@ -2685,7 +2502,7 @@
           <a:bodyPr wrap="square" lIns="0" tIns="0" rIns="0" bIns="0" rtlCol="0" anchor="t"/>
           <a:lstStyle/>
           <a:p>
-            <a:pPr indent="0" marL="0">
+            <a:pPr marL="0" indent="0">
               <a:buNone/>
             </a:pPr>
             <a:r>
@@ -2724,7 +2541,7 @@
           <a:bodyPr wrap="square" lIns="0" tIns="0" rIns="0" bIns="0" rtlCol="0" anchor="t"/>
           <a:lstStyle/>
           <a:p>
-            <a:pPr indent="0" marL="0">
+            <a:pPr marL="0" indent="0">
               <a:buNone/>
             </a:pPr>
             <a:r>
@@ -2763,7 +2580,7 @@
           <a:bodyPr wrap="square" lIns="0" tIns="0" rIns="0" bIns="0" rtlCol="0" anchor="t"/>
           <a:lstStyle/>
           <a:p>
-            <a:pPr indent="0" marL="0">
+            <a:pPr marL="0" indent="0">
               <a:buNone/>
             </a:pPr>
             <a:r>
@@ -2775,39 +2592,9 @@
                 <a:ea typeface="Times New Roman" pitchFamily="34" charset="-122"/>
                 <a:cs typeface="Times New Roman" pitchFamily="34" charset="-120"/>
               </a:rPr>
-              <a:t>Supratik Bhowal  ·  IEM Kolkata  ·  with Apart Research</a:t>
+              <a:t>Supratik Bhowal  ·  with Apart Research</a:t>
             </a:r>
             <a:endParaRPr lang="en-US" sz="1500" dirty="0"/>
-          </a:p>
-        </p:txBody>
-      </p:sp>
-      <p:sp>
-        <p:nvSpPr>
-          <p:cNvPr id="13" name="Text 0"/>
-          <p:cNvSpPr/>
-          <p:nvPr>
-            <p:ph idx="100" type="title" hasCustomPrompt="1"/>
-          </p:nvPr>
-        </p:nvSpPr>
-        <p:spPr>
-          <a:xfrm>
-            <a:off x="548640" y="320040"/>
-            <a:ext cx="11064240" cy="822960"/>
-          </a:xfrm>
-          <a:prstGeom prst="rect">
-            <a:avLst/>
-          </a:prstGeom>
-          <a:noFill/>
-          <a:ln/>
-        </p:spPr>
-        <p:txBody>
-          <a:bodyPr wrap="square" rtlCol="0" anchor="ctr"/>
-          <a:lstStyle/>
-          <a:p>
-            <a:pPr algn="l" indent="0" marL="0">
-              <a:buNone/>
-            </a:pPr>
-            <a:endParaRPr lang="en-US" sz="3000" dirty="0"/>
           </a:p>
         </p:txBody>
       </p:sp>
@@ -2831,7 +2618,7 @@
           </a:prstGeom>
           <a:extLst>
             <a:ext uri="{C572A759-6A51-4108-AA02-DFA0A04FC94B}">
-              <ma14:wrappingTextBoxFlag xmlns:ma14="http://schemas.microsoft.com/office/mac/drawingml/2011/main" val="0"/>
+              <ma14:wrappingTextBoxFlag xmlns:ma14="http://schemas.microsoft.com/office/mac/drawingml/2011/main" xmlns="" val="0"/>
             </a:ext>
           </a:extLst>
         </p:spPr>
@@ -2852,7 +2639,7 @@
           <a:p>
             <a:pPr algn="l"/>
             <a:fld id="{F7021451-1387-4CA6-816F-3879F97B5CBC}" type="slidenum">
-              <a:rPr b="0" lang="en-US"/>
+              <a:rPr lang="en-US" b="0"/>
               <a:t>1</a:t>
             </a:fld>
             <a:endParaRPr lang="en-US"/>
@@ -2887,9 +2674,11 @@
       <p:sp>
         <p:nvSpPr>
           <p:cNvPr id="2" name="Text 1"/>
-          <p:cNvSpPr/>
+          <p:cNvSpPr>
+            <a:spLocks noGrp="1"/>
+          </p:cNvSpPr>
           <p:nvPr>
-            <p:ph idx="101" type="title" hasCustomPrompt="1"/>
+            <p:ph type="title" idx="101" hasCustomPrompt="1"/>
           </p:nvPr>
         </p:nvSpPr>
         <p:spPr>
@@ -2907,7 +2696,7 @@
           <a:bodyPr wrap="square" rtlCol="0" anchor="ctr"/>
           <a:lstStyle/>
           <a:p>
-            <a:pPr algn="l" indent="0" marL="0">
+            <a:pPr marL="0" indent="0" algn="l">
               <a:buNone/>
             </a:pPr>
             <a:r>
@@ -2973,7 +2762,7 @@
           <a:bodyPr wrap="square" lIns="0" tIns="0" rIns="0" bIns="0" rtlCol="0" anchor="t"/>
           <a:lstStyle/>
           <a:p>
-            <a:pPr indent="0" marL="0">
+            <a:pPr marL="0" indent="0">
               <a:buNone/>
             </a:pPr>
             <a:r>
@@ -3145,7 +2934,7 @@
           <a:bodyPr wrap="square" lIns="0" tIns="0" rIns="0" bIns="0" rtlCol="0" anchor="t"/>
           <a:lstStyle/>
           <a:p>
-            <a:pPr indent="0" marL="0">
+            <a:pPr marL="0" indent="0">
               <a:buNone/>
             </a:pPr>
             <a:r>
@@ -3269,7 +3058,7 @@
           <a:bodyPr wrap="square" lIns="0" tIns="0" rIns="0" bIns="0" rtlCol="0" anchor="t"/>
           <a:lstStyle/>
           <a:p>
-            <a:pPr indent="0" marL="0">
+            <a:pPr marL="0" indent="0">
               <a:buNone/>
             </a:pPr>
             <a:r>
@@ -3308,7 +3097,7 @@
           <a:bodyPr wrap="square" lIns="0" tIns="0" rIns="0" bIns="0" rtlCol="0" anchor="t"/>
           <a:lstStyle/>
           <a:p>
-            <a:pPr indent="0" marL="0">
+            <a:pPr marL="0" indent="0">
               <a:buNone/>
             </a:pPr>
             <a:r>
@@ -3319,7 +3108,7 @@
                 <a:latin typeface="Times New Roman" pitchFamily="34" charset="0"/>
                 <a:ea typeface="Times New Roman" pitchFamily="34" charset="-122"/>
                 <a:cs typeface="Times New Roman" pitchFamily="34" charset="-120"/>
-                <a:hlinkClick r:id="rId1" invalidUrl="" action="" tgtFrame="" tooltip="" history="1" highlightClick="0" endSnd="0">
+                <a:hlinkClick r:id="rId3">
                   <a:extLst>
                     <a:ext uri="{A12FA001-AC4F-418D-AE19-62706E023703}">
                       <ahyp:hlinkClr xmlns:ahyp="http://schemas.microsoft.com/office/drawing/2018/hyperlinkcolor" val="tx"/>
@@ -3353,7 +3142,7 @@
           </a:prstGeom>
           <a:extLst>
             <a:ext uri="{C572A759-6A51-4108-AA02-DFA0A04FC94B}">
-              <ma14:wrappingTextBoxFlag xmlns:ma14="http://schemas.microsoft.com/office/mac/drawingml/2011/main" val="0"/>
+              <ma14:wrappingTextBoxFlag xmlns:ma14="http://schemas.microsoft.com/office/mac/drawingml/2011/main" xmlns="" val="0"/>
             </a:ext>
           </a:extLst>
         </p:spPr>
@@ -3374,7 +3163,7 @@
           <a:p>
             <a:pPr algn="l"/>
             <a:fld id="{F7021451-1387-4CA6-816F-3879F97B5CBC}" type="slidenum">
-              <a:rPr b="0" lang="en-US"/>
+              <a:rPr lang="en-US" b="0"/>
               <a:t>10</a:t>
             </a:fld>
             <a:endParaRPr lang="en-US"/>
@@ -3409,9 +3198,11 @@
       <p:sp>
         <p:nvSpPr>
           <p:cNvPr id="2" name="Text 1"/>
-          <p:cNvSpPr/>
+          <p:cNvSpPr>
+            <a:spLocks noGrp="1"/>
+          </p:cNvSpPr>
           <p:nvPr>
-            <p:ph idx="101" type="title" hasCustomPrompt="1"/>
+            <p:ph type="title" idx="101" hasCustomPrompt="1"/>
           </p:nvPr>
         </p:nvSpPr>
         <p:spPr>
@@ -3429,7 +3220,7 @@
           <a:bodyPr wrap="square" rtlCol="0" anchor="ctr"/>
           <a:lstStyle/>
           <a:p>
-            <a:pPr algn="l" indent="0" marL="0">
+            <a:pPr marL="0" indent="0" algn="l">
               <a:buNone/>
             </a:pPr>
             <a:r>
@@ -3468,7 +3259,7 @@
           <a:bodyPr wrap="square" lIns="0" tIns="0" rIns="0" bIns="0" rtlCol="0" anchor="t"/>
           <a:lstStyle/>
           <a:p>
-            <a:pPr indent="0" marL="0">
+            <a:pPr marL="0" indent="0">
               <a:buNone/>
             </a:pPr>
             <a:r>
@@ -3485,7 +3276,7 @@
             <a:endParaRPr lang="en-US" sz="1800" dirty="0"/>
           </a:p>
           <a:p>
-            <a:pPr indent="0" marL="0">
+            <a:pPr marL="0" indent="0">
               <a:buNone/>
             </a:pPr>
             <a:r>
@@ -3502,7 +3293,7 @@
             <a:endParaRPr lang="en-US" sz="1800" dirty="0"/>
           </a:p>
           <a:p>
-            <a:pPr indent="0" marL="0">
+            <a:pPr marL="0" indent="0">
               <a:buNone/>
             </a:pPr>
             <a:r>
@@ -3519,7 +3310,7 @@
             <a:endParaRPr lang="en-US" sz="1800" dirty="0"/>
           </a:p>
           <a:p>
-            <a:pPr indent="0" marL="0">
+            <a:pPr marL="0" indent="0">
               <a:buNone/>
             </a:pPr>
             <a:r>
@@ -3536,7 +3327,7 @@
             <a:endParaRPr lang="en-US" sz="1800" dirty="0"/>
           </a:p>
           <a:p>
-            <a:pPr indent="0" marL="0">
+            <a:pPr marL="0" indent="0">
               <a:buNone/>
             </a:pPr>
             <a:r>
@@ -3627,7 +3418,7 @@
           <a:bodyPr wrap="square" lIns="0" tIns="0" rIns="0" bIns="0" rtlCol="0" anchor="ctr"/>
           <a:lstStyle/>
           <a:p>
-            <a:pPr algn="ctr" indent="0" marL="0">
+            <a:pPr marL="0" indent="0" algn="ctr">
               <a:buNone/>
             </a:pPr>
             <a:r>
@@ -3666,7 +3457,7 @@
           <a:bodyPr wrap="square" lIns="0" tIns="0" rIns="0" bIns="0" rtlCol="0" anchor="t"/>
           <a:lstStyle/>
           <a:p>
-            <a:pPr indent="0" marL="0">
+            <a:pPr marL="0" indent="0">
               <a:buNone/>
             </a:pPr>
             <a:r>
@@ -3705,7 +3496,7 @@
           <a:bodyPr wrap="square" lIns="0" tIns="0" rIns="0" bIns="0" rtlCol="0" anchor="t"/>
           <a:lstStyle/>
           <a:p>
-            <a:pPr indent="0" marL="0">
+            <a:pPr marL="0" indent="0">
               <a:buNone/>
             </a:pPr>
             <a:r>
@@ -3796,7 +3587,7 @@
           <a:bodyPr wrap="square" lIns="0" tIns="0" rIns="0" bIns="0" rtlCol="0" anchor="ctr"/>
           <a:lstStyle/>
           <a:p>
-            <a:pPr algn="ctr" indent="0" marL="0">
+            <a:pPr marL="0" indent="0" algn="ctr">
               <a:buNone/>
             </a:pPr>
             <a:r>
@@ -3835,7 +3626,7 @@
           <a:bodyPr wrap="square" lIns="0" tIns="0" rIns="0" bIns="0" rtlCol="0" anchor="t"/>
           <a:lstStyle/>
           <a:p>
-            <a:pPr indent="0" marL="0">
+            <a:pPr marL="0" indent="0">
               <a:buNone/>
             </a:pPr>
             <a:r>
@@ -3874,7 +3665,7 @@
           <a:bodyPr wrap="square" lIns="0" tIns="0" rIns="0" bIns="0" rtlCol="0" anchor="t"/>
           <a:lstStyle/>
           <a:p>
-            <a:pPr indent="0" marL="0">
+            <a:pPr marL="0" indent="0">
               <a:buNone/>
             </a:pPr>
             <a:r>
@@ -3965,7 +3756,7 @@
           <a:bodyPr wrap="square" lIns="0" tIns="0" rIns="0" bIns="0" rtlCol="0" anchor="ctr"/>
           <a:lstStyle/>
           <a:p>
-            <a:pPr algn="ctr" indent="0" marL="0">
+            <a:pPr marL="0" indent="0" algn="ctr">
               <a:buNone/>
             </a:pPr>
             <a:r>
@@ -4004,7 +3795,7 @@
           <a:bodyPr wrap="square" lIns="0" tIns="0" rIns="0" bIns="0" rtlCol="0" anchor="t"/>
           <a:lstStyle/>
           <a:p>
-            <a:pPr indent="0" marL="0">
+            <a:pPr marL="0" indent="0">
               <a:buNone/>
             </a:pPr>
             <a:r>
@@ -4043,7 +3834,7 @@
           <a:bodyPr wrap="square" lIns="0" tIns="0" rIns="0" bIns="0" rtlCol="0" anchor="t"/>
           <a:lstStyle/>
           <a:p>
-            <a:pPr indent="0" marL="0">
+            <a:pPr marL="0" indent="0">
               <a:buNone/>
             </a:pPr>
             <a:r>
@@ -4081,7 +3872,7 @@
           </a:prstGeom>
           <a:extLst>
             <a:ext uri="{C572A759-6A51-4108-AA02-DFA0A04FC94B}">
-              <ma14:wrappingTextBoxFlag xmlns:ma14="http://schemas.microsoft.com/office/mac/drawingml/2011/main" val="0"/>
+              <ma14:wrappingTextBoxFlag xmlns:ma14="http://schemas.microsoft.com/office/mac/drawingml/2011/main" xmlns="" val="0"/>
             </a:ext>
           </a:extLst>
         </p:spPr>
@@ -4102,7 +3893,7 @@
           <a:p>
             <a:pPr algn="l"/>
             <a:fld id="{F7021451-1387-4CA6-816F-3879F97B5CBC}" type="slidenum">
-              <a:rPr b="0" lang="en-US"/>
+              <a:rPr lang="en-US" b="0"/>
               <a:t>2</a:t>
             </a:fld>
             <a:endParaRPr lang="en-US"/>
@@ -4137,9 +3928,11 @@
       <p:sp>
         <p:nvSpPr>
           <p:cNvPr id="2" name="Text 1"/>
-          <p:cNvSpPr/>
+          <p:cNvSpPr>
+            <a:spLocks noGrp="1"/>
+          </p:cNvSpPr>
           <p:nvPr>
-            <p:ph idx="101" type="title" hasCustomPrompt="1"/>
+            <p:ph type="title" idx="101" hasCustomPrompt="1"/>
           </p:nvPr>
         </p:nvSpPr>
         <p:spPr>
@@ -4157,7 +3950,7 @@
           <a:bodyPr wrap="square" rtlCol="0" anchor="ctr"/>
           <a:lstStyle/>
           <a:p>
-            <a:pPr algn="l" indent="0" marL="0">
+            <a:pPr marL="0" indent="0" algn="l">
               <a:buNone/>
             </a:pPr>
             <a:r>
@@ -4196,7 +3989,7 @@
           <a:bodyPr wrap="square" lIns="0" tIns="0" rIns="0" bIns="0" rtlCol="0" anchor="t"/>
           <a:lstStyle/>
           <a:p>
-            <a:pPr indent="0" marL="0">
+            <a:pPr marL="0" indent="0">
               <a:spcAft>
                 <a:spcPts val="600"/>
               </a:spcAft>
@@ -4213,14 +4006,28 @@
               </a:rPr>
               <a:t>Market: </a:t>
             </a:r>
-            <a:pPr indent="0" marL="0">
+            <a:r>
+              <a:rPr lang="en-US" sz="1800" dirty="0">
+                <a:solidFill>
+                  <a:srgbClr val="2B2F36"/>
+                </a:solidFill>
+                <a:latin typeface="Times New Roman" pitchFamily="34" charset="0"/>
+                <a:ea typeface="Times New Roman" pitchFamily="34" charset="-122"/>
+                <a:cs typeface="Times New Roman" pitchFamily="34" charset="-120"/>
+              </a:rPr>
+              <a:t>two firms sell similar products; buyers choose by price (logit Bertrand duopoly, Calvano et al. 2020).</a:t>
+            </a:r>
+            <a:endParaRPr lang="en-US" sz="1800" dirty="0"/>
+          </a:p>
+          <a:p>
+            <a:pPr marL="0" indent="0">
               <a:spcAft>
                 <a:spcPts val="600"/>
               </a:spcAft>
               <a:buNone/>
             </a:pPr>
             <a:r>
-              <a:rPr lang="en-US" sz="1800" dirty="0">
+              <a:rPr lang="en-US" sz="800" dirty="0">
                 <a:solidFill>
                   <a:srgbClr val="2B2F36"/>
                 </a:solidFill>
@@ -4228,19 +4035,19 @@
                 <a:ea typeface="Times New Roman" pitchFamily="34" charset="-122"/>
                 <a:cs typeface="Times New Roman" pitchFamily="34" charset="-120"/>
               </a:rPr>
-              <a:t>two firms sell similar products; buyers choose by price (logit Bertrand duopoly, Calvano et al. 2020).</a:t>
+              <a:t> </a:t>
             </a:r>
             <a:endParaRPr lang="en-US" sz="1800" dirty="0"/>
           </a:p>
           <a:p>
-            <a:pPr indent="0" marL="0">
+            <a:pPr marL="0" indent="0">
               <a:spcAft>
                 <a:spcPts val="600"/>
               </a:spcAft>
               <a:buNone/>
             </a:pPr>
             <a:r>
-              <a:rPr lang="en-US" sz="800" dirty="0">
+              <a:rPr lang="en-US" sz="1800" b="1" dirty="0">
                 <a:solidFill>
                   <a:srgbClr val="2B2F36"/>
                 </a:solidFill>
@@ -4248,19 +4055,30 @@
                 <a:ea typeface="Times New Roman" pitchFamily="34" charset="-122"/>
                 <a:cs typeface="Times New Roman" pitchFamily="34" charset="-120"/>
               </a:rPr>
-              <a:t> </a:t>
+              <a:t>Agents: </a:t>
+            </a:r>
+            <a:r>
+              <a:rPr lang="en-US" sz="1800" dirty="0">
+                <a:solidFill>
+                  <a:srgbClr val="2B2F36"/>
+                </a:solidFill>
+                <a:latin typeface="Times New Roman" pitchFamily="34" charset="0"/>
+                <a:ea typeface="Times New Roman" pitchFamily="34" charset="-122"/>
+                <a:cs typeface="Times New Roman" pitchFamily="34" charset="-120"/>
+              </a:rPr>
+              <a:t>each firm is an open LLM. Each round it sees the rules, its last 30 rounds and its notes, and answers with a price and new notes. The prompt never mentions collusion.</a:t>
             </a:r>
             <a:endParaRPr lang="en-US" sz="1800" dirty="0"/>
           </a:p>
           <a:p>
-            <a:pPr indent="0" marL="0">
+            <a:pPr marL="0" indent="0">
               <a:spcAft>
                 <a:spcPts val="600"/>
               </a:spcAft>
               <a:buNone/>
             </a:pPr>
             <a:r>
-              <a:rPr lang="en-US" sz="1800" b="1" dirty="0">
+              <a:rPr lang="en-US" sz="800" dirty="0">
                 <a:solidFill>
                   <a:srgbClr val="2B2F36"/>
                 </a:solidFill>
@@ -4268,16 +4086,19 @@
                 <a:ea typeface="Times New Roman" pitchFamily="34" charset="-122"/>
                 <a:cs typeface="Times New Roman" pitchFamily="34" charset="-120"/>
               </a:rPr>
-              <a:t>Agents: </a:t>
-            </a:r>
-            <a:pPr indent="0" marL="0">
+              <a:t> </a:t>
+            </a:r>
+            <a:endParaRPr lang="en-US" sz="1800" dirty="0"/>
+          </a:p>
+          <a:p>
+            <a:pPr marL="0" indent="0">
               <a:spcAft>
                 <a:spcPts val="600"/>
               </a:spcAft>
               <a:buNone/>
             </a:pPr>
             <a:r>
-              <a:rPr lang="en-US" sz="1800" dirty="0">
+              <a:rPr lang="en-US" sz="1800" b="1" dirty="0">
                 <a:solidFill>
                   <a:srgbClr val="2B2F36"/>
                 </a:solidFill>
@@ -4285,54 +4106,8 @@
                 <a:ea typeface="Times New Roman" pitchFamily="34" charset="-122"/>
                 <a:cs typeface="Times New Roman" pitchFamily="34" charset="-120"/>
               </a:rPr>
-              <a:t>each firm is an open LLM. Each round it sees the rules, its last 30 rounds and its notes, and answers with a price and new notes. The prompt never mentions collusion.</a:t>
-            </a:r>
-            <a:endParaRPr lang="en-US" sz="1800" dirty="0"/>
-          </a:p>
-          <a:p>
-            <a:pPr indent="0" marL="0">
-              <a:spcAft>
-                <a:spcPts val="600"/>
-              </a:spcAft>
-              <a:buNone/>
-            </a:pPr>
-            <a:r>
-              <a:rPr lang="en-US" sz="800" dirty="0">
-                <a:solidFill>
-                  <a:srgbClr val="2B2F36"/>
-                </a:solidFill>
-                <a:latin typeface="Times New Roman" pitchFamily="34" charset="0"/>
-                <a:ea typeface="Times New Roman" pitchFamily="34" charset="-122"/>
-                <a:cs typeface="Times New Roman" pitchFamily="34" charset="-120"/>
-              </a:rPr>
-              <a:t> </a:t>
-            </a:r>
-            <a:endParaRPr lang="en-US" sz="1800" dirty="0"/>
-          </a:p>
-          <a:p>
-            <a:pPr indent="0" marL="0">
-              <a:spcAft>
-                <a:spcPts val="600"/>
-              </a:spcAft>
-              <a:buNone/>
-            </a:pPr>
-            <a:r>
-              <a:rPr lang="en-US" sz="1800" b="1" dirty="0">
-                <a:solidFill>
-                  <a:srgbClr val="2B2F36"/>
-                </a:solidFill>
-                <a:latin typeface="Times New Roman" pitchFamily="34" charset="0"/>
-                <a:ea typeface="Times New Roman" pitchFamily="34" charset="-122"/>
-                <a:cs typeface="Times New Roman" pitchFamily="34" charset="-120"/>
-              </a:rPr>
               <a:t>Models: </a:t>
             </a:r>
-            <a:pPr indent="0" marL="0">
-              <a:spcAft>
-                <a:spcPts val="600"/>
-              </a:spcAft>
-              <a:buNone/>
-            </a:pPr>
             <a:r>
               <a:rPr lang="en-US" sz="1800" dirty="0">
                 <a:solidFill>
@@ -4396,7 +4171,7 @@
           <a:bodyPr wrap="square" lIns="0" tIns="0" rIns="0" bIns="0" rtlCol="0" anchor="t"/>
           <a:lstStyle/>
           <a:p>
-            <a:pPr indent="0" marL="0">
+            <a:pPr marL="0" indent="0">
               <a:buNone/>
             </a:pPr>
             <a:r>
@@ -4510,7 +4285,7 @@
           <a:bodyPr wrap="square" lIns="0" tIns="0" rIns="0" bIns="0" rtlCol="0" anchor="t"/>
           <a:lstStyle/>
           <a:p>
-            <a:pPr indent="0" marL="0">
+            <a:pPr marL="0" indent="0">
               <a:buNone/>
             </a:pPr>
             <a:r>
@@ -4527,7 +4302,7 @@
             <a:endParaRPr lang="en-US" sz="1400" dirty="0"/>
           </a:p>
           <a:p>
-            <a:pPr indent="0" marL="0">
+            <a:pPr marL="0" indent="0">
               <a:buNone/>
             </a:pPr>
             <a:r>
@@ -4566,7 +4341,7 @@
           <a:bodyPr wrap="square" lIns="0" tIns="0" rIns="0" bIns="0" rtlCol="0" anchor="t"/>
           <a:lstStyle/>
           <a:p>
-            <a:pPr algn="r" indent="0" marL="0">
+            <a:pPr marL="0" indent="0" algn="r">
               <a:buNone/>
             </a:pPr>
             <a:r>
@@ -4583,7 +4358,7 @@
             <a:endParaRPr lang="en-US" sz="1400" dirty="0"/>
           </a:p>
           <a:p>
-            <a:pPr algn="r" indent="0" marL="0">
+            <a:pPr marL="0" indent="0" algn="r">
               <a:buNone/>
             </a:pPr>
             <a:r>
@@ -4622,7 +4397,7 @@
           <a:bodyPr wrap="square" lIns="0" tIns="0" rIns="0" bIns="0" rtlCol="0" anchor="t"/>
           <a:lstStyle/>
           <a:p>
-            <a:pPr indent="0" marL="0">
+            <a:pPr marL="0" indent="0">
               <a:buNone/>
             </a:pPr>
             <a:r>
@@ -4660,7 +4435,7 @@
           </a:prstGeom>
           <a:extLst>
             <a:ext uri="{C572A759-6A51-4108-AA02-DFA0A04FC94B}">
-              <ma14:wrappingTextBoxFlag xmlns:ma14="http://schemas.microsoft.com/office/mac/drawingml/2011/main" val="0"/>
+              <ma14:wrappingTextBoxFlag xmlns:ma14="http://schemas.microsoft.com/office/mac/drawingml/2011/main" xmlns="" val="0"/>
             </a:ext>
           </a:extLst>
         </p:spPr>
@@ -4681,7 +4456,7 @@
           <a:p>
             <a:pPr algn="l"/>
             <a:fld id="{F7021451-1387-4CA6-816F-3879F97B5CBC}" type="slidenum">
-              <a:rPr b="0" lang="en-US"/>
+              <a:rPr lang="en-US" b="0"/>
               <a:t>3</a:t>
             </a:fld>
             <a:endParaRPr lang="en-US"/>
@@ -4716,9 +4491,11 @@
       <p:sp>
         <p:nvSpPr>
           <p:cNvPr id="2" name="Text 1"/>
-          <p:cNvSpPr/>
+          <p:cNvSpPr>
+            <a:spLocks noGrp="1"/>
+          </p:cNvSpPr>
           <p:nvPr>
-            <p:ph idx="101" type="title" hasCustomPrompt="1"/>
+            <p:ph type="title" idx="101" hasCustomPrompt="1"/>
           </p:nvPr>
         </p:nvSpPr>
         <p:spPr>
@@ -4736,7 +4513,7 @@
           <a:bodyPr wrap="square" rtlCol="0" anchor="ctr"/>
           <a:lstStyle/>
           <a:p>
-            <a:pPr algn="l" indent="0" marL="0">
+            <a:pPr marL="0" indent="0" algn="l">
               <a:buNone/>
             </a:pPr>
             <a:r>
@@ -4827,7 +4604,7 @@
           <a:bodyPr wrap="square" lIns="0" tIns="0" rIns="0" bIns="0" rtlCol="0" anchor="ctr"/>
           <a:lstStyle/>
           <a:p>
-            <a:pPr algn="ctr" indent="0" marL="0">
+            <a:pPr marL="0" indent="0" algn="ctr">
               <a:buNone/>
             </a:pPr>
             <a:r>
@@ -4866,7 +4643,7 @@
           <a:bodyPr wrap="square" lIns="0" tIns="0" rIns="0" bIns="0" rtlCol="0" anchor="t"/>
           <a:lstStyle/>
           <a:p>
-            <a:pPr indent="0" marL="0">
+            <a:pPr marL="0" indent="0">
               <a:buNone/>
             </a:pPr>
             <a:r>
@@ -4905,7 +4682,7 @@
           <a:bodyPr wrap="square" lIns="0" tIns="0" rIns="0" bIns="0" rtlCol="0" anchor="t"/>
           <a:lstStyle/>
           <a:p>
-            <a:pPr indent="0" marL="0">
+            <a:pPr marL="0" indent="0">
               <a:buNone/>
             </a:pPr>
             <a:r>
@@ -4996,7 +4773,7 @@
           <a:bodyPr wrap="square" lIns="0" tIns="0" rIns="0" bIns="0" rtlCol="0" anchor="ctr"/>
           <a:lstStyle/>
           <a:p>
-            <a:pPr algn="ctr" indent="0" marL="0">
+            <a:pPr marL="0" indent="0" algn="ctr">
               <a:buNone/>
             </a:pPr>
             <a:r>
@@ -5035,7 +4812,7 @@
           <a:bodyPr wrap="square" lIns="0" tIns="0" rIns="0" bIns="0" rtlCol="0" anchor="t"/>
           <a:lstStyle/>
           <a:p>
-            <a:pPr indent="0" marL="0">
+            <a:pPr marL="0" indent="0">
               <a:buNone/>
             </a:pPr>
             <a:r>
@@ -5074,7 +4851,7 @@
           <a:bodyPr wrap="square" lIns="0" tIns="0" rIns="0" bIns="0" rtlCol="0" anchor="t"/>
           <a:lstStyle/>
           <a:p>
-            <a:pPr indent="0" marL="0">
+            <a:pPr marL="0" indent="0">
               <a:buNone/>
             </a:pPr>
             <a:r>
@@ -5165,7 +4942,7 @@
           <a:bodyPr wrap="square" lIns="0" tIns="0" rIns="0" bIns="0" rtlCol="0" anchor="ctr"/>
           <a:lstStyle/>
           <a:p>
-            <a:pPr algn="ctr" indent="0" marL="0">
+            <a:pPr marL="0" indent="0" algn="ctr">
               <a:buNone/>
             </a:pPr>
             <a:r>
@@ -5204,7 +4981,7 @@
           <a:bodyPr wrap="square" lIns="0" tIns="0" rIns="0" bIns="0" rtlCol="0" anchor="t"/>
           <a:lstStyle/>
           <a:p>
-            <a:pPr indent="0" marL="0">
+            <a:pPr marL="0" indent="0">
               <a:buNone/>
             </a:pPr>
             <a:r>
@@ -5243,7 +5020,7 @@
           <a:bodyPr wrap="square" lIns="0" tIns="0" rIns="0" bIns="0" rtlCol="0" anchor="t"/>
           <a:lstStyle/>
           <a:p>
-            <a:pPr indent="0" marL="0">
+            <a:pPr marL="0" indent="0">
               <a:buNone/>
             </a:pPr>
             <a:r>
@@ -5334,7 +5111,7 @@
           <a:bodyPr wrap="square" lIns="0" tIns="0" rIns="0" bIns="0" rtlCol="0" anchor="ctr"/>
           <a:lstStyle/>
           <a:p>
-            <a:pPr algn="ctr" indent="0" marL="0">
+            <a:pPr marL="0" indent="0" algn="ctr">
               <a:buNone/>
             </a:pPr>
             <a:r>
@@ -5373,7 +5150,7 @@
           <a:bodyPr wrap="square" lIns="0" tIns="0" rIns="0" bIns="0" rtlCol="0" anchor="t"/>
           <a:lstStyle/>
           <a:p>
-            <a:pPr indent="0" marL="0">
+            <a:pPr marL="0" indent="0">
               <a:buNone/>
             </a:pPr>
             <a:r>
@@ -5412,7 +5189,7 @@
           <a:bodyPr wrap="square" lIns="0" tIns="0" rIns="0" bIns="0" rtlCol="0" anchor="t"/>
           <a:lstStyle/>
           <a:p>
-            <a:pPr indent="0" marL="0">
+            <a:pPr marL="0" indent="0">
               <a:buNone/>
             </a:pPr>
             <a:r>
@@ -5478,7 +5255,7 @@
           <a:bodyPr wrap="square" lIns="0" tIns="0" rIns="0" bIns="0" rtlCol="0" anchor="t"/>
           <a:lstStyle/>
           <a:p>
-            <a:pPr indent="0" marL="0">
+            <a:pPr marL="0" indent="0">
               <a:buNone/>
             </a:pPr>
             <a:r>
@@ -5517,7 +5294,7 @@
           <a:bodyPr wrap="square" lIns="0" tIns="0" rIns="0" bIns="0" rtlCol="0" anchor="t"/>
           <a:lstStyle/>
           <a:p>
-            <a:pPr indent="0" marL="0">
+            <a:pPr marL="0" indent="0">
               <a:buNone/>
             </a:pPr>
             <a:r>
@@ -5583,7 +5360,7 @@
           <a:bodyPr wrap="square" lIns="0" tIns="0" rIns="0" bIns="0" rtlCol="0" anchor="t"/>
           <a:lstStyle/>
           <a:p>
-            <a:pPr indent="0" marL="0">
+            <a:pPr marL="0" indent="0">
               <a:buNone/>
             </a:pPr>
             <a:r>
@@ -5622,7 +5399,7 @@
           <a:bodyPr wrap="square" lIns="0" tIns="0" rIns="0" bIns="0" rtlCol="0" anchor="t"/>
           <a:lstStyle/>
           <a:p>
-            <a:pPr indent="0" marL="0">
+            <a:pPr marL="0" indent="0">
               <a:buNone/>
             </a:pPr>
             <a:r>
@@ -5688,7 +5465,7 @@
           <a:bodyPr wrap="square" lIns="0" tIns="0" rIns="0" bIns="0" rtlCol="0" anchor="t"/>
           <a:lstStyle/>
           <a:p>
-            <a:pPr indent="0" marL="0">
+            <a:pPr marL="0" indent="0">
               <a:buNone/>
             </a:pPr>
             <a:r>
@@ -5727,7 +5504,7 @@
           <a:bodyPr wrap="square" lIns="0" tIns="0" rIns="0" bIns="0" rtlCol="0" anchor="t"/>
           <a:lstStyle/>
           <a:p>
-            <a:pPr indent="0" marL="0">
+            <a:pPr marL="0" indent="0">
               <a:buNone/>
             </a:pPr>
             <a:r>
@@ -5793,7 +5570,7 @@
           <a:bodyPr wrap="square" lIns="0" tIns="0" rIns="0" bIns="0" rtlCol="0" anchor="t"/>
           <a:lstStyle/>
           <a:p>
-            <a:pPr indent="0" marL="0">
+            <a:pPr marL="0" indent="0">
               <a:buNone/>
             </a:pPr>
             <a:r>
@@ -5832,7 +5609,7 @@
           <a:bodyPr wrap="square" lIns="0" tIns="0" rIns="0" bIns="0" rtlCol="0" anchor="t"/>
           <a:lstStyle/>
           <a:p>
-            <a:pPr indent="0" marL="0">
+            <a:pPr marL="0" indent="0">
               <a:buNone/>
             </a:pPr>
             <a:r>
@@ -5898,7 +5675,7 @@
           <a:bodyPr wrap="square" lIns="0" tIns="0" rIns="0" bIns="0" rtlCol="0" anchor="t"/>
           <a:lstStyle/>
           <a:p>
-            <a:pPr indent="0" marL="0">
+            <a:pPr marL="0" indent="0">
               <a:buNone/>
             </a:pPr>
             <a:r>
@@ -5937,7 +5714,7 @@
           <a:bodyPr wrap="square" lIns="0" tIns="0" rIns="0" bIns="0" rtlCol="0" anchor="t"/>
           <a:lstStyle/>
           <a:p>
-            <a:pPr indent="0" marL="0">
+            <a:pPr marL="0" indent="0">
               <a:buNone/>
             </a:pPr>
             <a:r>
@@ -6003,7 +5780,7 @@
           <a:bodyPr wrap="square" lIns="0" tIns="0" rIns="0" bIns="0" rtlCol="0" anchor="t"/>
           <a:lstStyle/>
           <a:p>
-            <a:pPr indent="0" marL="0">
+            <a:pPr marL="0" indent="0">
               <a:buNone/>
             </a:pPr>
             <a:r>
@@ -6042,7 +5819,7 @@
           <a:bodyPr wrap="square" lIns="0" tIns="0" rIns="0" bIns="0" rtlCol="0" anchor="t"/>
           <a:lstStyle/>
           <a:p>
-            <a:pPr indent="0" marL="0">
+            <a:pPr marL="0" indent="0">
               <a:buNone/>
             </a:pPr>
             <a:r>
@@ -6108,7 +5885,7 @@
           <a:bodyPr wrap="square" lIns="0" tIns="0" rIns="0" bIns="0" rtlCol="0" anchor="t"/>
           <a:lstStyle/>
           <a:p>
-            <a:pPr indent="0" marL="0">
+            <a:pPr marL="0" indent="0">
               <a:buNone/>
             </a:pPr>
             <a:r>
@@ -6147,7 +5924,7 @@
           <a:bodyPr wrap="square" lIns="0" tIns="0" rIns="0" bIns="0" rtlCol="0" anchor="t"/>
           <a:lstStyle/>
           <a:p>
-            <a:pPr indent="0" marL="0">
+            <a:pPr marL="0" indent="0">
               <a:buNone/>
             </a:pPr>
             <a:r>
@@ -6213,7 +5990,7 @@
           <a:bodyPr wrap="square" lIns="0" tIns="0" rIns="0" bIns="0" rtlCol="0" anchor="t"/>
           <a:lstStyle/>
           <a:p>
-            <a:pPr indent="0" marL="0">
+            <a:pPr marL="0" indent="0">
               <a:buNone/>
             </a:pPr>
             <a:r>
@@ -6252,7 +6029,7 @@
           <a:bodyPr wrap="square" lIns="0" tIns="0" rIns="0" bIns="0" rtlCol="0" anchor="t"/>
           <a:lstStyle/>
           <a:p>
-            <a:pPr indent="0" marL="0">
+            <a:pPr marL="0" indent="0">
               <a:buNone/>
             </a:pPr>
             <a:r>
@@ -6272,7 +6049,7 @@
       </p:sp>
       <p:sp>
         <p:nvSpPr>
-          <p:cNvPr id="25" name="Slide Number Placeholder 0"/>
+          <p:cNvPr id="47" name="Slide Number Placeholder 0"/>
           <p:cNvSpPr>
             <a:spLocks noGrp="1"/>
           </p:cNvSpPr>
@@ -6290,7 +6067,7 @@
           </a:prstGeom>
           <a:extLst>
             <a:ext uri="{C572A759-6A51-4108-AA02-DFA0A04FC94B}">
-              <ma14:wrappingTextBoxFlag xmlns:ma14="http://schemas.microsoft.com/office/mac/drawingml/2011/main" val="0"/>
+              <ma14:wrappingTextBoxFlag xmlns:ma14="http://schemas.microsoft.com/office/mac/drawingml/2011/main" xmlns="" val="0"/>
             </a:ext>
           </a:extLst>
         </p:spPr>
@@ -6311,7 +6088,7 @@
           <a:p>
             <a:pPr algn="l"/>
             <a:fld id="{F7021451-1387-4CA6-816F-3879F97B5CBC}" type="slidenum">
-              <a:rPr b="0" lang="en-US"/>
+              <a:rPr lang="en-US" b="0"/>
               <a:t>4</a:t>
             </a:fld>
             <a:endParaRPr lang="en-US"/>
@@ -6346,9 +6123,11 @@
       <p:sp>
         <p:nvSpPr>
           <p:cNvPr id="2" name="Text 1"/>
-          <p:cNvSpPr/>
+          <p:cNvSpPr>
+            <a:spLocks noGrp="1"/>
+          </p:cNvSpPr>
           <p:nvPr>
-            <p:ph idx="101" type="title" hasCustomPrompt="1"/>
+            <p:ph type="title" idx="101" hasCustomPrompt="1"/>
           </p:nvPr>
         </p:nvSpPr>
         <p:spPr>
@@ -6366,7 +6145,7 @@
           <a:bodyPr wrap="square" rtlCol="0" anchor="ctr"/>
           <a:lstStyle/>
           <a:p>
-            <a:pPr algn="l" indent="0" marL="0">
+            <a:pPr marL="0" indent="0" algn="l">
               <a:buNone/>
             </a:pPr>
             <a:r>
@@ -6386,7 +6165,7 @@
       </p:sp>
       <p:graphicFrame>
         <p:nvGraphicFramePr>
-          <p:cNvPr id="3" name="Chart 0" descr=""/>
+          <p:cNvPr id="3" name="Chart 0"/>
           <p:cNvGraphicFramePr/>
           <p:nvPr/>
         </p:nvGraphicFramePr>
@@ -6394,9 +6173,9 @@
           <a:off x="548640" y="1325880"/>
           <a:ext cx="6949440" cy="4846320"/>
         </p:xfrm>
-        <a:graphic xmlns:a="http://schemas.openxmlformats.org/drawingml/2006/main">
+        <a:graphic>
           <a:graphicData uri="http://schemas.openxmlformats.org/drawingml/2006/chart">
-            <c:chart xmlns:c="http://schemas.openxmlformats.org/drawingml/2006/chart" r:id="rId1"/>
+            <c:chart xmlns:c="http://schemas.openxmlformats.org/drawingml/2006/chart" xmlns:r="http://schemas.openxmlformats.org/officeDocument/2006/relationships" r:id="rId3"/>
           </a:graphicData>
         </a:graphic>
       </p:graphicFrame>
@@ -6448,7 +6227,7 @@
           <a:bodyPr wrap="square" lIns="0" tIns="0" rIns="0" bIns="0" rtlCol="0" anchor="t"/>
           <a:lstStyle/>
           <a:p>
-            <a:pPr indent="0" marL="0">
+            <a:pPr marL="0" indent="0">
               <a:buNone/>
             </a:pPr>
             <a:r>
@@ -6487,7 +6266,7 @@
           <a:bodyPr wrap="square" lIns="0" tIns="0" rIns="0" bIns="0" rtlCol="0" anchor="t"/>
           <a:lstStyle/>
           <a:p>
-            <a:pPr indent="0" marL="0">
+            <a:pPr marL="0" indent="0">
               <a:buNone/>
             </a:pPr>
             <a:r>
@@ -6553,7 +6332,7 @@
           <a:bodyPr wrap="square" lIns="0" tIns="0" rIns="0" bIns="0" rtlCol="0" anchor="t"/>
           <a:lstStyle/>
           <a:p>
-            <a:pPr indent="0" marL="0">
+            <a:pPr marL="0" indent="0">
               <a:buNone/>
             </a:pPr>
             <a:r>
@@ -6592,7 +6371,7 @@
           <a:bodyPr wrap="square" lIns="0" tIns="0" rIns="0" bIns="0" rtlCol="0" anchor="t"/>
           <a:lstStyle/>
           <a:p>
-            <a:pPr indent="0" marL="0">
+            <a:pPr marL="0" indent="0">
               <a:buNone/>
             </a:pPr>
             <a:r>
@@ -6630,7 +6409,7 @@
           </a:prstGeom>
           <a:extLst>
             <a:ext uri="{C572A759-6A51-4108-AA02-DFA0A04FC94B}">
-              <ma14:wrappingTextBoxFlag xmlns:ma14="http://schemas.microsoft.com/office/mac/drawingml/2011/main" val="0"/>
+              <ma14:wrappingTextBoxFlag xmlns:ma14="http://schemas.microsoft.com/office/mac/drawingml/2011/main" xmlns="" val="0"/>
             </a:ext>
           </a:extLst>
         </p:spPr>
@@ -6651,7 +6430,7 @@
           <a:p>
             <a:pPr algn="l"/>
             <a:fld id="{F7021451-1387-4CA6-816F-3879F97B5CBC}" type="slidenum">
-              <a:rPr b="0" lang="en-US"/>
+              <a:rPr lang="en-US" b="0"/>
               <a:t>5</a:t>
             </a:fld>
             <a:endParaRPr lang="en-US"/>
@@ -6686,9 +6465,11 @@
       <p:sp>
         <p:nvSpPr>
           <p:cNvPr id="2" name="Text 1"/>
-          <p:cNvSpPr/>
+          <p:cNvSpPr>
+            <a:spLocks noGrp="1"/>
+          </p:cNvSpPr>
           <p:nvPr>
-            <p:ph idx="101" type="title" hasCustomPrompt="1"/>
+            <p:ph type="title" idx="101" hasCustomPrompt="1"/>
           </p:nvPr>
         </p:nvSpPr>
         <p:spPr>
@@ -6706,7 +6487,7 @@
           <a:bodyPr wrap="square" rtlCol="0" anchor="ctr"/>
           <a:lstStyle/>
           <a:p>
-            <a:pPr algn="l" indent="0" marL="0">
+            <a:pPr marL="0" indent="0" algn="l">
               <a:buNone/>
             </a:pPr>
             <a:r>
@@ -6726,14 +6507,14 @@
       </p:sp>
       <p:pic>
         <p:nvPicPr>
-          <p:cNvPr id="3" name="Image 0" descr="/home/user/AI-Collusion-Research-Sprint/Apart Research/figures/fig_trajectories.png">    </p:cNvPr>
+          <p:cNvPr id="3" name="Image 0" descr="/home/user/AI-Collusion-Research-Sprint/Apart Research/figures/fig_trajectories.png"/>
           <p:cNvPicPr>
             <a:picLocks noChangeAspect="1"/>
           </p:cNvPicPr>
           <p:nvPr/>
         </p:nvPicPr>
         <p:blipFill>
-          <a:blip r:embed="rId1"/>
+          <a:blip r:embed="rId3"/>
           <a:stretch>
             <a:fillRect/>
           </a:stretch>
@@ -6769,7 +6550,7 @@
           <a:bodyPr wrap="square" lIns="0" tIns="0" rIns="0" bIns="0" rtlCol="0" anchor="t"/>
           <a:lstStyle/>
           <a:p>
-            <a:pPr indent="0" marL="0">
+            <a:pPr marL="0" indent="0">
               <a:buNone/>
             </a:pPr>
             <a:r>
@@ -6835,7 +6616,7 @@
           <a:bodyPr wrap="square" lIns="0" tIns="0" rIns="0" bIns="0" rtlCol="0" anchor="t"/>
           <a:lstStyle/>
           <a:p>
-            <a:pPr indent="0" marL="0">
+            <a:pPr marL="0" indent="0">
               <a:buNone/>
             </a:pPr>
             <a:r>
@@ -6874,7 +6655,7 @@
           <a:bodyPr wrap="square" lIns="0" tIns="0" rIns="0" bIns="0" rtlCol="0" anchor="t"/>
           <a:lstStyle/>
           <a:p>
-            <a:pPr indent="0" marL="0">
+            <a:pPr marL="0" indent="0">
               <a:buNone/>
             </a:pPr>
             <a:r>
@@ -6913,7 +6694,7 @@
           <a:bodyPr wrap="square" lIns="0" tIns="0" rIns="0" bIns="0" rtlCol="0" anchor="t"/>
           <a:lstStyle/>
           <a:p>
-            <a:pPr indent="0" marL="0">
+            <a:pPr marL="0" indent="0">
               <a:buNone/>
             </a:pPr>
             <a:r>
@@ -6952,7 +6733,7 @@
           <a:bodyPr wrap="square" lIns="0" tIns="0" rIns="0" bIns="0" rtlCol="0" anchor="t"/>
           <a:lstStyle/>
           <a:p>
-            <a:pPr indent="0" marL="0">
+            <a:pPr marL="0" indent="0">
               <a:buNone/>
             </a:pPr>
             <a:r>
@@ -6990,7 +6771,7 @@
           </a:prstGeom>
           <a:extLst>
             <a:ext uri="{C572A759-6A51-4108-AA02-DFA0A04FC94B}">
-              <ma14:wrappingTextBoxFlag xmlns:ma14="http://schemas.microsoft.com/office/mac/drawingml/2011/main" val="0"/>
+              <ma14:wrappingTextBoxFlag xmlns:ma14="http://schemas.microsoft.com/office/mac/drawingml/2011/main" xmlns="" val="0"/>
             </a:ext>
           </a:extLst>
         </p:spPr>
@@ -7011,7 +6792,7 @@
           <a:p>
             <a:pPr algn="l"/>
             <a:fld id="{F7021451-1387-4CA6-816F-3879F97B5CBC}" type="slidenum">
-              <a:rPr b="0" lang="en-US"/>
+              <a:rPr lang="en-US" b="0"/>
               <a:t>6</a:t>
             </a:fld>
             <a:endParaRPr lang="en-US"/>
@@ -7046,9 +6827,11 @@
       <p:sp>
         <p:nvSpPr>
           <p:cNvPr id="2" name="Text 1"/>
-          <p:cNvSpPr/>
+          <p:cNvSpPr>
+            <a:spLocks noGrp="1"/>
+          </p:cNvSpPr>
           <p:nvPr>
-            <p:ph idx="101" type="title" hasCustomPrompt="1"/>
+            <p:ph type="title" idx="101" hasCustomPrompt="1"/>
           </p:nvPr>
         </p:nvSpPr>
         <p:spPr>
@@ -7066,7 +6849,7 @@
           <a:bodyPr wrap="square" rtlCol="0" anchor="ctr"/>
           <a:lstStyle/>
           <a:p>
-            <a:pPr algn="l" indent="0" marL="0">
+            <a:pPr marL="0" indent="0" algn="l">
               <a:buNone/>
             </a:pPr>
             <a:r>
@@ -7132,7 +6915,7 @@
           <a:bodyPr wrap="square" lIns="0" tIns="0" rIns="0" bIns="0" rtlCol="0" anchor="t"/>
           <a:lstStyle/>
           <a:p>
-            <a:pPr indent="0" marL="0">
+            <a:pPr marL="0" indent="0">
               <a:buNone/>
             </a:pPr>
             <a:r>
@@ -7171,7 +6954,7 @@
           <a:bodyPr wrap="square" lIns="0" tIns="0" rIns="0" bIns="0" rtlCol="0" anchor="t"/>
           <a:lstStyle/>
           <a:p>
-            <a:pPr indent="0" marL="0">
+            <a:pPr marL="0" indent="0">
               <a:buNone/>
             </a:pPr>
             <a:r>
@@ -7210,7 +6993,7 @@
           <a:bodyPr wrap="square" lIns="0" tIns="0" rIns="0" bIns="0" rtlCol="0" anchor="t"/>
           <a:lstStyle/>
           <a:p>
-            <a:pPr indent="0" marL="0">
+            <a:pPr marL="0" indent="0">
               <a:buNone/>
             </a:pPr>
             <a:r>
@@ -7249,7 +7032,7 @@
           <a:bodyPr wrap="square" lIns="0" tIns="0" rIns="0" bIns="0" rtlCol="0" anchor="t"/>
           <a:lstStyle/>
           <a:p>
-            <a:pPr indent="0" marL="0">
+            <a:pPr marL="0" indent="0">
               <a:buNone/>
             </a:pPr>
             <a:r>
@@ -7315,7 +7098,7 @@
           <a:bodyPr wrap="square" lIns="0" tIns="0" rIns="0" bIns="0" rtlCol="0" anchor="t"/>
           <a:lstStyle/>
           <a:p>
-            <a:pPr indent="0" marL="0">
+            <a:pPr marL="0" indent="0">
               <a:buNone/>
             </a:pPr>
             <a:r>
@@ -7354,7 +7137,7 @@
           <a:bodyPr wrap="square" lIns="0" tIns="0" rIns="0" bIns="0" rtlCol="0" anchor="t"/>
           <a:lstStyle/>
           <a:p>
-            <a:pPr indent="0" marL="0">
+            <a:pPr marL="0" indent="0">
               <a:buNone/>
             </a:pPr>
             <a:r>
@@ -7393,7 +7176,7 @@
           <a:bodyPr wrap="square" lIns="0" tIns="0" rIns="0" bIns="0" rtlCol="0" anchor="t"/>
           <a:lstStyle/>
           <a:p>
-            <a:pPr indent="0" marL="0">
+            <a:pPr marL="0" indent="0">
               <a:buNone/>
             </a:pPr>
             <a:r>
@@ -7432,7 +7215,7 @@
           <a:bodyPr wrap="square" lIns="0" tIns="0" rIns="0" bIns="0" rtlCol="0" anchor="t"/>
           <a:lstStyle/>
           <a:p>
-            <a:pPr indent="0" marL="0">
+            <a:pPr marL="0" indent="0">
               <a:buNone/>
             </a:pPr>
             <a:r>
@@ -7471,7 +7254,7 @@
           <a:bodyPr wrap="square" lIns="0" tIns="0" rIns="0" bIns="0" rtlCol="0" anchor="t"/>
           <a:lstStyle/>
           <a:p>
-            <a:pPr indent="0" marL="0">
+            <a:pPr marL="0" indent="0">
               <a:buNone/>
             </a:pPr>
             <a:r>
@@ -7509,7 +7292,7 @@
           </a:prstGeom>
           <a:extLst>
             <a:ext uri="{C572A759-6A51-4108-AA02-DFA0A04FC94B}">
-              <ma14:wrappingTextBoxFlag xmlns:ma14="http://schemas.microsoft.com/office/mac/drawingml/2011/main" val="0"/>
+              <ma14:wrappingTextBoxFlag xmlns:ma14="http://schemas.microsoft.com/office/mac/drawingml/2011/main" xmlns="" val="0"/>
             </a:ext>
           </a:extLst>
         </p:spPr>
@@ -7530,7 +7313,7 @@
           <a:p>
             <a:pPr algn="l"/>
             <a:fld id="{F7021451-1387-4CA6-816F-3879F97B5CBC}" type="slidenum">
-              <a:rPr b="0" lang="en-US"/>
+              <a:rPr lang="en-US" b="0"/>
               <a:t>7</a:t>
             </a:fld>
             <a:endParaRPr lang="en-US"/>
@@ -7565,9 +7348,11 @@
       <p:sp>
         <p:nvSpPr>
           <p:cNvPr id="2" name="Text 1"/>
-          <p:cNvSpPr/>
+          <p:cNvSpPr>
+            <a:spLocks noGrp="1"/>
+          </p:cNvSpPr>
           <p:nvPr>
-            <p:ph idx="101" type="title" hasCustomPrompt="1"/>
+            <p:ph type="title" idx="101" hasCustomPrompt="1"/>
           </p:nvPr>
         </p:nvSpPr>
         <p:spPr>
@@ -7585,7 +7370,7 @@
           <a:bodyPr wrap="square" rtlCol="0" anchor="ctr"/>
           <a:lstStyle/>
           <a:p>
-            <a:pPr algn="l" indent="0" marL="0">
+            <a:pPr marL="0" indent="0" algn="l">
               <a:buNone/>
             </a:pPr>
             <a:r>
@@ -7676,7 +7461,7 @@
           <a:bodyPr wrap="square" lIns="0" tIns="0" rIns="0" bIns="0" rtlCol="0" anchor="ctr"/>
           <a:lstStyle/>
           <a:p>
-            <a:pPr algn="ctr" indent="0" marL="0">
+            <a:pPr marL="0" indent="0" algn="ctr">
               <a:buNone/>
             </a:pPr>
             <a:r>
@@ -7715,7 +7500,7 @@
           <a:bodyPr wrap="square" lIns="0" tIns="0" rIns="0" bIns="0" rtlCol="0" anchor="t"/>
           <a:lstStyle/>
           <a:p>
-            <a:pPr indent="0" marL="0">
+            <a:pPr marL="0" indent="0">
               <a:buNone/>
             </a:pPr>
             <a:r>
@@ -7754,7 +7539,7 @@
           <a:bodyPr wrap="square" lIns="0" tIns="0" rIns="0" bIns="0" rtlCol="0" anchor="t"/>
           <a:lstStyle/>
           <a:p>
-            <a:pPr indent="0" marL="0">
+            <a:pPr marL="0" indent="0">
               <a:buNone/>
             </a:pPr>
             <a:r>
@@ -7845,7 +7630,7 @@
           <a:bodyPr wrap="square" lIns="0" tIns="0" rIns="0" bIns="0" rtlCol="0" anchor="ctr"/>
           <a:lstStyle/>
           <a:p>
-            <a:pPr algn="ctr" indent="0" marL="0">
+            <a:pPr marL="0" indent="0" algn="ctr">
               <a:buNone/>
             </a:pPr>
             <a:r>
@@ -7884,7 +7669,7 @@
           <a:bodyPr wrap="square" lIns="0" tIns="0" rIns="0" bIns="0" rtlCol="0" anchor="t"/>
           <a:lstStyle/>
           <a:p>
-            <a:pPr indent="0" marL="0">
+            <a:pPr marL="0" indent="0">
               <a:buNone/>
             </a:pPr>
             <a:r>
@@ -7923,7 +7708,7 @@
           <a:bodyPr wrap="square" lIns="0" tIns="0" rIns="0" bIns="0" rtlCol="0" anchor="t"/>
           <a:lstStyle/>
           <a:p>
-            <a:pPr indent="0" marL="0">
+            <a:pPr marL="0" indent="0">
               <a:buNone/>
             </a:pPr>
             <a:r>
@@ -8014,7 +7799,7 @@
           <a:bodyPr wrap="square" lIns="0" tIns="0" rIns="0" bIns="0" rtlCol="0" anchor="ctr"/>
           <a:lstStyle/>
           <a:p>
-            <a:pPr algn="ctr" indent="0" marL="0">
+            <a:pPr marL="0" indent="0" algn="ctr">
               <a:buNone/>
             </a:pPr>
             <a:r>
@@ -8053,7 +7838,7 @@
           <a:bodyPr wrap="square" lIns="0" tIns="0" rIns="0" bIns="0" rtlCol="0" anchor="t"/>
           <a:lstStyle/>
           <a:p>
-            <a:pPr indent="0" marL="0">
+            <a:pPr marL="0" indent="0">
               <a:buNone/>
             </a:pPr>
             <a:r>
@@ -8092,7 +7877,7 @@
           <a:bodyPr wrap="square" lIns="0" tIns="0" rIns="0" bIns="0" rtlCol="0" anchor="t"/>
           <a:lstStyle/>
           <a:p>
-            <a:pPr indent="0" marL="0">
+            <a:pPr marL="0" indent="0">
               <a:buNone/>
             </a:pPr>
             <a:r>
@@ -8158,7 +7943,7 @@
           <a:bodyPr wrap="square" lIns="0" tIns="0" rIns="0" bIns="0" rtlCol="0" anchor="t"/>
           <a:lstStyle/>
           <a:p>
-            <a:pPr indent="0" marL="0">
+            <a:pPr marL="0" indent="0">
               <a:buNone/>
             </a:pPr>
             <a:r>
@@ -8197,7 +7982,7 @@
           <a:bodyPr wrap="square" lIns="0" tIns="0" rIns="0" bIns="0" rtlCol="0" anchor="t"/>
           <a:lstStyle/>
           <a:p>
-            <a:pPr indent="0" marL="0">
+            <a:pPr marL="0" indent="0">
               <a:buNone/>
             </a:pPr>
             <a:r>
@@ -8236,7 +8021,7 @@
           <a:bodyPr wrap="square" lIns="0" tIns="0" rIns="0" bIns="0" rtlCol="0" anchor="t"/>
           <a:lstStyle/>
           <a:p>
-            <a:pPr indent="0" marL="0">
+            <a:pPr marL="0" indent="0">
               <a:buNone/>
             </a:pPr>
             <a:r>
@@ -8275,7 +8060,7 @@
           <a:bodyPr wrap="square" lIns="0" tIns="0" rIns="0" bIns="0" rtlCol="0" anchor="t"/>
           <a:lstStyle/>
           <a:p>
-            <a:pPr indent="0" marL="0">
+            <a:pPr marL="0" indent="0">
               <a:buNone/>
             </a:pPr>
             <a:r>
@@ -8314,7 +8099,7 @@
           <a:bodyPr wrap="square" lIns="0" tIns="0" rIns="0" bIns="0" rtlCol="0" anchor="t"/>
           <a:lstStyle/>
           <a:p>
-            <a:pPr indent="0" marL="0">
+            <a:pPr marL="0" indent="0">
               <a:buNone/>
             </a:pPr>
             <a:r>
@@ -8353,7 +8138,7 @@
           <a:bodyPr wrap="square" lIns="0" tIns="0" rIns="0" bIns="0" rtlCol="0" anchor="t"/>
           <a:lstStyle/>
           <a:p>
-            <a:pPr indent="0" marL="0">
+            <a:pPr marL="0" indent="0">
               <a:buNone/>
             </a:pPr>
             <a:r>
@@ -8391,7 +8176,7 @@
           </a:prstGeom>
           <a:extLst>
             <a:ext uri="{C572A759-6A51-4108-AA02-DFA0A04FC94B}">
-              <ma14:wrappingTextBoxFlag xmlns:ma14="http://schemas.microsoft.com/office/mac/drawingml/2011/main" val="0"/>
+              <ma14:wrappingTextBoxFlag xmlns:ma14="http://schemas.microsoft.com/office/mac/drawingml/2011/main" xmlns="" val="0"/>
             </a:ext>
           </a:extLst>
         </p:spPr>
@@ -8412,7 +8197,7 @@
           <a:p>
             <a:pPr algn="l"/>
             <a:fld id="{F7021451-1387-4CA6-816F-3879F97B5CBC}" type="slidenum">
-              <a:rPr b="0" lang="en-US"/>
+              <a:rPr lang="en-US" b="0"/>
               <a:t>8</a:t>
             </a:fld>
             <a:endParaRPr lang="en-US"/>
@@ -8447,9 +8232,11 @@
       <p:sp>
         <p:nvSpPr>
           <p:cNvPr id="2" name="Text 0"/>
-          <p:cNvSpPr/>
+          <p:cNvSpPr>
+            <a:spLocks noGrp="1"/>
+          </p:cNvSpPr>
           <p:nvPr>
-            <p:ph idx="100" type="title" hasCustomPrompt="1"/>
+            <p:ph type="title" idx="100" hasCustomPrompt="1"/>
           </p:nvPr>
         </p:nvSpPr>
         <p:spPr>
@@ -8467,7 +8254,7 @@
           <a:bodyPr wrap="square" rtlCol="0" anchor="ctr"/>
           <a:lstStyle/>
           <a:p>
-            <a:pPr algn="l" indent="0" marL="0">
+            <a:pPr marL="0" indent="0" algn="l">
               <a:buNone/>
             </a:pPr>
             <a:r>
@@ -8533,7 +8320,7 @@
           <a:bodyPr wrap="square" lIns="0" tIns="0" rIns="0" bIns="0" rtlCol="0" anchor="t"/>
           <a:lstStyle/>
           <a:p>
-            <a:pPr indent="0" marL="0">
+            <a:pPr marL="0" indent="0">
               <a:buNone/>
             </a:pPr>
             <a:r>
@@ -8572,7 +8359,7 @@
           <a:bodyPr wrap="square" lIns="0" tIns="0" rIns="0" bIns="0" rtlCol="0" anchor="t"/>
           <a:lstStyle/>
           <a:p>
-            <a:pPr indent="0" marL="0">
+            <a:pPr marL="0" indent="0">
               <a:buNone/>
             </a:pPr>
             <a:r>
@@ -8638,7 +8425,7 @@
           <a:bodyPr wrap="square" lIns="0" tIns="0" rIns="0" bIns="0" rtlCol="0" anchor="t"/>
           <a:lstStyle/>
           <a:p>
-            <a:pPr indent="0" marL="0">
+            <a:pPr marL="0" indent="0">
               <a:buNone/>
             </a:pPr>
             <a:r>
@@ -8677,7 +8464,7 @@
           <a:bodyPr wrap="square" lIns="0" tIns="0" rIns="0" bIns="0" rtlCol="0" anchor="t"/>
           <a:lstStyle/>
           <a:p>
-            <a:pPr indent="0" marL="0">
+            <a:pPr marL="0" indent="0">
               <a:buNone/>
             </a:pPr>
             <a:r>
@@ -8743,7 +8530,7 @@
           <a:bodyPr wrap="square" lIns="0" tIns="0" rIns="0" bIns="0" rtlCol="0" anchor="t"/>
           <a:lstStyle/>
           <a:p>
-            <a:pPr indent="0" marL="0">
+            <a:pPr marL="0" indent="0">
               <a:buNone/>
             </a:pPr>
             <a:r>
@@ -8782,7 +8569,7 @@
           <a:bodyPr wrap="square" lIns="0" tIns="0" rIns="0" bIns="0" rtlCol="0" anchor="t"/>
           <a:lstStyle/>
           <a:p>
-            <a:pPr indent="0" marL="0">
+            <a:pPr marL="0" indent="0">
               <a:buNone/>
             </a:pPr>
             <a:r>
@@ -8848,7 +8635,7 @@
           <a:bodyPr wrap="square" lIns="0" tIns="0" rIns="0" bIns="0" rtlCol="0" anchor="t"/>
           <a:lstStyle/>
           <a:p>
-            <a:pPr indent="0" marL="0">
+            <a:pPr marL="0" indent="0">
               <a:buNone/>
             </a:pPr>
             <a:r>
@@ -8887,7 +8674,7 @@
           <a:bodyPr wrap="square" lIns="0" tIns="0" rIns="0" bIns="0" rtlCol="0" anchor="t"/>
           <a:lstStyle/>
           <a:p>
-            <a:pPr indent="0" marL="0">
+            <a:pPr marL="0" indent="0">
               <a:buNone/>
             </a:pPr>
             <a:r>
@@ -8925,7 +8712,7 @@
           </a:prstGeom>
           <a:extLst>
             <a:ext uri="{C572A759-6A51-4108-AA02-DFA0A04FC94B}">
-              <ma14:wrappingTextBoxFlag xmlns:ma14="http://schemas.microsoft.com/office/mac/drawingml/2011/main" val="0"/>
+              <ma14:wrappingTextBoxFlag xmlns:ma14="http://schemas.microsoft.com/office/mac/drawingml/2011/main" xmlns="" val="0"/>
             </a:ext>
           </a:extLst>
         </p:spPr>
@@ -8946,7 +8733,7 @@
           <a:p>
             <a:pPr algn="l"/>
             <a:fld id="{F7021451-1387-4CA6-816F-3879F97B5CBC}" type="slidenum">
-              <a:rPr b="0" lang="en-US"/>
+              <a:rPr lang="en-US" b="0"/>
               <a:t>9</a:t>
             </a:fld>
             <a:endParaRPr lang="en-US"/>
@@ -9254,4 +9041,299 @@
     </a:ext>
   </a:extLst>
 </a:theme>
+</file>
+
+<file path=ppt/theme/theme2.xml><?xml version="1.0" encoding="utf-8"?>
+<a:theme xmlns:a="http://schemas.openxmlformats.org/drawingml/2006/main" name="Office Theme">
+  <a:themeElements>
+    <a:clrScheme name="Office">
+      <a:dk1>
+        <a:sysClr val="windowText" lastClr="000000"/>
+      </a:dk1>
+      <a:lt1>
+        <a:sysClr val="window" lastClr="FFFFFF"/>
+      </a:lt1>
+      <a:dk2>
+        <a:srgbClr val="44546A"/>
+      </a:dk2>
+      <a:lt2>
+        <a:srgbClr val="E7E6E6"/>
+      </a:lt2>
+      <a:accent1>
+        <a:srgbClr val="4472C4"/>
+      </a:accent1>
+      <a:accent2>
+        <a:srgbClr val="ED7D31"/>
+      </a:accent2>
+      <a:accent3>
+        <a:srgbClr val="A5A5A5"/>
+      </a:accent3>
+      <a:accent4>
+        <a:srgbClr val="FFC000"/>
+      </a:accent4>
+      <a:accent5>
+        <a:srgbClr val="5B9BD5"/>
+      </a:accent5>
+      <a:accent6>
+        <a:srgbClr val="70AD47"/>
+      </a:accent6>
+      <a:hlink>
+        <a:srgbClr val="0563C1"/>
+      </a:hlink>
+      <a:folHlink>
+        <a:srgbClr val="954F72"/>
+      </a:folHlink>
+    </a:clrScheme>
+    <a:fontScheme name="Office">
+      <a:majorFont>
+        <a:latin typeface="Calibri Light" panose="020F0302020204030204"/>
+        <a:ea typeface=""/>
+        <a:cs typeface=""/>
+        <a:font script="Jpan" typeface="游ゴシック Light"/>
+        <a:font script="Hang" typeface="맑은 고딕"/>
+        <a:font script="Hans" typeface="等线 Light"/>
+        <a:font script="Hant" typeface="新細明體"/>
+        <a:font script="Arab" typeface="Times New Roman"/>
+        <a:font script="Hebr" typeface="Times New Roman"/>
+        <a:font script="Thai" typeface="Angsana New"/>
+        <a:font script="Ethi" typeface="Nyala"/>
+        <a:font script="Beng" typeface="Vrinda"/>
+        <a:font script="Gujr" typeface="Shruti"/>
+        <a:font script="Khmr" typeface="MoolBoran"/>
+        <a:font script="Knda" typeface="Tunga"/>
+        <a:font script="Guru" typeface="Raavi"/>
+        <a:font script="Cans" typeface="Euphemia"/>
+        <a:font script="Cher" typeface="Plantagenet Cherokee"/>
+        <a:font script="Yiii" typeface="Microsoft Yi Baiti"/>
+        <a:font script="Tibt" typeface="Microsoft Himalaya"/>
+        <a:font script="Thaa" typeface="MV Boli"/>
+        <a:font script="Deva" typeface="Mangal"/>
+        <a:font script="Telu" typeface="Gautami"/>
+        <a:font script="Taml" typeface="Latha"/>
+        <a:font script="Syrc" typeface="Estrangelo Edessa"/>
+        <a:font script="Orya" typeface="Kalinga"/>
+        <a:font script="Mlym" typeface="Kartika"/>
+        <a:font script="Laoo" typeface="DokChampa"/>
+        <a:font script="Sinh" typeface="Iskoola Pota"/>
+        <a:font script="Mong" typeface="Mongolian Baiti"/>
+        <a:font script="Viet" typeface="Times New Roman"/>
+        <a:font script="Uigh" typeface="Microsoft Uighur"/>
+        <a:font script="Geor" typeface="Sylfaen"/>
+        <a:font script="Armn" typeface="Arial"/>
+        <a:font script="Bugi" typeface="Leelawadee UI"/>
+        <a:font script="Bopo" typeface="Microsoft JhengHei"/>
+        <a:font script="Java" typeface="Javanese Text"/>
+        <a:font script="Lisu" typeface="Segoe UI"/>
+        <a:font script="Mymr" typeface="Myanmar Text"/>
+        <a:font script="Nkoo" typeface="Ebrima"/>
+        <a:font script="Olck" typeface="Nirmala UI"/>
+        <a:font script="Osma" typeface="Ebrima"/>
+        <a:font script="Phag" typeface="Phagspa"/>
+        <a:font script="Syrn" typeface="Estrangelo Edessa"/>
+        <a:font script="Syrj" typeface="Estrangelo Edessa"/>
+        <a:font script="Syre" typeface="Estrangelo Edessa"/>
+        <a:font script="Sora" typeface="Nirmala UI"/>
+        <a:font script="Tale" typeface="Microsoft Tai Le"/>
+        <a:font script="Talu" typeface="Microsoft New Tai Lue"/>
+        <a:font script="Tfng" typeface="Ebrima"/>
+      </a:majorFont>
+      <a:minorFont>
+        <a:latin typeface="Calibri" panose="020F0502020204030204"/>
+        <a:ea typeface=""/>
+        <a:cs typeface=""/>
+        <a:font script="Jpan" typeface="游ゴシック"/>
+        <a:font script="Hang" typeface="맑은 고딕"/>
+        <a:font script="Hans" typeface="等线"/>
+        <a:font script="Hant" typeface="新細明體"/>
+        <a:font script="Arab" typeface="Arial"/>
+        <a:font script="Hebr" typeface="Arial"/>
+        <a:font script="Thai" typeface="Cordia New"/>
+        <a:font script="Ethi" typeface="Nyala"/>
+        <a:font script="Beng" typeface="Vrinda"/>
+        <a:font script="Gujr" typeface="Shruti"/>
+        <a:font script="Khmr" typeface="DaunPenh"/>
+        <a:font script="Knda" typeface="Tunga"/>
+        <a:font script="Guru" typeface="Raavi"/>
+        <a:font script="Cans" typeface="Euphemia"/>
+        <a:font script="Cher" typeface="Plantagenet Cherokee"/>
+        <a:font script="Yiii" typeface="Microsoft Yi Baiti"/>
+        <a:font script="Tibt" typeface="Microsoft Himalaya"/>
+        <a:font script="Thaa" typeface="MV Boli"/>
+        <a:font script="Deva" typeface="Mangal"/>
+        <a:font script="Telu" typeface="Gautami"/>
+        <a:font script="Taml" typeface="Latha"/>
+        <a:font script="Syrc" typeface="Estrangelo Edessa"/>
+        <a:font script="Orya" typeface="Kalinga"/>
+        <a:font script="Mlym" typeface="Kartika"/>
+        <a:font script="Laoo" typeface="DokChampa"/>
+        <a:font script="Sinh" typeface="Iskoola Pota"/>
+        <a:font script="Mong" typeface="Mongolian Baiti"/>
+        <a:font script="Viet" typeface="Arial"/>
+        <a:font script="Uigh" typeface="Microsoft Uighur"/>
+        <a:font script="Geor" typeface="Sylfaen"/>
+        <a:font script="Armn" typeface="Arial"/>
+        <a:font script="Bugi" typeface="Leelawadee UI"/>
+        <a:font script="Bopo" typeface="Microsoft JhengHei"/>
+        <a:font script="Java" typeface="Javanese Text"/>
+        <a:font script="Lisu" typeface="Segoe UI"/>
+        <a:font script="Mymr" typeface="Myanmar Text"/>
+        <a:font script="Nkoo" typeface="Ebrima"/>
+        <a:font script="Olck" typeface="Nirmala UI"/>
+        <a:font script="Osma" typeface="Ebrima"/>
+        <a:font script="Phag" typeface="Phagspa"/>
+        <a:font script="Syrn" typeface="Estrangelo Edessa"/>
+        <a:font script="Syrj" typeface="Estrangelo Edessa"/>
+        <a:font script="Syre" typeface="Estrangelo Edessa"/>
+        <a:font script="Sora" typeface="Nirmala UI"/>
+        <a:font script="Tale" typeface="Microsoft Tai Le"/>
+        <a:font script="Talu" typeface="Microsoft New Tai Lue"/>
+        <a:font script="Tfng" typeface="Ebrima"/>
+      </a:minorFont>
+    </a:fontScheme>
+    <a:fmtScheme name="Office">
+      <a:fillStyleLst>
+        <a:solidFill>
+          <a:schemeClr val="phClr"/>
+        </a:solidFill>
+        <a:gradFill rotWithShape="1">
+          <a:gsLst>
+            <a:gs pos="0">
+              <a:schemeClr val="phClr">
+                <a:lumMod val="110000"/>
+                <a:satMod val="105000"/>
+                <a:tint val="67000"/>
+              </a:schemeClr>
+            </a:gs>
+            <a:gs pos="50000">
+              <a:schemeClr val="phClr">
+                <a:lumMod val="105000"/>
+                <a:satMod val="103000"/>
+                <a:tint val="73000"/>
+              </a:schemeClr>
+            </a:gs>
+            <a:gs pos="100000">
+              <a:schemeClr val="phClr">
+                <a:lumMod val="105000"/>
+                <a:satMod val="109000"/>
+                <a:tint val="81000"/>
+              </a:schemeClr>
+            </a:gs>
+          </a:gsLst>
+          <a:lin ang="5400000" scaled="0"/>
+        </a:gradFill>
+        <a:gradFill rotWithShape="1">
+          <a:gsLst>
+            <a:gs pos="0">
+              <a:schemeClr val="phClr">
+                <a:satMod val="103000"/>
+                <a:lumMod val="102000"/>
+                <a:tint val="94000"/>
+              </a:schemeClr>
+            </a:gs>
+            <a:gs pos="50000">
+              <a:schemeClr val="phClr">
+                <a:satMod val="110000"/>
+                <a:lumMod val="100000"/>
+                <a:shade val="100000"/>
+              </a:schemeClr>
+            </a:gs>
+            <a:gs pos="100000">
+              <a:schemeClr val="phClr">
+                <a:lumMod val="99000"/>
+                <a:satMod val="120000"/>
+                <a:shade val="78000"/>
+              </a:schemeClr>
+            </a:gs>
+          </a:gsLst>
+          <a:lin ang="5400000" scaled="0"/>
+        </a:gradFill>
+      </a:fillStyleLst>
+      <a:lnStyleLst>
+        <a:ln w="6350" cap="flat" cmpd="sng" algn="ctr">
+          <a:solidFill>
+            <a:schemeClr val="phClr"/>
+          </a:solidFill>
+          <a:prstDash val="solid"/>
+          <a:miter lim="800000"/>
+        </a:ln>
+        <a:ln w="12700" cap="flat" cmpd="sng" algn="ctr">
+          <a:solidFill>
+            <a:schemeClr val="phClr"/>
+          </a:solidFill>
+          <a:prstDash val="solid"/>
+          <a:miter lim="800000"/>
+        </a:ln>
+        <a:ln w="19050" cap="flat" cmpd="sng" algn="ctr">
+          <a:solidFill>
+            <a:schemeClr val="phClr"/>
+          </a:solidFill>
+          <a:prstDash val="solid"/>
+          <a:miter lim="800000"/>
+        </a:ln>
+      </a:lnStyleLst>
+      <a:effectStyleLst>
+        <a:effectStyle>
+          <a:effectLst/>
+        </a:effectStyle>
+        <a:effectStyle>
+          <a:effectLst/>
+        </a:effectStyle>
+        <a:effectStyle>
+          <a:effectLst>
+            <a:outerShdw blurRad="57150" dist="19050" dir="5400000" algn="ctr" rotWithShape="0">
+              <a:srgbClr val="000000">
+                <a:alpha val="63000"/>
+              </a:srgbClr>
+            </a:outerShdw>
+          </a:effectLst>
+        </a:effectStyle>
+      </a:effectStyleLst>
+      <a:bgFillStyleLst>
+        <a:solidFill>
+          <a:schemeClr val="phClr"/>
+        </a:solidFill>
+        <a:solidFill>
+          <a:schemeClr val="phClr">
+            <a:tint val="95000"/>
+            <a:satMod val="170000"/>
+          </a:schemeClr>
+        </a:solidFill>
+        <a:gradFill rotWithShape="1">
+          <a:gsLst>
+            <a:gs pos="0">
+              <a:schemeClr val="phClr">
+                <a:tint val="93000"/>
+                <a:satMod val="150000"/>
+                <a:shade val="98000"/>
+                <a:lumMod val="102000"/>
+              </a:schemeClr>
+            </a:gs>
+            <a:gs pos="50000">
+              <a:schemeClr val="phClr">
+                <a:tint val="98000"/>
+                <a:satMod val="130000"/>
+                <a:shade val="90000"/>
+                <a:lumMod val="103000"/>
+              </a:schemeClr>
+            </a:gs>
+            <a:gs pos="100000">
+              <a:schemeClr val="phClr">
+                <a:shade val="63000"/>
+                <a:satMod val="120000"/>
+              </a:schemeClr>
+            </a:gs>
+          </a:gsLst>
+          <a:lin ang="5400000" scaled="0"/>
+        </a:gradFill>
+      </a:bgFillStyleLst>
+    </a:fmtScheme>
+  </a:themeElements>
+  <a:objectDefaults/>
+  <a:extraClrSchemeLst/>
+  <a:extLst>
+    <a:ext uri="{05A4C25C-085E-4340-85A3-A5531E510DB2}">
+      <thm15:themeFamily xmlns:thm15="http://schemas.microsoft.com/office/thememl/2012/main" name="Office Theme" id="{62F939B6-93AF-4DB8-9C6B-D6C7DFDC589F}" vid="{4A3C46E8-61CC-4603-A589-7422A47A8E4A}"/>
+    </a:ext>
+  </a:extLst>
+</a:theme>
 </file>
</xml_diff>

<commit_message>
Tighten the report layout and add a code-only copy
- Add one blank line of space before each top-level section; the main text
  still ends on page 8 (LibreOffice export).
- Shorten the Introduction, Related Work and Discussion; explain the A/A check
  in Section 3.3; move Tables 3 and 5 and Figure 1 to remove page gaps.
- Remove the LLM Usage Statement, clock times and code/doc paths from the
  appendix, at the author's request. No number changed.
- Keep the author's title line break and slide-1 author line.
- Add scripts/make_public_copy.py and its output cartel-succession/: code,
  configs, tests, research brief and related work, with no mention of AI
  coding assistants or of the left-out docs.

Co-Authored-By: Claude Opus 5.5 <noreply@anthropic.com>
Claude-Session: https://claude.ai/code/session_01AouEcLyMhAyntpeQ675vpK
</commit_message>
<xml_diff>
--- a/Apart Research/slides.pptx
+++ b/Apart Research/slides.pptx
@@ -4,9 +4,6 @@
   <p:sldMasterIdLst>
     <p:sldMasterId id="2147483648" r:id="rId1"/>
   </p:sldMasterIdLst>
-  <p:notesMasterIdLst>
-    <p:notesMasterId r:id="rId12"/>
-  </p:notesMasterIdLst>
   <p:sldIdLst>
     <p:sldId id="256" r:id="rId2"/>
     <p:sldId id="257" r:id="rId3"/>
@@ -19,6 +16,9 @@
     <p:sldId id="264" r:id="rId10"/>
     <p:sldId id="265" r:id="rId11"/>
   </p:sldIdLst>
+  <p:notesMasterIdLst>
+    <p:notesMasterId r:id="rId12"/>
+  </p:notesMasterIdLst>
   <p:sldSz cx="12192000" cy="6858000"/>
   <p:notesSz cx="6858000" cy="12192000"/>
   <p:defaultTextStyle>
@@ -113,20 +113,13 @@
       </a:defRPr>
     </a:lvl9pPr>
   </p:defaultTextStyle>
-  <p:extLst>
-    <p:ext uri="{EFAFB233-063F-42B5-8137-9DF3F51BA10A}">
-      <p15:sldGuideLst xmlns:p15="http://schemas.microsoft.com/office/powerpoint/2012/main"/>
-    </p:ext>
-  </p:extLst>
 </p:presentation>
 </file>
 
 <file path=ppt/charts/chart1.xml><?xml version="1.0" encoding="utf-8"?>
-<c:chartSpace xmlns:c="http://schemas.openxmlformats.org/drawingml/2006/chart" xmlns:a="http://schemas.openxmlformats.org/drawingml/2006/main" xmlns:r="http://schemas.openxmlformats.org/officeDocument/2006/relationships" xmlns:c16r2="http://schemas.microsoft.com/office/drawing/2015/06/chart">
+<c:chartSpace xmlns:c="http://schemas.openxmlformats.org/drawingml/2006/chart" xmlns:a="http://schemas.openxmlformats.org/drawingml/2006/main" xmlns:r="http://schemas.openxmlformats.org/officeDocument/2006/relationships">
   <c:date1904 val="0"/>
-  <c:lang val="en-US"/>
   <c:roundedCorners val="1"/>
-  <c:style val="2"/>
   <c:chart>
     <c:title>
       <c:tx>
@@ -143,7 +136,7 @@
               </a:defRPr>
             </a:pPr>
             <a:r>
-              <a:rPr lang="en-US" sz="1500" b="0" i="0" u="none" strike="noStrike">
+              <a:rPr sz="1500" b="0" i="0" u="none" strike="noStrike">
                 <a:solidFill>
                   <a:srgbClr val="2B2F36"/>
                 </a:solidFill>
@@ -154,6 +147,7 @@
           </a:p>
         </c:rich>
       </c:tx>
+      <c:layout/>
       <c:overlay val="0"/>
     </c:title>
     <c:autoTitleDeleted val="0"/>
@@ -184,15 +178,40 @@
             <a:effectLst/>
           </c:spPr>
           <c:invertIfNegative val="0"/>
+          <c:dLbls>
+            <c:numFmt formatCode="0.000" sourceLinked="0"/>
+            <c:txPr>
+              <a:bodyPr/>
+              <a:lstStyle/>
+              <a:p>
+                <a:pPr>
+                  <a:defRPr b="0" i="0" strike="noStrike" sz="1300" u="none">
+                    <a:solidFill>
+                      <a:srgbClr val="2B2F36"/>
+                    </a:solidFill>
+                    <a:latin typeface="+mn-lt"/>
+                  </a:defRPr>
+                </a:pPr>
+              </a:p>
+            </c:txPr>
+            <c:showLegendKey val="0"/>
+            <c:showVal val="1"/>
+            <c:showCatName val="0"/>
+            <c:showSerName val="0"/>
+            <c:showPercent val="0"/>
+            <c:showBubbleSize val="0"/>
+            <c:showLeaderLines val="0"/>
+          </c:dLbls>
           <c:dPt>
             <c:idx val="0"/>
             <c:invertIfNegative val="0"/>
             <c:bubble3D val="0"/>
-            <c:extLst>
-              <c:ext xmlns:c16="http://schemas.microsoft.com/office/drawing/2014/chart" uri="{C3380CC4-5D6E-409C-BE32-E72D297353CC}">
-                <c16:uniqueId val="{00000001-1203-43C0-A483-3AC5DC55E42C}"/>
-              </c:ext>
-            </c:extLst>
+            <c:spPr>
+              <a:solidFill>
+                <a:srgbClr val="2B2F36"/>
+              </a:solidFill>
+              <a:effectLst/>
+            </c:spPr>
           </c:dPt>
           <c:dPt>
             <c:idx val="1"/>
@@ -204,11 +223,6 @@
               </a:solidFill>
               <a:effectLst/>
             </c:spPr>
-            <c:extLst>
-              <c:ext xmlns:c16="http://schemas.microsoft.com/office/drawing/2014/chart" uri="{C3380CC4-5D6E-409C-BE32-E72D297353CC}">
-                <c16:uniqueId val="{00000003-1203-43C0-A483-3AC5DC55E42C}"/>
-              </c:ext>
-            </c:extLst>
           </c:dPt>
           <c:dPt>
             <c:idx val="2"/>
@@ -220,11 +234,6 @@
               </a:solidFill>
               <a:effectLst/>
             </c:spPr>
-            <c:extLst>
-              <c:ext xmlns:c16="http://schemas.microsoft.com/office/drawing/2014/chart" uri="{C3380CC4-5D6E-409C-BE32-E72D297353CC}">
-                <c16:uniqueId val="{00000005-1203-43C0-A483-3AC5DC55E42C}"/>
-              </c:ext>
-            </c:extLst>
           </c:dPt>
           <c:dPt>
             <c:idx val="3"/>
@@ -236,11 +245,6 @@
               </a:solidFill>
               <a:effectLst/>
             </c:spPr>
-            <c:extLst>
-              <c:ext xmlns:c16="http://schemas.microsoft.com/office/drawing/2014/chart" uri="{C3380CC4-5D6E-409C-BE32-E72D297353CC}">
-                <c16:uniqueId val="{00000007-1203-43C0-A483-3AC5DC55E42C}"/>
-              </c:ext>
-            </c:extLst>
           </c:dPt>
           <c:dPt>
             <c:idx val="4"/>
@@ -252,11 +256,6 @@
               </a:solidFill>
               <a:effectLst/>
             </c:spPr>
-            <c:extLst>
-              <c:ext xmlns:c16="http://schemas.microsoft.com/office/drawing/2014/chart" uri="{C3380CC4-5D6E-409C-BE32-E72D297353CC}">
-                <c16:uniqueId val="{00000009-1203-43C0-A483-3AC5DC55E42C}"/>
-              </c:ext>
-            </c:extLst>
           </c:dPt>
           <c:dPt>
             <c:idx val="5"/>
@@ -268,11 +267,6 @@
               </a:solidFill>
               <a:effectLst/>
             </c:spPr>
-            <c:extLst>
-              <c:ext xmlns:c16="http://schemas.microsoft.com/office/drawing/2014/chart" uri="{C3380CC4-5D6E-409C-BE32-E72D297353CC}">
-                <c16:uniqueId val="{0000000B-1203-43C0-A483-3AC5DC55E42C}"/>
-              </c:ext>
-            </c:extLst>
           </c:dPt>
           <c:dPt>
             <c:idx val="6"/>
@@ -284,11 +278,6 @@
               </a:solidFill>
               <a:effectLst/>
             </c:spPr>
-            <c:extLst>
-              <c:ext xmlns:c16="http://schemas.microsoft.com/office/drawing/2014/chart" uri="{C3380CC4-5D6E-409C-BE32-E72D297353CC}">
-                <c16:uniqueId val="{0000000D-1203-43C0-A483-3AC5DC55E42C}"/>
-              </c:ext>
-            </c:extLst>
           </c:dPt>
           <c:dPt>
             <c:idx val="7"/>
@@ -300,80 +289,40 @@
               </a:solidFill>
               <a:effectLst/>
             </c:spPr>
-            <c:extLst>
-              <c:ext xmlns:c16="http://schemas.microsoft.com/office/drawing/2014/chart" uri="{C3380CC4-5D6E-409C-BE32-E72D297353CC}">
-                <c16:uniqueId val="{0000000F-1203-43C0-A483-3AC5DC55E42C}"/>
-              </c:ext>
-            </c:extLst>
           </c:dPt>
-          <c:dLbls>
-            <c:numFmt formatCode="0.000" sourceLinked="0"/>
-            <c:spPr>
-              <a:noFill/>
-              <a:ln>
-                <a:noFill/>
-              </a:ln>
-              <a:effectLst/>
-            </c:spPr>
-            <c:txPr>
-              <a:bodyPr/>
-              <a:lstStyle/>
-              <a:p>
-                <a:pPr>
-                  <a:defRPr sz="1300" b="0" i="0" u="none" strike="noStrike">
-                    <a:solidFill>
-                      <a:srgbClr val="2B2F36"/>
-                    </a:solidFill>
-                    <a:latin typeface="+mn-lt"/>
-                  </a:defRPr>
-                </a:pPr>
-                <a:endParaRPr lang="en-US"/>
-              </a:p>
-            </c:txPr>
-            <c:showLegendKey val="0"/>
-            <c:showVal val="1"/>
-            <c:showCatName val="0"/>
-            <c:showSerName val="0"/>
-            <c:showPercent val="0"/>
-            <c:showBubbleSize val="0"/>
-            <c:showLeaderLines val="0"/>
-            <c:extLst>
-              <c:ext xmlns:c15="http://schemas.microsoft.com/office/drawing/2012/chart" uri="{CE6537A1-D6FC-4f65-9D91-7224C49458BB}">
-                <c15:showLeaderLines val="0"/>
-              </c:ext>
-            </c:extLst>
-          </c:dLbls>
           <c:cat>
-            <c:strRef>
+            <c:multiLvlStrRef>
               <c:f>Sheet1!$A$2:$A$9</c:f>
-              <c:strCache>
+              <c:multiLvlStrCache>
                 <c:ptCount val="8"/>
-                <c:pt idx="0">
-                  <c:v>Control</c:v>
-                </c:pt>
-                <c:pt idx="1">
-                  <c:v>Placebo</c:v>
-                </c:pt>
-                <c:pt idx="2">
-                  <c:v>Same + history</c:v>
-                </c:pt>
-                <c:pt idx="3">
-                  <c:v>Same, notes only</c:v>
-                </c:pt>
-                <c:pt idx="4">
-                  <c:v>Same, no history</c:v>
-                </c:pt>
-                <c:pt idx="5">
-                  <c:v>Other + history</c:v>
-                </c:pt>
-                <c:pt idx="6">
-                  <c:v>Other, no history</c:v>
-                </c:pt>
-                <c:pt idx="7">
-                  <c:v>Best-response bot</c:v>
-                </c:pt>
-              </c:strCache>
-            </c:strRef>
+                <c:lvl>
+                  <c:pt idx="0">
+                    <c:v>Control</c:v>
+                  </c:pt>
+                  <c:pt idx="1">
+                    <c:v>Placebo</c:v>
+                  </c:pt>
+                  <c:pt idx="2">
+                    <c:v>Same + history</c:v>
+                  </c:pt>
+                  <c:pt idx="3">
+                    <c:v>Same, notes only</c:v>
+                  </c:pt>
+                  <c:pt idx="4">
+                    <c:v>Same, no history</c:v>
+                  </c:pt>
+                  <c:pt idx="5">
+                    <c:v>Other + history</c:v>
+                  </c:pt>
+                  <c:pt idx="6">
+                    <c:v>Other, no history</c:v>
+                  </c:pt>
+                  <c:pt idx="7">
+                    <c:v>Best-response bot</c:v>
+                  </c:pt>
+                </c:lvl>
+              </c:multiLvlStrCache>
+            </c:multiLvlStrRef>
           </c:cat>
           <c:val>
             <c:numRef>
@@ -385,7 +334,7 @@
                   <c:v>0.9</c:v>
                 </c:pt>
                 <c:pt idx="1">
-                  <c:v>0.88400000000000001</c:v>
+                  <c:v>0.884</c:v>
                 </c:pt>
                 <c:pt idx="2">
                   <c:v>0.876</c:v>
@@ -394,37 +343,50 @@
                   <c:v>0.63</c:v>
                 </c:pt>
                 <c:pt idx="4">
-                  <c:v>0.28899999999999998</c:v>
+                  <c:v>0.289</c:v>
                 </c:pt>
                 <c:pt idx="5">
-                  <c:v>0.19900000000000001</c:v>
+                  <c:v>0.199</c:v>
                 </c:pt>
                 <c:pt idx="6">
-                  <c:v>3.9E-2</c:v>
+                  <c:v>0.039</c:v>
                 </c:pt>
                 <c:pt idx="7">
-                  <c:v>2.3E-2</c:v>
+                  <c:v>0.023</c:v>
                 </c:pt>
               </c:numCache>
             </c:numRef>
           </c:val>
-          <c:extLst>
-            <c:ext xmlns:c16="http://schemas.microsoft.com/office/drawing/2014/chart" uri="{C3380CC4-5D6E-409C-BE32-E72D297353CC}">
-              <c16:uniqueId val="{00000010-1203-43C0-A483-3AC5DC55E42C}"/>
-            </c:ext>
-          </c:extLst>
         </c:ser>
         <c:dLbls>
+          <c:numFmt formatCode="0.000" sourceLinked="0"/>
+          <c:txPr>
+            <a:bodyPr/>
+            <a:lstStyle/>
+            <a:p>
+              <a:pPr>
+                <a:defRPr b="0" i="0" strike="noStrike" sz="1300" u="none">
+                  <a:solidFill>
+                    <a:srgbClr val="2B2F36"/>
+                  </a:solidFill>
+                  <a:latin typeface="+mn-lt"/>
+                </a:defRPr>
+              </a:pPr>
+            </a:p>
+          </c:txPr>
           <c:showLegendKey val="0"/>
           <c:showVal val="1"/>
           <c:showCatName val="0"/>
           <c:showSerName val="0"/>
           <c:showPercent val="0"/>
           <c:showBubbleSize val="0"/>
+          <c:showLeaderLines val="0"/>
         </c:dLbls>
         <c:gapWidth val="150"/>
+        <c:overlap val="0"/>
         <c:axId val="2094734554"/>
         <c:axId val="2094734552"/>
+        <c:axId val="2094734556"/>
       </c:barChart>
       <c:catAx>
         <c:axId val="2094734554"/>
@@ -465,7 +427,6 @@
         <c:crosses val="autoZero"/>
         <c:auto val="1"/>
         <c:lblAlgn val="ctr"/>
-        <c:lblOffset val="100"/>
         <c:noMultiLvlLbl val="1"/>
       </c:catAx>
       <c:valAx>
@@ -476,7 +437,7 @@
           <c:min val="0"/>
         </c:scaling>
         <c:delete val="0"/>
-        <c:axPos val="t"/>
+        <c:axPos val="b"/>
         <c:majorGridlines>
           <c:spPr>
             <a:ln w="9525" cap="flat">
@@ -530,7 +491,6 @@
     </c:plotArea>
     <c:plotVisOnly val="1"/>
     <c:dispBlanksAs val="span"/>
-    <c:showDLblsOverMax val="1"/>
   </c:chart>
   <c:spPr>
     <a:noFill/>
@@ -567,10 +527,234 @@
           <a:chExt cx="0" cy="0"/>
         </a:xfrm>
       </p:grpSpPr>
+      <p:sp>
+        <p:nvSpPr>
+          <p:cNvPr id="2" name="Header Placeholder 1"/>
+          <p:cNvSpPr>
+            <a:spLocks noGrp="1"/>
+          </p:cNvSpPr>
+          <p:nvPr>
+            <p:ph type="hdr" sz="quarter"/>
+          </p:nvPr>
+        </p:nvSpPr>
+        <p:spPr>
+          <a:xfrm>
+            <a:off x="0" y="0"/>
+            <a:ext cx="2971800" cy="458788"/>
+          </a:xfrm>
+          <a:prstGeom prst="rect">
+            <a:avLst/>
+          </a:prstGeom>
+        </p:spPr>
+        <p:txBody>
+          <a:bodyPr vert="horz" lIns="91440" tIns="45720" rIns="91440" bIns="45720" rtlCol="0"/>
+          <a:lstStyle>
+            <a:lvl1pPr algn="l">
+              <a:defRPr sz="1200"/>
+            </a:lvl1pPr>
+          </a:lstStyle>
+          <a:p>
+            <a:endParaRPr lang="en-US"/>
+          </a:p>
+        </p:txBody>
+      </p:sp>
+      <p:sp>
+        <p:nvSpPr>
+          <p:cNvPr id="3" name="Date Placeholder 2"/>
+          <p:cNvSpPr>
+            <a:spLocks noGrp="1"/>
+          </p:cNvSpPr>
+          <p:nvPr>
+            <p:ph type="dt" idx="1"/>
+          </p:nvPr>
+        </p:nvSpPr>
+        <p:spPr>
+          <a:xfrm>
+            <a:off x="3884613" y="0"/>
+            <a:ext cx="2971800" cy="458788"/>
+          </a:xfrm>
+          <a:prstGeom prst="rect">
+            <a:avLst/>
+          </a:prstGeom>
+        </p:spPr>
+        <p:txBody>
+          <a:bodyPr vert="horz" lIns="91440" tIns="45720" rIns="91440" bIns="45720" rtlCol="0"/>
+          <a:lstStyle>
+            <a:lvl1pPr algn="r">
+              <a:defRPr sz="1200"/>
+            </a:lvl1pPr>
+          </a:lstStyle>
+          <a:p>
+            <a:fld id="{5282F153-3F37-0F45-9E97-73ACFA13230C}" type="datetimeFigureOut">
+              <a:rPr lang="en-US"/>
+              <a:t>7/23/19</a:t>
+            </a:fld>
+            <a:endParaRPr lang="en-US"/>
+          </a:p>
+        </p:txBody>
+      </p:sp>
+      <p:sp>
+        <p:nvSpPr>
+          <p:cNvPr id="4" name="Slide Image Placeholder 3"/>
+          <p:cNvSpPr>
+            <a:spLocks noGrp="1" noRot="1" noChangeAspect="1"/>
+          </p:cNvSpPr>
+          <p:nvPr>
+            <p:ph type="sldImg" idx="2"/>
+          </p:nvPr>
+        </p:nvSpPr>
+        <p:spPr>
+          <a:xfrm>
+            <a:off x="685800" y="1143000"/>
+            <a:ext cx="5486400" cy="3086100"/>
+          </a:xfrm>
+          <a:prstGeom prst="rect">
+            <a:avLst/>
+          </a:prstGeom>
+          <a:noFill/>
+          <a:ln w="12700">
+            <a:solidFill>
+              <a:prstClr val="black"/>
+            </a:solidFill>
+          </a:ln>
+        </p:spPr>
+        <p:txBody>
+          <a:bodyPr vert="horz" lIns="91440" tIns="45720" rIns="91440" bIns="45720" rtlCol="0" anchor="ctr"/>
+          <a:lstStyle/>
+          <a:p>
+            <a:endParaRPr lang="en-US"/>
+          </a:p>
+        </p:txBody>
+      </p:sp>
+      <p:sp>
+        <p:nvSpPr>
+          <p:cNvPr id="5" name="Notes Placeholder 4"/>
+          <p:cNvSpPr>
+            <a:spLocks noGrp="1"/>
+          </p:cNvSpPr>
+          <p:nvPr>
+            <p:ph type="body" sz="quarter" idx="3"/>
+          </p:nvPr>
+        </p:nvSpPr>
+        <p:spPr>
+          <a:xfrm>
+            <a:off x="685800" y="4400550"/>
+            <a:ext cx="5486400" cy="3600450"/>
+          </a:xfrm>
+          <a:prstGeom prst="rect">
+            <a:avLst/>
+          </a:prstGeom>
+        </p:spPr>
+        <p:txBody>
+          <a:bodyPr vert="horz" lIns="91440" tIns="45720" rIns="91440" bIns="45720" rtlCol="0"/>
+          <a:lstStyle/>
+          <a:p>
+            <a:pPr lvl="0"/>
+            <a:r>
+              <a:rPr lang="en-US"/>
+              <a:t>Click to edit Master text styles</a:t>
+            </a:r>
+          </a:p>
+          <a:p>
+            <a:pPr lvl="1"/>
+            <a:r>
+              <a:rPr lang="en-US"/>
+              <a:t>Second level</a:t>
+            </a:r>
+          </a:p>
+          <a:p>
+            <a:pPr lvl="2"/>
+            <a:r>
+              <a:rPr lang="en-US"/>
+              <a:t>Third level</a:t>
+            </a:r>
+          </a:p>
+          <a:p>
+            <a:pPr lvl="3"/>
+            <a:r>
+              <a:rPr lang="en-US"/>
+              <a:t>Fourth level</a:t>
+            </a:r>
+          </a:p>
+          <a:p>
+            <a:pPr lvl="4"/>
+            <a:r>
+              <a:rPr lang="en-US"/>
+              <a:t>Fifth level</a:t>
+            </a:r>
+          </a:p>
+        </p:txBody>
+      </p:sp>
+      <p:sp>
+        <p:nvSpPr>
+          <p:cNvPr id="6" name="Footer Placeholder 5"/>
+          <p:cNvSpPr>
+            <a:spLocks noGrp="1"/>
+          </p:cNvSpPr>
+          <p:nvPr>
+            <p:ph type="ftr" sz="quarter" idx="4"/>
+          </p:nvPr>
+        </p:nvSpPr>
+        <p:spPr>
+          <a:xfrm>
+            <a:off x="0" y="8685213"/>
+            <a:ext cx="2971800" cy="458787"/>
+          </a:xfrm>
+          <a:prstGeom prst="rect">
+            <a:avLst/>
+          </a:prstGeom>
+        </p:spPr>
+        <p:txBody>
+          <a:bodyPr vert="horz" lIns="91440" tIns="45720" rIns="91440" bIns="45720" rtlCol="0" anchor="b"/>
+          <a:lstStyle>
+            <a:lvl1pPr algn="l">
+              <a:defRPr sz="1200"/>
+            </a:lvl1pPr>
+          </a:lstStyle>
+          <a:p>
+            <a:endParaRPr lang="en-US"/>
+          </a:p>
+        </p:txBody>
+      </p:sp>
+      <p:sp>
+        <p:nvSpPr>
+          <p:cNvPr id="7" name="Slide Number Placeholder 6"/>
+          <p:cNvSpPr>
+            <a:spLocks noGrp="1"/>
+          </p:cNvSpPr>
+          <p:nvPr>
+            <p:ph type="sldNum" sz="quarter" idx="5"/>
+          </p:nvPr>
+        </p:nvSpPr>
+        <p:spPr>
+          <a:xfrm>
+            <a:off x="3884613" y="8685213"/>
+            <a:ext cx="2971800" cy="458787"/>
+          </a:xfrm>
+          <a:prstGeom prst="rect">
+            <a:avLst/>
+          </a:prstGeom>
+        </p:spPr>
+        <p:txBody>
+          <a:bodyPr vert="horz" lIns="91440" tIns="45720" rIns="91440" bIns="45720" rtlCol="0" anchor="b"/>
+          <a:lstStyle>
+            <a:lvl1pPr algn="r">
+              <a:defRPr sz="1200"/>
+            </a:lvl1pPr>
+          </a:lstStyle>
+          <a:p>
+            <a:fld id="{CE5E9CC1-C706-0F49-92D6-E571CC5EEA8F}" type="slidenum">
+              <a:rPr lang="en-US"/>
+              <a:t>‹#›</a:t>
+            </a:fld>
+            <a:endParaRPr lang="en-US"/>
+          </a:p>
+        </p:txBody>
+      </p:sp>
     </p:spTree>
     <p:extLst>
       <p:ext uri="{BB962C8B-B14F-4D97-AF65-F5344CB8AC3E}">
-        <p14:creationId xmlns:p14="http://schemas.microsoft.com/office/powerpoint/2010/main" val="1393504906"/>
+        <p14:creationId xmlns:p14="http://schemas.microsoft.com/office/powerpoint/2010/main" val="1024086991"/>
       </p:ext>
     </p:extLst>
   </p:cSld>
@@ -718,6 +902,7 @@
               <a:rPr lang="en-US" dirty="0"/>
               <a:t>Two AI agents that set prices for two competing firms often learn to keep prices high without being told to. We ask what happens when one of them is replaced. Short answer: the cartel survives if the new agent reads the old price history.</a:t>
             </a:r>
+            <a:endParaRPr lang="en-US" dirty="0"/>
           </a:p>
         </p:txBody>
       </p:sp>
@@ -805,6 +990,7 @@
               <a:rPr lang="en-US" dirty="0"/>
               <a:t>All numbers come from stored run data through the analysis code in the repository. The report lists every run, null results and failures.</a:t>
             </a:r>
+            <a:endParaRPr lang="en-US" dirty="0"/>
           </a:p>
         </p:txBody>
       </p:sp>
@@ -892,6 +1078,7 @@
               <a:rPr lang="en-US" dirty="0"/>
               <a:t>The answer tells a regulator which item a remedy must change: the agent, the data it inherits, or its memory.</a:t>
             </a:r>
+            <a:endParaRPr lang="en-US" dirty="0"/>
           </a:p>
         </p:txBody>
       </p:sp>
@@ -979,6 +1166,7 @@
               <a:rPr lang="en-US" dirty="0"/>
               <a:t>A profit index near 1 means the two agents behave like a cartel. We report both indices because they disagree when prices overshoot the monopoly price.</a:t>
             </a:r>
+            <a:endParaRPr lang="en-US" dirty="0"/>
           </a:p>
         </p:txBody>
       </p:sp>
@@ -1066,6 +1254,7 @@
               <a:rPr lang="en-US" dirty="0"/>
               <a:t>Six independent runs, hypotheses fixed in advance, 95% bootstrap intervals over markets. Runs without a stable cartel are reported too.</a:t>
             </a:r>
+            <a:endParaRPr lang="en-US" dirty="0"/>
           </a:p>
         </p:txBody>
       </p:sp>
@@ -1153,6 +1342,7 @@
               <a:rPr lang="en-US" dirty="0"/>
               <a:t>Profit index 0 = competitive, 1 = monopoly. 'Same + history' differs from no replacement by between -0.025 and +0.213 across the six runs.</a:t>
             </a:r>
+            <a:endParaRPr lang="en-US" dirty="0"/>
           </a:p>
         </p:txBody>
       </p:sp>
@@ -1240,6 +1430,7 @@
               <a:rPr lang="en-US" dirty="0"/>
               <a:t>The blank entrant has no anchor. It starts high and stays above the monopoly price, so both firms sell less. Only the best-response bot and the Mistral entrant reach competitive prices.</a:t>
             </a:r>
+            <a:endParaRPr lang="en-US" dirty="0"/>
           </a:p>
         </p:txBody>
       </p:sp>
@@ -1327,6 +1518,7 @@
               <a:rPr lang="en-US" dirty="0"/>
               <a:t>'A different model' is not one treatment. A sticky model keeps the inherited prices by inertia; an exploring model drifts to competition.</a:t>
             </a:r>
+            <a:endParaRPr lang="en-US" dirty="0"/>
           </a:p>
         </p:txBody>
       </p:sp>
@@ -1414,6 +1606,7 @@
               <a:rPr lang="en-US" dirty="0"/>
               <a:t>The inherited high prices persist because the agents anchor on what they see, not because they threaten a price war.</a:t>
             </a:r>
+            <a:endParaRPr lang="en-US" dirty="0"/>
           </a:p>
         </p:txBody>
       </p:sp>
@@ -1501,6 +1694,7 @@
               <a:rPr lang="en-US" dirty="0"/>
               <a:t>The unit of analysis moves from the agent to the agent and its context.</a:t>
             </a:r>
+            <a:endParaRPr lang="en-US" dirty="0"/>
           </a:p>
         </p:txBody>
       </p:sp>
@@ -1578,7 +1772,6 @@
         <a:solidFill>
           <a:srgbClr val="FFFFFF"/>
         </a:solidFill>
-        <a:effectLst/>
       </p:bgPr>
     </p:bg>
     <p:spTree>
@@ -1616,7 +1809,7 @@
           <a:bodyPr wrap="square" rtlCol="0" anchor="ctr"/>
           <a:lstStyle/>
           <a:p>
-            <a:pPr marL="0" indent="0">
+            <a:pPr indent="0" marL="0">
               <a:buNone/>
             </a:pPr>
             <a:r>
@@ -1637,11 +1830,9 @@
       <p:sp>
         <p:nvSpPr>
           <p:cNvPr id="3" name="Text 1"/>
-          <p:cNvSpPr>
-            <a:spLocks noGrp="1"/>
-          </p:cNvSpPr>
+          <p:cNvSpPr/>
           <p:nvPr>
-            <p:ph type="title" idx="101" hasCustomPrompt="1"/>
+            <p:ph idx="101" type="title" hasCustomPrompt="1"/>
           </p:nvPr>
         </p:nvSpPr>
         <p:spPr>
@@ -1658,7 +1849,7 @@
         <p:txBody>
           <a:bodyPr wrap="square" rtlCol="0"/>
           <a:lstStyle>
-            <a:lvl1pPr marL="0" indent="0" algn="l">
+            <a:lvl1pPr algn="l" indent="0" marL="0">
               <a:buNone/>
               <a:defRPr lang="en-US" sz="3000" b="1" dirty="0">
                 <a:solidFill>
@@ -1671,7 +1862,7 @@
             </a:lvl1pPr>
           </a:lstStyle>
           <a:p>
-            <a:pPr marL="0" indent="0" algn="l">
+            <a:pPr algn="l" indent="0" marL="0">
               <a:buNone/>
             </a:pPr>
             <a:endParaRPr lang="en-US" sz="3000" dirty="0"/>
@@ -1698,7 +1889,7 @@
           </a:prstGeom>
           <a:extLst>
             <a:ext uri="{C572A759-6A51-4108-AA02-DFA0A04FC94B}">
-              <ma14:wrappingTextBoxFlag xmlns:ma14="http://schemas.microsoft.com/office/mac/drawingml/2011/main" xmlns="" val="0"/>
+              <ma14:wrappingTextBoxFlag xmlns:ma14="http://schemas.microsoft.com/office/mac/drawingml/2011/main" val="0"/>
             </a:ext>
           </a:extLst>
         </p:spPr>
@@ -1719,8 +1910,8 @@
           <a:p>
             <a:pPr algn="l"/>
             <a:fld id="{F7021451-1387-4CA6-816F-3879F97B5CBC}" type="slidenum">
-              <a:rPr lang="en-US" b="0"/>
-              <a:t>‹#›</a:t>
+              <a:rPr b="0" lang="en-US"/>
+              <a:t>1002</a:t>
             </a:fld>
             <a:endParaRPr lang="en-US"/>
           </a:p>
@@ -1742,7 +1933,6 @@
         <a:solidFill>
           <a:srgbClr val="FFFFFF"/>
         </a:solidFill>
-        <a:effectLst/>
       </p:bgPr>
     </p:bg>
     <p:spTree>
@@ -1762,11 +1952,9 @@
       <p:sp>
         <p:nvSpPr>
           <p:cNvPr id="2" name="Text 0"/>
-          <p:cNvSpPr>
-            <a:spLocks noGrp="1"/>
-          </p:cNvSpPr>
+          <p:cNvSpPr/>
           <p:nvPr>
-            <p:ph type="title" idx="100" hasCustomPrompt="1"/>
+            <p:ph idx="100" type="title" hasCustomPrompt="1"/>
           </p:nvPr>
         </p:nvSpPr>
         <p:spPr>
@@ -1783,7 +1971,7 @@
         <p:txBody>
           <a:bodyPr wrap="square" rtlCol="0"/>
           <a:lstStyle>
-            <a:lvl1pPr marL="0" indent="0" algn="l">
+            <a:lvl1pPr algn="l" indent="0" marL="0">
               <a:buNone/>
               <a:defRPr lang="en-US" sz="3000" b="1" dirty="0">
                 <a:solidFill>
@@ -1796,7 +1984,7 @@
             </a:lvl1pPr>
           </a:lstStyle>
           <a:p>
-            <a:pPr marL="0" indent="0" algn="l">
+            <a:pPr algn="l" indent="0" marL="0">
               <a:buNone/>
             </a:pPr>
             <a:endParaRPr lang="en-US" sz="3000" dirty="0"/>
@@ -1823,7 +2011,7 @@
           </a:prstGeom>
           <a:extLst>
             <a:ext uri="{C572A759-6A51-4108-AA02-DFA0A04FC94B}">
-              <ma14:wrappingTextBoxFlag xmlns:ma14="http://schemas.microsoft.com/office/mac/drawingml/2011/main" xmlns="" val="0"/>
+              <ma14:wrappingTextBoxFlag xmlns:ma14="http://schemas.microsoft.com/office/mac/drawingml/2011/main" val="0"/>
             </a:ext>
           </a:extLst>
         </p:spPr>
@@ -1844,8 +2032,8 @@
           <a:p>
             <a:pPr algn="l"/>
             <a:fld id="{F7021451-1387-4CA6-816F-3879F97B5CBC}" type="slidenum">
-              <a:rPr lang="en-US" b="0"/>
-              <a:t>‹#›</a:t>
+              <a:rPr b="0" lang="en-US"/>
+              <a:t>1003</a:t>
             </a:fld>
             <a:endParaRPr lang="en-US"/>
           </a:p>
@@ -1862,11 +2050,6 @@
 <file path=ppt/slideMasters/slideMaster1.xml><?xml version="1.0" encoding="utf-8"?>
 <p:sldMaster xmlns:a="http://schemas.openxmlformats.org/drawingml/2006/main" xmlns:r="http://schemas.openxmlformats.org/officeDocument/2006/relationships" xmlns:p="http://schemas.openxmlformats.org/presentationml/2006/main">
   <p:cSld>
-    <p:bg>
-      <p:bgRef idx="1001">
-        <a:schemeClr val="bg1"/>
-      </p:bgRef>
-    </p:bg>
     <p:spTree>
       <p:nvGrpSpPr>
         <p:cNvPr id="1" name=""/>
@@ -1901,7 +2084,7 @@
           </a:prstGeom>
           <a:extLst>
             <a:ext uri="{C572A759-6A51-4108-AA02-DFA0A04FC94B}">
-              <ma14:wrappingTextBoxFlag xmlns:ma14="http://schemas.microsoft.com/office/mac/drawingml/2011/main" xmlns="" val="0"/>
+              <ma14:wrappingTextBoxFlag xmlns:ma14="http://schemas.microsoft.com/office/mac/drawingml/2011/main" val="0"/>
             </a:ext>
           </a:extLst>
         </p:spPr>
@@ -1922,8 +2105,8 @@
           <a:p>
             <a:pPr algn="l"/>
             <a:fld id="{F7021451-1387-4CA6-816F-3879F97B5CBC}" type="slidenum">
-              <a:rPr lang="en-US" b="0"/>
-              <a:t>‹#›</a:t>
+              <a:rPr b="0" lang="en-US"/>
+              <a:t>null</a:t>
             </a:fld>
             <a:endParaRPr lang="en-US"/>
           </a:p>
@@ -2229,7 +2412,7 @@
           <a:bodyPr wrap="square" lIns="0" tIns="0" rIns="0" bIns="0" rtlCol="0" anchor="t"/>
           <a:lstStyle/>
           <a:p>
-            <a:pPr marL="0" indent="0">
+            <a:pPr indent="0" marL="0">
               <a:buNone/>
             </a:pPr>
             <a:r>
@@ -2268,7 +2451,7 @@
           <a:bodyPr wrap="square" lIns="0" tIns="0" rIns="0" bIns="0" rtlCol="0" anchor="t"/>
           <a:lstStyle/>
           <a:p>
-            <a:pPr marL="0" indent="0">
+            <a:pPr indent="0" marL="0">
               <a:buNone/>
             </a:pPr>
             <a:r>
@@ -2307,7 +2490,7 @@
           <a:bodyPr wrap="square" lIns="0" tIns="0" rIns="0" bIns="0" rtlCol="0" anchor="t"/>
           <a:lstStyle/>
           <a:p>
-            <a:pPr marL="0" indent="0">
+            <a:pPr indent="0" marL="0">
               <a:buNone/>
             </a:pPr>
             <a:r>
@@ -2346,7 +2529,7 @@
           <a:bodyPr wrap="square" lIns="0" tIns="0" rIns="0" bIns="0" rtlCol="0" anchor="t"/>
           <a:lstStyle/>
           <a:p>
-            <a:pPr marL="0" indent="0">
+            <a:pPr indent="0" marL="0">
               <a:buNone/>
             </a:pPr>
             <a:r>
@@ -2385,7 +2568,7 @@
           <a:bodyPr wrap="square" lIns="0" tIns="0" rIns="0" bIns="0" rtlCol="0" anchor="t"/>
           <a:lstStyle/>
           <a:p>
-            <a:pPr marL="0" indent="0">
+            <a:pPr indent="0" marL="0">
               <a:buNone/>
             </a:pPr>
             <a:r>
@@ -2424,7 +2607,7 @@
           <a:bodyPr wrap="square" lIns="0" tIns="0" rIns="0" bIns="0" rtlCol="0" anchor="t"/>
           <a:lstStyle/>
           <a:p>
-            <a:pPr marL="0" indent="0">
+            <a:pPr indent="0" marL="0">
               <a:buNone/>
             </a:pPr>
             <a:r>
@@ -2463,7 +2646,7 @@
           <a:bodyPr wrap="square" lIns="0" tIns="0" rIns="0" bIns="0" rtlCol="0" anchor="t"/>
           <a:lstStyle/>
           <a:p>
-            <a:pPr marL="0" indent="0">
+            <a:pPr indent="0" marL="0">
               <a:buNone/>
             </a:pPr>
             <a:r>
@@ -2502,7 +2685,7 @@
           <a:bodyPr wrap="square" lIns="0" tIns="0" rIns="0" bIns="0" rtlCol="0" anchor="t"/>
           <a:lstStyle/>
           <a:p>
-            <a:pPr marL="0" indent="0">
+            <a:pPr indent="0" marL="0">
               <a:buNone/>
             </a:pPr>
             <a:r>
@@ -2541,7 +2724,7 @@
           <a:bodyPr wrap="square" lIns="0" tIns="0" rIns="0" bIns="0" rtlCol="0" anchor="t"/>
           <a:lstStyle/>
           <a:p>
-            <a:pPr marL="0" indent="0">
+            <a:pPr indent="0" marL="0">
               <a:buNone/>
             </a:pPr>
             <a:r>
@@ -2580,7 +2763,7 @@
           <a:bodyPr wrap="square" lIns="0" tIns="0" rIns="0" bIns="0" rtlCol="0" anchor="t"/>
           <a:lstStyle/>
           <a:p>
-            <a:pPr marL="0" indent="0">
+            <a:pPr indent="0" marL="0">
               <a:buNone/>
             </a:pPr>
             <a:r>
@@ -2595,6 +2778,36 @@
               <a:t>Supratik Bhowal  ·  with Apart Research</a:t>
             </a:r>
             <a:endParaRPr lang="en-US" sz="1500" dirty="0"/>
+          </a:p>
+        </p:txBody>
+      </p:sp>
+      <p:sp>
+        <p:nvSpPr>
+          <p:cNvPr id="13" name="Text 0"/>
+          <p:cNvSpPr/>
+          <p:nvPr>
+            <p:ph idx="100" type="title" hasCustomPrompt="1"/>
+          </p:nvPr>
+        </p:nvSpPr>
+        <p:spPr>
+          <a:xfrm>
+            <a:off x="548640" y="320040"/>
+            <a:ext cx="11064240" cy="822960"/>
+          </a:xfrm>
+          <a:prstGeom prst="rect">
+            <a:avLst/>
+          </a:prstGeom>
+          <a:noFill/>
+          <a:ln/>
+        </p:spPr>
+        <p:txBody>
+          <a:bodyPr wrap="square" rtlCol="0" anchor="ctr"/>
+          <a:lstStyle/>
+          <a:p>
+            <a:pPr algn="l" indent="0" marL="0">
+              <a:buNone/>
+            </a:pPr>
+            <a:endParaRPr lang="en-US" sz="3000" dirty="0"/>
           </a:p>
         </p:txBody>
       </p:sp>
@@ -2618,7 +2831,7 @@
           </a:prstGeom>
           <a:extLst>
             <a:ext uri="{C572A759-6A51-4108-AA02-DFA0A04FC94B}">
-              <ma14:wrappingTextBoxFlag xmlns:ma14="http://schemas.microsoft.com/office/mac/drawingml/2011/main" xmlns="" val="0"/>
+              <ma14:wrappingTextBoxFlag xmlns:ma14="http://schemas.microsoft.com/office/mac/drawingml/2011/main" val="0"/>
             </a:ext>
           </a:extLst>
         </p:spPr>
@@ -2639,7 +2852,7 @@
           <a:p>
             <a:pPr algn="l"/>
             <a:fld id="{F7021451-1387-4CA6-816F-3879F97B5CBC}" type="slidenum">
-              <a:rPr lang="en-US" b="0"/>
+              <a:rPr b="0" lang="en-US"/>
               <a:t>1</a:t>
             </a:fld>
             <a:endParaRPr lang="en-US"/>
@@ -2674,11 +2887,9 @@
       <p:sp>
         <p:nvSpPr>
           <p:cNvPr id="2" name="Text 1"/>
-          <p:cNvSpPr>
-            <a:spLocks noGrp="1"/>
-          </p:cNvSpPr>
+          <p:cNvSpPr/>
           <p:nvPr>
-            <p:ph type="title" idx="101" hasCustomPrompt="1"/>
+            <p:ph idx="101" type="title" hasCustomPrompt="1"/>
           </p:nvPr>
         </p:nvSpPr>
         <p:spPr>
@@ -2696,7 +2907,7 @@
           <a:bodyPr wrap="square" rtlCol="0" anchor="ctr"/>
           <a:lstStyle/>
           <a:p>
-            <a:pPr marL="0" indent="0" algn="l">
+            <a:pPr algn="l" indent="0" marL="0">
               <a:buNone/>
             </a:pPr>
             <a:r>
@@ -2762,7 +2973,7 @@
           <a:bodyPr wrap="square" lIns="0" tIns="0" rIns="0" bIns="0" rtlCol="0" anchor="t"/>
           <a:lstStyle/>
           <a:p>
-            <a:pPr marL="0" indent="0">
+            <a:pPr indent="0" marL="0">
               <a:buNone/>
             </a:pPr>
             <a:r>
@@ -2934,7 +3145,7 @@
           <a:bodyPr wrap="square" lIns="0" tIns="0" rIns="0" bIns="0" rtlCol="0" anchor="t"/>
           <a:lstStyle/>
           <a:p>
-            <a:pPr marL="0" indent="0">
+            <a:pPr indent="0" marL="0">
               <a:buNone/>
             </a:pPr>
             <a:r>
@@ -3058,7 +3269,7 @@
           <a:bodyPr wrap="square" lIns="0" tIns="0" rIns="0" bIns="0" rtlCol="0" anchor="t"/>
           <a:lstStyle/>
           <a:p>
-            <a:pPr marL="0" indent="0">
+            <a:pPr indent="0" marL="0">
               <a:buNone/>
             </a:pPr>
             <a:r>
@@ -3097,7 +3308,7 @@
           <a:bodyPr wrap="square" lIns="0" tIns="0" rIns="0" bIns="0" rtlCol="0" anchor="t"/>
           <a:lstStyle/>
           <a:p>
-            <a:pPr marL="0" indent="0">
+            <a:pPr indent="0" marL="0">
               <a:buNone/>
             </a:pPr>
             <a:r>
@@ -3108,7 +3319,7 @@
                 <a:latin typeface="Times New Roman" pitchFamily="34" charset="0"/>
                 <a:ea typeface="Times New Roman" pitchFamily="34" charset="-122"/>
                 <a:cs typeface="Times New Roman" pitchFamily="34" charset="-120"/>
-                <a:hlinkClick r:id="rId3">
+                <a:hlinkClick r:id="rId1" invalidUrl="" action="" tgtFrame="" tooltip="" history="1" highlightClick="0" endSnd="0">
                   <a:extLst>
                     <a:ext uri="{A12FA001-AC4F-418D-AE19-62706E023703}">
                       <ahyp:hlinkClr xmlns:ahyp="http://schemas.microsoft.com/office/drawing/2018/hyperlinkcolor" val="tx"/>
@@ -3142,7 +3353,7 @@
           </a:prstGeom>
           <a:extLst>
             <a:ext uri="{C572A759-6A51-4108-AA02-DFA0A04FC94B}">
-              <ma14:wrappingTextBoxFlag xmlns:ma14="http://schemas.microsoft.com/office/mac/drawingml/2011/main" xmlns="" val="0"/>
+              <ma14:wrappingTextBoxFlag xmlns:ma14="http://schemas.microsoft.com/office/mac/drawingml/2011/main" val="0"/>
             </a:ext>
           </a:extLst>
         </p:spPr>
@@ -3163,7 +3374,7 @@
           <a:p>
             <a:pPr algn="l"/>
             <a:fld id="{F7021451-1387-4CA6-816F-3879F97B5CBC}" type="slidenum">
-              <a:rPr lang="en-US" b="0"/>
+              <a:rPr b="0" lang="en-US"/>
               <a:t>10</a:t>
             </a:fld>
             <a:endParaRPr lang="en-US"/>
@@ -3198,11 +3409,9 @@
       <p:sp>
         <p:nvSpPr>
           <p:cNvPr id="2" name="Text 1"/>
-          <p:cNvSpPr>
-            <a:spLocks noGrp="1"/>
-          </p:cNvSpPr>
+          <p:cNvSpPr/>
           <p:nvPr>
-            <p:ph type="title" idx="101" hasCustomPrompt="1"/>
+            <p:ph idx="101" type="title" hasCustomPrompt="1"/>
           </p:nvPr>
         </p:nvSpPr>
         <p:spPr>
@@ -3220,7 +3429,7 @@
           <a:bodyPr wrap="square" rtlCol="0" anchor="ctr"/>
           <a:lstStyle/>
           <a:p>
-            <a:pPr marL="0" indent="0" algn="l">
+            <a:pPr algn="l" indent="0" marL="0">
               <a:buNone/>
             </a:pPr>
             <a:r>
@@ -3259,7 +3468,7 @@
           <a:bodyPr wrap="square" lIns="0" tIns="0" rIns="0" bIns="0" rtlCol="0" anchor="t"/>
           <a:lstStyle/>
           <a:p>
-            <a:pPr marL="0" indent="0">
+            <a:pPr indent="0" marL="0">
               <a:buNone/>
             </a:pPr>
             <a:r>
@@ -3276,7 +3485,7 @@
             <a:endParaRPr lang="en-US" sz="1800" dirty="0"/>
           </a:p>
           <a:p>
-            <a:pPr marL="0" indent="0">
+            <a:pPr indent="0" marL="0">
               <a:buNone/>
             </a:pPr>
             <a:r>
@@ -3293,7 +3502,7 @@
             <a:endParaRPr lang="en-US" sz="1800" dirty="0"/>
           </a:p>
           <a:p>
-            <a:pPr marL="0" indent="0">
+            <a:pPr indent="0" marL="0">
               <a:buNone/>
             </a:pPr>
             <a:r>
@@ -3310,7 +3519,7 @@
             <a:endParaRPr lang="en-US" sz="1800" dirty="0"/>
           </a:p>
           <a:p>
-            <a:pPr marL="0" indent="0">
+            <a:pPr indent="0" marL="0">
               <a:buNone/>
             </a:pPr>
             <a:r>
@@ -3327,7 +3536,7 @@
             <a:endParaRPr lang="en-US" sz="1800" dirty="0"/>
           </a:p>
           <a:p>
-            <a:pPr marL="0" indent="0">
+            <a:pPr indent="0" marL="0">
               <a:buNone/>
             </a:pPr>
             <a:r>
@@ -3418,7 +3627,7 @@
           <a:bodyPr wrap="square" lIns="0" tIns="0" rIns="0" bIns="0" rtlCol="0" anchor="ctr"/>
           <a:lstStyle/>
           <a:p>
-            <a:pPr marL="0" indent="0" algn="ctr">
+            <a:pPr algn="ctr" indent="0" marL="0">
               <a:buNone/>
             </a:pPr>
             <a:r>
@@ -3457,7 +3666,7 @@
           <a:bodyPr wrap="square" lIns="0" tIns="0" rIns="0" bIns="0" rtlCol="0" anchor="t"/>
           <a:lstStyle/>
           <a:p>
-            <a:pPr marL="0" indent="0">
+            <a:pPr indent="0" marL="0">
               <a:buNone/>
             </a:pPr>
             <a:r>
@@ -3496,7 +3705,7 @@
           <a:bodyPr wrap="square" lIns="0" tIns="0" rIns="0" bIns="0" rtlCol="0" anchor="t"/>
           <a:lstStyle/>
           <a:p>
-            <a:pPr marL="0" indent="0">
+            <a:pPr indent="0" marL="0">
               <a:buNone/>
             </a:pPr>
             <a:r>
@@ -3587,7 +3796,7 @@
           <a:bodyPr wrap="square" lIns="0" tIns="0" rIns="0" bIns="0" rtlCol="0" anchor="ctr"/>
           <a:lstStyle/>
           <a:p>
-            <a:pPr marL="0" indent="0" algn="ctr">
+            <a:pPr algn="ctr" indent="0" marL="0">
               <a:buNone/>
             </a:pPr>
             <a:r>
@@ -3626,7 +3835,7 @@
           <a:bodyPr wrap="square" lIns="0" tIns="0" rIns="0" bIns="0" rtlCol="0" anchor="t"/>
           <a:lstStyle/>
           <a:p>
-            <a:pPr marL="0" indent="0">
+            <a:pPr indent="0" marL="0">
               <a:buNone/>
             </a:pPr>
             <a:r>
@@ -3665,7 +3874,7 @@
           <a:bodyPr wrap="square" lIns="0" tIns="0" rIns="0" bIns="0" rtlCol="0" anchor="t"/>
           <a:lstStyle/>
           <a:p>
-            <a:pPr marL="0" indent="0">
+            <a:pPr indent="0" marL="0">
               <a:buNone/>
             </a:pPr>
             <a:r>
@@ -3756,7 +3965,7 @@
           <a:bodyPr wrap="square" lIns="0" tIns="0" rIns="0" bIns="0" rtlCol="0" anchor="ctr"/>
           <a:lstStyle/>
           <a:p>
-            <a:pPr marL="0" indent="0" algn="ctr">
+            <a:pPr algn="ctr" indent="0" marL="0">
               <a:buNone/>
             </a:pPr>
             <a:r>
@@ -3795,7 +4004,7 @@
           <a:bodyPr wrap="square" lIns="0" tIns="0" rIns="0" bIns="0" rtlCol="0" anchor="t"/>
           <a:lstStyle/>
           <a:p>
-            <a:pPr marL="0" indent="0">
+            <a:pPr indent="0" marL="0">
               <a:buNone/>
             </a:pPr>
             <a:r>
@@ -3834,7 +4043,7 @@
           <a:bodyPr wrap="square" lIns="0" tIns="0" rIns="0" bIns="0" rtlCol="0" anchor="t"/>
           <a:lstStyle/>
           <a:p>
-            <a:pPr marL="0" indent="0">
+            <a:pPr indent="0" marL="0">
               <a:buNone/>
             </a:pPr>
             <a:r>
@@ -3872,7 +4081,7 @@
           </a:prstGeom>
           <a:extLst>
             <a:ext uri="{C572A759-6A51-4108-AA02-DFA0A04FC94B}">
-              <ma14:wrappingTextBoxFlag xmlns:ma14="http://schemas.microsoft.com/office/mac/drawingml/2011/main" xmlns="" val="0"/>
+              <ma14:wrappingTextBoxFlag xmlns:ma14="http://schemas.microsoft.com/office/mac/drawingml/2011/main" val="0"/>
             </a:ext>
           </a:extLst>
         </p:spPr>
@@ -3893,7 +4102,7 @@
           <a:p>
             <a:pPr algn="l"/>
             <a:fld id="{F7021451-1387-4CA6-816F-3879F97B5CBC}" type="slidenum">
-              <a:rPr lang="en-US" b="0"/>
+              <a:rPr b="0" lang="en-US"/>
               <a:t>2</a:t>
             </a:fld>
             <a:endParaRPr lang="en-US"/>
@@ -3928,11 +4137,9 @@
       <p:sp>
         <p:nvSpPr>
           <p:cNvPr id="2" name="Text 1"/>
-          <p:cNvSpPr>
-            <a:spLocks noGrp="1"/>
-          </p:cNvSpPr>
+          <p:cNvSpPr/>
           <p:nvPr>
-            <p:ph type="title" idx="101" hasCustomPrompt="1"/>
+            <p:ph idx="101" type="title" hasCustomPrompt="1"/>
           </p:nvPr>
         </p:nvSpPr>
         <p:spPr>
@@ -3950,7 +4157,7 @@
           <a:bodyPr wrap="square" rtlCol="0" anchor="ctr"/>
           <a:lstStyle/>
           <a:p>
-            <a:pPr marL="0" indent="0" algn="l">
+            <a:pPr algn="l" indent="0" marL="0">
               <a:buNone/>
             </a:pPr>
             <a:r>
@@ -3989,7 +4196,7 @@
           <a:bodyPr wrap="square" lIns="0" tIns="0" rIns="0" bIns="0" rtlCol="0" anchor="t"/>
           <a:lstStyle/>
           <a:p>
-            <a:pPr marL="0" indent="0">
+            <a:pPr indent="0" marL="0">
               <a:spcAft>
                 <a:spcPts val="600"/>
               </a:spcAft>
@@ -4006,28 +4213,14 @@
               </a:rPr>
               <a:t>Market: </a:t>
             </a:r>
-            <a:r>
-              <a:rPr lang="en-US" sz="1800" dirty="0">
-                <a:solidFill>
-                  <a:srgbClr val="2B2F36"/>
-                </a:solidFill>
-                <a:latin typeface="Times New Roman" pitchFamily="34" charset="0"/>
-                <a:ea typeface="Times New Roman" pitchFamily="34" charset="-122"/>
-                <a:cs typeface="Times New Roman" pitchFamily="34" charset="-120"/>
-              </a:rPr>
-              <a:t>two firms sell similar products; buyers choose by price (logit Bertrand duopoly, Calvano et al. 2020).</a:t>
-            </a:r>
-            <a:endParaRPr lang="en-US" sz="1800" dirty="0"/>
-          </a:p>
-          <a:p>
-            <a:pPr marL="0" indent="0">
+            <a:pPr indent="0" marL="0">
               <a:spcAft>
                 <a:spcPts val="600"/>
               </a:spcAft>
               <a:buNone/>
             </a:pPr>
             <a:r>
-              <a:rPr lang="en-US" sz="800" dirty="0">
+              <a:rPr lang="en-US" sz="1800" dirty="0">
                 <a:solidFill>
                   <a:srgbClr val="2B2F36"/>
                 </a:solidFill>
@@ -4035,19 +4228,19 @@
                 <a:ea typeface="Times New Roman" pitchFamily="34" charset="-122"/>
                 <a:cs typeface="Times New Roman" pitchFamily="34" charset="-120"/>
               </a:rPr>
-              <a:t> </a:t>
+              <a:t>two firms sell similar products; buyers choose by price (logit Bertrand duopoly, Calvano et al. 2020).</a:t>
             </a:r>
             <a:endParaRPr lang="en-US" sz="1800" dirty="0"/>
           </a:p>
           <a:p>
-            <a:pPr marL="0" indent="0">
+            <a:pPr indent="0" marL="0">
               <a:spcAft>
                 <a:spcPts val="600"/>
               </a:spcAft>
               <a:buNone/>
             </a:pPr>
             <a:r>
-              <a:rPr lang="en-US" sz="1800" b="1" dirty="0">
+              <a:rPr lang="en-US" sz="800" dirty="0">
                 <a:solidFill>
                   <a:srgbClr val="2B2F36"/>
                 </a:solidFill>
@@ -4055,30 +4248,19 @@
                 <a:ea typeface="Times New Roman" pitchFamily="34" charset="-122"/>
                 <a:cs typeface="Times New Roman" pitchFamily="34" charset="-120"/>
               </a:rPr>
-              <a:t>Agents: </a:t>
-            </a:r>
-            <a:r>
-              <a:rPr lang="en-US" sz="1800" dirty="0">
-                <a:solidFill>
-                  <a:srgbClr val="2B2F36"/>
-                </a:solidFill>
-                <a:latin typeface="Times New Roman" pitchFamily="34" charset="0"/>
-                <a:ea typeface="Times New Roman" pitchFamily="34" charset="-122"/>
-                <a:cs typeface="Times New Roman" pitchFamily="34" charset="-120"/>
-              </a:rPr>
-              <a:t>each firm is an open LLM. Each round it sees the rules, its last 30 rounds and its notes, and answers with a price and new notes. The prompt never mentions collusion.</a:t>
+              <a:t> </a:t>
             </a:r>
             <a:endParaRPr lang="en-US" sz="1800" dirty="0"/>
           </a:p>
           <a:p>
-            <a:pPr marL="0" indent="0">
+            <a:pPr indent="0" marL="0">
               <a:spcAft>
                 <a:spcPts val="600"/>
               </a:spcAft>
               <a:buNone/>
             </a:pPr>
             <a:r>
-              <a:rPr lang="en-US" sz="800" dirty="0">
+              <a:rPr lang="en-US" sz="1800" b="1" dirty="0">
                 <a:solidFill>
                   <a:srgbClr val="2B2F36"/>
                 </a:solidFill>
@@ -4086,18 +4268,55 @@
                 <a:ea typeface="Times New Roman" pitchFamily="34" charset="-122"/>
                 <a:cs typeface="Times New Roman" pitchFamily="34" charset="-120"/>
               </a:rPr>
-              <a:t> </a:t>
-            </a:r>
-            <a:endParaRPr lang="en-US" sz="1800" dirty="0"/>
-          </a:p>
-          <a:p>
-            <a:pPr marL="0" indent="0">
+              <a:t>Agents: </a:t>
+            </a:r>
+            <a:pPr indent="0" marL="0">
               <a:spcAft>
                 <a:spcPts val="600"/>
               </a:spcAft>
               <a:buNone/>
             </a:pPr>
             <a:r>
+              <a:rPr lang="en-US" sz="1800" dirty="0">
+                <a:solidFill>
+                  <a:srgbClr val="2B2F36"/>
+                </a:solidFill>
+                <a:latin typeface="Times New Roman" pitchFamily="34" charset="0"/>
+                <a:ea typeface="Times New Roman" pitchFamily="34" charset="-122"/>
+                <a:cs typeface="Times New Roman" pitchFamily="34" charset="-120"/>
+              </a:rPr>
+              <a:t>each firm is an open LLM. Each round it sees the rules, its last 30 rounds and its notes, and answers with a price and new notes. The prompt never mentions collusion.</a:t>
+            </a:r>
+            <a:endParaRPr lang="en-US" sz="1800" dirty="0"/>
+          </a:p>
+          <a:p>
+            <a:pPr indent="0" marL="0">
+              <a:spcAft>
+                <a:spcPts val="600"/>
+              </a:spcAft>
+              <a:buNone/>
+            </a:pPr>
+            <a:r>
+              <a:rPr lang="en-US" sz="800" dirty="0">
+                <a:solidFill>
+                  <a:srgbClr val="2B2F36"/>
+                </a:solidFill>
+                <a:latin typeface="Times New Roman" pitchFamily="34" charset="0"/>
+                <a:ea typeface="Times New Roman" pitchFamily="34" charset="-122"/>
+                <a:cs typeface="Times New Roman" pitchFamily="34" charset="-120"/>
+              </a:rPr>
+              <a:t> </a:t>
+            </a:r>
+            <a:endParaRPr lang="en-US" sz="1800" dirty="0"/>
+          </a:p>
+          <a:p>
+            <a:pPr indent="0" marL="0">
+              <a:spcAft>
+                <a:spcPts val="600"/>
+              </a:spcAft>
+              <a:buNone/>
+            </a:pPr>
+            <a:r>
               <a:rPr lang="en-US" sz="1800" b="1" dirty="0">
                 <a:solidFill>
                   <a:srgbClr val="2B2F36"/>
@@ -4108,6 +4327,12 @@
               </a:rPr>
               <a:t>Models: </a:t>
             </a:r>
+            <a:pPr indent="0" marL="0">
+              <a:spcAft>
+                <a:spcPts val="600"/>
+              </a:spcAft>
+              <a:buNone/>
+            </a:pPr>
             <a:r>
               <a:rPr lang="en-US" sz="1800" dirty="0">
                 <a:solidFill>
@@ -4171,7 +4396,7 @@
           <a:bodyPr wrap="square" lIns="0" tIns="0" rIns="0" bIns="0" rtlCol="0" anchor="t"/>
           <a:lstStyle/>
           <a:p>
-            <a:pPr marL="0" indent="0">
+            <a:pPr indent="0" marL="0">
               <a:buNone/>
             </a:pPr>
             <a:r>
@@ -4285,7 +4510,7 @@
           <a:bodyPr wrap="square" lIns="0" tIns="0" rIns="0" bIns="0" rtlCol="0" anchor="t"/>
           <a:lstStyle/>
           <a:p>
-            <a:pPr marL="0" indent="0">
+            <a:pPr indent="0" marL="0">
               <a:buNone/>
             </a:pPr>
             <a:r>
@@ -4302,7 +4527,7 @@
             <a:endParaRPr lang="en-US" sz="1400" dirty="0"/>
           </a:p>
           <a:p>
-            <a:pPr marL="0" indent="0">
+            <a:pPr indent="0" marL="0">
               <a:buNone/>
             </a:pPr>
             <a:r>
@@ -4341,7 +4566,7 @@
           <a:bodyPr wrap="square" lIns="0" tIns="0" rIns="0" bIns="0" rtlCol="0" anchor="t"/>
           <a:lstStyle/>
           <a:p>
-            <a:pPr marL="0" indent="0" algn="r">
+            <a:pPr algn="r" indent="0" marL="0">
               <a:buNone/>
             </a:pPr>
             <a:r>
@@ -4358,7 +4583,7 @@
             <a:endParaRPr lang="en-US" sz="1400" dirty="0"/>
           </a:p>
           <a:p>
-            <a:pPr marL="0" indent="0" algn="r">
+            <a:pPr algn="r" indent="0" marL="0">
               <a:buNone/>
             </a:pPr>
             <a:r>
@@ -4397,7 +4622,7 @@
           <a:bodyPr wrap="square" lIns="0" tIns="0" rIns="0" bIns="0" rtlCol="0" anchor="t"/>
           <a:lstStyle/>
           <a:p>
-            <a:pPr marL="0" indent="0">
+            <a:pPr indent="0" marL="0">
               <a:buNone/>
             </a:pPr>
             <a:r>
@@ -4435,7 +4660,7 @@
           </a:prstGeom>
           <a:extLst>
             <a:ext uri="{C572A759-6A51-4108-AA02-DFA0A04FC94B}">
-              <ma14:wrappingTextBoxFlag xmlns:ma14="http://schemas.microsoft.com/office/mac/drawingml/2011/main" xmlns="" val="0"/>
+              <ma14:wrappingTextBoxFlag xmlns:ma14="http://schemas.microsoft.com/office/mac/drawingml/2011/main" val="0"/>
             </a:ext>
           </a:extLst>
         </p:spPr>
@@ -4456,7 +4681,7 @@
           <a:p>
             <a:pPr algn="l"/>
             <a:fld id="{F7021451-1387-4CA6-816F-3879F97B5CBC}" type="slidenum">
-              <a:rPr lang="en-US" b="0"/>
+              <a:rPr b="0" lang="en-US"/>
               <a:t>3</a:t>
             </a:fld>
             <a:endParaRPr lang="en-US"/>
@@ -4491,11 +4716,9 @@
       <p:sp>
         <p:nvSpPr>
           <p:cNvPr id="2" name="Text 1"/>
-          <p:cNvSpPr>
-            <a:spLocks noGrp="1"/>
-          </p:cNvSpPr>
+          <p:cNvSpPr/>
           <p:nvPr>
-            <p:ph type="title" idx="101" hasCustomPrompt="1"/>
+            <p:ph idx="101" type="title" hasCustomPrompt="1"/>
           </p:nvPr>
         </p:nvSpPr>
         <p:spPr>
@@ -4513,7 +4736,7 @@
           <a:bodyPr wrap="square" rtlCol="0" anchor="ctr"/>
           <a:lstStyle/>
           <a:p>
-            <a:pPr marL="0" indent="0" algn="l">
+            <a:pPr algn="l" indent="0" marL="0">
               <a:buNone/>
             </a:pPr>
             <a:r>
@@ -4604,7 +4827,7 @@
           <a:bodyPr wrap="square" lIns="0" tIns="0" rIns="0" bIns="0" rtlCol="0" anchor="ctr"/>
           <a:lstStyle/>
           <a:p>
-            <a:pPr marL="0" indent="0" algn="ctr">
+            <a:pPr algn="ctr" indent="0" marL="0">
               <a:buNone/>
             </a:pPr>
             <a:r>
@@ -4643,7 +4866,7 @@
           <a:bodyPr wrap="square" lIns="0" tIns="0" rIns="0" bIns="0" rtlCol="0" anchor="t"/>
           <a:lstStyle/>
           <a:p>
-            <a:pPr marL="0" indent="0">
+            <a:pPr indent="0" marL="0">
               <a:buNone/>
             </a:pPr>
             <a:r>
@@ -4682,7 +4905,7 @@
           <a:bodyPr wrap="square" lIns="0" tIns="0" rIns="0" bIns="0" rtlCol="0" anchor="t"/>
           <a:lstStyle/>
           <a:p>
-            <a:pPr marL="0" indent="0">
+            <a:pPr indent="0" marL="0">
               <a:buNone/>
             </a:pPr>
             <a:r>
@@ -4773,7 +4996,7 @@
           <a:bodyPr wrap="square" lIns="0" tIns="0" rIns="0" bIns="0" rtlCol="0" anchor="ctr"/>
           <a:lstStyle/>
           <a:p>
-            <a:pPr marL="0" indent="0" algn="ctr">
+            <a:pPr algn="ctr" indent="0" marL="0">
               <a:buNone/>
             </a:pPr>
             <a:r>
@@ -4812,7 +5035,7 @@
           <a:bodyPr wrap="square" lIns="0" tIns="0" rIns="0" bIns="0" rtlCol="0" anchor="t"/>
           <a:lstStyle/>
           <a:p>
-            <a:pPr marL="0" indent="0">
+            <a:pPr indent="0" marL="0">
               <a:buNone/>
             </a:pPr>
             <a:r>
@@ -4851,7 +5074,7 @@
           <a:bodyPr wrap="square" lIns="0" tIns="0" rIns="0" bIns="0" rtlCol="0" anchor="t"/>
           <a:lstStyle/>
           <a:p>
-            <a:pPr marL="0" indent="0">
+            <a:pPr indent="0" marL="0">
               <a:buNone/>
             </a:pPr>
             <a:r>
@@ -4942,7 +5165,7 @@
           <a:bodyPr wrap="square" lIns="0" tIns="0" rIns="0" bIns="0" rtlCol="0" anchor="ctr"/>
           <a:lstStyle/>
           <a:p>
-            <a:pPr marL="0" indent="0" algn="ctr">
+            <a:pPr algn="ctr" indent="0" marL="0">
               <a:buNone/>
             </a:pPr>
             <a:r>
@@ -4981,7 +5204,7 @@
           <a:bodyPr wrap="square" lIns="0" tIns="0" rIns="0" bIns="0" rtlCol="0" anchor="t"/>
           <a:lstStyle/>
           <a:p>
-            <a:pPr marL="0" indent="0">
+            <a:pPr indent="0" marL="0">
               <a:buNone/>
             </a:pPr>
             <a:r>
@@ -5020,7 +5243,7 @@
           <a:bodyPr wrap="square" lIns="0" tIns="0" rIns="0" bIns="0" rtlCol="0" anchor="t"/>
           <a:lstStyle/>
           <a:p>
-            <a:pPr marL="0" indent="0">
+            <a:pPr indent="0" marL="0">
               <a:buNone/>
             </a:pPr>
             <a:r>
@@ -5111,7 +5334,7 @@
           <a:bodyPr wrap="square" lIns="0" tIns="0" rIns="0" bIns="0" rtlCol="0" anchor="ctr"/>
           <a:lstStyle/>
           <a:p>
-            <a:pPr marL="0" indent="0" algn="ctr">
+            <a:pPr algn="ctr" indent="0" marL="0">
               <a:buNone/>
             </a:pPr>
             <a:r>
@@ -5150,7 +5373,7 @@
           <a:bodyPr wrap="square" lIns="0" tIns="0" rIns="0" bIns="0" rtlCol="0" anchor="t"/>
           <a:lstStyle/>
           <a:p>
-            <a:pPr marL="0" indent="0">
+            <a:pPr indent="0" marL="0">
               <a:buNone/>
             </a:pPr>
             <a:r>
@@ -5189,7 +5412,7 @@
           <a:bodyPr wrap="square" lIns="0" tIns="0" rIns="0" bIns="0" rtlCol="0" anchor="t"/>
           <a:lstStyle/>
           <a:p>
-            <a:pPr marL="0" indent="0">
+            <a:pPr indent="0" marL="0">
               <a:buNone/>
             </a:pPr>
             <a:r>
@@ -5255,7 +5478,7 @@
           <a:bodyPr wrap="square" lIns="0" tIns="0" rIns="0" bIns="0" rtlCol="0" anchor="t"/>
           <a:lstStyle/>
           <a:p>
-            <a:pPr marL="0" indent="0">
+            <a:pPr indent="0" marL="0">
               <a:buNone/>
             </a:pPr>
             <a:r>
@@ -5294,7 +5517,7 @@
           <a:bodyPr wrap="square" lIns="0" tIns="0" rIns="0" bIns="0" rtlCol="0" anchor="t"/>
           <a:lstStyle/>
           <a:p>
-            <a:pPr marL="0" indent="0">
+            <a:pPr indent="0" marL="0">
               <a:buNone/>
             </a:pPr>
             <a:r>
@@ -5360,7 +5583,7 @@
           <a:bodyPr wrap="square" lIns="0" tIns="0" rIns="0" bIns="0" rtlCol="0" anchor="t"/>
           <a:lstStyle/>
           <a:p>
-            <a:pPr marL="0" indent="0">
+            <a:pPr indent="0" marL="0">
               <a:buNone/>
             </a:pPr>
             <a:r>
@@ -5399,7 +5622,7 @@
           <a:bodyPr wrap="square" lIns="0" tIns="0" rIns="0" bIns="0" rtlCol="0" anchor="t"/>
           <a:lstStyle/>
           <a:p>
-            <a:pPr marL="0" indent="0">
+            <a:pPr indent="0" marL="0">
               <a:buNone/>
             </a:pPr>
             <a:r>
@@ -5465,7 +5688,7 @@
           <a:bodyPr wrap="square" lIns="0" tIns="0" rIns="0" bIns="0" rtlCol="0" anchor="t"/>
           <a:lstStyle/>
           <a:p>
-            <a:pPr marL="0" indent="0">
+            <a:pPr indent="0" marL="0">
               <a:buNone/>
             </a:pPr>
             <a:r>
@@ -5504,7 +5727,7 @@
           <a:bodyPr wrap="square" lIns="0" tIns="0" rIns="0" bIns="0" rtlCol="0" anchor="t"/>
           <a:lstStyle/>
           <a:p>
-            <a:pPr marL="0" indent="0">
+            <a:pPr indent="0" marL="0">
               <a:buNone/>
             </a:pPr>
             <a:r>
@@ -5570,7 +5793,7 @@
           <a:bodyPr wrap="square" lIns="0" tIns="0" rIns="0" bIns="0" rtlCol="0" anchor="t"/>
           <a:lstStyle/>
           <a:p>
-            <a:pPr marL="0" indent="0">
+            <a:pPr indent="0" marL="0">
               <a:buNone/>
             </a:pPr>
             <a:r>
@@ -5609,7 +5832,7 @@
           <a:bodyPr wrap="square" lIns="0" tIns="0" rIns="0" bIns="0" rtlCol="0" anchor="t"/>
           <a:lstStyle/>
           <a:p>
-            <a:pPr marL="0" indent="0">
+            <a:pPr indent="0" marL="0">
               <a:buNone/>
             </a:pPr>
             <a:r>
@@ -5675,7 +5898,7 @@
           <a:bodyPr wrap="square" lIns="0" tIns="0" rIns="0" bIns="0" rtlCol="0" anchor="t"/>
           <a:lstStyle/>
           <a:p>
-            <a:pPr marL="0" indent="0">
+            <a:pPr indent="0" marL="0">
               <a:buNone/>
             </a:pPr>
             <a:r>
@@ -5714,7 +5937,7 @@
           <a:bodyPr wrap="square" lIns="0" tIns="0" rIns="0" bIns="0" rtlCol="0" anchor="t"/>
           <a:lstStyle/>
           <a:p>
-            <a:pPr marL="0" indent="0">
+            <a:pPr indent="0" marL="0">
               <a:buNone/>
             </a:pPr>
             <a:r>
@@ -5780,7 +6003,7 @@
           <a:bodyPr wrap="square" lIns="0" tIns="0" rIns="0" bIns="0" rtlCol="0" anchor="t"/>
           <a:lstStyle/>
           <a:p>
-            <a:pPr marL="0" indent="0">
+            <a:pPr indent="0" marL="0">
               <a:buNone/>
             </a:pPr>
             <a:r>
@@ -5819,7 +6042,7 @@
           <a:bodyPr wrap="square" lIns="0" tIns="0" rIns="0" bIns="0" rtlCol="0" anchor="t"/>
           <a:lstStyle/>
           <a:p>
-            <a:pPr marL="0" indent="0">
+            <a:pPr indent="0" marL="0">
               <a:buNone/>
             </a:pPr>
             <a:r>
@@ -5885,7 +6108,7 @@
           <a:bodyPr wrap="square" lIns="0" tIns="0" rIns="0" bIns="0" rtlCol="0" anchor="t"/>
           <a:lstStyle/>
           <a:p>
-            <a:pPr marL="0" indent="0">
+            <a:pPr indent="0" marL="0">
               <a:buNone/>
             </a:pPr>
             <a:r>
@@ -5924,7 +6147,7 @@
           <a:bodyPr wrap="square" lIns="0" tIns="0" rIns="0" bIns="0" rtlCol="0" anchor="t"/>
           <a:lstStyle/>
           <a:p>
-            <a:pPr marL="0" indent="0">
+            <a:pPr indent="0" marL="0">
               <a:buNone/>
             </a:pPr>
             <a:r>
@@ -5990,7 +6213,7 @@
           <a:bodyPr wrap="square" lIns="0" tIns="0" rIns="0" bIns="0" rtlCol="0" anchor="t"/>
           <a:lstStyle/>
           <a:p>
-            <a:pPr marL="0" indent="0">
+            <a:pPr indent="0" marL="0">
               <a:buNone/>
             </a:pPr>
             <a:r>
@@ -6029,7 +6252,7 @@
           <a:bodyPr wrap="square" lIns="0" tIns="0" rIns="0" bIns="0" rtlCol="0" anchor="t"/>
           <a:lstStyle/>
           <a:p>
-            <a:pPr marL="0" indent="0">
+            <a:pPr indent="0" marL="0">
               <a:buNone/>
             </a:pPr>
             <a:r>
@@ -6049,7 +6272,7 @@
       </p:sp>
       <p:sp>
         <p:nvSpPr>
-          <p:cNvPr id="47" name="Slide Number Placeholder 0"/>
+          <p:cNvPr id="25" name="Slide Number Placeholder 0"/>
           <p:cNvSpPr>
             <a:spLocks noGrp="1"/>
           </p:cNvSpPr>
@@ -6067,7 +6290,7 @@
           </a:prstGeom>
           <a:extLst>
             <a:ext uri="{C572A759-6A51-4108-AA02-DFA0A04FC94B}">
-              <ma14:wrappingTextBoxFlag xmlns:ma14="http://schemas.microsoft.com/office/mac/drawingml/2011/main" xmlns="" val="0"/>
+              <ma14:wrappingTextBoxFlag xmlns:ma14="http://schemas.microsoft.com/office/mac/drawingml/2011/main" val="0"/>
             </a:ext>
           </a:extLst>
         </p:spPr>
@@ -6088,7 +6311,7 @@
           <a:p>
             <a:pPr algn="l"/>
             <a:fld id="{F7021451-1387-4CA6-816F-3879F97B5CBC}" type="slidenum">
-              <a:rPr lang="en-US" b="0"/>
+              <a:rPr b="0" lang="en-US"/>
               <a:t>4</a:t>
             </a:fld>
             <a:endParaRPr lang="en-US"/>
@@ -6123,11 +6346,9 @@
       <p:sp>
         <p:nvSpPr>
           <p:cNvPr id="2" name="Text 1"/>
-          <p:cNvSpPr>
-            <a:spLocks noGrp="1"/>
-          </p:cNvSpPr>
+          <p:cNvSpPr/>
           <p:nvPr>
-            <p:ph type="title" idx="101" hasCustomPrompt="1"/>
+            <p:ph idx="101" type="title" hasCustomPrompt="1"/>
           </p:nvPr>
         </p:nvSpPr>
         <p:spPr>
@@ -6145,7 +6366,7 @@
           <a:bodyPr wrap="square" rtlCol="0" anchor="ctr"/>
           <a:lstStyle/>
           <a:p>
-            <a:pPr marL="0" indent="0" algn="l">
+            <a:pPr algn="l" indent="0" marL="0">
               <a:buNone/>
             </a:pPr>
             <a:r>
@@ -6165,7 +6386,7 @@
       </p:sp>
       <p:graphicFrame>
         <p:nvGraphicFramePr>
-          <p:cNvPr id="3" name="Chart 0"/>
+          <p:cNvPr id="3" name="Chart 0" descr=""/>
           <p:cNvGraphicFramePr/>
           <p:nvPr/>
         </p:nvGraphicFramePr>
@@ -6173,9 +6394,9 @@
           <a:off x="548640" y="1325880"/>
           <a:ext cx="6949440" cy="4846320"/>
         </p:xfrm>
-        <a:graphic>
+        <a:graphic xmlns:a="http://schemas.openxmlformats.org/drawingml/2006/main">
           <a:graphicData uri="http://schemas.openxmlformats.org/drawingml/2006/chart">
-            <c:chart xmlns:c="http://schemas.openxmlformats.org/drawingml/2006/chart" xmlns:r="http://schemas.openxmlformats.org/officeDocument/2006/relationships" r:id="rId3"/>
+            <c:chart xmlns:c="http://schemas.openxmlformats.org/drawingml/2006/chart" r:id="rId1"/>
           </a:graphicData>
         </a:graphic>
       </p:graphicFrame>
@@ -6227,7 +6448,7 @@
           <a:bodyPr wrap="square" lIns="0" tIns="0" rIns="0" bIns="0" rtlCol="0" anchor="t"/>
           <a:lstStyle/>
           <a:p>
-            <a:pPr marL="0" indent="0">
+            <a:pPr indent="0" marL="0">
               <a:buNone/>
             </a:pPr>
             <a:r>
@@ -6266,7 +6487,7 @@
           <a:bodyPr wrap="square" lIns="0" tIns="0" rIns="0" bIns="0" rtlCol="0" anchor="t"/>
           <a:lstStyle/>
           <a:p>
-            <a:pPr marL="0" indent="0">
+            <a:pPr indent="0" marL="0">
               <a:buNone/>
             </a:pPr>
             <a:r>
@@ -6332,7 +6553,7 @@
           <a:bodyPr wrap="square" lIns="0" tIns="0" rIns="0" bIns="0" rtlCol="0" anchor="t"/>
           <a:lstStyle/>
           <a:p>
-            <a:pPr marL="0" indent="0">
+            <a:pPr indent="0" marL="0">
               <a:buNone/>
             </a:pPr>
             <a:r>
@@ -6371,7 +6592,7 @@
           <a:bodyPr wrap="square" lIns="0" tIns="0" rIns="0" bIns="0" rtlCol="0" anchor="t"/>
           <a:lstStyle/>
           <a:p>
-            <a:pPr marL="0" indent="0">
+            <a:pPr indent="0" marL="0">
               <a:buNone/>
             </a:pPr>
             <a:r>
@@ -6409,7 +6630,7 @@
           </a:prstGeom>
           <a:extLst>
             <a:ext uri="{C572A759-6A51-4108-AA02-DFA0A04FC94B}">
-              <ma14:wrappingTextBoxFlag xmlns:ma14="http://schemas.microsoft.com/office/mac/drawingml/2011/main" xmlns="" val="0"/>
+              <ma14:wrappingTextBoxFlag xmlns:ma14="http://schemas.microsoft.com/office/mac/drawingml/2011/main" val="0"/>
             </a:ext>
           </a:extLst>
         </p:spPr>
@@ -6430,7 +6651,7 @@
           <a:p>
             <a:pPr algn="l"/>
             <a:fld id="{F7021451-1387-4CA6-816F-3879F97B5CBC}" type="slidenum">
-              <a:rPr lang="en-US" b="0"/>
+              <a:rPr b="0" lang="en-US"/>
               <a:t>5</a:t>
             </a:fld>
             <a:endParaRPr lang="en-US"/>
@@ -6465,11 +6686,9 @@
       <p:sp>
         <p:nvSpPr>
           <p:cNvPr id="2" name="Text 1"/>
-          <p:cNvSpPr>
-            <a:spLocks noGrp="1"/>
-          </p:cNvSpPr>
+          <p:cNvSpPr/>
           <p:nvPr>
-            <p:ph type="title" idx="101" hasCustomPrompt="1"/>
+            <p:ph idx="101" type="title" hasCustomPrompt="1"/>
           </p:nvPr>
         </p:nvSpPr>
         <p:spPr>
@@ -6487,7 +6706,7 @@
           <a:bodyPr wrap="square" rtlCol="0" anchor="ctr"/>
           <a:lstStyle/>
           <a:p>
-            <a:pPr marL="0" indent="0" algn="l">
+            <a:pPr algn="l" indent="0" marL="0">
               <a:buNone/>
             </a:pPr>
             <a:r>
@@ -6507,14 +6726,14 @@
       </p:sp>
       <p:pic>
         <p:nvPicPr>
-          <p:cNvPr id="3" name="Image 0" descr="/home/user/AI-Collusion-Research-Sprint/Apart Research/figures/fig_trajectories.png"/>
+          <p:cNvPr id="3" name="Image 0" descr="/home/user/AI-Collusion-Research-Sprint/Apart Research/figures/fig_trajectories.png">    </p:cNvPr>
           <p:cNvPicPr>
             <a:picLocks noChangeAspect="1"/>
           </p:cNvPicPr>
           <p:nvPr/>
         </p:nvPicPr>
         <p:blipFill>
-          <a:blip r:embed="rId3"/>
+          <a:blip r:embed="rId1"/>
           <a:stretch>
             <a:fillRect/>
           </a:stretch>
@@ -6550,7 +6769,7 @@
           <a:bodyPr wrap="square" lIns="0" tIns="0" rIns="0" bIns="0" rtlCol="0" anchor="t"/>
           <a:lstStyle/>
           <a:p>
-            <a:pPr marL="0" indent="0">
+            <a:pPr indent="0" marL="0">
               <a:buNone/>
             </a:pPr>
             <a:r>
@@ -6616,7 +6835,7 @@
           <a:bodyPr wrap="square" lIns="0" tIns="0" rIns="0" bIns="0" rtlCol="0" anchor="t"/>
           <a:lstStyle/>
           <a:p>
-            <a:pPr marL="0" indent="0">
+            <a:pPr indent="0" marL="0">
               <a:buNone/>
             </a:pPr>
             <a:r>
@@ -6655,7 +6874,7 @@
           <a:bodyPr wrap="square" lIns="0" tIns="0" rIns="0" bIns="0" rtlCol="0" anchor="t"/>
           <a:lstStyle/>
           <a:p>
-            <a:pPr marL="0" indent="0">
+            <a:pPr indent="0" marL="0">
               <a:buNone/>
             </a:pPr>
             <a:r>
@@ -6694,7 +6913,7 @@
           <a:bodyPr wrap="square" lIns="0" tIns="0" rIns="0" bIns="0" rtlCol="0" anchor="t"/>
           <a:lstStyle/>
           <a:p>
-            <a:pPr marL="0" indent="0">
+            <a:pPr indent="0" marL="0">
               <a:buNone/>
             </a:pPr>
             <a:r>
@@ -6733,7 +6952,7 @@
           <a:bodyPr wrap="square" lIns="0" tIns="0" rIns="0" bIns="0" rtlCol="0" anchor="t"/>
           <a:lstStyle/>
           <a:p>
-            <a:pPr marL="0" indent="0">
+            <a:pPr indent="0" marL="0">
               <a:buNone/>
             </a:pPr>
             <a:r>
@@ -6771,7 +6990,7 @@
           </a:prstGeom>
           <a:extLst>
             <a:ext uri="{C572A759-6A51-4108-AA02-DFA0A04FC94B}">
-              <ma14:wrappingTextBoxFlag xmlns:ma14="http://schemas.microsoft.com/office/mac/drawingml/2011/main" xmlns="" val="0"/>
+              <ma14:wrappingTextBoxFlag xmlns:ma14="http://schemas.microsoft.com/office/mac/drawingml/2011/main" val="0"/>
             </a:ext>
           </a:extLst>
         </p:spPr>
@@ -6792,7 +7011,7 @@
           <a:p>
             <a:pPr algn="l"/>
             <a:fld id="{F7021451-1387-4CA6-816F-3879F97B5CBC}" type="slidenum">
-              <a:rPr lang="en-US" b="0"/>
+              <a:rPr b="0" lang="en-US"/>
               <a:t>6</a:t>
             </a:fld>
             <a:endParaRPr lang="en-US"/>
@@ -6827,11 +7046,9 @@
       <p:sp>
         <p:nvSpPr>
           <p:cNvPr id="2" name="Text 1"/>
-          <p:cNvSpPr>
-            <a:spLocks noGrp="1"/>
-          </p:cNvSpPr>
+          <p:cNvSpPr/>
           <p:nvPr>
-            <p:ph type="title" idx="101" hasCustomPrompt="1"/>
+            <p:ph idx="101" type="title" hasCustomPrompt="1"/>
           </p:nvPr>
         </p:nvSpPr>
         <p:spPr>
@@ -6849,7 +7066,7 @@
           <a:bodyPr wrap="square" rtlCol="0" anchor="ctr"/>
           <a:lstStyle/>
           <a:p>
-            <a:pPr marL="0" indent="0" algn="l">
+            <a:pPr algn="l" indent="0" marL="0">
               <a:buNone/>
             </a:pPr>
             <a:r>
@@ -6915,7 +7132,7 @@
           <a:bodyPr wrap="square" lIns="0" tIns="0" rIns="0" bIns="0" rtlCol="0" anchor="t"/>
           <a:lstStyle/>
           <a:p>
-            <a:pPr marL="0" indent="0">
+            <a:pPr indent="0" marL="0">
               <a:buNone/>
             </a:pPr>
             <a:r>
@@ -6954,7 +7171,7 @@
           <a:bodyPr wrap="square" lIns="0" tIns="0" rIns="0" bIns="0" rtlCol="0" anchor="t"/>
           <a:lstStyle/>
           <a:p>
-            <a:pPr marL="0" indent="0">
+            <a:pPr indent="0" marL="0">
               <a:buNone/>
             </a:pPr>
             <a:r>
@@ -6993,7 +7210,7 @@
           <a:bodyPr wrap="square" lIns="0" tIns="0" rIns="0" bIns="0" rtlCol="0" anchor="t"/>
           <a:lstStyle/>
           <a:p>
-            <a:pPr marL="0" indent="0">
+            <a:pPr indent="0" marL="0">
               <a:buNone/>
             </a:pPr>
             <a:r>
@@ -7032,7 +7249,7 @@
           <a:bodyPr wrap="square" lIns="0" tIns="0" rIns="0" bIns="0" rtlCol="0" anchor="t"/>
           <a:lstStyle/>
           <a:p>
-            <a:pPr marL="0" indent="0">
+            <a:pPr indent="0" marL="0">
               <a:buNone/>
             </a:pPr>
             <a:r>
@@ -7098,7 +7315,7 @@
           <a:bodyPr wrap="square" lIns="0" tIns="0" rIns="0" bIns="0" rtlCol="0" anchor="t"/>
           <a:lstStyle/>
           <a:p>
-            <a:pPr marL="0" indent="0">
+            <a:pPr indent="0" marL="0">
               <a:buNone/>
             </a:pPr>
             <a:r>
@@ -7137,7 +7354,7 @@
           <a:bodyPr wrap="square" lIns="0" tIns="0" rIns="0" bIns="0" rtlCol="0" anchor="t"/>
           <a:lstStyle/>
           <a:p>
-            <a:pPr marL="0" indent="0">
+            <a:pPr indent="0" marL="0">
               <a:buNone/>
             </a:pPr>
             <a:r>
@@ -7176,7 +7393,7 @@
           <a:bodyPr wrap="square" lIns="0" tIns="0" rIns="0" bIns="0" rtlCol="0" anchor="t"/>
           <a:lstStyle/>
           <a:p>
-            <a:pPr marL="0" indent="0">
+            <a:pPr indent="0" marL="0">
               <a:buNone/>
             </a:pPr>
             <a:r>
@@ -7215,7 +7432,7 @@
           <a:bodyPr wrap="square" lIns="0" tIns="0" rIns="0" bIns="0" rtlCol="0" anchor="t"/>
           <a:lstStyle/>
           <a:p>
-            <a:pPr marL="0" indent="0">
+            <a:pPr indent="0" marL="0">
               <a:buNone/>
             </a:pPr>
             <a:r>
@@ -7254,7 +7471,7 @@
           <a:bodyPr wrap="square" lIns="0" tIns="0" rIns="0" bIns="0" rtlCol="0" anchor="t"/>
           <a:lstStyle/>
           <a:p>
-            <a:pPr marL="0" indent="0">
+            <a:pPr indent="0" marL="0">
               <a:buNone/>
             </a:pPr>
             <a:r>
@@ -7292,7 +7509,7 @@
           </a:prstGeom>
           <a:extLst>
             <a:ext uri="{C572A759-6A51-4108-AA02-DFA0A04FC94B}">
-              <ma14:wrappingTextBoxFlag xmlns:ma14="http://schemas.microsoft.com/office/mac/drawingml/2011/main" xmlns="" val="0"/>
+              <ma14:wrappingTextBoxFlag xmlns:ma14="http://schemas.microsoft.com/office/mac/drawingml/2011/main" val="0"/>
             </a:ext>
           </a:extLst>
         </p:spPr>
@@ -7313,7 +7530,7 @@
           <a:p>
             <a:pPr algn="l"/>
             <a:fld id="{F7021451-1387-4CA6-816F-3879F97B5CBC}" type="slidenum">
-              <a:rPr lang="en-US" b="0"/>
+              <a:rPr b="0" lang="en-US"/>
               <a:t>7</a:t>
             </a:fld>
             <a:endParaRPr lang="en-US"/>
@@ -7348,11 +7565,9 @@
       <p:sp>
         <p:nvSpPr>
           <p:cNvPr id="2" name="Text 1"/>
-          <p:cNvSpPr>
-            <a:spLocks noGrp="1"/>
-          </p:cNvSpPr>
+          <p:cNvSpPr/>
           <p:nvPr>
-            <p:ph type="title" idx="101" hasCustomPrompt="1"/>
+            <p:ph idx="101" type="title" hasCustomPrompt="1"/>
           </p:nvPr>
         </p:nvSpPr>
         <p:spPr>
@@ -7370,7 +7585,7 @@
           <a:bodyPr wrap="square" rtlCol="0" anchor="ctr"/>
           <a:lstStyle/>
           <a:p>
-            <a:pPr marL="0" indent="0" algn="l">
+            <a:pPr algn="l" indent="0" marL="0">
               <a:buNone/>
             </a:pPr>
             <a:r>
@@ -7461,7 +7676,7 @@
           <a:bodyPr wrap="square" lIns="0" tIns="0" rIns="0" bIns="0" rtlCol="0" anchor="ctr"/>
           <a:lstStyle/>
           <a:p>
-            <a:pPr marL="0" indent="0" algn="ctr">
+            <a:pPr algn="ctr" indent="0" marL="0">
               <a:buNone/>
             </a:pPr>
             <a:r>
@@ -7500,7 +7715,7 @@
           <a:bodyPr wrap="square" lIns="0" tIns="0" rIns="0" bIns="0" rtlCol="0" anchor="t"/>
           <a:lstStyle/>
           <a:p>
-            <a:pPr marL="0" indent="0">
+            <a:pPr indent="0" marL="0">
               <a:buNone/>
             </a:pPr>
             <a:r>
@@ -7539,7 +7754,7 @@
           <a:bodyPr wrap="square" lIns="0" tIns="0" rIns="0" bIns="0" rtlCol="0" anchor="t"/>
           <a:lstStyle/>
           <a:p>
-            <a:pPr marL="0" indent="0">
+            <a:pPr indent="0" marL="0">
               <a:buNone/>
             </a:pPr>
             <a:r>
@@ -7630,7 +7845,7 @@
           <a:bodyPr wrap="square" lIns="0" tIns="0" rIns="0" bIns="0" rtlCol="0" anchor="ctr"/>
           <a:lstStyle/>
           <a:p>
-            <a:pPr marL="0" indent="0" algn="ctr">
+            <a:pPr algn="ctr" indent="0" marL="0">
               <a:buNone/>
             </a:pPr>
             <a:r>
@@ -7669,7 +7884,7 @@
           <a:bodyPr wrap="square" lIns="0" tIns="0" rIns="0" bIns="0" rtlCol="0" anchor="t"/>
           <a:lstStyle/>
           <a:p>
-            <a:pPr marL="0" indent="0">
+            <a:pPr indent="0" marL="0">
               <a:buNone/>
             </a:pPr>
             <a:r>
@@ -7708,7 +7923,7 @@
           <a:bodyPr wrap="square" lIns="0" tIns="0" rIns="0" bIns="0" rtlCol="0" anchor="t"/>
           <a:lstStyle/>
           <a:p>
-            <a:pPr marL="0" indent="0">
+            <a:pPr indent="0" marL="0">
               <a:buNone/>
             </a:pPr>
             <a:r>
@@ -7799,7 +8014,7 @@
           <a:bodyPr wrap="square" lIns="0" tIns="0" rIns="0" bIns="0" rtlCol="0" anchor="ctr"/>
           <a:lstStyle/>
           <a:p>
-            <a:pPr marL="0" indent="0" algn="ctr">
+            <a:pPr algn="ctr" indent="0" marL="0">
               <a:buNone/>
             </a:pPr>
             <a:r>
@@ -7838,7 +8053,7 @@
           <a:bodyPr wrap="square" lIns="0" tIns="0" rIns="0" bIns="0" rtlCol="0" anchor="t"/>
           <a:lstStyle/>
           <a:p>
-            <a:pPr marL="0" indent="0">
+            <a:pPr indent="0" marL="0">
               <a:buNone/>
             </a:pPr>
             <a:r>
@@ -7877,7 +8092,7 @@
           <a:bodyPr wrap="square" lIns="0" tIns="0" rIns="0" bIns="0" rtlCol="0" anchor="t"/>
           <a:lstStyle/>
           <a:p>
-            <a:pPr marL="0" indent="0">
+            <a:pPr indent="0" marL="0">
               <a:buNone/>
             </a:pPr>
             <a:r>
@@ -7943,7 +8158,7 @@
           <a:bodyPr wrap="square" lIns="0" tIns="0" rIns="0" bIns="0" rtlCol="0" anchor="t"/>
           <a:lstStyle/>
           <a:p>
-            <a:pPr marL="0" indent="0">
+            <a:pPr indent="0" marL="0">
               <a:buNone/>
             </a:pPr>
             <a:r>
@@ -7982,7 +8197,7 @@
           <a:bodyPr wrap="square" lIns="0" tIns="0" rIns="0" bIns="0" rtlCol="0" anchor="t"/>
           <a:lstStyle/>
           <a:p>
-            <a:pPr marL="0" indent="0">
+            <a:pPr indent="0" marL="0">
               <a:buNone/>
             </a:pPr>
             <a:r>
@@ -8021,7 +8236,7 @@
           <a:bodyPr wrap="square" lIns="0" tIns="0" rIns="0" bIns="0" rtlCol="0" anchor="t"/>
           <a:lstStyle/>
           <a:p>
-            <a:pPr marL="0" indent="0">
+            <a:pPr indent="0" marL="0">
               <a:buNone/>
             </a:pPr>
             <a:r>
@@ -8060,7 +8275,7 @@
           <a:bodyPr wrap="square" lIns="0" tIns="0" rIns="0" bIns="0" rtlCol="0" anchor="t"/>
           <a:lstStyle/>
           <a:p>
-            <a:pPr marL="0" indent="0">
+            <a:pPr indent="0" marL="0">
               <a:buNone/>
             </a:pPr>
             <a:r>
@@ -8099,7 +8314,7 @@
           <a:bodyPr wrap="square" lIns="0" tIns="0" rIns="0" bIns="0" rtlCol="0" anchor="t"/>
           <a:lstStyle/>
           <a:p>
-            <a:pPr marL="0" indent="0">
+            <a:pPr indent="0" marL="0">
               <a:buNone/>
             </a:pPr>
             <a:r>
@@ -8138,7 +8353,7 @@
           <a:bodyPr wrap="square" lIns="0" tIns="0" rIns="0" bIns="0" rtlCol="0" anchor="t"/>
           <a:lstStyle/>
           <a:p>
-            <a:pPr marL="0" indent="0">
+            <a:pPr indent="0" marL="0">
               <a:buNone/>
             </a:pPr>
             <a:r>
@@ -8176,7 +8391,7 @@
           </a:prstGeom>
           <a:extLst>
             <a:ext uri="{C572A759-6A51-4108-AA02-DFA0A04FC94B}">
-              <ma14:wrappingTextBoxFlag xmlns:ma14="http://schemas.microsoft.com/office/mac/drawingml/2011/main" xmlns="" val="0"/>
+              <ma14:wrappingTextBoxFlag xmlns:ma14="http://schemas.microsoft.com/office/mac/drawingml/2011/main" val="0"/>
             </a:ext>
           </a:extLst>
         </p:spPr>
@@ -8197,7 +8412,7 @@
           <a:p>
             <a:pPr algn="l"/>
             <a:fld id="{F7021451-1387-4CA6-816F-3879F97B5CBC}" type="slidenum">
-              <a:rPr lang="en-US" b="0"/>
+              <a:rPr b="0" lang="en-US"/>
               <a:t>8</a:t>
             </a:fld>
             <a:endParaRPr lang="en-US"/>
@@ -8232,11 +8447,9 @@
       <p:sp>
         <p:nvSpPr>
           <p:cNvPr id="2" name="Text 0"/>
-          <p:cNvSpPr>
-            <a:spLocks noGrp="1"/>
-          </p:cNvSpPr>
+          <p:cNvSpPr/>
           <p:nvPr>
-            <p:ph type="title" idx="100" hasCustomPrompt="1"/>
+            <p:ph idx="100" type="title" hasCustomPrompt="1"/>
           </p:nvPr>
         </p:nvSpPr>
         <p:spPr>
@@ -8254,7 +8467,7 @@
           <a:bodyPr wrap="square" rtlCol="0" anchor="ctr"/>
           <a:lstStyle/>
           <a:p>
-            <a:pPr marL="0" indent="0" algn="l">
+            <a:pPr algn="l" indent="0" marL="0">
               <a:buNone/>
             </a:pPr>
             <a:r>
@@ -8320,7 +8533,7 @@
           <a:bodyPr wrap="square" lIns="0" tIns="0" rIns="0" bIns="0" rtlCol="0" anchor="t"/>
           <a:lstStyle/>
           <a:p>
-            <a:pPr marL="0" indent="0">
+            <a:pPr indent="0" marL="0">
               <a:buNone/>
             </a:pPr>
             <a:r>
@@ -8359,7 +8572,7 @@
           <a:bodyPr wrap="square" lIns="0" tIns="0" rIns="0" bIns="0" rtlCol="0" anchor="t"/>
           <a:lstStyle/>
           <a:p>
-            <a:pPr marL="0" indent="0">
+            <a:pPr indent="0" marL="0">
               <a:buNone/>
             </a:pPr>
             <a:r>
@@ -8425,7 +8638,7 @@
           <a:bodyPr wrap="square" lIns="0" tIns="0" rIns="0" bIns="0" rtlCol="0" anchor="t"/>
           <a:lstStyle/>
           <a:p>
-            <a:pPr marL="0" indent="0">
+            <a:pPr indent="0" marL="0">
               <a:buNone/>
             </a:pPr>
             <a:r>
@@ -8464,7 +8677,7 @@
           <a:bodyPr wrap="square" lIns="0" tIns="0" rIns="0" bIns="0" rtlCol="0" anchor="t"/>
           <a:lstStyle/>
           <a:p>
-            <a:pPr marL="0" indent="0">
+            <a:pPr indent="0" marL="0">
               <a:buNone/>
             </a:pPr>
             <a:r>
@@ -8530,7 +8743,7 @@
           <a:bodyPr wrap="square" lIns="0" tIns="0" rIns="0" bIns="0" rtlCol="0" anchor="t"/>
           <a:lstStyle/>
           <a:p>
-            <a:pPr marL="0" indent="0">
+            <a:pPr indent="0" marL="0">
               <a:buNone/>
             </a:pPr>
             <a:r>
@@ -8569,7 +8782,7 @@
           <a:bodyPr wrap="square" lIns="0" tIns="0" rIns="0" bIns="0" rtlCol="0" anchor="t"/>
           <a:lstStyle/>
           <a:p>
-            <a:pPr marL="0" indent="0">
+            <a:pPr indent="0" marL="0">
               <a:buNone/>
             </a:pPr>
             <a:r>
@@ -8635,7 +8848,7 @@
           <a:bodyPr wrap="square" lIns="0" tIns="0" rIns="0" bIns="0" rtlCol="0" anchor="t"/>
           <a:lstStyle/>
           <a:p>
-            <a:pPr marL="0" indent="0">
+            <a:pPr indent="0" marL="0">
               <a:buNone/>
             </a:pPr>
             <a:r>
@@ -8674,7 +8887,7 @@
           <a:bodyPr wrap="square" lIns="0" tIns="0" rIns="0" bIns="0" rtlCol="0" anchor="t"/>
           <a:lstStyle/>
           <a:p>
-            <a:pPr marL="0" indent="0">
+            <a:pPr indent="0" marL="0">
               <a:buNone/>
             </a:pPr>
             <a:r>
@@ -8712,7 +8925,7 @@
           </a:prstGeom>
           <a:extLst>
             <a:ext uri="{C572A759-6A51-4108-AA02-DFA0A04FC94B}">
-              <ma14:wrappingTextBoxFlag xmlns:ma14="http://schemas.microsoft.com/office/mac/drawingml/2011/main" xmlns="" val="0"/>
+              <ma14:wrappingTextBoxFlag xmlns:ma14="http://schemas.microsoft.com/office/mac/drawingml/2011/main" val="0"/>
             </a:ext>
           </a:extLst>
         </p:spPr>
@@ -8733,7 +8946,7 @@
           <a:p>
             <a:pPr algn="l"/>
             <a:fld id="{F7021451-1387-4CA6-816F-3879F97B5CBC}" type="slidenum">
-              <a:rPr lang="en-US" b="0"/>
+              <a:rPr b="0" lang="en-US"/>
               <a:t>9</a:t>
             </a:fld>
             <a:endParaRPr lang="en-US"/>
@@ -9041,299 +9254,4 @@
     </a:ext>
   </a:extLst>
 </a:theme>
-</file>
-
-<file path=ppt/theme/theme2.xml><?xml version="1.0" encoding="utf-8"?>
-<a:theme xmlns:a="http://schemas.openxmlformats.org/drawingml/2006/main" name="Office Theme">
-  <a:themeElements>
-    <a:clrScheme name="Office">
-      <a:dk1>
-        <a:sysClr val="windowText" lastClr="000000"/>
-      </a:dk1>
-      <a:lt1>
-        <a:sysClr val="window" lastClr="FFFFFF"/>
-      </a:lt1>
-      <a:dk2>
-        <a:srgbClr val="44546A"/>
-      </a:dk2>
-      <a:lt2>
-        <a:srgbClr val="E7E6E6"/>
-      </a:lt2>
-      <a:accent1>
-        <a:srgbClr val="4472C4"/>
-      </a:accent1>
-      <a:accent2>
-        <a:srgbClr val="ED7D31"/>
-      </a:accent2>
-      <a:accent3>
-        <a:srgbClr val="A5A5A5"/>
-      </a:accent3>
-      <a:accent4>
-        <a:srgbClr val="FFC000"/>
-      </a:accent4>
-      <a:accent5>
-        <a:srgbClr val="5B9BD5"/>
-      </a:accent5>
-      <a:accent6>
-        <a:srgbClr val="70AD47"/>
-      </a:accent6>
-      <a:hlink>
-        <a:srgbClr val="0563C1"/>
-      </a:hlink>
-      <a:folHlink>
-        <a:srgbClr val="954F72"/>
-      </a:folHlink>
-    </a:clrScheme>
-    <a:fontScheme name="Office">
-      <a:majorFont>
-        <a:latin typeface="Calibri Light" panose="020F0302020204030204"/>
-        <a:ea typeface=""/>
-        <a:cs typeface=""/>
-        <a:font script="Jpan" typeface="游ゴシック Light"/>
-        <a:font script="Hang" typeface="맑은 고딕"/>
-        <a:font script="Hans" typeface="等线 Light"/>
-        <a:font script="Hant" typeface="新細明體"/>
-        <a:font script="Arab" typeface="Times New Roman"/>
-        <a:font script="Hebr" typeface="Times New Roman"/>
-        <a:font script="Thai" typeface="Angsana New"/>
-        <a:font script="Ethi" typeface="Nyala"/>
-        <a:font script="Beng" typeface="Vrinda"/>
-        <a:font script="Gujr" typeface="Shruti"/>
-        <a:font script="Khmr" typeface="MoolBoran"/>
-        <a:font script="Knda" typeface="Tunga"/>
-        <a:font script="Guru" typeface="Raavi"/>
-        <a:font script="Cans" typeface="Euphemia"/>
-        <a:font script="Cher" typeface="Plantagenet Cherokee"/>
-        <a:font script="Yiii" typeface="Microsoft Yi Baiti"/>
-        <a:font script="Tibt" typeface="Microsoft Himalaya"/>
-        <a:font script="Thaa" typeface="MV Boli"/>
-        <a:font script="Deva" typeface="Mangal"/>
-        <a:font script="Telu" typeface="Gautami"/>
-        <a:font script="Taml" typeface="Latha"/>
-        <a:font script="Syrc" typeface="Estrangelo Edessa"/>
-        <a:font script="Orya" typeface="Kalinga"/>
-        <a:font script="Mlym" typeface="Kartika"/>
-        <a:font script="Laoo" typeface="DokChampa"/>
-        <a:font script="Sinh" typeface="Iskoola Pota"/>
-        <a:font script="Mong" typeface="Mongolian Baiti"/>
-        <a:font script="Viet" typeface="Times New Roman"/>
-        <a:font script="Uigh" typeface="Microsoft Uighur"/>
-        <a:font script="Geor" typeface="Sylfaen"/>
-        <a:font script="Armn" typeface="Arial"/>
-        <a:font script="Bugi" typeface="Leelawadee UI"/>
-        <a:font script="Bopo" typeface="Microsoft JhengHei"/>
-        <a:font script="Java" typeface="Javanese Text"/>
-        <a:font script="Lisu" typeface="Segoe UI"/>
-        <a:font script="Mymr" typeface="Myanmar Text"/>
-        <a:font script="Nkoo" typeface="Ebrima"/>
-        <a:font script="Olck" typeface="Nirmala UI"/>
-        <a:font script="Osma" typeface="Ebrima"/>
-        <a:font script="Phag" typeface="Phagspa"/>
-        <a:font script="Syrn" typeface="Estrangelo Edessa"/>
-        <a:font script="Syrj" typeface="Estrangelo Edessa"/>
-        <a:font script="Syre" typeface="Estrangelo Edessa"/>
-        <a:font script="Sora" typeface="Nirmala UI"/>
-        <a:font script="Tale" typeface="Microsoft Tai Le"/>
-        <a:font script="Talu" typeface="Microsoft New Tai Lue"/>
-        <a:font script="Tfng" typeface="Ebrima"/>
-      </a:majorFont>
-      <a:minorFont>
-        <a:latin typeface="Calibri" panose="020F0502020204030204"/>
-        <a:ea typeface=""/>
-        <a:cs typeface=""/>
-        <a:font script="Jpan" typeface="游ゴシック"/>
-        <a:font script="Hang" typeface="맑은 고딕"/>
-        <a:font script="Hans" typeface="等线"/>
-        <a:font script="Hant" typeface="新細明體"/>
-        <a:font script="Arab" typeface="Arial"/>
-        <a:font script="Hebr" typeface="Arial"/>
-        <a:font script="Thai" typeface="Cordia New"/>
-        <a:font script="Ethi" typeface="Nyala"/>
-        <a:font script="Beng" typeface="Vrinda"/>
-        <a:font script="Gujr" typeface="Shruti"/>
-        <a:font script="Khmr" typeface="DaunPenh"/>
-        <a:font script="Knda" typeface="Tunga"/>
-        <a:font script="Guru" typeface="Raavi"/>
-        <a:font script="Cans" typeface="Euphemia"/>
-        <a:font script="Cher" typeface="Plantagenet Cherokee"/>
-        <a:font script="Yiii" typeface="Microsoft Yi Baiti"/>
-        <a:font script="Tibt" typeface="Microsoft Himalaya"/>
-        <a:font script="Thaa" typeface="MV Boli"/>
-        <a:font script="Deva" typeface="Mangal"/>
-        <a:font script="Telu" typeface="Gautami"/>
-        <a:font script="Taml" typeface="Latha"/>
-        <a:font script="Syrc" typeface="Estrangelo Edessa"/>
-        <a:font script="Orya" typeface="Kalinga"/>
-        <a:font script="Mlym" typeface="Kartika"/>
-        <a:font script="Laoo" typeface="DokChampa"/>
-        <a:font script="Sinh" typeface="Iskoola Pota"/>
-        <a:font script="Mong" typeface="Mongolian Baiti"/>
-        <a:font script="Viet" typeface="Arial"/>
-        <a:font script="Uigh" typeface="Microsoft Uighur"/>
-        <a:font script="Geor" typeface="Sylfaen"/>
-        <a:font script="Armn" typeface="Arial"/>
-        <a:font script="Bugi" typeface="Leelawadee UI"/>
-        <a:font script="Bopo" typeface="Microsoft JhengHei"/>
-        <a:font script="Java" typeface="Javanese Text"/>
-        <a:font script="Lisu" typeface="Segoe UI"/>
-        <a:font script="Mymr" typeface="Myanmar Text"/>
-        <a:font script="Nkoo" typeface="Ebrima"/>
-        <a:font script="Olck" typeface="Nirmala UI"/>
-        <a:font script="Osma" typeface="Ebrima"/>
-        <a:font script="Phag" typeface="Phagspa"/>
-        <a:font script="Syrn" typeface="Estrangelo Edessa"/>
-        <a:font script="Syrj" typeface="Estrangelo Edessa"/>
-        <a:font script="Syre" typeface="Estrangelo Edessa"/>
-        <a:font script="Sora" typeface="Nirmala UI"/>
-        <a:font script="Tale" typeface="Microsoft Tai Le"/>
-        <a:font script="Talu" typeface="Microsoft New Tai Lue"/>
-        <a:font script="Tfng" typeface="Ebrima"/>
-      </a:minorFont>
-    </a:fontScheme>
-    <a:fmtScheme name="Office">
-      <a:fillStyleLst>
-        <a:solidFill>
-          <a:schemeClr val="phClr"/>
-        </a:solidFill>
-        <a:gradFill rotWithShape="1">
-          <a:gsLst>
-            <a:gs pos="0">
-              <a:schemeClr val="phClr">
-                <a:lumMod val="110000"/>
-                <a:satMod val="105000"/>
-                <a:tint val="67000"/>
-              </a:schemeClr>
-            </a:gs>
-            <a:gs pos="50000">
-              <a:schemeClr val="phClr">
-                <a:lumMod val="105000"/>
-                <a:satMod val="103000"/>
-                <a:tint val="73000"/>
-              </a:schemeClr>
-            </a:gs>
-            <a:gs pos="100000">
-              <a:schemeClr val="phClr">
-                <a:lumMod val="105000"/>
-                <a:satMod val="109000"/>
-                <a:tint val="81000"/>
-              </a:schemeClr>
-            </a:gs>
-          </a:gsLst>
-          <a:lin ang="5400000" scaled="0"/>
-        </a:gradFill>
-        <a:gradFill rotWithShape="1">
-          <a:gsLst>
-            <a:gs pos="0">
-              <a:schemeClr val="phClr">
-                <a:satMod val="103000"/>
-                <a:lumMod val="102000"/>
-                <a:tint val="94000"/>
-              </a:schemeClr>
-            </a:gs>
-            <a:gs pos="50000">
-              <a:schemeClr val="phClr">
-                <a:satMod val="110000"/>
-                <a:lumMod val="100000"/>
-                <a:shade val="100000"/>
-              </a:schemeClr>
-            </a:gs>
-            <a:gs pos="100000">
-              <a:schemeClr val="phClr">
-                <a:lumMod val="99000"/>
-                <a:satMod val="120000"/>
-                <a:shade val="78000"/>
-              </a:schemeClr>
-            </a:gs>
-          </a:gsLst>
-          <a:lin ang="5400000" scaled="0"/>
-        </a:gradFill>
-      </a:fillStyleLst>
-      <a:lnStyleLst>
-        <a:ln w="6350" cap="flat" cmpd="sng" algn="ctr">
-          <a:solidFill>
-            <a:schemeClr val="phClr"/>
-          </a:solidFill>
-          <a:prstDash val="solid"/>
-          <a:miter lim="800000"/>
-        </a:ln>
-        <a:ln w="12700" cap="flat" cmpd="sng" algn="ctr">
-          <a:solidFill>
-            <a:schemeClr val="phClr"/>
-          </a:solidFill>
-          <a:prstDash val="solid"/>
-          <a:miter lim="800000"/>
-        </a:ln>
-        <a:ln w="19050" cap="flat" cmpd="sng" algn="ctr">
-          <a:solidFill>
-            <a:schemeClr val="phClr"/>
-          </a:solidFill>
-          <a:prstDash val="solid"/>
-          <a:miter lim="800000"/>
-        </a:ln>
-      </a:lnStyleLst>
-      <a:effectStyleLst>
-        <a:effectStyle>
-          <a:effectLst/>
-        </a:effectStyle>
-        <a:effectStyle>
-          <a:effectLst/>
-        </a:effectStyle>
-        <a:effectStyle>
-          <a:effectLst>
-            <a:outerShdw blurRad="57150" dist="19050" dir="5400000" algn="ctr" rotWithShape="0">
-              <a:srgbClr val="000000">
-                <a:alpha val="63000"/>
-              </a:srgbClr>
-            </a:outerShdw>
-          </a:effectLst>
-        </a:effectStyle>
-      </a:effectStyleLst>
-      <a:bgFillStyleLst>
-        <a:solidFill>
-          <a:schemeClr val="phClr"/>
-        </a:solidFill>
-        <a:solidFill>
-          <a:schemeClr val="phClr">
-            <a:tint val="95000"/>
-            <a:satMod val="170000"/>
-          </a:schemeClr>
-        </a:solidFill>
-        <a:gradFill rotWithShape="1">
-          <a:gsLst>
-            <a:gs pos="0">
-              <a:schemeClr val="phClr">
-                <a:tint val="93000"/>
-                <a:satMod val="150000"/>
-                <a:shade val="98000"/>
-                <a:lumMod val="102000"/>
-              </a:schemeClr>
-            </a:gs>
-            <a:gs pos="50000">
-              <a:schemeClr val="phClr">
-                <a:tint val="98000"/>
-                <a:satMod val="130000"/>
-                <a:shade val="90000"/>
-                <a:lumMod val="103000"/>
-              </a:schemeClr>
-            </a:gs>
-            <a:gs pos="100000">
-              <a:schemeClr val="phClr">
-                <a:shade val="63000"/>
-                <a:satMod val="120000"/>
-              </a:schemeClr>
-            </a:gs>
-          </a:gsLst>
-          <a:lin ang="5400000" scaled="0"/>
-        </a:gradFill>
-      </a:bgFillStyleLst>
-    </a:fmtScheme>
-  </a:themeElements>
-  <a:objectDefaults/>
-  <a:extraClrSchemeLst/>
-  <a:extLst>
-    <a:ext uri="{05A4C25C-085E-4340-85A3-A5531E510DB2}">
-      <thm15:themeFamily xmlns:thm15="http://schemas.microsoft.com/office/thememl/2012/main" name="Office Theme" id="{62F939B6-93AF-4DB8-9C6B-D6C7DFDC589F}" vid="{4A3C46E8-61CC-4603-A589-7422A47A8E4A}"/>
-    </a:ext>
-  </a:extLst>
-</a:theme>
 </file>
</xml_diff>

<commit_message>
Use native Word equations; restyle the slides and the project image
Co-Authored-By: Claude Opus 5.5 <noreply@anthropic.com>
Claude-Session: https://claude.ai/code/session_01AouEcLyMhAyntpeQ675vpK
</commit_message>
<xml_diff>
--- a/Apart Research/slides.pptx
+++ b/Apart Research/slides.pptx
@@ -130,7 +130,7 @@
             <a:pPr>
               <a:defRPr sz="1500" b="0" i="0" u="none" strike="noStrike">
                 <a:solidFill>
-                  <a:srgbClr val="2B2F36"/>
+                  <a:srgbClr val="1E2A44"/>
                 </a:solidFill>
                 <a:latin typeface="+mn-lt"/>
               </a:defRPr>
@@ -138,7 +138,7 @@
             <a:r>
               <a:rPr sz="1500" b="0" i="0" u="none" strike="noStrike">
                 <a:solidFill>
-                  <a:srgbClr val="2B2F36"/>
+                  <a:srgbClr val="1E2A44"/>
                 </a:solidFill>
                 <a:latin typeface="+mn-lt"/>
               </a:rPr>
@@ -173,7 +173,7 @@
           </c:tx>
           <c:spPr>
             <a:solidFill>
-              <a:srgbClr val="2B2F36"/>
+              <a:srgbClr val="1E2A44"/>
             </a:solidFill>
             <a:effectLst/>
           </c:spPr>
@@ -187,7 +187,7 @@
                 <a:pPr>
                   <a:defRPr b="0" i="0" strike="noStrike" sz="1300" u="none">
                     <a:solidFill>
-                      <a:srgbClr val="2B2F36"/>
+                      <a:srgbClr val="1E2A44"/>
                     </a:solidFill>
                     <a:latin typeface="+mn-lt"/>
                   </a:defRPr>
@@ -208,7 +208,7 @@
             <c:bubble3D val="0"/>
             <c:spPr>
               <a:solidFill>
-                <a:srgbClr val="2B2F36"/>
+                <a:srgbClr val="1E2A44"/>
               </a:solidFill>
               <a:effectLst/>
             </c:spPr>
@@ -219,7 +219,7 @@
             <c:bubble3D val="0"/>
             <c:spPr>
               <a:solidFill>
-                <a:srgbClr val="B8BEC7"/>
+                <a:srgbClr val="AEB8C6"/>
               </a:solidFill>
               <a:effectLst/>
             </c:spPr>
@@ -230,7 +230,7 @@
             <c:bubble3D val="0"/>
             <c:spPr>
               <a:solidFill>
-                <a:srgbClr val="1F5FBF"/>
+                <a:srgbClr val="1F6F8B"/>
               </a:solidFill>
               <a:effectLst/>
             </c:spPr>
@@ -241,7 +241,7 @@
             <c:bubble3D val="0"/>
             <c:spPr>
               <a:solidFill>
-                <a:srgbClr val="B8BEC7"/>
+                <a:srgbClr val="C8553D"/>
               </a:solidFill>
               <a:effectLst/>
             </c:spPr>
@@ -252,7 +252,7 @@
             <c:bubble3D val="0"/>
             <c:spPr>
               <a:solidFill>
-                <a:srgbClr val="B8BEC7"/>
+                <a:srgbClr val="AEB8C6"/>
               </a:solidFill>
               <a:effectLst/>
             </c:spPr>
@@ -263,7 +263,7 @@
             <c:bubble3D val="0"/>
             <c:spPr>
               <a:solidFill>
-                <a:srgbClr val="B8BEC7"/>
+                <a:srgbClr val="AEB8C6"/>
               </a:solidFill>
               <a:effectLst/>
             </c:spPr>
@@ -274,7 +274,7 @@
             <c:bubble3D val="0"/>
             <c:spPr>
               <a:solidFill>
-                <a:srgbClr val="B8BEC7"/>
+                <a:srgbClr val="AEB8C6"/>
               </a:solidFill>
               <a:effectLst/>
             </c:spPr>
@@ -285,7 +285,7 @@
             <c:bubble3D val="0"/>
             <c:spPr>
               <a:solidFill>
-                <a:srgbClr val="B8BEC7"/>
+                <a:srgbClr val="AEB8C6"/>
               </a:solidFill>
               <a:effectLst/>
             </c:spPr>
@@ -367,7 +367,7 @@
               <a:pPr>
                 <a:defRPr b="0" i="0" strike="noStrike" sz="1300" u="none">
                   <a:solidFill>
-                    <a:srgbClr val="2B2F36"/>
+                    <a:srgbClr val="1E2A44"/>
                   </a:solidFill>
                   <a:latin typeface="+mn-lt"/>
                 </a:defRPr>
@@ -415,7 +415,7 @@
             <a:pPr>
               <a:defRPr sz="1400" b="0" i="0" u="none" strike="noStrike">
                 <a:solidFill>
-                  <a:srgbClr val="2B2F36"/>
+                  <a:srgbClr val="1E2A44"/>
                 </a:solidFill>
                 <a:latin typeface="+mn-lt"/>
               </a:defRPr>
@@ -442,7 +442,7 @@
           <c:spPr>
             <a:ln w="9525" cap="flat">
               <a:solidFill>
-                <a:srgbClr val="E5E7EB"/>
+                <a:srgbClr val="E7DCCB"/>
               </a:solidFill>
               <a:prstDash val="solid"/>
               <a:round/>
@@ -469,7 +469,7 @@
             <a:pPr>
               <a:defRPr sz="1200" b="0" i="0" u="none" strike="noStrike">
                 <a:solidFill>
-                  <a:srgbClr val="6B7280"/>
+                  <a:srgbClr val="626B7F"/>
                 </a:solidFill>
                 <a:latin typeface="+mn-lt"/>
               </a:defRPr>
@@ -1340,7 +1340,7 @@
           <a:p>
             <a:r>
               <a:rPr lang="en-US" dirty="0"/>
-              <a:t>Profit index 0 = competitive, 1 = monopoly. 'Same + history' differs from no replacement by between -0.025 and +0.213 across the six runs.</a:t>
+              <a:t>Profit index 0 = competitive, 1 = monopoly. 'Same + history' differs from no replacement by between –0.025 and +0.213 across the six runs.</a:t>
             </a:r>
             <a:endParaRPr lang="en-US" dirty="0"/>
           </a:p>
@@ -1770,7 +1770,7 @@
     <p:bg>
       <p:bgPr>
         <a:solidFill>
-          <a:srgbClr val="FFFFFF"/>
+          <a:srgbClr val="F6F1E8"/>
         </a:solidFill>
       </p:bgPr>
     </p:bg>
@@ -1790,7 +1790,47 @@
       </p:grpSpPr>
       <p:sp>
         <p:nvSpPr>
-          <p:cNvPr id="2" name="Text 0"/>
+          <p:cNvPr id="2" name="Shape 0"/>
+          <p:cNvSpPr/>
+          <p:nvPr/>
+        </p:nvSpPr>
+        <p:spPr>
+          <a:xfrm>
+            <a:off x="0" y="0"/>
+            <a:ext cx="12188952" cy="109728"/>
+          </a:xfrm>
+          <a:prstGeom prst="rect">
+            <a:avLst/>
+          </a:prstGeom>
+          <a:solidFill>
+            <a:srgbClr val="1F6F8B"/>
+          </a:solidFill>
+          <a:ln/>
+        </p:spPr>
+      </p:sp>
+      <p:sp>
+        <p:nvSpPr>
+          <p:cNvPr id="3" name="Shape 1"/>
+          <p:cNvSpPr/>
+          <p:nvPr/>
+        </p:nvSpPr>
+        <p:spPr>
+          <a:xfrm>
+            <a:off x="548640" y="1143000"/>
+            <a:ext cx="1097280" cy="54864"/>
+          </a:xfrm>
+          <a:prstGeom prst="rect">
+            <a:avLst/>
+          </a:prstGeom>
+          <a:solidFill>
+            <a:srgbClr val="C8553D"/>
+          </a:solidFill>
+          <a:ln/>
+        </p:spPr>
+      </p:sp>
+      <p:sp>
+        <p:nvSpPr>
+          <p:cNvPr id="4" name="Text 2"/>
           <p:cNvSpPr/>
           <p:nvPr/>
         </p:nvSpPr>
@@ -1815,7 +1855,7 @@
             <a:r>
               <a:rPr lang="en-US" sz="1000" dirty="0">
                 <a:solidFill>
-                  <a:srgbClr val="6B7280"/>
+                  <a:srgbClr val="626B7F"/>
                 </a:solidFill>
                 <a:latin typeface="Times New Roman" pitchFamily="34" charset="0"/>
                 <a:ea typeface="Times New Roman" pitchFamily="34" charset="-122"/>
@@ -1829,10 +1869,10 @@
       </p:sp>
       <p:sp>
         <p:nvSpPr>
-          <p:cNvPr id="3" name="Text 1"/>
+          <p:cNvPr id="5" name="Text 3"/>
           <p:cNvSpPr/>
           <p:nvPr>
-            <p:ph idx="101" type="title" hasCustomPrompt="1"/>
+            <p:ph idx="103" type="title" hasCustomPrompt="1"/>
           </p:nvPr>
         </p:nvSpPr>
         <p:spPr>
@@ -1853,7 +1893,7 @@
               <a:buNone/>
               <a:defRPr lang="en-US" sz="3000" b="1" dirty="0">
                 <a:solidFill>
-                  <a:srgbClr val="2B2F36"/>
+                  <a:srgbClr val="1E2A44"/>
                 </a:solidFill>
                 <a:latin typeface="Times New Roman" pitchFamily="34" charset="0"/>
                 <a:ea typeface="Times New Roman" pitchFamily="34" charset="-122"/>
@@ -1899,7 +1939,7 @@
             <a:lvl1pPr>
               <a:defRPr sz="1000">
                 <a:solidFill>
-                  <a:srgbClr val="6B7280"/>
+                  <a:srgbClr val="626B7F"/>
                 </a:solidFill>
                 <a:latin typeface="Times New Roman"/>
                 <a:ea typeface="Times New Roman"/>
@@ -1931,7 +1971,7 @@
     <p:bg>
       <p:bgPr>
         <a:solidFill>
-          <a:srgbClr val="FFFFFF"/>
+          <a:srgbClr val="F6F1E8"/>
         </a:solidFill>
       </p:bgPr>
     </p:bg>
@@ -1951,10 +1991,50 @@
       </p:grpSpPr>
       <p:sp>
         <p:nvSpPr>
-          <p:cNvPr id="2" name="Text 0"/>
+          <p:cNvPr id="2" name="Shape 0"/>
+          <p:cNvSpPr/>
+          <p:nvPr/>
+        </p:nvSpPr>
+        <p:spPr>
+          <a:xfrm>
+            <a:off x="0" y="0"/>
+            <a:ext cx="256032" cy="6858000"/>
+          </a:xfrm>
+          <a:prstGeom prst="rect">
+            <a:avLst/>
+          </a:prstGeom>
+          <a:solidFill>
+            <a:srgbClr val="1F6F8B"/>
+          </a:solidFill>
+          <a:ln/>
+        </p:spPr>
+      </p:sp>
+      <p:sp>
+        <p:nvSpPr>
+          <p:cNvPr id="3" name="Shape 1"/>
+          <p:cNvSpPr/>
+          <p:nvPr/>
+        </p:nvSpPr>
+        <p:spPr>
+          <a:xfrm>
+            <a:off x="256032" y="0"/>
+            <a:ext cx="73152" cy="6858000"/>
+          </a:xfrm>
+          <a:prstGeom prst="rect">
+            <a:avLst/>
+          </a:prstGeom>
+          <a:solidFill>
+            <a:srgbClr val="C8553D"/>
+          </a:solidFill>
+          <a:ln/>
+        </p:spPr>
+      </p:sp>
+      <p:sp>
+        <p:nvSpPr>
+          <p:cNvPr id="4" name="Text 2"/>
           <p:cNvSpPr/>
           <p:nvPr>
-            <p:ph idx="100" type="title" hasCustomPrompt="1"/>
+            <p:ph idx="102" type="title" hasCustomPrompt="1"/>
           </p:nvPr>
         </p:nvSpPr>
         <p:spPr>
@@ -1975,7 +2055,7 @@
               <a:buNone/>
               <a:defRPr lang="en-US" sz="3000" b="1" dirty="0">
                 <a:solidFill>
-                  <a:srgbClr val="2B2F36"/>
+                  <a:srgbClr val="1E2A44"/>
                 </a:solidFill>
                 <a:latin typeface="Times New Roman" pitchFamily="34" charset="0"/>
                 <a:ea typeface="Times New Roman" pitchFamily="34" charset="-122"/>
@@ -2021,7 +2101,7 @@
             <a:lvl1pPr>
               <a:defRPr sz="1000">
                 <a:solidFill>
-                  <a:srgbClr val="6B7280"/>
+                  <a:srgbClr val="626B7F"/>
                 </a:solidFill>
                 <a:latin typeface="Times New Roman"/>
                 <a:ea typeface="Times New Roman"/>
@@ -2094,7 +2174,7 @@
             <a:lvl1pPr>
               <a:defRPr sz="1000">
                 <a:solidFill>
-                  <a:srgbClr val="6B7280"/>
+                  <a:srgbClr val="626B7F"/>
                 </a:solidFill>
                 <a:latin typeface="Times New Roman"/>
                 <a:ea typeface="Times New Roman"/>
@@ -2418,7 +2498,7 @@
             <a:r>
               <a:rPr lang="en-US" sz="1300" b="1" dirty="0">
                 <a:solidFill>
-                  <a:srgbClr val="6B7280"/>
+                  <a:srgbClr val="626B7F"/>
                 </a:solidFill>
                 <a:latin typeface="Times New Roman" pitchFamily="34" charset="0"/>
                 <a:ea typeface="Times New Roman" pitchFamily="34" charset="-122"/>
@@ -2457,7 +2537,7 @@
             <a:r>
               <a:rPr lang="en-US" sz="5400" b="1" dirty="0">
                 <a:solidFill>
-                  <a:srgbClr val="2B2F36"/>
+                  <a:srgbClr val="1E2A44"/>
                 </a:solidFill>
                 <a:latin typeface="Times New Roman" pitchFamily="34" charset="0"/>
                 <a:ea typeface="Times New Roman" pitchFamily="34" charset="-122"/>
@@ -2496,7 +2576,7 @@
             <a:r>
               <a:rPr lang="en-US" sz="2400" dirty="0">
                 <a:solidFill>
-                  <a:srgbClr val="6B7280"/>
+                  <a:srgbClr val="626B7F"/>
                 </a:solidFill>
                 <a:latin typeface="Times New Roman" pitchFamily="34" charset="0"/>
                 <a:ea typeface="Times New Roman" pitchFamily="34" charset="-122"/>
@@ -2535,7 +2615,7 @@
             <a:r>
               <a:rPr lang="en-US" sz="3600" b="1" dirty="0">
                 <a:solidFill>
-                  <a:srgbClr val="1F5FBF"/>
+                  <a:srgbClr val="1F6F8B"/>
                 </a:solidFill>
                 <a:latin typeface="Times New Roman" pitchFamily="34" charset="0"/>
                 <a:ea typeface="Times New Roman" pitchFamily="34" charset="-122"/>
@@ -2574,7 +2654,7 @@
             <a:r>
               <a:rPr lang="en-US" sz="1500" dirty="0">
                 <a:solidFill>
-                  <a:srgbClr val="2B2F36"/>
+                  <a:srgbClr val="1E2A44"/>
                 </a:solidFill>
                 <a:latin typeface="Times New Roman" pitchFamily="34" charset="0"/>
                 <a:ea typeface="Times New Roman" pitchFamily="34" charset="-122"/>
@@ -2613,7 +2693,7 @@
             <a:r>
               <a:rPr lang="en-US" sz="3600" b="1" dirty="0">
                 <a:solidFill>
-                  <a:srgbClr val="1F5FBF"/>
+                  <a:srgbClr val="1F6F8B"/>
                 </a:solidFill>
                 <a:latin typeface="Times New Roman" pitchFamily="34" charset="0"/>
                 <a:ea typeface="Times New Roman" pitchFamily="34" charset="-122"/>
@@ -2652,7 +2732,7 @@
             <a:r>
               <a:rPr lang="en-US" sz="1500" dirty="0">
                 <a:solidFill>
-                  <a:srgbClr val="2B2F36"/>
+                  <a:srgbClr val="1E2A44"/>
                 </a:solidFill>
                 <a:latin typeface="Times New Roman" pitchFamily="34" charset="0"/>
                 <a:ea typeface="Times New Roman" pitchFamily="34" charset="-122"/>
@@ -2691,7 +2771,7 @@
             <a:r>
               <a:rPr lang="en-US" sz="3600" b="1" dirty="0">
                 <a:solidFill>
-                  <a:srgbClr val="1F5FBF"/>
+                  <a:srgbClr val="1F6F8B"/>
                 </a:solidFill>
                 <a:latin typeface="Times New Roman" pitchFamily="34" charset="0"/>
                 <a:ea typeface="Times New Roman" pitchFamily="34" charset="-122"/>
@@ -2730,7 +2810,7 @@
             <a:r>
               <a:rPr lang="en-US" sz="1500" dirty="0">
                 <a:solidFill>
-                  <a:srgbClr val="2B2F36"/>
+                  <a:srgbClr val="1E2A44"/>
                 </a:solidFill>
                 <a:latin typeface="Times New Roman" pitchFamily="34" charset="0"/>
                 <a:ea typeface="Times New Roman" pitchFamily="34" charset="-122"/>
@@ -2769,7 +2849,7 @@
             <a:r>
               <a:rPr lang="en-US" sz="1500" dirty="0">
                 <a:solidFill>
-                  <a:srgbClr val="6B7280"/>
+                  <a:srgbClr val="626B7F"/>
                 </a:solidFill>
                 <a:latin typeface="Times New Roman" pitchFamily="34" charset="0"/>
                 <a:ea typeface="Times New Roman" pitchFamily="34" charset="-122"/>
@@ -2783,10 +2863,10 @@
       </p:sp>
       <p:sp>
         <p:nvSpPr>
-          <p:cNvPr id="13" name="Text 0"/>
+          <p:cNvPr id="13" name="Text 2"/>
           <p:cNvSpPr/>
           <p:nvPr>
-            <p:ph idx="100" type="title" hasCustomPrompt="1"/>
+            <p:ph idx="102" type="title" hasCustomPrompt="1"/>
           </p:nvPr>
         </p:nvSpPr>
         <p:spPr>
@@ -2841,7 +2921,7 @@
             <a:lvl1pPr>
               <a:defRPr sz="1000">
                 <a:solidFill>
-                  <a:srgbClr val="6B7280"/>
+                  <a:srgbClr val="626B7F"/>
                 </a:solidFill>
                 <a:latin typeface="Times New Roman"/>
                 <a:ea typeface="Times New Roman"/>
@@ -2886,10 +2966,10 @@
       </p:grpSpPr>
       <p:sp>
         <p:nvSpPr>
-          <p:cNvPr id="2" name="Text 1"/>
+          <p:cNvPr id="2" name="Text 3"/>
           <p:cNvSpPr/>
           <p:nvPr>
-            <p:ph idx="101" type="title" hasCustomPrompt="1"/>
+            <p:ph idx="103" type="title" hasCustomPrompt="1"/>
           </p:nvPr>
         </p:nvSpPr>
         <p:spPr>
@@ -2913,7 +2993,7 @@
             <a:r>
               <a:rPr lang="en-US" sz="3000" b="1" dirty="0">
                 <a:solidFill>
-                  <a:srgbClr val="2B2F36"/>
+                  <a:srgbClr val="1E2A44"/>
                 </a:solidFill>
                 <a:latin typeface="Times New Roman" pitchFamily="34" charset="0"/>
                 <a:ea typeface="Times New Roman" pitchFamily="34" charset="-122"/>
@@ -2938,18 +3018,25 @@
           </a:xfrm>
           <a:prstGeom prst="roundRect">
             <a:avLst>
-              <a:gd name="adj" fmla="val 2449"/>
+              <a:gd name="adj" fmla="val 2857"/>
             </a:avLst>
           </a:prstGeom>
           <a:solidFill>
-            <a:srgbClr val="F3F4F6"/>
+            <a:srgbClr val="FFFBF4"/>
           </a:solidFill>
           <a:ln w="12700">
             <a:solidFill>
-              <a:srgbClr val="F3F4F6"/>
+              <a:srgbClr val="E7DCCB"/>
             </a:solidFill>
             <a:prstDash val="solid"/>
           </a:ln>
+          <a:effectLst>
+            <a:outerShdw sx="100000" sy="100000" kx="0" ky="0" algn="bl" rotWithShape="0" blurRad="76200" dist="25400" dir="5400000">
+              <a:srgbClr val="BFB3A0">
+                <a:alpha val="25000"/>
+              </a:srgbClr>
+            </a:outerShdw>
+          </a:effectLst>
         </p:spPr>
       </p:sp>
       <p:sp>
@@ -2979,7 +3066,7 @@
             <a:r>
               <a:rPr lang="en-US" sz="2000" b="1" dirty="0">
                 <a:solidFill>
-                  <a:srgbClr val="2B2F36"/>
+                  <a:srgbClr val="1E2A44"/>
                 </a:solidFill>
                 <a:latin typeface="Times New Roman" pitchFamily="34" charset="0"/>
                 <a:ea typeface="Times New Roman" pitchFamily="34" charset="-122"/>
@@ -3022,7 +3109,7 @@
             <a:r>
               <a:rPr lang="en-US" sz="1500" dirty="0">
                 <a:solidFill>
-                  <a:srgbClr val="2B2F36"/>
+                  <a:srgbClr val="2F3B55"/>
                 </a:solidFill>
                 <a:latin typeface="Times New Roman" pitchFamily="34" charset="0"/>
                 <a:ea typeface="Times New Roman" pitchFamily="34" charset="-122"/>
@@ -3043,7 +3130,7 @@
             <a:r>
               <a:rPr lang="en-US" sz="1500" dirty="0">
                 <a:solidFill>
-                  <a:srgbClr val="2B2F36"/>
+                  <a:srgbClr val="2F3B55"/>
                 </a:solidFill>
                 <a:latin typeface="Times New Roman" pitchFamily="34" charset="0"/>
                 <a:ea typeface="Times New Roman" pitchFamily="34" charset="-122"/>
@@ -3064,7 +3151,7 @@
             <a:r>
               <a:rPr lang="en-US" sz="1500" dirty="0">
                 <a:solidFill>
-                  <a:srgbClr val="2B2F36"/>
+                  <a:srgbClr val="2F3B55"/>
                 </a:solidFill>
                 <a:latin typeface="Times New Roman" pitchFamily="34" charset="0"/>
                 <a:ea typeface="Times New Roman" pitchFamily="34" charset="-122"/>
@@ -3085,7 +3172,7 @@
             <a:r>
               <a:rPr lang="en-US" sz="1500" dirty="0">
                 <a:solidFill>
-                  <a:srgbClr val="2B2F36"/>
+                  <a:srgbClr val="2F3B55"/>
                 </a:solidFill>
                 <a:latin typeface="Times New Roman" pitchFamily="34" charset="0"/>
                 <a:ea typeface="Times New Roman" pitchFamily="34" charset="-122"/>
@@ -3110,18 +3197,25 @@
           </a:xfrm>
           <a:prstGeom prst="roundRect">
             <a:avLst>
-              <a:gd name="adj" fmla="val 2449"/>
+              <a:gd name="adj" fmla="val 2857"/>
             </a:avLst>
           </a:prstGeom>
           <a:solidFill>
-            <a:srgbClr val="F3F4F6"/>
+            <a:srgbClr val="FFFBF4"/>
           </a:solidFill>
           <a:ln w="12700">
             <a:solidFill>
-              <a:srgbClr val="F3F4F6"/>
+              <a:srgbClr val="E7DCCB"/>
             </a:solidFill>
             <a:prstDash val="solid"/>
           </a:ln>
+          <a:effectLst>
+            <a:outerShdw sx="100000" sy="100000" kx="0" ky="0" algn="bl" rotWithShape="0" blurRad="76200" dist="25400" dir="5400000">
+              <a:srgbClr val="BFB3A0">
+                <a:alpha val="25000"/>
+              </a:srgbClr>
+            </a:outerShdw>
+          </a:effectLst>
         </p:spPr>
       </p:sp>
       <p:sp>
@@ -3151,7 +3245,7 @@
             <a:r>
               <a:rPr lang="en-US" sz="2000" b="1" dirty="0">
                 <a:solidFill>
-                  <a:srgbClr val="2B2F36"/>
+                  <a:srgbClr val="1E2A44"/>
                 </a:solidFill>
                 <a:latin typeface="Times New Roman" pitchFamily="34" charset="0"/>
                 <a:ea typeface="Times New Roman" pitchFamily="34" charset="-122"/>
@@ -3194,7 +3288,7 @@
             <a:r>
               <a:rPr lang="en-US" sz="1500" dirty="0">
                 <a:solidFill>
-                  <a:srgbClr val="2B2F36"/>
+                  <a:srgbClr val="2F3B55"/>
                 </a:solidFill>
                 <a:latin typeface="Times New Roman" pitchFamily="34" charset="0"/>
                 <a:ea typeface="Times New Roman" pitchFamily="34" charset="-122"/>
@@ -3215,7 +3309,7 @@
             <a:r>
               <a:rPr lang="en-US" sz="1500" dirty="0">
                 <a:solidFill>
-                  <a:srgbClr val="2B2F36"/>
+                  <a:srgbClr val="2F3B55"/>
                 </a:solidFill>
                 <a:latin typeface="Times New Roman" pitchFamily="34" charset="0"/>
                 <a:ea typeface="Times New Roman" pitchFamily="34" charset="-122"/>
@@ -3236,7 +3330,7 @@
             <a:r>
               <a:rPr lang="en-US" sz="1500" dirty="0">
                 <a:solidFill>
-                  <a:srgbClr val="2B2F36"/>
+                  <a:srgbClr val="2F3B55"/>
                 </a:solidFill>
                 <a:latin typeface="Times New Roman" pitchFamily="34" charset="0"/>
                 <a:ea typeface="Times New Roman" pitchFamily="34" charset="-122"/>
@@ -3275,13 +3369,13 @@
             <a:r>
               <a:rPr lang="en-US" sz="1500" b="1" dirty="0">
                 <a:solidFill>
-                  <a:srgbClr val="2B2F36"/>
-                </a:solidFill>
-                <a:latin typeface="Times New Roman" pitchFamily="34" charset="0"/>
-                <a:ea typeface="Times New Roman" pitchFamily="34" charset="-122"/>
-                <a:cs typeface="Times New Roman" pitchFamily="34" charset="-120"/>
-              </a:rPr>
-              <a:t>Code, data and report:</a:t>
+                  <a:srgbClr val="1E2A44"/>
+                </a:solidFill>
+                <a:latin typeface="Times New Roman" pitchFamily="34" charset="0"/>
+                <a:ea typeface="Times New Roman" pitchFamily="34" charset="-122"/>
+                <a:cs typeface="Times New Roman" pitchFamily="34" charset="-120"/>
+              </a:rPr>
+              <a:t>Code:</a:t>
             </a:r>
             <a:endParaRPr lang="en-US" sz="1500" dirty="0"/>
           </a:p>
@@ -3314,7 +3408,7 @@
             <a:r>
               <a:rPr lang="en-US" sz="1400" u="sng" dirty="0">
                 <a:solidFill>
-                  <a:srgbClr val="1F5FBF"/>
+                  <a:srgbClr val="1F6F8B"/>
                 </a:solidFill>
                 <a:latin typeface="Times New Roman" pitchFamily="34" charset="0"/>
                 <a:ea typeface="Times New Roman" pitchFamily="34" charset="-122"/>
@@ -3327,7 +3421,7 @@
                   </a:extLst>
                 </a:hlinkClick>
               </a:rPr>
-              <a:t>github.com/SSCoderz2123/AI-Collusion-Research-Sprint</a:t>
+              <a:t>github.com/SupratikB23/LLM-Cartel-Succession</a:t>
             </a:r>
             <a:endParaRPr lang="en-US" sz="1400" dirty="0"/>
           </a:p>
@@ -3363,7 +3457,7 @@
             <a:lvl1pPr>
               <a:defRPr sz="1000">
                 <a:solidFill>
-                  <a:srgbClr val="6B7280"/>
+                  <a:srgbClr val="626B7F"/>
                 </a:solidFill>
                 <a:latin typeface="Times New Roman"/>
                 <a:ea typeface="Times New Roman"/>
@@ -3408,10 +3502,10 @@
       </p:grpSpPr>
       <p:sp>
         <p:nvSpPr>
-          <p:cNvPr id="2" name="Text 1"/>
+          <p:cNvPr id="2" name="Text 3"/>
           <p:cNvSpPr/>
           <p:nvPr>
-            <p:ph idx="101" type="title" hasCustomPrompt="1"/>
+            <p:ph idx="103" type="title" hasCustomPrompt="1"/>
           </p:nvPr>
         </p:nvSpPr>
         <p:spPr>
@@ -3435,7 +3529,7 @@
             <a:r>
               <a:rPr lang="en-US" sz="3000" b="1" dirty="0">
                 <a:solidFill>
-                  <a:srgbClr val="2B2F36"/>
+                  <a:srgbClr val="1E2A44"/>
                 </a:solidFill>
                 <a:latin typeface="Times New Roman" pitchFamily="34" charset="0"/>
                 <a:ea typeface="Times New Roman" pitchFamily="34" charset="-122"/>
@@ -3474,7 +3568,7 @@
             <a:r>
               <a:rPr lang="en-US" sz="1800" dirty="0">
                 <a:solidFill>
-                  <a:srgbClr val="2B2F36"/>
+                  <a:srgbClr val="2F3B55"/>
                 </a:solidFill>
                 <a:latin typeface="Times New Roman" pitchFamily="34" charset="0"/>
                 <a:ea typeface="Times New Roman" pitchFamily="34" charset="-122"/>
@@ -3491,7 +3585,7 @@
             <a:r>
               <a:rPr lang="en-US" sz="800" dirty="0">
                 <a:solidFill>
-                  <a:srgbClr val="2B2F36"/>
+                  <a:srgbClr val="2F3B55"/>
                 </a:solidFill>
                 <a:latin typeface="Times New Roman" pitchFamily="34" charset="0"/>
                 <a:ea typeface="Times New Roman" pitchFamily="34" charset="-122"/>
@@ -3508,7 +3602,7 @@
             <a:r>
               <a:rPr lang="en-US" sz="1800" dirty="0">
                 <a:solidFill>
-                  <a:srgbClr val="2B2F36"/>
+                  <a:srgbClr val="2F3B55"/>
                 </a:solidFill>
                 <a:latin typeface="Times New Roman" pitchFamily="34" charset="0"/>
                 <a:ea typeface="Times New Roman" pitchFamily="34" charset="-122"/>
@@ -3525,7 +3619,7 @@
             <a:r>
               <a:rPr lang="en-US" sz="800" dirty="0">
                 <a:solidFill>
-                  <a:srgbClr val="2B2F36"/>
+                  <a:srgbClr val="2F3B55"/>
                 </a:solidFill>
                 <a:latin typeface="Times New Roman" pitchFamily="34" charset="0"/>
                 <a:ea typeface="Times New Roman" pitchFamily="34" charset="-122"/>
@@ -3542,7 +3636,7 @@
             <a:r>
               <a:rPr lang="en-US" sz="1800" dirty="0">
                 <a:solidFill>
-                  <a:srgbClr val="2B2F36"/>
+                  <a:srgbClr val="2F3B55"/>
                 </a:solidFill>
                 <a:latin typeface="Times New Roman" pitchFamily="34" charset="0"/>
                 <a:ea typeface="Times New Roman" pitchFamily="34" charset="-122"/>
@@ -3567,18 +3661,25 @@
           </a:xfrm>
           <a:prstGeom prst="roundRect">
             <a:avLst>
-              <a:gd name="adj" fmla="val 8889"/>
+              <a:gd name="adj" fmla="val 10370"/>
             </a:avLst>
           </a:prstGeom>
           <a:solidFill>
-            <a:srgbClr val="F3F4F6"/>
+            <a:srgbClr val="DCEBF0"/>
           </a:solidFill>
           <a:ln w="12700">
             <a:solidFill>
-              <a:srgbClr val="F3F4F6"/>
+              <a:srgbClr val="E7DCCB"/>
             </a:solidFill>
             <a:prstDash val="solid"/>
           </a:ln>
+          <a:effectLst>
+            <a:outerShdw sx="100000" sy="100000" kx="0" ky="0" algn="bl" rotWithShape="0" blurRad="76200" dist="25400" dir="5400000">
+              <a:srgbClr val="BFB3A0">
+                <a:alpha val="25000"/>
+              </a:srgbClr>
+            </a:outerShdw>
+          </a:effectLst>
         </p:spPr>
       </p:sp>
       <p:sp>
@@ -3596,11 +3697,11 @@
             <a:avLst/>
           </a:prstGeom>
           <a:solidFill>
-            <a:srgbClr val="1F5FBF"/>
+            <a:srgbClr val="1F6F8B"/>
           </a:solidFill>
           <a:ln w="12700">
             <a:solidFill>
-              <a:srgbClr val="1F5FBF"/>
+              <a:srgbClr val="1F6F8B"/>
             </a:solidFill>
             <a:prstDash val="solid"/>
           </a:ln>
@@ -3672,7 +3773,7 @@
             <a:r>
               <a:rPr lang="en-US" sz="2000" b="1" dirty="0">
                 <a:solidFill>
-                  <a:srgbClr val="2B2F36"/>
+                  <a:srgbClr val="1E2A44"/>
                 </a:solidFill>
                 <a:latin typeface="Times New Roman" pitchFamily="34" charset="0"/>
                 <a:ea typeface="Times New Roman" pitchFamily="34" charset="-122"/>
@@ -3711,7 +3812,7 @@
             <a:r>
               <a:rPr lang="en-US" sz="1500" dirty="0">
                 <a:solidFill>
-                  <a:srgbClr val="6B7280"/>
+                  <a:srgbClr val="626B7F"/>
                 </a:solidFill>
                 <a:latin typeface="Times New Roman" pitchFamily="34" charset="0"/>
                 <a:ea typeface="Times New Roman" pitchFamily="34" charset="-122"/>
@@ -3736,18 +3837,25 @@
           </a:xfrm>
           <a:prstGeom prst="roundRect">
             <a:avLst>
-              <a:gd name="adj" fmla="val 8889"/>
+              <a:gd name="adj" fmla="val 10370"/>
             </a:avLst>
           </a:prstGeom>
           <a:solidFill>
-            <a:srgbClr val="F3F4F6"/>
+            <a:srgbClr val="F8E1D7"/>
           </a:solidFill>
           <a:ln w="12700">
             <a:solidFill>
-              <a:srgbClr val="F3F4F6"/>
+              <a:srgbClr val="E7DCCB"/>
             </a:solidFill>
             <a:prstDash val="solid"/>
           </a:ln>
+          <a:effectLst>
+            <a:outerShdw sx="100000" sy="100000" kx="0" ky="0" algn="bl" rotWithShape="0" blurRad="76200" dist="25400" dir="5400000">
+              <a:srgbClr val="BFB3A0">
+                <a:alpha val="25000"/>
+              </a:srgbClr>
+            </a:outerShdw>
+          </a:effectLst>
         </p:spPr>
       </p:sp>
       <p:sp>
@@ -3765,11 +3873,11 @@
             <a:avLst/>
           </a:prstGeom>
           <a:solidFill>
-            <a:srgbClr val="1F5FBF"/>
+            <a:srgbClr val="C8553D"/>
           </a:solidFill>
           <a:ln w="12700">
             <a:solidFill>
-              <a:srgbClr val="1F5FBF"/>
+              <a:srgbClr val="C8553D"/>
             </a:solidFill>
             <a:prstDash val="solid"/>
           </a:ln>
@@ -3841,7 +3949,7 @@
             <a:r>
               <a:rPr lang="en-US" sz="2000" b="1" dirty="0">
                 <a:solidFill>
-                  <a:srgbClr val="2B2F36"/>
+                  <a:srgbClr val="1E2A44"/>
                 </a:solidFill>
                 <a:latin typeface="Times New Roman" pitchFamily="34" charset="0"/>
                 <a:ea typeface="Times New Roman" pitchFamily="34" charset="-122"/>
@@ -3880,7 +3988,7 @@
             <a:r>
               <a:rPr lang="en-US" sz="1500" dirty="0">
                 <a:solidFill>
-                  <a:srgbClr val="6B7280"/>
+                  <a:srgbClr val="626B7F"/>
                 </a:solidFill>
                 <a:latin typeface="Times New Roman" pitchFamily="34" charset="0"/>
                 <a:ea typeface="Times New Roman" pitchFamily="34" charset="-122"/>
@@ -3905,18 +4013,25 @@
           </a:xfrm>
           <a:prstGeom prst="roundRect">
             <a:avLst>
-              <a:gd name="adj" fmla="val 8889"/>
+              <a:gd name="adj" fmla="val 10370"/>
             </a:avLst>
           </a:prstGeom>
           <a:solidFill>
-            <a:srgbClr val="F3F4F6"/>
+            <a:srgbClr val="E4EEDF"/>
           </a:solidFill>
           <a:ln w="12700">
             <a:solidFill>
-              <a:srgbClr val="F3F4F6"/>
+              <a:srgbClr val="E7DCCB"/>
             </a:solidFill>
             <a:prstDash val="solid"/>
           </a:ln>
+          <a:effectLst>
+            <a:outerShdw sx="100000" sy="100000" kx="0" ky="0" algn="bl" rotWithShape="0" blurRad="76200" dist="25400" dir="5400000">
+              <a:srgbClr val="BFB3A0">
+                <a:alpha val="25000"/>
+              </a:srgbClr>
+            </a:outerShdw>
+          </a:effectLst>
         </p:spPr>
       </p:sp>
       <p:sp>
@@ -3934,11 +4049,11 @@
             <a:avLst/>
           </a:prstGeom>
           <a:solidFill>
-            <a:srgbClr val="1F5FBF"/>
+            <a:srgbClr val="5E8C61"/>
           </a:solidFill>
           <a:ln w="12700">
             <a:solidFill>
-              <a:srgbClr val="1F5FBF"/>
+              <a:srgbClr val="5E8C61"/>
             </a:solidFill>
             <a:prstDash val="solid"/>
           </a:ln>
@@ -4010,7 +4125,7 @@
             <a:r>
               <a:rPr lang="en-US" sz="2000" b="1" dirty="0">
                 <a:solidFill>
-                  <a:srgbClr val="2B2F36"/>
+                  <a:srgbClr val="1E2A44"/>
                 </a:solidFill>
                 <a:latin typeface="Times New Roman" pitchFamily="34" charset="0"/>
                 <a:ea typeface="Times New Roman" pitchFamily="34" charset="-122"/>
@@ -4049,7 +4164,7 @@
             <a:r>
               <a:rPr lang="en-US" sz="1500" dirty="0">
                 <a:solidFill>
-                  <a:srgbClr val="6B7280"/>
+                  <a:srgbClr val="626B7F"/>
                 </a:solidFill>
                 <a:latin typeface="Times New Roman" pitchFamily="34" charset="0"/>
                 <a:ea typeface="Times New Roman" pitchFamily="34" charset="-122"/>
@@ -4091,7 +4206,7 @@
             <a:lvl1pPr>
               <a:defRPr sz="1000">
                 <a:solidFill>
-                  <a:srgbClr val="6B7280"/>
+                  <a:srgbClr val="626B7F"/>
                 </a:solidFill>
                 <a:latin typeface="Times New Roman"/>
                 <a:ea typeface="Times New Roman"/>
@@ -4136,10 +4251,10 @@
       </p:grpSpPr>
       <p:sp>
         <p:nvSpPr>
-          <p:cNvPr id="2" name="Text 1"/>
+          <p:cNvPr id="2" name="Text 3"/>
           <p:cNvSpPr/>
           <p:nvPr>
-            <p:ph idx="101" type="title" hasCustomPrompt="1"/>
+            <p:ph idx="103" type="title" hasCustomPrompt="1"/>
           </p:nvPr>
         </p:nvSpPr>
         <p:spPr>
@@ -4163,7 +4278,7 @@
             <a:r>
               <a:rPr lang="en-US" sz="3000" b="1" dirty="0">
                 <a:solidFill>
-                  <a:srgbClr val="2B2F36"/>
+                  <a:srgbClr val="1E2A44"/>
                 </a:solidFill>
                 <a:latin typeface="Times New Roman" pitchFamily="34" charset="0"/>
                 <a:ea typeface="Times New Roman" pitchFamily="34" charset="-122"/>
@@ -4205,7 +4320,7 @@
             <a:r>
               <a:rPr lang="en-US" sz="1800" b="1" dirty="0">
                 <a:solidFill>
-                  <a:srgbClr val="2B2F36"/>
+                  <a:srgbClr val="2F3B55"/>
                 </a:solidFill>
                 <a:latin typeface="Times New Roman" pitchFamily="34" charset="0"/>
                 <a:ea typeface="Times New Roman" pitchFamily="34" charset="-122"/>
@@ -4222,7 +4337,7 @@
             <a:r>
               <a:rPr lang="en-US" sz="1800" dirty="0">
                 <a:solidFill>
-                  <a:srgbClr val="2B2F36"/>
+                  <a:srgbClr val="2F3B55"/>
                 </a:solidFill>
                 <a:latin typeface="Times New Roman" pitchFamily="34" charset="0"/>
                 <a:ea typeface="Times New Roman" pitchFamily="34" charset="-122"/>
@@ -4242,7 +4357,7 @@
             <a:r>
               <a:rPr lang="en-US" sz="800" dirty="0">
                 <a:solidFill>
-                  <a:srgbClr val="2B2F36"/>
+                  <a:srgbClr val="2F3B55"/>
                 </a:solidFill>
                 <a:latin typeface="Times New Roman" pitchFamily="34" charset="0"/>
                 <a:ea typeface="Times New Roman" pitchFamily="34" charset="-122"/>
@@ -4262,7 +4377,7 @@
             <a:r>
               <a:rPr lang="en-US" sz="1800" b="1" dirty="0">
                 <a:solidFill>
-                  <a:srgbClr val="2B2F36"/>
+                  <a:srgbClr val="2F3B55"/>
                 </a:solidFill>
                 <a:latin typeface="Times New Roman" pitchFamily="34" charset="0"/>
                 <a:ea typeface="Times New Roman" pitchFamily="34" charset="-122"/>
@@ -4279,7 +4394,7 @@
             <a:r>
               <a:rPr lang="en-US" sz="1800" dirty="0">
                 <a:solidFill>
-                  <a:srgbClr val="2B2F36"/>
+                  <a:srgbClr val="2F3B55"/>
                 </a:solidFill>
                 <a:latin typeface="Times New Roman" pitchFamily="34" charset="0"/>
                 <a:ea typeface="Times New Roman" pitchFamily="34" charset="-122"/>
@@ -4299,7 +4414,7 @@
             <a:r>
               <a:rPr lang="en-US" sz="800" dirty="0">
                 <a:solidFill>
-                  <a:srgbClr val="2B2F36"/>
+                  <a:srgbClr val="2F3B55"/>
                 </a:solidFill>
                 <a:latin typeface="Times New Roman" pitchFamily="34" charset="0"/>
                 <a:ea typeface="Times New Roman" pitchFamily="34" charset="-122"/>
@@ -4319,7 +4434,7 @@
             <a:r>
               <a:rPr lang="en-US" sz="1800" b="1" dirty="0">
                 <a:solidFill>
-                  <a:srgbClr val="2B2F36"/>
+                  <a:srgbClr val="2F3B55"/>
                 </a:solidFill>
                 <a:latin typeface="Times New Roman" pitchFamily="34" charset="0"/>
                 <a:ea typeface="Times New Roman" pitchFamily="34" charset="-122"/>
@@ -4336,7 +4451,7 @@
             <a:r>
               <a:rPr lang="en-US" sz="1800" dirty="0">
                 <a:solidFill>
-                  <a:srgbClr val="2B2F36"/>
+                  <a:srgbClr val="2F3B55"/>
                 </a:solidFill>
                 <a:latin typeface="Times New Roman" pitchFamily="34" charset="0"/>
                 <a:ea typeface="Times New Roman" pitchFamily="34" charset="-122"/>
@@ -4361,18 +4476,25 @@
           </a:xfrm>
           <a:prstGeom prst="roundRect">
             <a:avLst>
-              <a:gd name="adj" fmla="val 2609"/>
+              <a:gd name="adj" fmla="val 3043"/>
             </a:avLst>
           </a:prstGeom>
           <a:solidFill>
-            <a:srgbClr val="F3F4F6"/>
+            <a:srgbClr val="FFFBF4"/>
           </a:solidFill>
           <a:ln w="12700">
             <a:solidFill>
-              <a:srgbClr val="F3F4F6"/>
+              <a:srgbClr val="E7DCCB"/>
             </a:solidFill>
             <a:prstDash val="solid"/>
           </a:ln>
+          <a:effectLst>
+            <a:outerShdw sx="100000" sy="100000" kx="0" ky="0" algn="bl" rotWithShape="0" blurRad="76200" dist="25400" dir="5400000">
+              <a:srgbClr val="BFB3A0">
+                <a:alpha val="25000"/>
+              </a:srgbClr>
+            </a:outerShdw>
+          </a:effectLst>
         </p:spPr>
       </p:sp>
       <p:sp>
@@ -4402,7 +4524,7 @@
             <a:r>
               <a:rPr lang="en-US" sz="1800" b="1" dirty="0">
                 <a:solidFill>
-                  <a:srgbClr val="2B2F36"/>
+                  <a:srgbClr val="1E2A44"/>
                 </a:solidFill>
                 <a:latin typeface="Times New Roman" pitchFamily="34" charset="0"/>
                 <a:ea typeface="Times New Roman" pitchFamily="34" charset="-122"/>
@@ -4429,11 +4551,11 @@
             <a:avLst/>
           </a:prstGeom>
           <a:solidFill>
-            <a:srgbClr val="D1D5DB"/>
+            <a:srgbClr val="D9CFBF"/>
           </a:solidFill>
           <a:ln w="12700">
             <a:solidFill>
-              <a:srgbClr val="D1D5DB"/>
+              <a:srgbClr val="D9CFBF"/>
             </a:solidFill>
             <a:prstDash val="solid"/>
           </a:ln>
@@ -4454,11 +4576,11 @@
             <a:avLst/>
           </a:prstGeom>
           <a:solidFill>
-            <a:srgbClr val="2B2F36"/>
+            <a:srgbClr val="1E2A44"/>
           </a:solidFill>
           <a:ln w="12700">
             <a:solidFill>
-              <a:srgbClr val="2B2F36"/>
+              <a:srgbClr val="1E2A44"/>
             </a:solidFill>
             <a:prstDash val="solid"/>
           </a:ln>
@@ -4479,11 +4601,11 @@
             <a:avLst/>
           </a:prstGeom>
           <a:solidFill>
-            <a:srgbClr val="1F5FBF"/>
+            <a:srgbClr val="1F6F8B"/>
           </a:solidFill>
           <a:ln w="12700">
             <a:solidFill>
-              <a:srgbClr val="1F5FBF"/>
+              <a:srgbClr val="1F6F8B"/>
             </a:solidFill>
             <a:prstDash val="solid"/>
           </a:ln>
@@ -4516,7 +4638,7 @@
             <a:r>
               <a:rPr lang="en-US" sz="1400" b="1" dirty="0">
                 <a:solidFill>
-                  <a:srgbClr val="2B2F36"/>
+                  <a:srgbClr val="1E2A44"/>
                 </a:solidFill>
                 <a:latin typeface="Times New Roman" pitchFamily="34" charset="0"/>
                 <a:ea typeface="Times New Roman" pitchFamily="34" charset="-122"/>
@@ -4533,7 +4655,7 @@
             <a:r>
               <a:rPr lang="en-US" sz="1400" b="1" dirty="0">
                 <a:solidFill>
-                  <a:srgbClr val="2B2F36"/>
+                  <a:srgbClr val="1E2A44"/>
                 </a:solidFill>
                 <a:latin typeface="Times New Roman" pitchFamily="34" charset="0"/>
                 <a:ea typeface="Times New Roman" pitchFamily="34" charset="-122"/>
@@ -4572,7 +4694,7 @@
             <a:r>
               <a:rPr lang="en-US" sz="1400" b="1" dirty="0">
                 <a:solidFill>
-                  <a:srgbClr val="1F5FBF"/>
+                  <a:srgbClr val="1F6F8B"/>
                 </a:solidFill>
                 <a:latin typeface="Times New Roman" pitchFamily="34" charset="0"/>
                 <a:ea typeface="Times New Roman" pitchFamily="34" charset="-122"/>
@@ -4589,7 +4711,7 @@
             <a:r>
               <a:rPr lang="en-US" sz="1400" b="1" dirty="0">
                 <a:solidFill>
-                  <a:srgbClr val="1F5FBF"/>
+                  <a:srgbClr val="1F6F8B"/>
                 </a:solidFill>
                 <a:latin typeface="Times New Roman" pitchFamily="34" charset="0"/>
                 <a:ea typeface="Times New Roman" pitchFamily="34" charset="-122"/>
@@ -4628,7 +4750,7 @@
             <a:r>
               <a:rPr lang="en-US" sz="1400" dirty="0">
                 <a:solidFill>
-                  <a:srgbClr val="6B7280"/>
+                  <a:srgbClr val="626B7F"/>
                 </a:solidFill>
                 <a:latin typeface="Times New Roman" pitchFamily="34" charset="0"/>
                 <a:ea typeface="Times New Roman" pitchFamily="34" charset="-122"/>
@@ -4670,7 +4792,7 @@
             <a:lvl1pPr>
               <a:defRPr sz="1000">
                 <a:solidFill>
-                  <a:srgbClr val="6B7280"/>
+                  <a:srgbClr val="626B7F"/>
                 </a:solidFill>
                 <a:latin typeface="Times New Roman"/>
                 <a:ea typeface="Times New Roman"/>
@@ -4715,10 +4837,10 @@
       </p:grpSpPr>
       <p:sp>
         <p:nvSpPr>
-          <p:cNvPr id="2" name="Text 1"/>
+          <p:cNvPr id="2" name="Text 3"/>
           <p:cNvSpPr/>
           <p:nvPr>
-            <p:ph idx="101" type="title" hasCustomPrompt="1"/>
+            <p:ph idx="103" type="title" hasCustomPrompt="1"/>
           </p:nvPr>
         </p:nvSpPr>
         <p:spPr>
@@ -4742,7 +4864,7 @@
             <a:r>
               <a:rPr lang="en-US" sz="3000" b="1" dirty="0">
                 <a:solidFill>
-                  <a:srgbClr val="2B2F36"/>
+                  <a:srgbClr val="1E2A44"/>
                 </a:solidFill>
                 <a:latin typeface="Times New Roman" pitchFamily="34" charset="0"/>
                 <a:ea typeface="Times New Roman" pitchFamily="34" charset="-122"/>
@@ -4767,18 +4889,25 @@
           </a:xfrm>
           <a:prstGeom prst="roundRect">
             <a:avLst>
-              <a:gd name="adj" fmla="val 6316"/>
+              <a:gd name="adj" fmla="val 7368"/>
             </a:avLst>
           </a:prstGeom>
           <a:solidFill>
-            <a:srgbClr val="F3F4F6"/>
+            <a:srgbClr val="DCEBF0"/>
           </a:solidFill>
           <a:ln w="12700">
             <a:solidFill>
-              <a:srgbClr val="F3F4F6"/>
+              <a:srgbClr val="E7DCCB"/>
             </a:solidFill>
             <a:prstDash val="solid"/>
           </a:ln>
+          <a:effectLst>
+            <a:outerShdw sx="100000" sy="100000" kx="0" ky="0" algn="bl" rotWithShape="0" blurRad="76200" dist="25400" dir="5400000">
+              <a:srgbClr val="BFB3A0">
+                <a:alpha val="25000"/>
+              </a:srgbClr>
+            </a:outerShdw>
+          </a:effectLst>
         </p:spPr>
       </p:sp>
       <p:sp>
@@ -4796,11 +4925,11 @@
             <a:avLst/>
           </a:prstGeom>
           <a:solidFill>
-            <a:srgbClr val="2B2F36"/>
+            <a:srgbClr val="1F6F8B"/>
           </a:solidFill>
           <a:ln w="12700">
             <a:solidFill>
-              <a:srgbClr val="2B2F36"/>
+              <a:srgbClr val="1F6F8B"/>
             </a:solidFill>
             <a:prstDash val="solid"/>
           </a:ln>
@@ -4872,7 +5001,7 @@
             <a:r>
               <a:rPr lang="en-US" sz="1700" b="1" dirty="0">
                 <a:solidFill>
-                  <a:srgbClr val="2B2F36"/>
+                  <a:srgbClr val="1E2A44"/>
                 </a:solidFill>
                 <a:latin typeface="Times New Roman" pitchFamily="34" charset="0"/>
                 <a:ea typeface="Times New Roman" pitchFamily="34" charset="-122"/>
@@ -4911,7 +5040,7 @@
             <a:r>
               <a:rPr lang="en-US" sz="1400" dirty="0">
                 <a:solidFill>
-                  <a:srgbClr val="6B7280"/>
+                  <a:srgbClr val="626B7F"/>
                 </a:solidFill>
                 <a:latin typeface="Times New Roman" pitchFamily="34" charset="0"/>
                 <a:ea typeface="Times New Roman" pitchFamily="34" charset="-122"/>
@@ -4936,18 +5065,25 @@
           </a:xfrm>
           <a:prstGeom prst="roundRect">
             <a:avLst>
-              <a:gd name="adj" fmla="val 6316"/>
+              <a:gd name="adj" fmla="val 7368"/>
             </a:avLst>
           </a:prstGeom>
           <a:solidFill>
-            <a:srgbClr val="F3F4F6"/>
+            <a:srgbClr val="F8E1D7"/>
           </a:solidFill>
           <a:ln w="12700">
             <a:solidFill>
-              <a:srgbClr val="F3F4F6"/>
+              <a:srgbClr val="E7DCCB"/>
             </a:solidFill>
             <a:prstDash val="solid"/>
           </a:ln>
+          <a:effectLst>
+            <a:outerShdw sx="100000" sy="100000" kx="0" ky="0" algn="bl" rotWithShape="0" blurRad="76200" dist="25400" dir="5400000">
+              <a:srgbClr val="BFB3A0">
+                <a:alpha val="25000"/>
+              </a:srgbClr>
+            </a:outerShdw>
+          </a:effectLst>
         </p:spPr>
       </p:sp>
       <p:sp>
@@ -4965,11 +5101,11 @@
             <a:avLst/>
           </a:prstGeom>
           <a:solidFill>
-            <a:srgbClr val="2B2F36"/>
+            <a:srgbClr val="C8553D"/>
           </a:solidFill>
           <a:ln w="12700">
             <a:solidFill>
-              <a:srgbClr val="2B2F36"/>
+              <a:srgbClr val="C8553D"/>
             </a:solidFill>
             <a:prstDash val="solid"/>
           </a:ln>
@@ -5041,7 +5177,7 @@
             <a:r>
               <a:rPr lang="en-US" sz="1700" b="1" dirty="0">
                 <a:solidFill>
-                  <a:srgbClr val="2B2F36"/>
+                  <a:srgbClr val="1E2A44"/>
                 </a:solidFill>
                 <a:latin typeface="Times New Roman" pitchFamily="34" charset="0"/>
                 <a:ea typeface="Times New Roman" pitchFamily="34" charset="-122"/>
@@ -5080,7 +5216,7 @@
             <a:r>
               <a:rPr lang="en-US" sz="1400" dirty="0">
                 <a:solidFill>
-                  <a:srgbClr val="6B7280"/>
+                  <a:srgbClr val="626B7F"/>
                 </a:solidFill>
                 <a:latin typeface="Times New Roman" pitchFamily="34" charset="0"/>
                 <a:ea typeface="Times New Roman" pitchFamily="34" charset="-122"/>
@@ -5105,18 +5241,25 @@
           </a:xfrm>
           <a:prstGeom prst="roundRect">
             <a:avLst>
-              <a:gd name="adj" fmla="val 6316"/>
+              <a:gd name="adj" fmla="val 7368"/>
             </a:avLst>
           </a:prstGeom>
           <a:solidFill>
-            <a:srgbClr val="F3F4F6"/>
+            <a:srgbClr val="E4EEDF"/>
           </a:solidFill>
           <a:ln w="12700">
             <a:solidFill>
-              <a:srgbClr val="F3F4F6"/>
+              <a:srgbClr val="E7DCCB"/>
             </a:solidFill>
             <a:prstDash val="solid"/>
           </a:ln>
+          <a:effectLst>
+            <a:outerShdw sx="100000" sy="100000" kx="0" ky="0" algn="bl" rotWithShape="0" blurRad="76200" dist="25400" dir="5400000">
+              <a:srgbClr val="BFB3A0">
+                <a:alpha val="25000"/>
+              </a:srgbClr>
+            </a:outerShdw>
+          </a:effectLst>
         </p:spPr>
       </p:sp>
       <p:sp>
@@ -5134,11 +5277,11 @@
             <a:avLst/>
           </a:prstGeom>
           <a:solidFill>
-            <a:srgbClr val="2B2F36"/>
+            <a:srgbClr val="5E8C61"/>
           </a:solidFill>
           <a:ln w="12700">
             <a:solidFill>
-              <a:srgbClr val="2B2F36"/>
+              <a:srgbClr val="5E8C61"/>
             </a:solidFill>
             <a:prstDash val="solid"/>
           </a:ln>
@@ -5210,7 +5353,7 @@
             <a:r>
               <a:rPr lang="en-US" sz="1700" b="1" dirty="0">
                 <a:solidFill>
-                  <a:srgbClr val="2B2F36"/>
+                  <a:srgbClr val="1E2A44"/>
                 </a:solidFill>
                 <a:latin typeface="Times New Roman" pitchFamily="34" charset="0"/>
                 <a:ea typeface="Times New Roman" pitchFamily="34" charset="-122"/>
@@ -5249,7 +5392,7 @@
             <a:r>
               <a:rPr lang="en-US" sz="1400" dirty="0">
                 <a:solidFill>
-                  <a:srgbClr val="6B7280"/>
+                  <a:srgbClr val="626B7F"/>
                 </a:solidFill>
                 <a:latin typeface="Times New Roman" pitchFamily="34" charset="0"/>
                 <a:ea typeface="Times New Roman" pitchFamily="34" charset="-122"/>
@@ -5274,18 +5417,25 @@
           </a:xfrm>
           <a:prstGeom prst="roundRect">
             <a:avLst>
-              <a:gd name="adj" fmla="val 6316"/>
+              <a:gd name="adj" fmla="val 7368"/>
             </a:avLst>
           </a:prstGeom>
           <a:solidFill>
-            <a:srgbClr val="F3F4F6"/>
+            <a:srgbClr val="E8E3F2"/>
           </a:solidFill>
           <a:ln w="12700">
             <a:solidFill>
-              <a:srgbClr val="F3F4F6"/>
+              <a:srgbClr val="E7DCCB"/>
             </a:solidFill>
             <a:prstDash val="solid"/>
           </a:ln>
+          <a:effectLst>
+            <a:outerShdw sx="100000" sy="100000" kx="0" ky="0" algn="bl" rotWithShape="0" blurRad="76200" dist="25400" dir="5400000">
+              <a:srgbClr val="BFB3A0">
+                <a:alpha val="25000"/>
+              </a:srgbClr>
+            </a:outerShdw>
+          </a:effectLst>
         </p:spPr>
       </p:sp>
       <p:sp>
@@ -5303,11 +5453,11 @@
             <a:avLst/>
           </a:prstGeom>
           <a:solidFill>
-            <a:srgbClr val="2B2F36"/>
+            <a:srgbClr val="6A5A9C"/>
           </a:solidFill>
           <a:ln w="12700">
             <a:solidFill>
-              <a:srgbClr val="2B2F36"/>
+              <a:srgbClr val="6A5A9C"/>
             </a:solidFill>
             <a:prstDash val="solid"/>
           </a:ln>
@@ -5379,7 +5529,7 @@
             <a:r>
               <a:rPr lang="en-US" sz="1700" b="1" dirty="0">
                 <a:solidFill>
-                  <a:srgbClr val="2B2F36"/>
+                  <a:srgbClr val="1E2A44"/>
                 </a:solidFill>
                 <a:latin typeface="Times New Roman" pitchFamily="34" charset="0"/>
                 <a:ea typeface="Times New Roman" pitchFamily="34" charset="-122"/>
@@ -5418,7 +5568,7 @@
             <a:r>
               <a:rPr lang="en-US" sz="1400" dirty="0">
                 <a:solidFill>
-                  <a:srgbClr val="6B7280"/>
+                  <a:srgbClr val="626B7F"/>
                 </a:solidFill>
                 <a:latin typeface="Times New Roman" pitchFamily="34" charset="0"/>
                 <a:ea typeface="Times New Roman" pitchFamily="34" charset="-122"/>
@@ -5447,11 +5597,11 @@
             </a:avLst>
           </a:prstGeom>
           <a:solidFill>
-            <a:srgbClr val="FFFFFF"/>
+            <a:srgbClr val="FFFBF4"/>
           </a:solidFill>
           <a:ln w="12700">
             <a:solidFill>
-              <a:srgbClr val="D1D5DB"/>
+              <a:srgbClr val="E7DCCB"/>
             </a:solidFill>
             <a:prstDash val="solid"/>
           </a:ln>
@@ -5484,7 +5634,7 @@
             <a:r>
               <a:rPr lang="en-US" sz="1600" b="1" dirty="0">
                 <a:solidFill>
-                  <a:srgbClr val="2B2F36"/>
+                  <a:srgbClr val="1E2A44"/>
                 </a:solidFill>
                 <a:latin typeface="Times New Roman" pitchFamily="34" charset="0"/>
                 <a:ea typeface="Times New Roman" pitchFamily="34" charset="-122"/>
@@ -5523,7 +5673,7 @@
             <a:r>
               <a:rPr lang="en-US" sz="1400" dirty="0">
                 <a:solidFill>
-                  <a:srgbClr val="6B7280"/>
+                  <a:srgbClr val="626B7F"/>
                 </a:solidFill>
                 <a:latin typeface="Times New Roman" pitchFamily="34" charset="0"/>
                 <a:ea typeface="Times New Roman" pitchFamily="34" charset="-122"/>
@@ -5552,11 +5702,11 @@
             </a:avLst>
           </a:prstGeom>
           <a:solidFill>
-            <a:srgbClr val="FFFFFF"/>
+            <a:srgbClr val="FFFBF4"/>
           </a:solidFill>
           <a:ln w="12700">
             <a:solidFill>
-              <a:srgbClr val="D1D5DB"/>
+              <a:srgbClr val="E7DCCB"/>
             </a:solidFill>
             <a:prstDash val="solid"/>
           </a:ln>
@@ -5589,7 +5739,7 @@
             <a:r>
               <a:rPr lang="en-US" sz="1600" b="1" dirty="0">
                 <a:solidFill>
-                  <a:srgbClr val="2B2F36"/>
+                  <a:srgbClr val="1E2A44"/>
                 </a:solidFill>
                 <a:latin typeface="Times New Roman" pitchFamily="34" charset="0"/>
                 <a:ea typeface="Times New Roman" pitchFamily="34" charset="-122"/>
@@ -5628,7 +5778,7 @@
             <a:r>
               <a:rPr lang="en-US" sz="1400" dirty="0">
                 <a:solidFill>
-                  <a:srgbClr val="6B7280"/>
+                  <a:srgbClr val="626B7F"/>
                 </a:solidFill>
                 <a:latin typeface="Times New Roman" pitchFamily="34" charset="0"/>
                 <a:ea typeface="Times New Roman" pitchFamily="34" charset="-122"/>
@@ -5657,11 +5807,11 @@
             </a:avLst>
           </a:prstGeom>
           <a:solidFill>
-            <a:srgbClr val="FFFFFF"/>
+            <a:srgbClr val="FFFBF4"/>
           </a:solidFill>
-          <a:ln w="12700">
+          <a:ln w="25400">
             <a:solidFill>
-              <a:srgbClr val="D1D5DB"/>
+              <a:srgbClr val="1F6F8B"/>
             </a:solidFill>
             <a:prstDash val="solid"/>
           </a:ln>
@@ -5694,7 +5844,7 @@
             <a:r>
               <a:rPr lang="en-US" sz="1600" b="1" dirty="0">
                 <a:solidFill>
-                  <a:srgbClr val="2B2F36"/>
+                  <a:srgbClr val="1E2A44"/>
                 </a:solidFill>
                 <a:latin typeface="Times New Roman" pitchFamily="34" charset="0"/>
                 <a:ea typeface="Times New Roman" pitchFamily="34" charset="-122"/>
@@ -5733,7 +5883,7 @@
             <a:r>
               <a:rPr lang="en-US" sz="1400" dirty="0">
                 <a:solidFill>
-                  <a:srgbClr val="6B7280"/>
+                  <a:srgbClr val="626B7F"/>
                 </a:solidFill>
                 <a:latin typeface="Times New Roman" pitchFamily="34" charset="0"/>
                 <a:ea typeface="Times New Roman" pitchFamily="34" charset="-122"/>
@@ -5762,11 +5912,11 @@
             </a:avLst>
           </a:prstGeom>
           <a:solidFill>
-            <a:srgbClr val="FFFFFF"/>
+            <a:srgbClr val="FFFBF4"/>
           </a:solidFill>
           <a:ln w="12700">
             <a:solidFill>
-              <a:srgbClr val="D1D5DB"/>
+              <a:srgbClr val="E7DCCB"/>
             </a:solidFill>
             <a:prstDash val="solid"/>
           </a:ln>
@@ -5799,7 +5949,7 @@
             <a:r>
               <a:rPr lang="en-US" sz="1600" b="1" dirty="0">
                 <a:solidFill>
-                  <a:srgbClr val="2B2F36"/>
+                  <a:srgbClr val="1E2A44"/>
                 </a:solidFill>
                 <a:latin typeface="Times New Roman" pitchFamily="34" charset="0"/>
                 <a:ea typeface="Times New Roman" pitchFamily="34" charset="-122"/>
@@ -5838,7 +5988,7 @@
             <a:r>
               <a:rPr lang="en-US" sz="1400" dirty="0">
                 <a:solidFill>
-                  <a:srgbClr val="6B7280"/>
+                  <a:srgbClr val="626B7F"/>
                 </a:solidFill>
                 <a:latin typeface="Times New Roman" pitchFamily="34" charset="0"/>
                 <a:ea typeface="Times New Roman" pitchFamily="34" charset="-122"/>
@@ -5867,11 +6017,11 @@
             </a:avLst>
           </a:prstGeom>
           <a:solidFill>
-            <a:srgbClr val="FFFFFF"/>
+            <a:srgbClr val="FFFBF4"/>
           </a:solidFill>
           <a:ln w="12700">
             <a:solidFill>
-              <a:srgbClr val="D1D5DB"/>
+              <a:srgbClr val="E7DCCB"/>
             </a:solidFill>
             <a:prstDash val="solid"/>
           </a:ln>
@@ -5904,7 +6054,7 @@
             <a:r>
               <a:rPr lang="en-US" sz="1600" b="1" dirty="0">
                 <a:solidFill>
-                  <a:srgbClr val="2B2F36"/>
+                  <a:srgbClr val="1E2A44"/>
                 </a:solidFill>
                 <a:latin typeface="Times New Roman" pitchFamily="34" charset="0"/>
                 <a:ea typeface="Times New Roman" pitchFamily="34" charset="-122"/>
@@ -5943,7 +6093,7 @@
             <a:r>
               <a:rPr lang="en-US" sz="1400" dirty="0">
                 <a:solidFill>
-                  <a:srgbClr val="6B7280"/>
+                  <a:srgbClr val="626B7F"/>
                 </a:solidFill>
                 <a:latin typeface="Times New Roman" pitchFamily="34" charset="0"/>
                 <a:ea typeface="Times New Roman" pitchFamily="34" charset="-122"/>
@@ -5972,11 +6122,11 @@
             </a:avLst>
           </a:prstGeom>
           <a:solidFill>
-            <a:srgbClr val="FFFFFF"/>
+            <a:srgbClr val="FFFBF4"/>
           </a:solidFill>
           <a:ln w="12700">
             <a:solidFill>
-              <a:srgbClr val="D1D5DB"/>
+              <a:srgbClr val="E7DCCB"/>
             </a:solidFill>
             <a:prstDash val="solid"/>
           </a:ln>
@@ -6009,7 +6159,7 @@
             <a:r>
               <a:rPr lang="en-US" sz="1600" b="1" dirty="0">
                 <a:solidFill>
-                  <a:srgbClr val="2B2F36"/>
+                  <a:srgbClr val="1E2A44"/>
                 </a:solidFill>
                 <a:latin typeface="Times New Roman" pitchFamily="34" charset="0"/>
                 <a:ea typeface="Times New Roman" pitchFamily="34" charset="-122"/>
@@ -6048,7 +6198,7 @@
             <a:r>
               <a:rPr lang="en-US" sz="1400" dirty="0">
                 <a:solidFill>
-                  <a:srgbClr val="6B7280"/>
+                  <a:srgbClr val="626B7F"/>
                 </a:solidFill>
                 <a:latin typeface="Times New Roman" pitchFamily="34" charset="0"/>
                 <a:ea typeface="Times New Roman" pitchFamily="34" charset="-122"/>
@@ -6077,11 +6227,11 @@
             </a:avLst>
           </a:prstGeom>
           <a:solidFill>
-            <a:srgbClr val="FFFFFF"/>
+            <a:srgbClr val="FFFBF4"/>
           </a:solidFill>
           <a:ln w="12700">
             <a:solidFill>
-              <a:srgbClr val="D1D5DB"/>
+              <a:srgbClr val="E7DCCB"/>
             </a:solidFill>
             <a:prstDash val="solid"/>
           </a:ln>
@@ -6114,7 +6264,7 @@
             <a:r>
               <a:rPr lang="en-US" sz="1600" b="1" dirty="0">
                 <a:solidFill>
-                  <a:srgbClr val="2B2F36"/>
+                  <a:srgbClr val="1E2A44"/>
                 </a:solidFill>
                 <a:latin typeface="Times New Roman" pitchFamily="34" charset="0"/>
                 <a:ea typeface="Times New Roman" pitchFamily="34" charset="-122"/>
@@ -6153,7 +6303,7 @@
             <a:r>
               <a:rPr lang="en-US" sz="1400" dirty="0">
                 <a:solidFill>
-                  <a:srgbClr val="6B7280"/>
+                  <a:srgbClr val="626B7F"/>
                 </a:solidFill>
                 <a:latin typeface="Times New Roman" pitchFamily="34" charset="0"/>
                 <a:ea typeface="Times New Roman" pitchFamily="34" charset="-122"/>
@@ -6182,11 +6332,11 @@
             </a:avLst>
           </a:prstGeom>
           <a:solidFill>
-            <a:srgbClr val="FFFFFF"/>
+            <a:srgbClr val="FFFBF4"/>
           </a:solidFill>
           <a:ln w="12700">
             <a:solidFill>
-              <a:srgbClr val="D1D5DB"/>
+              <a:srgbClr val="E7DCCB"/>
             </a:solidFill>
             <a:prstDash val="solid"/>
           </a:ln>
@@ -6219,7 +6369,7 @@
             <a:r>
               <a:rPr lang="en-US" sz="1600" b="1" dirty="0">
                 <a:solidFill>
-                  <a:srgbClr val="2B2F36"/>
+                  <a:srgbClr val="1E2A44"/>
                 </a:solidFill>
                 <a:latin typeface="Times New Roman" pitchFamily="34" charset="0"/>
                 <a:ea typeface="Times New Roman" pitchFamily="34" charset="-122"/>
@@ -6258,7 +6408,7 @@
             <a:r>
               <a:rPr lang="en-US" sz="1400" dirty="0">
                 <a:solidFill>
-                  <a:srgbClr val="6B7280"/>
+                  <a:srgbClr val="626B7F"/>
                 </a:solidFill>
                 <a:latin typeface="Times New Roman" pitchFamily="34" charset="0"/>
                 <a:ea typeface="Times New Roman" pitchFamily="34" charset="-122"/>
@@ -6300,7 +6450,7 @@
             <a:lvl1pPr>
               <a:defRPr sz="1000">
                 <a:solidFill>
-                  <a:srgbClr val="6B7280"/>
+                  <a:srgbClr val="626B7F"/>
                 </a:solidFill>
                 <a:latin typeface="Times New Roman"/>
                 <a:ea typeface="Times New Roman"/>
@@ -6345,10 +6495,10 @@
       </p:grpSpPr>
       <p:sp>
         <p:nvSpPr>
-          <p:cNvPr id="2" name="Text 1"/>
+          <p:cNvPr id="2" name="Text 3"/>
           <p:cNvSpPr/>
           <p:nvPr>
-            <p:ph idx="101" type="title" hasCustomPrompt="1"/>
+            <p:ph idx="103" type="title" hasCustomPrompt="1"/>
           </p:nvPr>
         </p:nvSpPr>
         <p:spPr>
@@ -6372,7 +6522,7 @@
             <a:r>
               <a:rPr lang="en-US" sz="3000" b="1" dirty="0">
                 <a:solidFill>
-                  <a:srgbClr val="2B2F36"/>
+                  <a:srgbClr val="1E2A44"/>
                 </a:solidFill>
                 <a:latin typeface="Times New Roman" pitchFamily="34" charset="0"/>
                 <a:ea typeface="Times New Roman" pitchFamily="34" charset="-122"/>
@@ -6413,18 +6563,25 @@
           </a:xfrm>
           <a:prstGeom prst="roundRect">
             <a:avLst>
-              <a:gd name="adj" fmla="val 5217"/>
+              <a:gd name="adj" fmla="val 6087"/>
             </a:avLst>
           </a:prstGeom>
           <a:solidFill>
-            <a:srgbClr val="F3F4F6"/>
+            <a:srgbClr val="FFFBF4"/>
           </a:solidFill>
           <a:ln w="12700">
             <a:solidFill>
-              <a:srgbClr val="F3F4F6"/>
+              <a:srgbClr val="E7DCCB"/>
             </a:solidFill>
             <a:prstDash val="solid"/>
           </a:ln>
+          <a:effectLst>
+            <a:outerShdw sx="100000" sy="100000" kx="0" ky="0" algn="bl" rotWithShape="0" blurRad="76200" dist="25400" dir="5400000">
+              <a:srgbClr val="BFB3A0">
+                <a:alpha val="25000"/>
+              </a:srgbClr>
+            </a:outerShdw>
+          </a:effectLst>
         </p:spPr>
       </p:sp>
       <p:sp>
@@ -6454,7 +6611,7 @@
             <a:r>
               <a:rPr lang="en-US" sz="4000" b="1" dirty="0">
                 <a:solidFill>
-                  <a:srgbClr val="1F5FBF"/>
+                  <a:srgbClr val="1F6F8B"/>
                 </a:solidFill>
                 <a:latin typeface="Times New Roman" pitchFamily="34" charset="0"/>
                 <a:ea typeface="Times New Roman" pitchFamily="34" charset="-122"/>
@@ -6493,7 +6650,7 @@
             <a:r>
               <a:rPr lang="en-US" sz="1500" dirty="0">
                 <a:solidFill>
-                  <a:srgbClr val="2B2F36"/>
+                  <a:srgbClr val="2F3B55"/>
                 </a:solidFill>
                 <a:latin typeface="Times New Roman" pitchFamily="34" charset="0"/>
                 <a:ea typeface="Times New Roman" pitchFamily="34" charset="-122"/>
@@ -6518,18 +6675,25 @@
           </a:xfrm>
           <a:prstGeom prst="roundRect">
             <a:avLst>
-              <a:gd name="adj" fmla="val 4706"/>
+              <a:gd name="adj" fmla="val 5490"/>
             </a:avLst>
           </a:prstGeom>
           <a:solidFill>
-            <a:srgbClr val="F3F4F6"/>
+            <a:srgbClr val="FFFBF4"/>
           </a:solidFill>
           <a:ln w="12700">
             <a:solidFill>
-              <a:srgbClr val="F3F4F6"/>
+              <a:srgbClr val="E7DCCB"/>
             </a:solidFill>
             <a:prstDash val="solid"/>
           </a:ln>
+          <a:effectLst>
+            <a:outerShdw sx="100000" sy="100000" kx="0" ky="0" algn="bl" rotWithShape="0" blurRad="76200" dist="25400" dir="5400000">
+              <a:srgbClr val="BFB3A0">
+                <a:alpha val="25000"/>
+              </a:srgbClr>
+            </a:outerShdw>
+          </a:effectLst>
         </p:spPr>
       </p:sp>
       <p:sp>
@@ -6559,7 +6723,7 @@
             <a:r>
               <a:rPr lang="en-US" sz="1800" b="1" dirty="0">
                 <a:solidFill>
-                  <a:srgbClr val="2B2F36"/>
+                  <a:srgbClr val="1E2A44"/>
                 </a:solidFill>
                 <a:latin typeface="Times New Roman" pitchFamily="34" charset="0"/>
                 <a:ea typeface="Times New Roman" pitchFamily="34" charset="-122"/>
@@ -6598,7 +6762,7 @@
             <a:r>
               <a:rPr lang="en-US" sz="1500" dirty="0">
                 <a:solidFill>
-                  <a:srgbClr val="2B2F36"/>
+                  <a:srgbClr val="2F3B55"/>
                 </a:solidFill>
                 <a:latin typeface="Times New Roman" pitchFamily="34" charset="0"/>
                 <a:ea typeface="Times New Roman" pitchFamily="34" charset="-122"/>
@@ -6640,7 +6804,7 @@
             <a:lvl1pPr>
               <a:defRPr sz="1000">
                 <a:solidFill>
-                  <a:srgbClr val="6B7280"/>
+                  <a:srgbClr val="626B7F"/>
                 </a:solidFill>
                 <a:latin typeface="Times New Roman"/>
                 <a:ea typeface="Times New Roman"/>
@@ -6685,10 +6849,10 @@
       </p:grpSpPr>
       <p:sp>
         <p:nvSpPr>
-          <p:cNvPr id="2" name="Text 1"/>
+          <p:cNvPr id="2" name="Text 3"/>
           <p:cNvSpPr/>
           <p:nvPr>
-            <p:ph idx="101" type="title" hasCustomPrompt="1"/>
+            <p:ph idx="103" type="title" hasCustomPrompt="1"/>
           </p:nvPr>
         </p:nvSpPr>
         <p:spPr>
@@ -6712,7 +6876,7 @@
             <a:r>
               <a:rPr lang="en-US" sz="3000" b="1" dirty="0">
                 <a:solidFill>
-                  <a:srgbClr val="2B2F36"/>
+                  <a:srgbClr val="1E2A44"/>
                 </a:solidFill>
                 <a:latin typeface="Times New Roman" pitchFamily="34" charset="0"/>
                 <a:ea typeface="Times New Roman" pitchFamily="34" charset="-122"/>
@@ -6723,10 +6887,44 @@
             <a:endParaRPr lang="en-US" sz="3000" dirty="0"/>
           </a:p>
         </p:txBody>
+      </p:sp>
+      <p:sp>
+        <p:nvSpPr>
+          <p:cNvPr id="3" name="Shape 1"/>
+          <p:cNvSpPr/>
+          <p:nvPr/>
+        </p:nvSpPr>
+        <p:spPr>
+          <a:xfrm>
+            <a:off x="457200" y="1280160"/>
+            <a:ext cx="7863840" cy="2944368"/>
+          </a:xfrm>
+          <a:prstGeom prst="roundRect">
+            <a:avLst>
+              <a:gd name="adj" fmla="val 4348"/>
+            </a:avLst>
+          </a:prstGeom>
+          <a:solidFill>
+            <a:srgbClr val="FFFFFF"/>
+          </a:solidFill>
+          <a:ln w="12700">
+            <a:solidFill>
+              <a:srgbClr val="E7DCCB"/>
+            </a:solidFill>
+            <a:prstDash val="solid"/>
+          </a:ln>
+          <a:effectLst>
+            <a:outerShdw sx="100000" sy="100000" kx="0" ky="0" algn="bl" rotWithShape="0" blurRad="76200" dist="25400" dir="5400000">
+              <a:srgbClr val="BFB3A0">
+                <a:alpha val="25000"/>
+              </a:srgbClr>
+            </a:outerShdw>
+          </a:effectLst>
+        </p:spPr>
       </p:sp>
       <p:pic>
         <p:nvPicPr>
-          <p:cNvPr id="3" name="Image 0" descr="/home/user/AI-Collusion-Research-Sprint/Apart Research/figures/fig_trajectories.png">    </p:cNvPr>
+          <p:cNvPr id="4" name="Image 0" descr="/home/user/AI-Collusion-Research-Sprint/Apart Research/figures/fig_trajectories.png">    </p:cNvPr>
           <p:cNvPicPr>
             <a:picLocks noChangeAspect="1"/>
           </p:cNvPicPr>
@@ -6750,7 +6948,7 @@
       </p:pic>
       <p:sp>
         <p:nvSpPr>
-          <p:cNvPr id="4" name="Text 1"/>
+          <p:cNvPr id="5" name="Text 2"/>
           <p:cNvSpPr txBox="1"/>
           <p:nvPr/>
         </p:nvSpPr>
@@ -6775,7 +6973,7 @@
             <a:r>
               <a:rPr lang="en-US" sz="1300" dirty="0">
                 <a:solidFill>
-                  <a:srgbClr val="6B7280"/>
+                  <a:srgbClr val="626B7F"/>
                 </a:solidFill>
                 <a:latin typeface="Times New Roman" pitchFamily="34" charset="0"/>
                 <a:ea typeface="Times New Roman" pitchFamily="34" charset="-122"/>
@@ -6789,7 +6987,7 @@
       </p:sp>
       <p:sp>
         <p:nvSpPr>
-          <p:cNvPr id="5" name="Shape 2"/>
+          <p:cNvPr id="6" name="Shape 3"/>
           <p:cNvSpPr/>
           <p:nvPr/>
         </p:nvSpPr>
@@ -6800,23 +6998,30 @@
           </a:xfrm>
           <a:prstGeom prst="roundRect">
             <a:avLst>
-              <a:gd name="adj" fmla="val 3636"/>
+              <a:gd name="adj" fmla="val 4242"/>
             </a:avLst>
           </a:prstGeom>
           <a:solidFill>
-            <a:srgbClr val="F3F4F6"/>
+            <a:srgbClr val="FFFBF4"/>
           </a:solidFill>
           <a:ln w="12700">
             <a:solidFill>
-              <a:srgbClr val="F3F4F6"/>
+              <a:srgbClr val="E7DCCB"/>
             </a:solidFill>
             <a:prstDash val="solid"/>
           </a:ln>
-        </p:spPr>
-      </p:sp>
-      <p:sp>
-        <p:nvSpPr>
-          <p:cNvPr id="6" name="Text 3"/>
+          <a:effectLst>
+            <a:outerShdw sx="100000" sy="100000" kx="0" ky="0" algn="bl" rotWithShape="0" blurRad="76200" dist="25400" dir="5400000">
+              <a:srgbClr val="BFB3A0">
+                <a:alpha val="25000"/>
+              </a:srgbClr>
+            </a:outerShdw>
+          </a:effectLst>
+        </p:spPr>
+      </p:sp>
+      <p:sp>
+        <p:nvSpPr>
+          <p:cNvPr id="7" name="Text 4"/>
           <p:cNvSpPr txBox="1"/>
           <p:nvPr/>
         </p:nvSpPr>
@@ -6841,7 +7046,7 @@
             <a:r>
               <a:rPr lang="en-US" sz="4000" b="1" dirty="0">
                 <a:solidFill>
-                  <a:srgbClr val="1F5FBF"/>
+                  <a:srgbClr val="1F6F8B"/>
                 </a:solidFill>
                 <a:latin typeface="Times New Roman" pitchFamily="34" charset="0"/>
                 <a:ea typeface="Times New Roman" pitchFamily="34" charset="-122"/>
@@ -6855,7 +7060,7 @@
       </p:sp>
       <p:sp>
         <p:nvSpPr>
-          <p:cNvPr id="7" name="Text 4"/>
+          <p:cNvPr id="8" name="Text 5"/>
           <p:cNvSpPr txBox="1"/>
           <p:nvPr/>
         </p:nvSpPr>
@@ -6880,7 +7085,7 @@
             <a:r>
               <a:rPr lang="en-US" sz="1500" dirty="0">
                 <a:solidFill>
-                  <a:srgbClr val="2B2F36"/>
+                  <a:srgbClr val="2F3B55"/>
                 </a:solidFill>
                 <a:latin typeface="Times New Roman" pitchFamily="34" charset="0"/>
                 <a:ea typeface="Times New Roman" pitchFamily="34" charset="-122"/>
@@ -6894,7 +7099,7 @@
       </p:sp>
       <p:sp>
         <p:nvSpPr>
-          <p:cNvPr id="8" name="Text 5"/>
+          <p:cNvPr id="9" name="Text 6"/>
           <p:cNvSpPr txBox="1"/>
           <p:nvPr/>
         </p:nvSpPr>
@@ -6919,7 +7124,7 @@
             <a:r>
               <a:rPr lang="en-US" sz="1500" dirty="0">
                 <a:solidFill>
-                  <a:srgbClr val="2B2F36"/>
+                  <a:srgbClr val="2F3B55"/>
                 </a:solidFill>
                 <a:latin typeface="Times New Roman" pitchFamily="34" charset="0"/>
                 <a:ea typeface="Times New Roman" pitchFamily="34" charset="-122"/>
@@ -6933,7 +7138,7 @@
       </p:sp>
       <p:sp>
         <p:nvSpPr>
-          <p:cNvPr id="9" name="Text 6"/>
+          <p:cNvPr id="10" name="Text 7"/>
           <p:cNvSpPr txBox="1"/>
           <p:nvPr/>
         </p:nvSpPr>
@@ -6958,7 +7163,7 @@
             <a:r>
               <a:rPr lang="en-US" sz="1600" b="1" dirty="0">
                 <a:solidFill>
-                  <a:srgbClr val="2B2F36"/>
+                  <a:srgbClr val="2F3B55"/>
                 </a:solidFill>
                 <a:latin typeface="Times New Roman" pitchFamily="34" charset="0"/>
                 <a:ea typeface="Times New Roman" pitchFamily="34" charset="-122"/>
@@ -7000,7 +7205,7 @@
             <a:lvl1pPr>
               <a:defRPr sz="1000">
                 <a:solidFill>
-                  <a:srgbClr val="6B7280"/>
+                  <a:srgbClr val="626B7F"/>
                 </a:solidFill>
                 <a:latin typeface="Times New Roman"/>
                 <a:ea typeface="Times New Roman"/>
@@ -7045,10 +7250,10 @@
       </p:grpSpPr>
       <p:sp>
         <p:nvSpPr>
-          <p:cNvPr id="2" name="Text 1"/>
+          <p:cNvPr id="2" name="Text 3"/>
           <p:cNvSpPr/>
           <p:nvPr>
-            <p:ph idx="101" type="title" hasCustomPrompt="1"/>
+            <p:ph idx="103" type="title" hasCustomPrompt="1"/>
           </p:nvPr>
         </p:nvSpPr>
         <p:spPr>
@@ -7072,7 +7277,7 @@
             <a:r>
               <a:rPr lang="en-US" sz="3000" b="1" dirty="0">
                 <a:solidFill>
-                  <a:srgbClr val="2B2F36"/>
+                  <a:srgbClr val="1E2A44"/>
                 </a:solidFill>
                 <a:latin typeface="Times New Roman" pitchFamily="34" charset="0"/>
                 <a:ea typeface="Times New Roman" pitchFamily="34" charset="-122"/>
@@ -7097,18 +7302,25 @@
           </a:xfrm>
           <a:prstGeom prst="roundRect">
             <a:avLst>
-              <a:gd name="adj" fmla="val 2609"/>
+              <a:gd name="adj" fmla="val 3043"/>
             </a:avLst>
           </a:prstGeom>
           <a:solidFill>
-            <a:srgbClr val="F3F4F6"/>
+            <a:srgbClr val="DCEBF0"/>
           </a:solidFill>
           <a:ln w="12700">
             <a:solidFill>
-              <a:srgbClr val="F3F4F6"/>
+              <a:srgbClr val="E7DCCB"/>
             </a:solidFill>
             <a:prstDash val="solid"/>
           </a:ln>
+          <a:effectLst>
+            <a:outerShdw sx="100000" sy="100000" kx="0" ky="0" algn="bl" rotWithShape="0" blurRad="76200" dist="25400" dir="5400000">
+              <a:srgbClr val="BFB3A0">
+                <a:alpha val="25000"/>
+              </a:srgbClr>
+            </a:outerShdw>
+          </a:effectLst>
         </p:spPr>
       </p:sp>
       <p:sp>
@@ -7138,7 +7350,7 @@
             <a:r>
               <a:rPr lang="en-US" sz="2200" b="1" dirty="0">
                 <a:solidFill>
-                  <a:srgbClr val="2B2F36"/>
+                  <a:srgbClr val="1E2A44"/>
                 </a:solidFill>
                 <a:latin typeface="Times New Roman" pitchFamily="34" charset="0"/>
                 <a:ea typeface="Times New Roman" pitchFamily="34" charset="-122"/>
@@ -7177,7 +7389,7 @@
             <a:r>
               <a:rPr lang="en-US" sz="4400" b="1" dirty="0">
                 <a:solidFill>
-                  <a:srgbClr val="2B2F36"/>
+                  <a:srgbClr val="1F6F8B"/>
                 </a:solidFill>
                 <a:latin typeface="Times New Roman" pitchFamily="34" charset="0"/>
                 <a:ea typeface="Times New Roman" pitchFamily="34" charset="-122"/>
@@ -7216,7 +7428,7 @@
             <a:r>
               <a:rPr lang="en-US" sz="1500" dirty="0">
                 <a:solidFill>
-                  <a:srgbClr val="6B7280"/>
+                  <a:srgbClr val="626B7F"/>
                 </a:solidFill>
                 <a:latin typeface="Times New Roman" pitchFamily="34" charset="0"/>
                 <a:ea typeface="Times New Roman" pitchFamily="34" charset="-122"/>
@@ -7255,7 +7467,7 @@
             <a:r>
               <a:rPr lang="en-US" sz="1600" dirty="0">
                 <a:solidFill>
-                  <a:srgbClr val="2B2F36"/>
+                  <a:srgbClr val="2F3B55"/>
                 </a:solidFill>
                 <a:latin typeface="Times New Roman" pitchFamily="34" charset="0"/>
                 <a:ea typeface="Times New Roman" pitchFamily="34" charset="-122"/>
@@ -7280,18 +7492,25 @@
           </a:xfrm>
           <a:prstGeom prst="roundRect">
             <a:avLst>
-              <a:gd name="adj" fmla="val 2609"/>
+              <a:gd name="adj" fmla="val 3043"/>
             </a:avLst>
           </a:prstGeom>
           <a:solidFill>
-            <a:srgbClr val="F3F4F6"/>
+            <a:srgbClr val="F8E1D7"/>
           </a:solidFill>
           <a:ln w="12700">
             <a:solidFill>
-              <a:srgbClr val="F3F4F6"/>
+              <a:srgbClr val="E7DCCB"/>
             </a:solidFill>
             <a:prstDash val="solid"/>
           </a:ln>
+          <a:effectLst>
+            <a:outerShdw sx="100000" sy="100000" kx="0" ky="0" algn="bl" rotWithShape="0" blurRad="76200" dist="25400" dir="5400000">
+              <a:srgbClr val="BFB3A0">
+                <a:alpha val="25000"/>
+              </a:srgbClr>
+            </a:outerShdw>
+          </a:effectLst>
         </p:spPr>
       </p:sp>
       <p:sp>
@@ -7321,7 +7540,7 @@
             <a:r>
               <a:rPr lang="en-US" sz="2200" b="1" dirty="0">
                 <a:solidFill>
-                  <a:srgbClr val="2B2F36"/>
+                  <a:srgbClr val="1E2A44"/>
                 </a:solidFill>
                 <a:latin typeface="Times New Roman" pitchFamily="34" charset="0"/>
                 <a:ea typeface="Times New Roman" pitchFamily="34" charset="-122"/>
@@ -7360,7 +7579,7 @@
             <a:r>
               <a:rPr lang="en-US" sz="4400" b="1" dirty="0">
                 <a:solidFill>
-                  <a:srgbClr val="1F5FBF"/>
+                  <a:srgbClr val="C8553D"/>
                 </a:solidFill>
                 <a:latin typeface="Times New Roman" pitchFamily="34" charset="0"/>
                 <a:ea typeface="Times New Roman" pitchFamily="34" charset="-122"/>
@@ -7399,7 +7618,7 @@
             <a:r>
               <a:rPr lang="en-US" sz="1500" dirty="0">
                 <a:solidFill>
-                  <a:srgbClr val="6B7280"/>
+                  <a:srgbClr val="626B7F"/>
                 </a:solidFill>
                 <a:latin typeface="Times New Roman" pitchFamily="34" charset="0"/>
                 <a:ea typeface="Times New Roman" pitchFamily="34" charset="-122"/>
@@ -7438,7 +7657,7 @@
             <a:r>
               <a:rPr lang="en-US" sz="1600" dirty="0">
                 <a:solidFill>
-                  <a:srgbClr val="2B2F36"/>
+                  <a:srgbClr val="2F3B55"/>
                 </a:solidFill>
                 <a:latin typeface="Times New Roman" pitchFamily="34" charset="0"/>
                 <a:ea typeface="Times New Roman" pitchFamily="34" charset="-122"/>
@@ -7477,7 +7696,7 @@
             <a:r>
               <a:rPr lang="en-US" sz="1500" dirty="0">
                 <a:solidFill>
-                  <a:srgbClr val="2B2F36"/>
+                  <a:srgbClr val="2F3B55"/>
                 </a:solidFill>
                 <a:latin typeface="Times New Roman" pitchFamily="34" charset="0"/>
                 <a:ea typeface="Times New Roman" pitchFamily="34" charset="-122"/>
@@ -7519,7 +7738,7 @@
             <a:lvl1pPr>
               <a:defRPr sz="1000">
                 <a:solidFill>
-                  <a:srgbClr val="6B7280"/>
+                  <a:srgbClr val="626B7F"/>
                 </a:solidFill>
                 <a:latin typeface="Times New Roman"/>
                 <a:ea typeface="Times New Roman"/>
@@ -7564,10 +7783,10 @@
       </p:grpSpPr>
       <p:sp>
         <p:nvSpPr>
-          <p:cNvPr id="2" name="Text 1"/>
+          <p:cNvPr id="2" name="Text 3"/>
           <p:cNvSpPr/>
           <p:nvPr>
-            <p:ph idx="101" type="title" hasCustomPrompt="1"/>
+            <p:ph idx="103" type="title" hasCustomPrompt="1"/>
           </p:nvPr>
         </p:nvSpPr>
         <p:spPr>
@@ -7591,7 +7810,7 @@
             <a:r>
               <a:rPr lang="en-US" sz="3000" b="1" dirty="0">
                 <a:solidFill>
-                  <a:srgbClr val="2B2F36"/>
+                  <a:srgbClr val="1E2A44"/>
                 </a:solidFill>
                 <a:latin typeface="Times New Roman" pitchFamily="34" charset="0"/>
                 <a:ea typeface="Times New Roman" pitchFamily="34" charset="-122"/>
@@ -7616,18 +7835,25 @@
           </a:xfrm>
           <a:prstGeom prst="roundRect">
             <a:avLst>
-              <a:gd name="adj" fmla="val 8571"/>
+              <a:gd name="adj" fmla="val 10000"/>
             </a:avLst>
           </a:prstGeom>
           <a:solidFill>
-            <a:srgbClr val="F3F4F6"/>
+            <a:srgbClr val="DCEBF0"/>
           </a:solidFill>
           <a:ln w="12700">
             <a:solidFill>
-              <a:srgbClr val="F3F4F6"/>
+              <a:srgbClr val="E7DCCB"/>
             </a:solidFill>
             <a:prstDash val="solid"/>
           </a:ln>
+          <a:effectLst>
+            <a:outerShdw sx="100000" sy="100000" kx="0" ky="0" algn="bl" rotWithShape="0" blurRad="76200" dist="25400" dir="5400000">
+              <a:srgbClr val="BFB3A0">
+                <a:alpha val="25000"/>
+              </a:srgbClr>
+            </a:outerShdw>
+          </a:effectLst>
         </p:spPr>
       </p:sp>
       <p:sp>
@@ -7645,11 +7871,11 @@
             <a:avLst/>
           </a:prstGeom>
           <a:solidFill>
-            <a:srgbClr val="2B2F36"/>
+            <a:srgbClr val="1F6F8B"/>
           </a:solidFill>
           <a:ln w="12700">
             <a:solidFill>
-              <a:srgbClr val="2B2F36"/>
+              <a:srgbClr val="1F6F8B"/>
             </a:solidFill>
             <a:prstDash val="solid"/>
           </a:ln>
@@ -7721,7 +7947,7 @@
             <a:r>
               <a:rPr lang="en-US" sz="1800" b="1" dirty="0">
                 <a:solidFill>
-                  <a:srgbClr val="2B2F36"/>
+                  <a:srgbClr val="1E2A44"/>
                 </a:solidFill>
                 <a:latin typeface="Times New Roman" pitchFamily="34" charset="0"/>
                 <a:ea typeface="Times New Roman" pitchFamily="34" charset="-122"/>
@@ -7760,7 +7986,7 @@
             <a:r>
               <a:rPr lang="en-US" sz="1400" dirty="0">
                 <a:solidFill>
-                  <a:srgbClr val="6B7280"/>
+                  <a:srgbClr val="626B7F"/>
                 </a:solidFill>
                 <a:latin typeface="Times New Roman" pitchFamily="34" charset="0"/>
                 <a:ea typeface="Times New Roman" pitchFamily="34" charset="-122"/>
@@ -7785,18 +8011,25 @@
           </a:xfrm>
           <a:prstGeom prst="roundRect">
             <a:avLst>
-              <a:gd name="adj" fmla="val 8571"/>
+              <a:gd name="adj" fmla="val 10000"/>
             </a:avLst>
           </a:prstGeom>
           <a:solidFill>
-            <a:srgbClr val="F3F4F6"/>
+            <a:srgbClr val="F8E1D7"/>
           </a:solidFill>
           <a:ln w="12700">
             <a:solidFill>
-              <a:srgbClr val="F3F4F6"/>
+              <a:srgbClr val="E7DCCB"/>
             </a:solidFill>
             <a:prstDash val="solid"/>
           </a:ln>
+          <a:effectLst>
+            <a:outerShdw sx="100000" sy="100000" kx="0" ky="0" algn="bl" rotWithShape="0" blurRad="76200" dist="25400" dir="5400000">
+              <a:srgbClr val="BFB3A0">
+                <a:alpha val="25000"/>
+              </a:srgbClr>
+            </a:outerShdw>
+          </a:effectLst>
         </p:spPr>
       </p:sp>
       <p:sp>
@@ -7814,11 +8047,11 @@
             <a:avLst/>
           </a:prstGeom>
           <a:solidFill>
-            <a:srgbClr val="2B2F36"/>
+            <a:srgbClr val="C8553D"/>
           </a:solidFill>
           <a:ln w="12700">
             <a:solidFill>
-              <a:srgbClr val="2B2F36"/>
+              <a:srgbClr val="C8553D"/>
             </a:solidFill>
             <a:prstDash val="solid"/>
           </a:ln>
@@ -7890,7 +8123,7 @@
             <a:r>
               <a:rPr lang="en-US" sz="1800" b="1" dirty="0">
                 <a:solidFill>
-                  <a:srgbClr val="2B2F36"/>
+                  <a:srgbClr val="1E2A44"/>
                 </a:solidFill>
                 <a:latin typeface="Times New Roman" pitchFamily="34" charset="0"/>
                 <a:ea typeface="Times New Roman" pitchFamily="34" charset="-122"/>
@@ -7929,7 +8162,7 @@
             <a:r>
               <a:rPr lang="en-US" sz="1400" dirty="0">
                 <a:solidFill>
-                  <a:srgbClr val="6B7280"/>
+                  <a:srgbClr val="626B7F"/>
                 </a:solidFill>
                 <a:latin typeface="Times New Roman" pitchFamily="34" charset="0"/>
                 <a:ea typeface="Times New Roman" pitchFamily="34" charset="-122"/>
@@ -7954,18 +8187,25 @@
           </a:xfrm>
           <a:prstGeom prst="roundRect">
             <a:avLst>
-              <a:gd name="adj" fmla="val 8571"/>
+              <a:gd name="adj" fmla="val 10000"/>
             </a:avLst>
           </a:prstGeom>
           <a:solidFill>
-            <a:srgbClr val="F3F4F6"/>
+            <a:srgbClr val="E4EEDF"/>
           </a:solidFill>
           <a:ln w="12700">
             <a:solidFill>
-              <a:srgbClr val="F3F4F6"/>
+              <a:srgbClr val="E7DCCB"/>
             </a:solidFill>
             <a:prstDash val="solid"/>
           </a:ln>
+          <a:effectLst>
+            <a:outerShdw sx="100000" sy="100000" kx="0" ky="0" algn="bl" rotWithShape="0" blurRad="76200" dist="25400" dir="5400000">
+              <a:srgbClr val="BFB3A0">
+                <a:alpha val="25000"/>
+              </a:srgbClr>
+            </a:outerShdw>
+          </a:effectLst>
         </p:spPr>
       </p:sp>
       <p:sp>
@@ -7983,11 +8223,11 @@
             <a:avLst/>
           </a:prstGeom>
           <a:solidFill>
-            <a:srgbClr val="2B2F36"/>
+            <a:srgbClr val="5E8C61"/>
           </a:solidFill>
           <a:ln w="12700">
             <a:solidFill>
-              <a:srgbClr val="2B2F36"/>
+              <a:srgbClr val="5E8C61"/>
             </a:solidFill>
             <a:prstDash val="solid"/>
           </a:ln>
@@ -8059,7 +8299,7 @@
             <a:r>
               <a:rPr lang="en-US" sz="1800" b="1" dirty="0">
                 <a:solidFill>
-                  <a:srgbClr val="2B2F36"/>
+                  <a:srgbClr val="1E2A44"/>
                 </a:solidFill>
                 <a:latin typeface="Times New Roman" pitchFamily="34" charset="0"/>
                 <a:ea typeface="Times New Roman" pitchFamily="34" charset="-122"/>
@@ -8098,7 +8338,7 @@
             <a:r>
               <a:rPr lang="en-US" sz="1400" dirty="0">
                 <a:solidFill>
-                  <a:srgbClr val="6B7280"/>
+                  <a:srgbClr val="626B7F"/>
                 </a:solidFill>
                 <a:latin typeface="Times New Roman" pitchFamily="34" charset="0"/>
                 <a:ea typeface="Times New Roman" pitchFamily="34" charset="-122"/>
@@ -8123,18 +8363,25 @@
           </a:xfrm>
           <a:prstGeom prst="roundRect">
             <a:avLst>
-              <a:gd name="adj" fmla="val 2609"/>
+              <a:gd name="adj" fmla="val 3043"/>
             </a:avLst>
           </a:prstGeom>
           <a:solidFill>
-            <a:srgbClr val="F3F4F6"/>
+            <a:srgbClr val="FFFBF4"/>
           </a:solidFill>
           <a:ln w="12700">
             <a:solidFill>
-              <a:srgbClr val="F3F4F6"/>
+              <a:srgbClr val="E7DCCB"/>
             </a:solidFill>
             <a:prstDash val="solid"/>
           </a:ln>
+          <a:effectLst>
+            <a:outerShdw sx="100000" sy="100000" kx="0" ky="0" algn="bl" rotWithShape="0" blurRad="76200" dist="25400" dir="5400000">
+              <a:srgbClr val="BFB3A0">
+                <a:alpha val="25000"/>
+              </a:srgbClr>
+            </a:outerShdw>
+          </a:effectLst>
         </p:spPr>
       </p:sp>
       <p:sp>
@@ -8164,7 +8411,7 @@
             <a:r>
               <a:rPr lang="en-US" sz="1800" b="1" dirty="0">
                 <a:solidFill>
-                  <a:srgbClr val="2B2F36"/>
+                  <a:srgbClr val="1E2A44"/>
                 </a:solidFill>
                 <a:latin typeface="Times New Roman" pitchFamily="34" charset="0"/>
                 <a:ea typeface="Times New Roman" pitchFamily="34" charset="-122"/>
@@ -8203,7 +8450,7 @@
             <a:r>
               <a:rPr lang="en-US" sz="4000" b="1" dirty="0">
                 <a:solidFill>
-                  <a:srgbClr val="1F5FBF"/>
+                  <a:srgbClr val="1F6F8B"/>
                 </a:solidFill>
                 <a:latin typeface="Times New Roman" pitchFamily="34" charset="0"/>
                 <a:ea typeface="Times New Roman" pitchFamily="34" charset="-122"/>
@@ -8242,7 +8489,7 @@
             <a:r>
               <a:rPr lang="en-US" sz="1500" dirty="0">
                 <a:solidFill>
-                  <a:srgbClr val="2B2F36"/>
+                  <a:srgbClr val="1E2A44"/>
                 </a:solidFill>
                 <a:latin typeface="Times New Roman" pitchFamily="34" charset="0"/>
                 <a:ea typeface="Times New Roman" pitchFamily="34" charset="-122"/>
@@ -8281,7 +8528,7 @@
             <a:r>
               <a:rPr lang="en-US" sz="4000" b="1" dirty="0">
                 <a:solidFill>
-                  <a:srgbClr val="1F5FBF"/>
+                  <a:srgbClr val="1F6F8B"/>
                 </a:solidFill>
                 <a:latin typeface="Times New Roman" pitchFamily="34" charset="0"/>
                 <a:ea typeface="Times New Roman" pitchFamily="34" charset="-122"/>
@@ -8320,7 +8567,7 @@
             <a:r>
               <a:rPr lang="en-US" sz="1500" dirty="0">
                 <a:solidFill>
-                  <a:srgbClr val="2B2F36"/>
+                  <a:srgbClr val="1E2A44"/>
                 </a:solidFill>
                 <a:latin typeface="Times New Roman" pitchFamily="34" charset="0"/>
                 <a:ea typeface="Times New Roman" pitchFamily="34" charset="-122"/>
@@ -8359,7 +8606,7 @@
             <a:r>
               <a:rPr lang="en-US" sz="1500" b="1" dirty="0">
                 <a:solidFill>
-                  <a:srgbClr val="2B2F36"/>
+                  <a:srgbClr val="2F3B55"/>
                 </a:solidFill>
                 <a:latin typeface="Times New Roman" pitchFamily="34" charset="0"/>
                 <a:ea typeface="Times New Roman" pitchFamily="34" charset="-122"/>
@@ -8401,7 +8648,7 @@
             <a:lvl1pPr>
               <a:defRPr sz="1000">
                 <a:solidFill>
-                  <a:srgbClr val="6B7280"/>
+                  <a:srgbClr val="626B7F"/>
                 </a:solidFill>
                 <a:latin typeface="Times New Roman"/>
                 <a:ea typeface="Times New Roman"/>
@@ -8446,10 +8693,10 @@
       </p:grpSpPr>
       <p:sp>
         <p:nvSpPr>
-          <p:cNvPr id="2" name="Text 0"/>
+          <p:cNvPr id="2" name="Text 2"/>
           <p:cNvSpPr/>
           <p:nvPr>
-            <p:ph idx="100" type="title" hasCustomPrompt="1"/>
+            <p:ph idx="102" type="title" hasCustomPrompt="1"/>
           </p:nvPr>
         </p:nvSpPr>
         <p:spPr>
@@ -8473,7 +8720,7 @@
             <a:r>
               <a:rPr lang="en-US" sz="3000" b="1" dirty="0">
                 <a:solidFill>
-                  <a:srgbClr val="2B2F36"/>
+                  <a:srgbClr val="1E2A44"/>
                 </a:solidFill>
                 <a:latin typeface="Times New Roman" pitchFamily="34" charset="0"/>
                 <a:ea typeface="Times New Roman" pitchFamily="34" charset="-122"/>
@@ -8498,18 +8745,25 @@
           </a:xfrm>
           <a:prstGeom prst="roundRect">
             <a:avLst>
-              <a:gd name="adj" fmla="val 5217"/>
+              <a:gd name="adj" fmla="val 6087"/>
             </a:avLst>
           </a:prstGeom>
           <a:solidFill>
-            <a:srgbClr val="F3F4F6"/>
+            <a:srgbClr val="DCEBF0"/>
           </a:solidFill>
           <a:ln w="12700">
             <a:solidFill>
-              <a:srgbClr val="F3F4F6"/>
+              <a:srgbClr val="E7DCCB"/>
             </a:solidFill>
             <a:prstDash val="solid"/>
           </a:ln>
+          <a:effectLst>
+            <a:outerShdw sx="100000" sy="100000" kx="0" ky="0" algn="bl" rotWithShape="0" blurRad="76200" dist="25400" dir="5400000">
+              <a:srgbClr val="BFB3A0">
+                <a:alpha val="25000"/>
+              </a:srgbClr>
+            </a:outerShdw>
+          </a:effectLst>
         </p:spPr>
       </p:sp>
       <p:sp>
@@ -8539,7 +8793,7 @@
             <a:r>
               <a:rPr lang="en-US" sz="2000" b="1" dirty="0">
                 <a:solidFill>
-                  <a:srgbClr val="1F5FBF"/>
+                  <a:srgbClr val="1F6F8B"/>
                 </a:solidFill>
                 <a:latin typeface="Times New Roman" pitchFamily="34" charset="0"/>
                 <a:ea typeface="Times New Roman" pitchFamily="34" charset="-122"/>
@@ -8578,7 +8832,7 @@
             <a:r>
               <a:rPr lang="en-US" sz="1600" dirty="0">
                 <a:solidFill>
-                  <a:srgbClr val="2B2F36"/>
+                  <a:srgbClr val="1E2A44"/>
                 </a:solidFill>
                 <a:latin typeface="Times New Roman" pitchFamily="34" charset="0"/>
                 <a:ea typeface="Times New Roman" pitchFamily="34" charset="-122"/>
@@ -8603,18 +8857,25 @@
           </a:xfrm>
           <a:prstGeom prst="roundRect">
             <a:avLst>
-              <a:gd name="adj" fmla="val 5217"/>
+              <a:gd name="adj" fmla="val 6087"/>
             </a:avLst>
           </a:prstGeom>
           <a:solidFill>
-            <a:srgbClr val="F3F4F6"/>
+            <a:srgbClr val="F8E1D7"/>
           </a:solidFill>
           <a:ln w="12700">
             <a:solidFill>
-              <a:srgbClr val="F3F4F6"/>
+              <a:srgbClr val="E7DCCB"/>
             </a:solidFill>
             <a:prstDash val="solid"/>
           </a:ln>
+          <a:effectLst>
+            <a:outerShdw sx="100000" sy="100000" kx="0" ky="0" algn="bl" rotWithShape="0" blurRad="76200" dist="25400" dir="5400000">
+              <a:srgbClr val="BFB3A0">
+                <a:alpha val="25000"/>
+              </a:srgbClr>
+            </a:outerShdw>
+          </a:effectLst>
         </p:spPr>
       </p:sp>
       <p:sp>
@@ -8644,7 +8905,7 @@
             <a:r>
               <a:rPr lang="en-US" sz="2000" b="1" dirty="0">
                 <a:solidFill>
-                  <a:srgbClr val="1F5FBF"/>
+                  <a:srgbClr val="C8553D"/>
                 </a:solidFill>
                 <a:latin typeface="Times New Roman" pitchFamily="34" charset="0"/>
                 <a:ea typeface="Times New Roman" pitchFamily="34" charset="-122"/>
@@ -8683,7 +8944,7 @@
             <a:r>
               <a:rPr lang="en-US" sz="1600" dirty="0">
                 <a:solidFill>
-                  <a:srgbClr val="2B2F36"/>
+                  <a:srgbClr val="1E2A44"/>
                 </a:solidFill>
                 <a:latin typeface="Times New Roman" pitchFamily="34" charset="0"/>
                 <a:ea typeface="Times New Roman" pitchFamily="34" charset="-122"/>
@@ -8708,18 +8969,25 @@
           </a:xfrm>
           <a:prstGeom prst="roundRect">
             <a:avLst>
-              <a:gd name="adj" fmla="val 5217"/>
+              <a:gd name="adj" fmla="val 6087"/>
             </a:avLst>
           </a:prstGeom>
           <a:solidFill>
-            <a:srgbClr val="F3F4F6"/>
+            <a:srgbClr val="E4EEDF"/>
           </a:solidFill>
           <a:ln w="12700">
             <a:solidFill>
-              <a:srgbClr val="F3F4F6"/>
+              <a:srgbClr val="E7DCCB"/>
             </a:solidFill>
             <a:prstDash val="solid"/>
           </a:ln>
+          <a:effectLst>
+            <a:outerShdw sx="100000" sy="100000" kx="0" ky="0" algn="bl" rotWithShape="0" blurRad="76200" dist="25400" dir="5400000">
+              <a:srgbClr val="BFB3A0">
+                <a:alpha val="25000"/>
+              </a:srgbClr>
+            </a:outerShdw>
+          </a:effectLst>
         </p:spPr>
       </p:sp>
       <p:sp>
@@ -8749,7 +9017,7 @@
             <a:r>
               <a:rPr lang="en-US" sz="2000" b="1" dirty="0">
                 <a:solidFill>
-                  <a:srgbClr val="1F5FBF"/>
+                  <a:srgbClr val="5E8C61"/>
                 </a:solidFill>
                 <a:latin typeface="Times New Roman" pitchFamily="34" charset="0"/>
                 <a:ea typeface="Times New Roman" pitchFamily="34" charset="-122"/>
@@ -8788,7 +9056,7 @@
             <a:r>
               <a:rPr lang="en-US" sz="1600" dirty="0">
                 <a:solidFill>
-                  <a:srgbClr val="2B2F36"/>
+                  <a:srgbClr val="1E2A44"/>
                 </a:solidFill>
                 <a:latin typeface="Times New Roman" pitchFamily="34" charset="0"/>
                 <a:ea typeface="Times New Roman" pitchFamily="34" charset="-122"/>
@@ -8813,18 +9081,25 @@
           </a:xfrm>
           <a:prstGeom prst="roundRect">
             <a:avLst>
-              <a:gd name="adj" fmla="val 5217"/>
+              <a:gd name="adj" fmla="val 6087"/>
             </a:avLst>
           </a:prstGeom>
           <a:solidFill>
-            <a:srgbClr val="F3F4F6"/>
+            <a:srgbClr val="E8E3F2"/>
           </a:solidFill>
           <a:ln w="12700">
             <a:solidFill>
-              <a:srgbClr val="F3F4F6"/>
+              <a:srgbClr val="E7DCCB"/>
             </a:solidFill>
             <a:prstDash val="solid"/>
           </a:ln>
+          <a:effectLst>
+            <a:outerShdw sx="100000" sy="100000" kx="0" ky="0" algn="bl" rotWithShape="0" blurRad="76200" dist="25400" dir="5400000">
+              <a:srgbClr val="BFB3A0">
+                <a:alpha val="25000"/>
+              </a:srgbClr>
+            </a:outerShdw>
+          </a:effectLst>
         </p:spPr>
       </p:sp>
       <p:sp>
@@ -8854,7 +9129,7 @@
             <a:r>
               <a:rPr lang="en-US" sz="2000" b="1" dirty="0">
                 <a:solidFill>
-                  <a:srgbClr val="1F5FBF"/>
+                  <a:srgbClr val="6A5A9C"/>
                 </a:solidFill>
                 <a:latin typeface="Times New Roman" pitchFamily="34" charset="0"/>
                 <a:ea typeface="Times New Roman" pitchFamily="34" charset="-122"/>
@@ -8893,7 +9168,7 @@
             <a:r>
               <a:rPr lang="en-US" sz="1600" dirty="0">
                 <a:solidFill>
-                  <a:srgbClr val="2B2F36"/>
+                  <a:srgbClr val="1E2A44"/>
                 </a:solidFill>
                 <a:latin typeface="Times New Roman" pitchFamily="34" charset="0"/>
                 <a:ea typeface="Times New Roman" pitchFamily="34" charset="-122"/>
@@ -8935,7 +9210,7 @@
             <a:lvl1pPr>
               <a:defRPr sz="1000">
                 <a:solidFill>
-                  <a:srgbClr val="6B7280"/>
+                  <a:srgbClr val="626B7F"/>
                 </a:solidFill>
                 <a:latin typeface="Times New Roman"/>
                 <a:ea typeface="Times New Roman"/>

</xml_diff>

<commit_message>
feat: add report and slides documents for Apart Research sprint
</commit_message>
<xml_diff>
--- a/Apart Research/slides.pptx
+++ b/Apart Research/slides.pptx
@@ -4,6 +4,9 @@
   <p:sldMasterIdLst>
     <p:sldMasterId id="2147483648" r:id="rId1"/>
   </p:sldMasterIdLst>
+  <p:notesMasterIdLst>
+    <p:notesMasterId r:id="rId12"/>
+  </p:notesMasterIdLst>
   <p:sldIdLst>
     <p:sldId id="256" r:id="rId2"/>
     <p:sldId id="257" r:id="rId3"/>
@@ -16,9 +19,6 @@
     <p:sldId id="264" r:id="rId10"/>
     <p:sldId id="265" r:id="rId11"/>
   </p:sldIdLst>
-  <p:notesMasterIdLst>
-    <p:notesMasterId r:id="rId12"/>
-  </p:notesMasterIdLst>
   <p:sldSz cx="12192000" cy="6858000"/>
   <p:notesSz cx="6858000" cy="12192000"/>
   <p:defaultTextStyle>
@@ -113,13 +113,20 @@
       </a:defRPr>
     </a:lvl9pPr>
   </p:defaultTextStyle>
+  <p:extLst>
+    <p:ext uri="{EFAFB233-063F-42B5-8137-9DF3F51BA10A}">
+      <p15:sldGuideLst xmlns:p15="http://schemas.microsoft.com/office/powerpoint/2012/main"/>
+    </p:ext>
+  </p:extLst>
 </p:presentation>
 </file>
 
 <file path=ppt/charts/chart1.xml><?xml version="1.0" encoding="utf-8"?>
-<c:chartSpace xmlns:c="http://schemas.openxmlformats.org/drawingml/2006/chart" xmlns:a="http://schemas.openxmlformats.org/drawingml/2006/main" xmlns:r="http://schemas.openxmlformats.org/officeDocument/2006/relationships">
+<c:chartSpace xmlns:c="http://schemas.openxmlformats.org/drawingml/2006/chart" xmlns:a="http://schemas.openxmlformats.org/drawingml/2006/main" xmlns:r="http://schemas.openxmlformats.org/officeDocument/2006/relationships" xmlns:c16r2="http://schemas.microsoft.com/office/drawing/2015/06/chart">
   <c:date1904 val="0"/>
+  <c:lang val="en-US"/>
   <c:roundedCorners val="1"/>
+  <c:style val="2"/>
   <c:chart>
     <c:title>
       <c:tx>
@@ -136,7 +143,7 @@
               </a:defRPr>
             </a:pPr>
             <a:r>
-              <a:rPr sz="1500" b="0" i="0" u="none" strike="noStrike">
+              <a:rPr lang="en-US" sz="1500" b="0" i="0" u="none" strike="noStrike">
                 <a:solidFill>
                   <a:srgbClr val="1E2A44"/>
                 </a:solidFill>
@@ -147,7 +154,6 @@
           </a:p>
         </c:rich>
       </c:tx>
-      <c:layout/>
       <c:overlay val="0"/>
     </c:title>
     <c:autoTitleDeleted val="0"/>
@@ -178,40 +184,15 @@
             <a:effectLst/>
           </c:spPr>
           <c:invertIfNegative val="0"/>
-          <c:dLbls>
-            <c:numFmt formatCode="0.000" sourceLinked="0"/>
-            <c:txPr>
-              <a:bodyPr/>
-              <a:lstStyle/>
-              <a:p>
-                <a:pPr>
-                  <a:defRPr b="0" i="0" strike="noStrike" sz="1300" u="none">
-                    <a:solidFill>
-                      <a:srgbClr val="1E2A44"/>
-                    </a:solidFill>
-                    <a:latin typeface="+mn-lt"/>
-                  </a:defRPr>
-                </a:pPr>
-              </a:p>
-            </c:txPr>
-            <c:showLegendKey val="0"/>
-            <c:showVal val="1"/>
-            <c:showCatName val="0"/>
-            <c:showSerName val="0"/>
-            <c:showPercent val="0"/>
-            <c:showBubbleSize val="0"/>
-            <c:showLeaderLines val="0"/>
-          </c:dLbls>
           <c:dPt>
             <c:idx val="0"/>
             <c:invertIfNegative val="0"/>
             <c:bubble3D val="0"/>
-            <c:spPr>
-              <a:solidFill>
-                <a:srgbClr val="1E2A44"/>
-              </a:solidFill>
-              <a:effectLst/>
-            </c:spPr>
+            <c:extLst>
+              <c:ext xmlns:c16="http://schemas.microsoft.com/office/drawing/2014/chart" uri="{C3380CC4-5D6E-409C-BE32-E72D297353CC}">
+                <c16:uniqueId val="{00000001-A519-426E-A48F-A564C55CC377}"/>
+              </c:ext>
+            </c:extLst>
           </c:dPt>
           <c:dPt>
             <c:idx val="1"/>
@@ -223,6 +204,11 @@
               </a:solidFill>
               <a:effectLst/>
             </c:spPr>
+            <c:extLst>
+              <c:ext xmlns:c16="http://schemas.microsoft.com/office/drawing/2014/chart" uri="{C3380CC4-5D6E-409C-BE32-E72D297353CC}">
+                <c16:uniqueId val="{00000003-A519-426E-A48F-A564C55CC377}"/>
+              </c:ext>
+            </c:extLst>
           </c:dPt>
           <c:dPt>
             <c:idx val="2"/>
@@ -234,6 +220,11 @@
               </a:solidFill>
               <a:effectLst/>
             </c:spPr>
+            <c:extLst>
+              <c:ext xmlns:c16="http://schemas.microsoft.com/office/drawing/2014/chart" uri="{C3380CC4-5D6E-409C-BE32-E72D297353CC}">
+                <c16:uniqueId val="{00000005-A519-426E-A48F-A564C55CC377}"/>
+              </c:ext>
+            </c:extLst>
           </c:dPt>
           <c:dPt>
             <c:idx val="3"/>
@@ -245,6 +236,11 @@
               </a:solidFill>
               <a:effectLst/>
             </c:spPr>
+            <c:extLst>
+              <c:ext xmlns:c16="http://schemas.microsoft.com/office/drawing/2014/chart" uri="{C3380CC4-5D6E-409C-BE32-E72D297353CC}">
+                <c16:uniqueId val="{00000007-A519-426E-A48F-A564C55CC377}"/>
+              </c:ext>
+            </c:extLst>
           </c:dPt>
           <c:dPt>
             <c:idx val="4"/>
@@ -256,6 +252,11 @@
               </a:solidFill>
               <a:effectLst/>
             </c:spPr>
+            <c:extLst>
+              <c:ext xmlns:c16="http://schemas.microsoft.com/office/drawing/2014/chart" uri="{C3380CC4-5D6E-409C-BE32-E72D297353CC}">
+                <c16:uniqueId val="{00000009-A519-426E-A48F-A564C55CC377}"/>
+              </c:ext>
+            </c:extLst>
           </c:dPt>
           <c:dPt>
             <c:idx val="5"/>
@@ -267,6 +268,11 @@
               </a:solidFill>
               <a:effectLst/>
             </c:spPr>
+            <c:extLst>
+              <c:ext xmlns:c16="http://schemas.microsoft.com/office/drawing/2014/chart" uri="{C3380CC4-5D6E-409C-BE32-E72D297353CC}">
+                <c16:uniqueId val="{0000000B-A519-426E-A48F-A564C55CC377}"/>
+              </c:ext>
+            </c:extLst>
           </c:dPt>
           <c:dPt>
             <c:idx val="6"/>
@@ -278,6 +284,11 @@
               </a:solidFill>
               <a:effectLst/>
             </c:spPr>
+            <c:extLst>
+              <c:ext xmlns:c16="http://schemas.microsoft.com/office/drawing/2014/chart" uri="{C3380CC4-5D6E-409C-BE32-E72D297353CC}">
+                <c16:uniqueId val="{0000000D-A519-426E-A48F-A564C55CC377}"/>
+              </c:ext>
+            </c:extLst>
           </c:dPt>
           <c:dPt>
             <c:idx val="7"/>
@@ -289,40 +300,80 @@
               </a:solidFill>
               <a:effectLst/>
             </c:spPr>
+            <c:extLst>
+              <c:ext xmlns:c16="http://schemas.microsoft.com/office/drawing/2014/chart" uri="{C3380CC4-5D6E-409C-BE32-E72D297353CC}">
+                <c16:uniqueId val="{0000000F-A519-426E-A48F-A564C55CC377}"/>
+              </c:ext>
+            </c:extLst>
           </c:dPt>
+          <c:dLbls>
+            <c:numFmt formatCode="0.000" sourceLinked="0"/>
+            <c:spPr>
+              <a:noFill/>
+              <a:ln>
+                <a:noFill/>
+              </a:ln>
+              <a:effectLst/>
+            </c:spPr>
+            <c:txPr>
+              <a:bodyPr/>
+              <a:lstStyle/>
+              <a:p>
+                <a:pPr>
+                  <a:defRPr sz="1300" b="0" i="0" u="none" strike="noStrike">
+                    <a:solidFill>
+                      <a:srgbClr val="1E2A44"/>
+                    </a:solidFill>
+                    <a:latin typeface="+mn-lt"/>
+                  </a:defRPr>
+                </a:pPr>
+                <a:endParaRPr lang="en-US"/>
+              </a:p>
+            </c:txPr>
+            <c:showLegendKey val="0"/>
+            <c:showVal val="1"/>
+            <c:showCatName val="0"/>
+            <c:showSerName val="0"/>
+            <c:showPercent val="0"/>
+            <c:showBubbleSize val="0"/>
+            <c:showLeaderLines val="0"/>
+            <c:extLst>
+              <c:ext xmlns:c15="http://schemas.microsoft.com/office/drawing/2012/chart" uri="{CE6537A1-D6FC-4f65-9D91-7224C49458BB}">
+                <c15:showLeaderLines val="0"/>
+              </c:ext>
+            </c:extLst>
+          </c:dLbls>
           <c:cat>
-            <c:multiLvlStrRef>
+            <c:strRef>
               <c:f>Sheet1!$A$2:$A$9</c:f>
-              <c:multiLvlStrCache>
+              <c:strCache>
                 <c:ptCount val="8"/>
-                <c:lvl>
-                  <c:pt idx="0">
-                    <c:v>Control</c:v>
-                  </c:pt>
-                  <c:pt idx="1">
-                    <c:v>Placebo</c:v>
-                  </c:pt>
-                  <c:pt idx="2">
-                    <c:v>Same + history</c:v>
-                  </c:pt>
-                  <c:pt idx="3">
-                    <c:v>Same, notes only</c:v>
-                  </c:pt>
-                  <c:pt idx="4">
-                    <c:v>Same, no history</c:v>
-                  </c:pt>
-                  <c:pt idx="5">
-                    <c:v>Other + history</c:v>
-                  </c:pt>
-                  <c:pt idx="6">
-                    <c:v>Other, no history</c:v>
-                  </c:pt>
-                  <c:pt idx="7">
-                    <c:v>Best-response bot</c:v>
-                  </c:pt>
-                </c:lvl>
-              </c:multiLvlStrCache>
-            </c:multiLvlStrRef>
+                <c:pt idx="0">
+                  <c:v>Control</c:v>
+                </c:pt>
+                <c:pt idx="1">
+                  <c:v>Placebo</c:v>
+                </c:pt>
+                <c:pt idx="2">
+                  <c:v>Same + history</c:v>
+                </c:pt>
+                <c:pt idx="3">
+                  <c:v>Same, notes only</c:v>
+                </c:pt>
+                <c:pt idx="4">
+                  <c:v>Same, no history</c:v>
+                </c:pt>
+                <c:pt idx="5">
+                  <c:v>Other + history</c:v>
+                </c:pt>
+                <c:pt idx="6">
+                  <c:v>Other, no history</c:v>
+                </c:pt>
+                <c:pt idx="7">
+                  <c:v>Best-response bot</c:v>
+                </c:pt>
+              </c:strCache>
+            </c:strRef>
           </c:cat>
           <c:val>
             <c:numRef>
@@ -334,7 +385,7 @@
                   <c:v>0.9</c:v>
                 </c:pt>
                 <c:pt idx="1">
-                  <c:v>0.884</c:v>
+                  <c:v>0.88400000000000001</c:v>
                 </c:pt>
                 <c:pt idx="2">
                   <c:v>0.876</c:v>
@@ -343,50 +394,37 @@
                   <c:v>0.63</c:v>
                 </c:pt>
                 <c:pt idx="4">
-                  <c:v>0.289</c:v>
+                  <c:v>0.28899999999999998</c:v>
                 </c:pt>
                 <c:pt idx="5">
-                  <c:v>0.199</c:v>
+                  <c:v>0.19900000000000001</c:v>
                 </c:pt>
                 <c:pt idx="6">
-                  <c:v>0.039</c:v>
+                  <c:v>3.9E-2</c:v>
                 </c:pt>
                 <c:pt idx="7">
-                  <c:v>0.023</c:v>
+                  <c:v>2.3E-2</c:v>
                 </c:pt>
               </c:numCache>
             </c:numRef>
           </c:val>
+          <c:extLst>
+            <c:ext xmlns:c16="http://schemas.microsoft.com/office/drawing/2014/chart" uri="{C3380CC4-5D6E-409C-BE32-E72D297353CC}">
+              <c16:uniqueId val="{00000010-A519-426E-A48F-A564C55CC377}"/>
+            </c:ext>
+          </c:extLst>
         </c:ser>
         <c:dLbls>
-          <c:numFmt formatCode="0.000" sourceLinked="0"/>
-          <c:txPr>
-            <a:bodyPr/>
-            <a:lstStyle/>
-            <a:p>
-              <a:pPr>
-                <a:defRPr b="0" i="0" strike="noStrike" sz="1300" u="none">
-                  <a:solidFill>
-                    <a:srgbClr val="1E2A44"/>
-                  </a:solidFill>
-                  <a:latin typeface="+mn-lt"/>
-                </a:defRPr>
-              </a:pPr>
-            </a:p>
-          </c:txPr>
           <c:showLegendKey val="0"/>
           <c:showVal val="1"/>
           <c:showCatName val="0"/>
           <c:showSerName val="0"/>
           <c:showPercent val="0"/>
           <c:showBubbleSize val="0"/>
-          <c:showLeaderLines val="0"/>
         </c:dLbls>
         <c:gapWidth val="150"/>
-        <c:overlap val="0"/>
         <c:axId val="2094734554"/>
         <c:axId val="2094734552"/>
-        <c:axId val="2094734556"/>
       </c:barChart>
       <c:catAx>
         <c:axId val="2094734554"/>
@@ -427,6 +465,7 @@
         <c:crosses val="autoZero"/>
         <c:auto val="1"/>
         <c:lblAlgn val="ctr"/>
+        <c:lblOffset val="100"/>
         <c:noMultiLvlLbl val="1"/>
       </c:catAx>
       <c:valAx>
@@ -437,7 +476,7 @@
           <c:min val="0"/>
         </c:scaling>
         <c:delete val="0"/>
-        <c:axPos val="b"/>
+        <c:axPos val="t"/>
         <c:majorGridlines>
           <c:spPr>
             <a:ln w="9525" cap="flat">
@@ -491,6 +530,7 @@
     </c:plotArea>
     <c:plotVisOnly val="1"/>
     <c:dispBlanksAs val="span"/>
+    <c:showDLblsOverMax val="1"/>
   </c:chart>
   <c:spPr>
     <a:noFill/>
@@ -527,234 +567,10 @@
           <a:chExt cx="0" cy="0"/>
         </a:xfrm>
       </p:grpSpPr>
-      <p:sp>
-        <p:nvSpPr>
-          <p:cNvPr id="2" name="Header Placeholder 1"/>
-          <p:cNvSpPr>
-            <a:spLocks noGrp="1"/>
-          </p:cNvSpPr>
-          <p:nvPr>
-            <p:ph type="hdr" sz="quarter"/>
-          </p:nvPr>
-        </p:nvSpPr>
-        <p:spPr>
-          <a:xfrm>
-            <a:off x="0" y="0"/>
-            <a:ext cx="2971800" cy="458788"/>
-          </a:xfrm>
-          <a:prstGeom prst="rect">
-            <a:avLst/>
-          </a:prstGeom>
-        </p:spPr>
-        <p:txBody>
-          <a:bodyPr vert="horz" lIns="91440" tIns="45720" rIns="91440" bIns="45720" rtlCol="0"/>
-          <a:lstStyle>
-            <a:lvl1pPr algn="l">
-              <a:defRPr sz="1200"/>
-            </a:lvl1pPr>
-          </a:lstStyle>
-          <a:p>
-            <a:endParaRPr lang="en-US"/>
-          </a:p>
-        </p:txBody>
-      </p:sp>
-      <p:sp>
-        <p:nvSpPr>
-          <p:cNvPr id="3" name="Date Placeholder 2"/>
-          <p:cNvSpPr>
-            <a:spLocks noGrp="1"/>
-          </p:cNvSpPr>
-          <p:nvPr>
-            <p:ph type="dt" idx="1"/>
-          </p:nvPr>
-        </p:nvSpPr>
-        <p:spPr>
-          <a:xfrm>
-            <a:off x="3884613" y="0"/>
-            <a:ext cx="2971800" cy="458788"/>
-          </a:xfrm>
-          <a:prstGeom prst="rect">
-            <a:avLst/>
-          </a:prstGeom>
-        </p:spPr>
-        <p:txBody>
-          <a:bodyPr vert="horz" lIns="91440" tIns="45720" rIns="91440" bIns="45720" rtlCol="0"/>
-          <a:lstStyle>
-            <a:lvl1pPr algn="r">
-              <a:defRPr sz="1200"/>
-            </a:lvl1pPr>
-          </a:lstStyle>
-          <a:p>
-            <a:fld id="{5282F153-3F37-0F45-9E97-73ACFA13230C}" type="datetimeFigureOut">
-              <a:rPr lang="en-US"/>
-              <a:t>7/23/19</a:t>
-            </a:fld>
-            <a:endParaRPr lang="en-US"/>
-          </a:p>
-        </p:txBody>
-      </p:sp>
-      <p:sp>
-        <p:nvSpPr>
-          <p:cNvPr id="4" name="Slide Image Placeholder 3"/>
-          <p:cNvSpPr>
-            <a:spLocks noGrp="1" noRot="1" noChangeAspect="1"/>
-          </p:cNvSpPr>
-          <p:nvPr>
-            <p:ph type="sldImg" idx="2"/>
-          </p:nvPr>
-        </p:nvSpPr>
-        <p:spPr>
-          <a:xfrm>
-            <a:off x="685800" y="1143000"/>
-            <a:ext cx="5486400" cy="3086100"/>
-          </a:xfrm>
-          <a:prstGeom prst="rect">
-            <a:avLst/>
-          </a:prstGeom>
-          <a:noFill/>
-          <a:ln w="12700">
-            <a:solidFill>
-              <a:prstClr val="black"/>
-            </a:solidFill>
-          </a:ln>
-        </p:spPr>
-        <p:txBody>
-          <a:bodyPr vert="horz" lIns="91440" tIns="45720" rIns="91440" bIns="45720" rtlCol="0" anchor="ctr"/>
-          <a:lstStyle/>
-          <a:p>
-            <a:endParaRPr lang="en-US"/>
-          </a:p>
-        </p:txBody>
-      </p:sp>
-      <p:sp>
-        <p:nvSpPr>
-          <p:cNvPr id="5" name="Notes Placeholder 4"/>
-          <p:cNvSpPr>
-            <a:spLocks noGrp="1"/>
-          </p:cNvSpPr>
-          <p:nvPr>
-            <p:ph type="body" sz="quarter" idx="3"/>
-          </p:nvPr>
-        </p:nvSpPr>
-        <p:spPr>
-          <a:xfrm>
-            <a:off x="685800" y="4400550"/>
-            <a:ext cx="5486400" cy="3600450"/>
-          </a:xfrm>
-          <a:prstGeom prst="rect">
-            <a:avLst/>
-          </a:prstGeom>
-        </p:spPr>
-        <p:txBody>
-          <a:bodyPr vert="horz" lIns="91440" tIns="45720" rIns="91440" bIns="45720" rtlCol="0"/>
-          <a:lstStyle/>
-          <a:p>
-            <a:pPr lvl="0"/>
-            <a:r>
-              <a:rPr lang="en-US"/>
-              <a:t>Click to edit Master text styles</a:t>
-            </a:r>
-          </a:p>
-          <a:p>
-            <a:pPr lvl="1"/>
-            <a:r>
-              <a:rPr lang="en-US"/>
-              <a:t>Second level</a:t>
-            </a:r>
-          </a:p>
-          <a:p>
-            <a:pPr lvl="2"/>
-            <a:r>
-              <a:rPr lang="en-US"/>
-              <a:t>Third level</a:t>
-            </a:r>
-          </a:p>
-          <a:p>
-            <a:pPr lvl="3"/>
-            <a:r>
-              <a:rPr lang="en-US"/>
-              <a:t>Fourth level</a:t>
-            </a:r>
-          </a:p>
-          <a:p>
-            <a:pPr lvl="4"/>
-            <a:r>
-              <a:rPr lang="en-US"/>
-              <a:t>Fifth level</a:t>
-            </a:r>
-          </a:p>
-        </p:txBody>
-      </p:sp>
-      <p:sp>
-        <p:nvSpPr>
-          <p:cNvPr id="6" name="Footer Placeholder 5"/>
-          <p:cNvSpPr>
-            <a:spLocks noGrp="1"/>
-          </p:cNvSpPr>
-          <p:nvPr>
-            <p:ph type="ftr" sz="quarter" idx="4"/>
-          </p:nvPr>
-        </p:nvSpPr>
-        <p:spPr>
-          <a:xfrm>
-            <a:off x="0" y="8685213"/>
-            <a:ext cx="2971800" cy="458787"/>
-          </a:xfrm>
-          <a:prstGeom prst="rect">
-            <a:avLst/>
-          </a:prstGeom>
-        </p:spPr>
-        <p:txBody>
-          <a:bodyPr vert="horz" lIns="91440" tIns="45720" rIns="91440" bIns="45720" rtlCol="0" anchor="b"/>
-          <a:lstStyle>
-            <a:lvl1pPr algn="l">
-              <a:defRPr sz="1200"/>
-            </a:lvl1pPr>
-          </a:lstStyle>
-          <a:p>
-            <a:endParaRPr lang="en-US"/>
-          </a:p>
-        </p:txBody>
-      </p:sp>
-      <p:sp>
-        <p:nvSpPr>
-          <p:cNvPr id="7" name="Slide Number Placeholder 6"/>
-          <p:cNvSpPr>
-            <a:spLocks noGrp="1"/>
-          </p:cNvSpPr>
-          <p:nvPr>
-            <p:ph type="sldNum" sz="quarter" idx="5"/>
-          </p:nvPr>
-        </p:nvSpPr>
-        <p:spPr>
-          <a:xfrm>
-            <a:off x="3884613" y="8685213"/>
-            <a:ext cx="2971800" cy="458787"/>
-          </a:xfrm>
-          <a:prstGeom prst="rect">
-            <a:avLst/>
-          </a:prstGeom>
-        </p:spPr>
-        <p:txBody>
-          <a:bodyPr vert="horz" lIns="91440" tIns="45720" rIns="91440" bIns="45720" rtlCol="0" anchor="b"/>
-          <a:lstStyle>
-            <a:lvl1pPr algn="r">
-              <a:defRPr sz="1200"/>
-            </a:lvl1pPr>
-          </a:lstStyle>
-          <a:p>
-            <a:fld id="{CE5E9CC1-C706-0F49-92D6-E571CC5EEA8F}" type="slidenum">
-              <a:rPr lang="en-US"/>
-              <a:t>‹#›</a:t>
-            </a:fld>
-            <a:endParaRPr lang="en-US"/>
-          </a:p>
-        </p:txBody>
-      </p:sp>
     </p:spTree>
     <p:extLst>
       <p:ext uri="{BB962C8B-B14F-4D97-AF65-F5344CB8AC3E}">
-        <p14:creationId xmlns:p14="http://schemas.microsoft.com/office/powerpoint/2010/main" val="1024086991"/>
+        <p14:creationId xmlns:p14="http://schemas.microsoft.com/office/powerpoint/2010/main" val="1757682958"/>
       </p:ext>
     </p:extLst>
   </p:cSld>
@@ -902,7 +718,6 @@
               <a:rPr lang="en-US" dirty="0"/>
               <a:t>Two AI agents that set prices for two competing firms often learn to keep prices high without being told to. We ask what happens when one of them is replaced. Short answer: the cartel survives if the new agent reads the old price history.</a:t>
             </a:r>
-            <a:endParaRPr lang="en-US" dirty="0"/>
           </a:p>
         </p:txBody>
       </p:sp>
@@ -990,7 +805,6 @@
               <a:rPr lang="en-US" dirty="0"/>
               <a:t>All numbers come from stored run data through the analysis code in the repository. The report lists every run, null results and failures.</a:t>
             </a:r>
-            <a:endParaRPr lang="en-US" dirty="0"/>
           </a:p>
         </p:txBody>
       </p:sp>
@@ -1078,7 +892,6 @@
               <a:rPr lang="en-US" dirty="0"/>
               <a:t>The answer tells a regulator which item a remedy must change: the agent, the data it inherits, or its memory.</a:t>
             </a:r>
-            <a:endParaRPr lang="en-US" dirty="0"/>
           </a:p>
         </p:txBody>
       </p:sp>
@@ -1166,7 +979,6 @@
               <a:rPr lang="en-US" dirty="0"/>
               <a:t>A profit index near 1 means the two agents behave like a cartel. We report both indices because they disagree when prices overshoot the monopoly price.</a:t>
             </a:r>
-            <a:endParaRPr lang="en-US" dirty="0"/>
           </a:p>
         </p:txBody>
       </p:sp>
@@ -1254,7 +1066,6 @@
               <a:rPr lang="en-US" dirty="0"/>
               <a:t>Six independent runs, hypotheses fixed in advance, 95% bootstrap intervals over markets. Runs without a stable cartel are reported too.</a:t>
             </a:r>
-            <a:endParaRPr lang="en-US" dirty="0"/>
           </a:p>
         </p:txBody>
       </p:sp>
@@ -1342,7 +1153,6 @@
               <a:rPr lang="en-US" dirty="0"/>
               <a:t>Profit index 0 = competitive, 1 = monopoly. 'Same + history' differs from no replacement by between –0.025 and +0.213 across the six runs.</a:t>
             </a:r>
-            <a:endParaRPr lang="en-US" dirty="0"/>
           </a:p>
         </p:txBody>
       </p:sp>
@@ -1430,7 +1240,6 @@
               <a:rPr lang="en-US" dirty="0"/>
               <a:t>The blank entrant has no anchor. It starts high and stays above the monopoly price, so both firms sell less. Only the best-response bot and the Mistral entrant reach competitive prices.</a:t>
             </a:r>
-            <a:endParaRPr lang="en-US" dirty="0"/>
           </a:p>
         </p:txBody>
       </p:sp>
@@ -1518,7 +1327,6 @@
               <a:rPr lang="en-US" dirty="0"/>
               <a:t>'A different model' is not one treatment. A sticky model keeps the inherited prices by inertia; an exploring model drifts to competition.</a:t>
             </a:r>
-            <a:endParaRPr lang="en-US" dirty="0"/>
           </a:p>
         </p:txBody>
       </p:sp>
@@ -1606,7 +1414,6 @@
               <a:rPr lang="en-US" dirty="0"/>
               <a:t>The inherited high prices persist because the agents anchor on what they see, not because they threaten a price war.</a:t>
             </a:r>
-            <a:endParaRPr lang="en-US" dirty="0"/>
           </a:p>
         </p:txBody>
       </p:sp>
@@ -1694,7 +1501,6 @@
               <a:rPr lang="en-US" dirty="0"/>
               <a:t>The unit of analysis moves from the agent to the agent and its context.</a:t>
             </a:r>
-            <a:endParaRPr lang="en-US" dirty="0"/>
           </a:p>
         </p:txBody>
       </p:sp>
@@ -1772,6 +1578,7 @@
         <a:solidFill>
           <a:srgbClr val="F6F1E8"/>
         </a:solidFill>
+        <a:effectLst/>
       </p:bgPr>
     </p:bg>
     <p:spTree>
@@ -1849,7 +1656,7 @@
           <a:bodyPr wrap="square" rtlCol="0" anchor="ctr"/>
           <a:lstStyle/>
           <a:p>
-            <a:pPr indent="0" marL="0">
+            <a:pPr marL="0" indent="0">
               <a:buNone/>
             </a:pPr>
             <a:r>
@@ -1870,9 +1677,11 @@
       <p:sp>
         <p:nvSpPr>
           <p:cNvPr id="5" name="Text 3"/>
-          <p:cNvSpPr/>
+          <p:cNvSpPr>
+            <a:spLocks noGrp="1"/>
+          </p:cNvSpPr>
           <p:nvPr>
-            <p:ph idx="103" type="title" hasCustomPrompt="1"/>
+            <p:ph type="title" idx="103" hasCustomPrompt="1"/>
           </p:nvPr>
         </p:nvSpPr>
         <p:spPr>
@@ -1889,7 +1698,7 @@
         <p:txBody>
           <a:bodyPr wrap="square" rtlCol="0"/>
           <a:lstStyle>
-            <a:lvl1pPr algn="l" indent="0" marL="0">
+            <a:lvl1pPr marL="0" indent="0" algn="l">
               <a:buNone/>
               <a:defRPr lang="en-US" sz="3000" b="1" dirty="0">
                 <a:solidFill>
@@ -1902,7 +1711,7 @@
             </a:lvl1pPr>
           </a:lstStyle>
           <a:p>
-            <a:pPr algn="l" indent="0" marL="0">
+            <a:pPr marL="0" indent="0" algn="l">
               <a:buNone/>
             </a:pPr>
             <a:endParaRPr lang="en-US" sz="3000" dirty="0"/>
@@ -1929,7 +1738,7 @@
           </a:prstGeom>
           <a:extLst>
             <a:ext uri="{C572A759-6A51-4108-AA02-DFA0A04FC94B}">
-              <ma14:wrappingTextBoxFlag xmlns:ma14="http://schemas.microsoft.com/office/mac/drawingml/2011/main" val="0"/>
+              <ma14:wrappingTextBoxFlag xmlns:ma14="http://schemas.microsoft.com/office/mac/drawingml/2011/main" xmlns="" val="0"/>
             </a:ext>
           </a:extLst>
         </p:spPr>
@@ -1950,8 +1759,8 @@
           <a:p>
             <a:pPr algn="l"/>
             <a:fld id="{F7021451-1387-4CA6-816F-3879F97B5CBC}" type="slidenum">
-              <a:rPr b="0" lang="en-US"/>
-              <a:t>1002</a:t>
+              <a:rPr lang="en-US" b="0"/>
+              <a:t>‹#›</a:t>
             </a:fld>
             <a:endParaRPr lang="en-US"/>
           </a:p>
@@ -1973,6 +1782,7 @@
         <a:solidFill>
           <a:srgbClr val="F6F1E8"/>
         </a:solidFill>
+        <a:effectLst/>
       </p:bgPr>
     </p:bg>
     <p:spTree>
@@ -2032,9 +1842,11 @@
       <p:sp>
         <p:nvSpPr>
           <p:cNvPr id="4" name="Text 2"/>
-          <p:cNvSpPr/>
+          <p:cNvSpPr>
+            <a:spLocks noGrp="1"/>
+          </p:cNvSpPr>
           <p:nvPr>
-            <p:ph idx="102" type="title" hasCustomPrompt="1"/>
+            <p:ph type="title" idx="102" hasCustomPrompt="1"/>
           </p:nvPr>
         </p:nvSpPr>
         <p:spPr>
@@ -2051,7 +1863,7 @@
         <p:txBody>
           <a:bodyPr wrap="square" rtlCol="0"/>
           <a:lstStyle>
-            <a:lvl1pPr algn="l" indent="0" marL="0">
+            <a:lvl1pPr marL="0" indent="0" algn="l">
               <a:buNone/>
               <a:defRPr lang="en-US" sz="3000" b="1" dirty="0">
                 <a:solidFill>
@@ -2064,7 +1876,7 @@
             </a:lvl1pPr>
           </a:lstStyle>
           <a:p>
-            <a:pPr algn="l" indent="0" marL="0">
+            <a:pPr marL="0" indent="0" algn="l">
               <a:buNone/>
             </a:pPr>
             <a:endParaRPr lang="en-US" sz="3000" dirty="0"/>
@@ -2091,7 +1903,7 @@
           </a:prstGeom>
           <a:extLst>
             <a:ext uri="{C572A759-6A51-4108-AA02-DFA0A04FC94B}">
-              <ma14:wrappingTextBoxFlag xmlns:ma14="http://schemas.microsoft.com/office/mac/drawingml/2011/main" val="0"/>
+              <ma14:wrappingTextBoxFlag xmlns:ma14="http://schemas.microsoft.com/office/mac/drawingml/2011/main" xmlns="" val="0"/>
             </a:ext>
           </a:extLst>
         </p:spPr>
@@ -2112,8 +1924,8 @@
           <a:p>
             <a:pPr algn="l"/>
             <a:fld id="{F7021451-1387-4CA6-816F-3879F97B5CBC}" type="slidenum">
-              <a:rPr b="0" lang="en-US"/>
-              <a:t>1003</a:t>
+              <a:rPr lang="en-US" b="0"/>
+              <a:t>‹#›</a:t>
             </a:fld>
             <a:endParaRPr lang="en-US"/>
           </a:p>
@@ -2130,6 +1942,11 @@
 <file path=ppt/slideMasters/slideMaster1.xml><?xml version="1.0" encoding="utf-8"?>
 <p:sldMaster xmlns:a="http://schemas.openxmlformats.org/drawingml/2006/main" xmlns:r="http://schemas.openxmlformats.org/officeDocument/2006/relationships" xmlns:p="http://schemas.openxmlformats.org/presentationml/2006/main">
   <p:cSld>
+    <p:bg>
+      <p:bgRef idx="1001">
+        <a:schemeClr val="bg1"/>
+      </p:bgRef>
+    </p:bg>
     <p:spTree>
       <p:nvGrpSpPr>
         <p:cNvPr id="1" name=""/>
@@ -2164,7 +1981,7 @@
           </a:prstGeom>
           <a:extLst>
             <a:ext uri="{C572A759-6A51-4108-AA02-DFA0A04FC94B}">
-              <ma14:wrappingTextBoxFlag xmlns:ma14="http://schemas.microsoft.com/office/mac/drawingml/2011/main" val="0"/>
+              <ma14:wrappingTextBoxFlag xmlns:ma14="http://schemas.microsoft.com/office/mac/drawingml/2011/main" xmlns="" val="0"/>
             </a:ext>
           </a:extLst>
         </p:spPr>
@@ -2185,8 +2002,8 @@
           <a:p>
             <a:pPr algn="l"/>
             <a:fld id="{F7021451-1387-4CA6-816F-3879F97B5CBC}" type="slidenum">
-              <a:rPr b="0" lang="en-US"/>
-              <a:t>null</a:t>
+              <a:rPr lang="en-US" b="0"/>
+              <a:t>‹#›</a:t>
             </a:fld>
             <a:endParaRPr lang="en-US"/>
           </a:p>
@@ -2492,7 +2309,7 @@
           <a:bodyPr wrap="square" lIns="0" tIns="0" rIns="0" bIns="0" rtlCol="0" anchor="t"/>
           <a:lstStyle/>
           <a:p>
-            <a:pPr indent="0" marL="0">
+            <a:pPr marL="0" indent="0">
               <a:buNone/>
             </a:pPr>
             <a:r>
@@ -2531,7 +2348,7 @@
           <a:bodyPr wrap="square" lIns="0" tIns="0" rIns="0" bIns="0" rtlCol="0" anchor="t"/>
           <a:lstStyle/>
           <a:p>
-            <a:pPr indent="0" marL="0">
+            <a:pPr marL="0" indent="0">
               <a:buNone/>
             </a:pPr>
             <a:r>
@@ -2570,7 +2387,7 @@
           <a:bodyPr wrap="square" lIns="0" tIns="0" rIns="0" bIns="0" rtlCol="0" anchor="t"/>
           <a:lstStyle/>
           <a:p>
-            <a:pPr indent="0" marL="0">
+            <a:pPr marL="0" indent="0">
               <a:buNone/>
             </a:pPr>
             <a:r>
@@ -2609,7 +2426,7 @@
           <a:bodyPr wrap="square" lIns="0" tIns="0" rIns="0" bIns="0" rtlCol="0" anchor="t"/>
           <a:lstStyle/>
           <a:p>
-            <a:pPr indent="0" marL="0">
+            <a:pPr marL="0" indent="0">
               <a:buNone/>
             </a:pPr>
             <a:r>
@@ -2648,7 +2465,7 @@
           <a:bodyPr wrap="square" lIns="0" tIns="0" rIns="0" bIns="0" rtlCol="0" anchor="t"/>
           <a:lstStyle/>
           <a:p>
-            <a:pPr indent="0" marL="0">
+            <a:pPr marL="0" indent="0">
               <a:buNone/>
             </a:pPr>
             <a:r>
@@ -2687,7 +2504,7 @@
           <a:bodyPr wrap="square" lIns="0" tIns="0" rIns="0" bIns="0" rtlCol="0" anchor="t"/>
           <a:lstStyle/>
           <a:p>
-            <a:pPr indent="0" marL="0">
+            <a:pPr marL="0" indent="0">
               <a:buNone/>
             </a:pPr>
             <a:r>
@@ -2726,7 +2543,7 @@
           <a:bodyPr wrap="square" lIns="0" tIns="0" rIns="0" bIns="0" rtlCol="0" anchor="t"/>
           <a:lstStyle/>
           <a:p>
-            <a:pPr indent="0" marL="0">
+            <a:pPr marL="0" indent="0">
               <a:buNone/>
             </a:pPr>
             <a:r>
@@ -2765,7 +2582,7 @@
           <a:bodyPr wrap="square" lIns="0" tIns="0" rIns="0" bIns="0" rtlCol="0" anchor="t"/>
           <a:lstStyle/>
           <a:p>
-            <a:pPr indent="0" marL="0">
+            <a:pPr marL="0" indent="0">
               <a:buNone/>
             </a:pPr>
             <a:r>
@@ -2804,7 +2621,7 @@
           <a:bodyPr wrap="square" lIns="0" tIns="0" rIns="0" bIns="0" rtlCol="0" anchor="t"/>
           <a:lstStyle/>
           <a:p>
-            <a:pPr indent="0" marL="0">
+            <a:pPr marL="0" indent="0">
               <a:buNone/>
             </a:pPr>
             <a:r>
@@ -2843,7 +2660,7 @@
           <a:bodyPr wrap="square" lIns="0" tIns="0" rIns="0" bIns="0" rtlCol="0" anchor="t"/>
           <a:lstStyle/>
           <a:p>
-            <a:pPr indent="0" marL="0">
+            <a:pPr marL="0" indent="0">
               <a:buNone/>
             </a:pPr>
             <a:r>
@@ -2855,39 +2672,9 @@
                 <a:ea typeface="Times New Roman" pitchFamily="34" charset="-122"/>
                 <a:cs typeface="Times New Roman" pitchFamily="34" charset="-120"/>
               </a:rPr>
-              <a:t>Supratik Bhowal  ·  with Apart Research</a:t>
+              <a:t>Supratik Bhowal  ·  Apart Research</a:t>
             </a:r>
             <a:endParaRPr lang="en-US" sz="1500" dirty="0"/>
-          </a:p>
-        </p:txBody>
-      </p:sp>
-      <p:sp>
-        <p:nvSpPr>
-          <p:cNvPr id="13" name="Text 2"/>
-          <p:cNvSpPr/>
-          <p:nvPr>
-            <p:ph idx="102" type="title" hasCustomPrompt="1"/>
-          </p:nvPr>
-        </p:nvSpPr>
-        <p:spPr>
-          <a:xfrm>
-            <a:off x="548640" y="320040"/>
-            <a:ext cx="11064240" cy="822960"/>
-          </a:xfrm>
-          <a:prstGeom prst="rect">
-            <a:avLst/>
-          </a:prstGeom>
-          <a:noFill/>
-          <a:ln/>
-        </p:spPr>
-        <p:txBody>
-          <a:bodyPr wrap="square" rtlCol="0" anchor="ctr"/>
-          <a:lstStyle/>
-          <a:p>
-            <a:pPr algn="l" indent="0" marL="0">
-              <a:buNone/>
-            </a:pPr>
-            <a:endParaRPr lang="en-US" sz="3000" dirty="0"/>
           </a:p>
         </p:txBody>
       </p:sp>
@@ -2911,7 +2698,7 @@
           </a:prstGeom>
           <a:extLst>
             <a:ext uri="{C572A759-6A51-4108-AA02-DFA0A04FC94B}">
-              <ma14:wrappingTextBoxFlag xmlns:ma14="http://schemas.microsoft.com/office/mac/drawingml/2011/main" val="0"/>
+              <ma14:wrappingTextBoxFlag xmlns:ma14="http://schemas.microsoft.com/office/mac/drawingml/2011/main" xmlns="" val="0"/>
             </a:ext>
           </a:extLst>
         </p:spPr>
@@ -2932,7 +2719,7 @@
           <a:p>
             <a:pPr algn="l"/>
             <a:fld id="{F7021451-1387-4CA6-816F-3879F97B5CBC}" type="slidenum">
-              <a:rPr b="0" lang="en-US"/>
+              <a:rPr lang="en-US" b="0"/>
               <a:t>1</a:t>
             </a:fld>
             <a:endParaRPr lang="en-US"/>
@@ -2967,9 +2754,11 @@
       <p:sp>
         <p:nvSpPr>
           <p:cNvPr id="2" name="Text 3"/>
-          <p:cNvSpPr/>
+          <p:cNvSpPr>
+            <a:spLocks noGrp="1"/>
+          </p:cNvSpPr>
           <p:nvPr>
-            <p:ph idx="103" type="title" hasCustomPrompt="1"/>
+            <p:ph type="title" idx="103" hasCustomPrompt="1"/>
           </p:nvPr>
         </p:nvSpPr>
         <p:spPr>
@@ -2987,7 +2776,7 @@
           <a:bodyPr wrap="square" rtlCol="0" anchor="ctr"/>
           <a:lstStyle/>
           <a:p>
-            <a:pPr algn="l" indent="0" marL="0">
+            <a:pPr marL="0" indent="0" algn="l">
               <a:buNone/>
             </a:pPr>
             <a:r>
@@ -3031,7 +2820,7 @@
             <a:prstDash val="solid"/>
           </a:ln>
           <a:effectLst>
-            <a:outerShdw sx="100000" sy="100000" kx="0" ky="0" algn="bl" rotWithShape="0" blurRad="76200" dist="25400" dir="5400000">
+            <a:outerShdw blurRad="76200" dist="25400" dir="5400000" algn="bl" rotWithShape="0">
               <a:srgbClr val="BFB3A0">
                 <a:alpha val="25000"/>
               </a:srgbClr>
@@ -3060,7 +2849,7 @@
           <a:bodyPr wrap="square" lIns="0" tIns="0" rIns="0" bIns="0" rtlCol="0" anchor="t"/>
           <a:lstStyle/>
           <a:p>
-            <a:pPr indent="0" marL="0">
+            <a:pPr marL="0" indent="0">
               <a:buNone/>
             </a:pPr>
             <a:r>
@@ -3210,7 +2999,7 @@
             <a:prstDash val="solid"/>
           </a:ln>
           <a:effectLst>
-            <a:outerShdw sx="100000" sy="100000" kx="0" ky="0" algn="bl" rotWithShape="0" blurRad="76200" dist="25400" dir="5400000">
+            <a:outerShdw blurRad="76200" dist="25400" dir="5400000" algn="bl" rotWithShape="0">
               <a:srgbClr val="BFB3A0">
                 <a:alpha val="25000"/>
               </a:srgbClr>
@@ -3239,7 +3028,7 @@
           <a:bodyPr wrap="square" lIns="0" tIns="0" rIns="0" bIns="0" rtlCol="0" anchor="t"/>
           <a:lstStyle/>
           <a:p>
-            <a:pPr indent="0" marL="0">
+            <a:pPr marL="0" indent="0">
               <a:buNone/>
             </a:pPr>
             <a:r>
@@ -3363,7 +3152,7 @@
           <a:bodyPr wrap="square" lIns="0" tIns="0" rIns="0" bIns="0" rtlCol="0" anchor="t"/>
           <a:lstStyle/>
           <a:p>
-            <a:pPr indent="0" marL="0">
+            <a:pPr marL="0" indent="0">
               <a:buNone/>
             </a:pPr>
             <a:r>
@@ -3402,7 +3191,7 @@
           <a:bodyPr wrap="square" lIns="0" tIns="0" rIns="0" bIns="0" rtlCol="0" anchor="t"/>
           <a:lstStyle/>
           <a:p>
-            <a:pPr indent="0" marL="0">
+            <a:pPr marL="0" indent="0">
               <a:buNone/>
             </a:pPr>
             <a:r>
@@ -3413,7 +3202,7 @@
                 <a:latin typeface="Times New Roman" pitchFamily="34" charset="0"/>
                 <a:ea typeface="Times New Roman" pitchFamily="34" charset="-122"/>
                 <a:cs typeface="Times New Roman" pitchFamily="34" charset="-120"/>
-                <a:hlinkClick r:id="rId1" invalidUrl="" action="" tgtFrame="" tooltip="" history="1" highlightClick="0" endSnd="0">
+                <a:hlinkClick r:id="rId3">
                   <a:extLst>
                     <a:ext uri="{A12FA001-AC4F-418D-AE19-62706E023703}">
                       <ahyp:hlinkClr xmlns:ahyp="http://schemas.microsoft.com/office/drawing/2018/hyperlinkcolor" val="tx"/>
@@ -3447,7 +3236,7 @@
           </a:prstGeom>
           <a:extLst>
             <a:ext uri="{C572A759-6A51-4108-AA02-DFA0A04FC94B}">
-              <ma14:wrappingTextBoxFlag xmlns:ma14="http://schemas.microsoft.com/office/mac/drawingml/2011/main" val="0"/>
+              <ma14:wrappingTextBoxFlag xmlns:ma14="http://schemas.microsoft.com/office/mac/drawingml/2011/main" xmlns="" val="0"/>
             </a:ext>
           </a:extLst>
         </p:spPr>
@@ -3468,7 +3257,7 @@
           <a:p>
             <a:pPr algn="l"/>
             <a:fld id="{F7021451-1387-4CA6-816F-3879F97B5CBC}" type="slidenum">
-              <a:rPr b="0" lang="en-US"/>
+              <a:rPr lang="en-US" b="0"/>
               <a:t>10</a:t>
             </a:fld>
             <a:endParaRPr lang="en-US"/>
@@ -3503,9 +3292,11 @@
       <p:sp>
         <p:nvSpPr>
           <p:cNvPr id="2" name="Text 3"/>
-          <p:cNvSpPr/>
+          <p:cNvSpPr>
+            <a:spLocks noGrp="1"/>
+          </p:cNvSpPr>
           <p:nvPr>
-            <p:ph idx="103" type="title" hasCustomPrompt="1"/>
+            <p:ph type="title" idx="103" hasCustomPrompt="1"/>
           </p:nvPr>
         </p:nvSpPr>
         <p:spPr>
@@ -3523,7 +3314,7 @@
           <a:bodyPr wrap="square" rtlCol="0" anchor="ctr"/>
           <a:lstStyle/>
           <a:p>
-            <a:pPr algn="l" indent="0" marL="0">
+            <a:pPr marL="0" indent="0" algn="l">
               <a:buNone/>
             </a:pPr>
             <a:r>
@@ -3562,7 +3353,7 @@
           <a:bodyPr wrap="square" lIns="0" tIns="0" rIns="0" bIns="0" rtlCol="0" anchor="t"/>
           <a:lstStyle/>
           <a:p>
-            <a:pPr indent="0" marL="0">
+            <a:pPr marL="0" indent="0">
               <a:buNone/>
             </a:pPr>
             <a:r>
@@ -3579,7 +3370,7 @@
             <a:endParaRPr lang="en-US" sz="1800" dirty="0"/>
           </a:p>
           <a:p>
-            <a:pPr indent="0" marL="0">
+            <a:pPr marL="0" indent="0">
               <a:buNone/>
             </a:pPr>
             <a:r>
@@ -3596,7 +3387,7 @@
             <a:endParaRPr lang="en-US" sz="1800" dirty="0"/>
           </a:p>
           <a:p>
-            <a:pPr indent="0" marL="0">
+            <a:pPr marL="0" indent="0">
               <a:buNone/>
             </a:pPr>
             <a:r>
@@ -3613,7 +3404,7 @@
             <a:endParaRPr lang="en-US" sz="1800" dirty="0"/>
           </a:p>
           <a:p>
-            <a:pPr indent="0" marL="0">
+            <a:pPr marL="0" indent="0">
               <a:buNone/>
             </a:pPr>
             <a:r>
@@ -3630,7 +3421,7 @@
             <a:endParaRPr lang="en-US" sz="1800" dirty="0"/>
           </a:p>
           <a:p>
-            <a:pPr indent="0" marL="0">
+            <a:pPr marL="0" indent="0">
               <a:buNone/>
             </a:pPr>
             <a:r>
@@ -3674,7 +3465,7 @@
             <a:prstDash val="solid"/>
           </a:ln>
           <a:effectLst>
-            <a:outerShdw sx="100000" sy="100000" kx="0" ky="0" algn="bl" rotWithShape="0" blurRad="76200" dist="25400" dir="5400000">
+            <a:outerShdw blurRad="76200" dist="25400" dir="5400000" algn="bl" rotWithShape="0">
               <a:srgbClr val="BFB3A0">
                 <a:alpha val="25000"/>
               </a:srgbClr>
@@ -3728,7 +3519,7 @@
           <a:bodyPr wrap="square" lIns="0" tIns="0" rIns="0" bIns="0" rtlCol="0" anchor="ctr"/>
           <a:lstStyle/>
           <a:p>
-            <a:pPr algn="ctr" indent="0" marL="0">
+            <a:pPr marL="0" indent="0" algn="ctr">
               <a:buNone/>
             </a:pPr>
             <a:r>
@@ -3767,7 +3558,7 @@
           <a:bodyPr wrap="square" lIns="0" tIns="0" rIns="0" bIns="0" rtlCol="0" anchor="t"/>
           <a:lstStyle/>
           <a:p>
-            <a:pPr indent="0" marL="0">
+            <a:pPr marL="0" indent="0">
               <a:buNone/>
             </a:pPr>
             <a:r>
@@ -3806,7 +3597,7 @@
           <a:bodyPr wrap="square" lIns="0" tIns="0" rIns="0" bIns="0" rtlCol="0" anchor="t"/>
           <a:lstStyle/>
           <a:p>
-            <a:pPr indent="0" marL="0">
+            <a:pPr marL="0" indent="0">
               <a:buNone/>
             </a:pPr>
             <a:r>
@@ -3850,7 +3641,7 @@
             <a:prstDash val="solid"/>
           </a:ln>
           <a:effectLst>
-            <a:outerShdw sx="100000" sy="100000" kx="0" ky="0" algn="bl" rotWithShape="0" blurRad="76200" dist="25400" dir="5400000">
+            <a:outerShdw blurRad="76200" dist="25400" dir="5400000" algn="bl" rotWithShape="0">
               <a:srgbClr val="BFB3A0">
                 <a:alpha val="25000"/>
               </a:srgbClr>
@@ -3904,7 +3695,7 @@
           <a:bodyPr wrap="square" lIns="0" tIns="0" rIns="0" bIns="0" rtlCol="0" anchor="ctr"/>
           <a:lstStyle/>
           <a:p>
-            <a:pPr algn="ctr" indent="0" marL="0">
+            <a:pPr marL="0" indent="0" algn="ctr">
               <a:buNone/>
             </a:pPr>
             <a:r>
@@ -3943,7 +3734,7 @@
           <a:bodyPr wrap="square" lIns="0" tIns="0" rIns="0" bIns="0" rtlCol="0" anchor="t"/>
           <a:lstStyle/>
           <a:p>
-            <a:pPr indent="0" marL="0">
+            <a:pPr marL="0" indent="0">
               <a:buNone/>
             </a:pPr>
             <a:r>
@@ -3982,7 +3773,7 @@
           <a:bodyPr wrap="square" lIns="0" tIns="0" rIns="0" bIns="0" rtlCol="0" anchor="t"/>
           <a:lstStyle/>
           <a:p>
-            <a:pPr indent="0" marL="0">
+            <a:pPr marL="0" indent="0">
               <a:buNone/>
             </a:pPr>
             <a:r>
@@ -4026,7 +3817,7 @@
             <a:prstDash val="solid"/>
           </a:ln>
           <a:effectLst>
-            <a:outerShdw sx="100000" sy="100000" kx="0" ky="0" algn="bl" rotWithShape="0" blurRad="76200" dist="25400" dir="5400000">
+            <a:outerShdw blurRad="76200" dist="25400" dir="5400000" algn="bl" rotWithShape="0">
               <a:srgbClr val="BFB3A0">
                 <a:alpha val="25000"/>
               </a:srgbClr>
@@ -4080,7 +3871,7 @@
           <a:bodyPr wrap="square" lIns="0" tIns="0" rIns="0" bIns="0" rtlCol="0" anchor="ctr"/>
           <a:lstStyle/>
           <a:p>
-            <a:pPr algn="ctr" indent="0" marL="0">
+            <a:pPr marL="0" indent="0" algn="ctr">
               <a:buNone/>
             </a:pPr>
             <a:r>
@@ -4119,7 +3910,7 @@
           <a:bodyPr wrap="square" lIns="0" tIns="0" rIns="0" bIns="0" rtlCol="0" anchor="t"/>
           <a:lstStyle/>
           <a:p>
-            <a:pPr indent="0" marL="0">
+            <a:pPr marL="0" indent="0">
               <a:buNone/>
             </a:pPr>
             <a:r>
@@ -4158,7 +3949,7 @@
           <a:bodyPr wrap="square" lIns="0" tIns="0" rIns="0" bIns="0" rtlCol="0" anchor="t"/>
           <a:lstStyle/>
           <a:p>
-            <a:pPr indent="0" marL="0">
+            <a:pPr marL="0" indent="0">
               <a:buNone/>
             </a:pPr>
             <a:r>
@@ -4196,7 +3987,7 @@
           </a:prstGeom>
           <a:extLst>
             <a:ext uri="{C572A759-6A51-4108-AA02-DFA0A04FC94B}">
-              <ma14:wrappingTextBoxFlag xmlns:ma14="http://schemas.microsoft.com/office/mac/drawingml/2011/main" val="0"/>
+              <ma14:wrappingTextBoxFlag xmlns:ma14="http://schemas.microsoft.com/office/mac/drawingml/2011/main" xmlns="" val="0"/>
             </a:ext>
           </a:extLst>
         </p:spPr>
@@ -4217,7 +4008,7 @@
           <a:p>
             <a:pPr algn="l"/>
             <a:fld id="{F7021451-1387-4CA6-816F-3879F97B5CBC}" type="slidenum">
-              <a:rPr b="0" lang="en-US"/>
+              <a:rPr lang="en-US" b="0"/>
               <a:t>2</a:t>
             </a:fld>
             <a:endParaRPr lang="en-US"/>
@@ -4252,9 +4043,11 @@
       <p:sp>
         <p:nvSpPr>
           <p:cNvPr id="2" name="Text 3"/>
-          <p:cNvSpPr/>
+          <p:cNvSpPr>
+            <a:spLocks noGrp="1"/>
+          </p:cNvSpPr>
           <p:nvPr>
-            <p:ph idx="103" type="title" hasCustomPrompt="1"/>
+            <p:ph type="title" idx="103" hasCustomPrompt="1"/>
           </p:nvPr>
         </p:nvSpPr>
         <p:spPr>
@@ -4272,7 +4065,7 @@
           <a:bodyPr wrap="square" rtlCol="0" anchor="ctr"/>
           <a:lstStyle/>
           <a:p>
-            <a:pPr algn="l" indent="0" marL="0">
+            <a:pPr marL="0" indent="0" algn="l">
               <a:buNone/>
             </a:pPr>
             <a:r>
@@ -4311,7 +4104,7 @@
           <a:bodyPr wrap="square" lIns="0" tIns="0" rIns="0" bIns="0" rtlCol="0" anchor="t"/>
           <a:lstStyle/>
           <a:p>
-            <a:pPr indent="0" marL="0">
+            <a:pPr marL="0" indent="0">
               <a:spcAft>
                 <a:spcPts val="600"/>
               </a:spcAft>
@@ -4328,14 +4121,28 @@
               </a:rPr>
               <a:t>Market: </a:t>
             </a:r>
-            <a:pPr indent="0" marL="0">
+            <a:r>
+              <a:rPr lang="en-US" sz="1800" dirty="0">
+                <a:solidFill>
+                  <a:srgbClr val="2F3B55"/>
+                </a:solidFill>
+                <a:latin typeface="Times New Roman" pitchFamily="34" charset="0"/>
+                <a:ea typeface="Times New Roman" pitchFamily="34" charset="-122"/>
+                <a:cs typeface="Times New Roman" pitchFamily="34" charset="-120"/>
+              </a:rPr>
+              <a:t>two firms sell similar products; buyers choose by price (logit Bertrand duopoly, Calvano et al. 2020).</a:t>
+            </a:r>
+            <a:endParaRPr lang="en-US" sz="1800" dirty="0"/>
+          </a:p>
+          <a:p>
+            <a:pPr marL="0" indent="0">
               <a:spcAft>
                 <a:spcPts val="600"/>
               </a:spcAft>
               <a:buNone/>
             </a:pPr>
             <a:r>
-              <a:rPr lang="en-US" sz="1800" dirty="0">
+              <a:rPr lang="en-US" sz="800" dirty="0">
                 <a:solidFill>
                   <a:srgbClr val="2F3B55"/>
                 </a:solidFill>
@@ -4343,19 +4150,19 @@
                 <a:ea typeface="Times New Roman" pitchFamily="34" charset="-122"/>
                 <a:cs typeface="Times New Roman" pitchFamily="34" charset="-120"/>
               </a:rPr>
-              <a:t>two firms sell similar products; buyers choose by price (logit Bertrand duopoly, Calvano et al. 2020).</a:t>
+              <a:t> </a:t>
             </a:r>
             <a:endParaRPr lang="en-US" sz="1800" dirty="0"/>
           </a:p>
           <a:p>
-            <a:pPr indent="0" marL="0">
+            <a:pPr marL="0" indent="0">
               <a:spcAft>
                 <a:spcPts val="600"/>
               </a:spcAft>
               <a:buNone/>
             </a:pPr>
             <a:r>
-              <a:rPr lang="en-US" sz="800" dirty="0">
+              <a:rPr lang="en-US" sz="1800" b="1" dirty="0">
                 <a:solidFill>
                   <a:srgbClr val="2F3B55"/>
                 </a:solidFill>
@@ -4363,19 +4170,30 @@
                 <a:ea typeface="Times New Roman" pitchFamily="34" charset="-122"/>
                 <a:cs typeface="Times New Roman" pitchFamily="34" charset="-120"/>
               </a:rPr>
-              <a:t> </a:t>
+              <a:t>Agents: </a:t>
+            </a:r>
+            <a:r>
+              <a:rPr lang="en-US" sz="1800" dirty="0">
+                <a:solidFill>
+                  <a:srgbClr val="2F3B55"/>
+                </a:solidFill>
+                <a:latin typeface="Times New Roman" pitchFamily="34" charset="0"/>
+                <a:ea typeface="Times New Roman" pitchFamily="34" charset="-122"/>
+                <a:cs typeface="Times New Roman" pitchFamily="34" charset="-120"/>
+              </a:rPr>
+              <a:t>each firm is an open LLM. Each round it sees the rules, its last 30 rounds and its notes, and answers with a price and new notes. The prompt never mentions collusion.</a:t>
             </a:r>
             <a:endParaRPr lang="en-US" sz="1800" dirty="0"/>
           </a:p>
           <a:p>
-            <a:pPr indent="0" marL="0">
+            <a:pPr marL="0" indent="0">
               <a:spcAft>
                 <a:spcPts val="600"/>
               </a:spcAft>
               <a:buNone/>
             </a:pPr>
             <a:r>
-              <a:rPr lang="en-US" sz="1800" b="1" dirty="0">
+              <a:rPr lang="en-US" sz="800" dirty="0">
                 <a:solidFill>
                   <a:srgbClr val="2F3B55"/>
                 </a:solidFill>
@@ -4383,16 +4201,19 @@
                 <a:ea typeface="Times New Roman" pitchFamily="34" charset="-122"/>
                 <a:cs typeface="Times New Roman" pitchFamily="34" charset="-120"/>
               </a:rPr>
-              <a:t>Agents: </a:t>
-            </a:r>
-            <a:pPr indent="0" marL="0">
+              <a:t> </a:t>
+            </a:r>
+            <a:endParaRPr lang="en-US" sz="1800" dirty="0"/>
+          </a:p>
+          <a:p>
+            <a:pPr marL="0" indent="0">
               <a:spcAft>
                 <a:spcPts val="600"/>
               </a:spcAft>
               <a:buNone/>
             </a:pPr>
             <a:r>
-              <a:rPr lang="en-US" sz="1800" dirty="0">
+              <a:rPr lang="en-US" sz="1800" b="1" dirty="0">
                 <a:solidFill>
                   <a:srgbClr val="2F3B55"/>
                 </a:solidFill>
@@ -4400,54 +4221,8 @@
                 <a:ea typeface="Times New Roman" pitchFamily="34" charset="-122"/>
                 <a:cs typeface="Times New Roman" pitchFamily="34" charset="-120"/>
               </a:rPr>
-              <a:t>each firm is an open LLM. Each round it sees the rules, its last 30 rounds and its notes, and answers with a price and new notes. The prompt never mentions collusion.</a:t>
-            </a:r>
-            <a:endParaRPr lang="en-US" sz="1800" dirty="0"/>
-          </a:p>
-          <a:p>
-            <a:pPr indent="0" marL="0">
-              <a:spcAft>
-                <a:spcPts val="600"/>
-              </a:spcAft>
-              <a:buNone/>
-            </a:pPr>
-            <a:r>
-              <a:rPr lang="en-US" sz="800" dirty="0">
-                <a:solidFill>
-                  <a:srgbClr val="2F3B55"/>
-                </a:solidFill>
-                <a:latin typeface="Times New Roman" pitchFamily="34" charset="0"/>
-                <a:ea typeface="Times New Roman" pitchFamily="34" charset="-122"/>
-                <a:cs typeface="Times New Roman" pitchFamily="34" charset="-120"/>
-              </a:rPr>
-              <a:t> </a:t>
-            </a:r>
-            <a:endParaRPr lang="en-US" sz="1800" dirty="0"/>
-          </a:p>
-          <a:p>
-            <a:pPr indent="0" marL="0">
-              <a:spcAft>
-                <a:spcPts val="600"/>
-              </a:spcAft>
-              <a:buNone/>
-            </a:pPr>
-            <a:r>
-              <a:rPr lang="en-US" sz="1800" b="1" dirty="0">
-                <a:solidFill>
-                  <a:srgbClr val="2F3B55"/>
-                </a:solidFill>
-                <a:latin typeface="Times New Roman" pitchFamily="34" charset="0"/>
-                <a:ea typeface="Times New Roman" pitchFamily="34" charset="-122"/>
-                <a:cs typeface="Times New Roman" pitchFamily="34" charset="-120"/>
-              </a:rPr>
               <a:t>Models: </a:t>
             </a:r>
-            <a:pPr indent="0" marL="0">
-              <a:spcAft>
-                <a:spcPts val="600"/>
-              </a:spcAft>
-              <a:buNone/>
-            </a:pPr>
             <a:r>
               <a:rPr lang="en-US" sz="1800" dirty="0">
                 <a:solidFill>
@@ -4489,7 +4264,7 @@
             <a:prstDash val="solid"/>
           </a:ln>
           <a:effectLst>
-            <a:outerShdw sx="100000" sy="100000" kx="0" ky="0" algn="bl" rotWithShape="0" blurRad="76200" dist="25400" dir="5400000">
+            <a:outerShdw blurRad="76200" dist="25400" dir="5400000" algn="bl" rotWithShape="0">
               <a:srgbClr val="BFB3A0">
                 <a:alpha val="25000"/>
               </a:srgbClr>
@@ -4518,7 +4293,7 @@
           <a:bodyPr wrap="square" lIns="0" tIns="0" rIns="0" bIns="0" rtlCol="0" anchor="t"/>
           <a:lstStyle/>
           <a:p>
-            <a:pPr indent="0" marL="0">
+            <a:pPr marL="0" indent="0">
               <a:buNone/>
             </a:pPr>
             <a:r>
@@ -4632,7 +4407,7 @@
           <a:bodyPr wrap="square" lIns="0" tIns="0" rIns="0" bIns="0" rtlCol="0" anchor="t"/>
           <a:lstStyle/>
           <a:p>
-            <a:pPr indent="0" marL="0">
+            <a:pPr marL="0" indent="0">
               <a:buNone/>
             </a:pPr>
             <a:r>
@@ -4649,7 +4424,7 @@
             <a:endParaRPr lang="en-US" sz="1400" dirty="0"/>
           </a:p>
           <a:p>
-            <a:pPr indent="0" marL="0">
+            <a:pPr marL="0" indent="0">
               <a:buNone/>
             </a:pPr>
             <a:r>
@@ -4688,7 +4463,7 @@
           <a:bodyPr wrap="square" lIns="0" tIns="0" rIns="0" bIns="0" rtlCol="0" anchor="t"/>
           <a:lstStyle/>
           <a:p>
-            <a:pPr algn="r" indent="0" marL="0">
+            <a:pPr marL="0" indent="0" algn="r">
               <a:buNone/>
             </a:pPr>
             <a:r>
@@ -4705,7 +4480,7 @@
             <a:endParaRPr lang="en-US" sz="1400" dirty="0"/>
           </a:p>
           <a:p>
-            <a:pPr algn="r" indent="0" marL="0">
+            <a:pPr marL="0" indent="0" algn="r">
               <a:buNone/>
             </a:pPr>
             <a:r>
@@ -4744,7 +4519,7 @@
           <a:bodyPr wrap="square" lIns="0" tIns="0" rIns="0" bIns="0" rtlCol="0" anchor="t"/>
           <a:lstStyle/>
           <a:p>
-            <a:pPr indent="0" marL="0">
+            <a:pPr marL="0" indent="0">
               <a:buNone/>
             </a:pPr>
             <a:r>
@@ -4782,7 +4557,7 @@
           </a:prstGeom>
           <a:extLst>
             <a:ext uri="{C572A759-6A51-4108-AA02-DFA0A04FC94B}">
-              <ma14:wrappingTextBoxFlag xmlns:ma14="http://schemas.microsoft.com/office/mac/drawingml/2011/main" val="0"/>
+              <ma14:wrappingTextBoxFlag xmlns:ma14="http://schemas.microsoft.com/office/mac/drawingml/2011/main" xmlns="" val="0"/>
             </a:ext>
           </a:extLst>
         </p:spPr>
@@ -4803,7 +4578,7 @@
           <a:p>
             <a:pPr algn="l"/>
             <a:fld id="{F7021451-1387-4CA6-816F-3879F97B5CBC}" type="slidenum">
-              <a:rPr b="0" lang="en-US"/>
+              <a:rPr lang="en-US" b="0"/>
               <a:t>3</a:t>
             </a:fld>
             <a:endParaRPr lang="en-US"/>
@@ -4838,9 +4613,11 @@
       <p:sp>
         <p:nvSpPr>
           <p:cNvPr id="2" name="Text 3"/>
-          <p:cNvSpPr/>
+          <p:cNvSpPr>
+            <a:spLocks noGrp="1"/>
+          </p:cNvSpPr>
           <p:nvPr>
-            <p:ph idx="103" type="title" hasCustomPrompt="1"/>
+            <p:ph type="title" idx="103" hasCustomPrompt="1"/>
           </p:nvPr>
         </p:nvSpPr>
         <p:spPr>
@@ -4858,7 +4635,7 @@
           <a:bodyPr wrap="square" rtlCol="0" anchor="ctr"/>
           <a:lstStyle/>
           <a:p>
-            <a:pPr algn="l" indent="0" marL="0">
+            <a:pPr marL="0" indent="0" algn="l">
               <a:buNone/>
             </a:pPr>
             <a:r>
@@ -4902,7 +4679,7 @@
             <a:prstDash val="solid"/>
           </a:ln>
           <a:effectLst>
-            <a:outerShdw sx="100000" sy="100000" kx="0" ky="0" algn="bl" rotWithShape="0" blurRad="76200" dist="25400" dir="5400000">
+            <a:outerShdw blurRad="76200" dist="25400" dir="5400000" algn="bl" rotWithShape="0">
               <a:srgbClr val="BFB3A0">
                 <a:alpha val="25000"/>
               </a:srgbClr>
@@ -4956,7 +4733,7 @@
           <a:bodyPr wrap="square" lIns="0" tIns="0" rIns="0" bIns="0" rtlCol="0" anchor="ctr"/>
           <a:lstStyle/>
           <a:p>
-            <a:pPr algn="ctr" indent="0" marL="0">
+            <a:pPr marL="0" indent="0" algn="ctr">
               <a:buNone/>
             </a:pPr>
             <a:r>
@@ -4995,7 +4772,7 @@
           <a:bodyPr wrap="square" lIns="0" tIns="0" rIns="0" bIns="0" rtlCol="0" anchor="t"/>
           <a:lstStyle/>
           <a:p>
-            <a:pPr indent="0" marL="0">
+            <a:pPr marL="0" indent="0">
               <a:buNone/>
             </a:pPr>
             <a:r>
@@ -5034,7 +4811,7 @@
           <a:bodyPr wrap="square" lIns="0" tIns="0" rIns="0" bIns="0" rtlCol="0" anchor="t"/>
           <a:lstStyle/>
           <a:p>
-            <a:pPr indent="0" marL="0">
+            <a:pPr marL="0" indent="0">
               <a:buNone/>
             </a:pPr>
             <a:r>
@@ -5078,7 +4855,7 @@
             <a:prstDash val="solid"/>
           </a:ln>
           <a:effectLst>
-            <a:outerShdw sx="100000" sy="100000" kx="0" ky="0" algn="bl" rotWithShape="0" blurRad="76200" dist="25400" dir="5400000">
+            <a:outerShdw blurRad="76200" dist="25400" dir="5400000" algn="bl" rotWithShape="0">
               <a:srgbClr val="BFB3A0">
                 <a:alpha val="25000"/>
               </a:srgbClr>
@@ -5132,7 +4909,7 @@
           <a:bodyPr wrap="square" lIns="0" tIns="0" rIns="0" bIns="0" rtlCol="0" anchor="ctr"/>
           <a:lstStyle/>
           <a:p>
-            <a:pPr algn="ctr" indent="0" marL="0">
+            <a:pPr marL="0" indent="0" algn="ctr">
               <a:buNone/>
             </a:pPr>
             <a:r>
@@ -5171,7 +4948,7 @@
           <a:bodyPr wrap="square" lIns="0" tIns="0" rIns="0" bIns="0" rtlCol="0" anchor="t"/>
           <a:lstStyle/>
           <a:p>
-            <a:pPr indent="0" marL="0">
+            <a:pPr marL="0" indent="0">
               <a:buNone/>
             </a:pPr>
             <a:r>
@@ -5210,7 +4987,7 @@
           <a:bodyPr wrap="square" lIns="0" tIns="0" rIns="0" bIns="0" rtlCol="0" anchor="t"/>
           <a:lstStyle/>
           <a:p>
-            <a:pPr indent="0" marL="0">
+            <a:pPr marL="0" indent="0">
               <a:buNone/>
             </a:pPr>
             <a:r>
@@ -5254,7 +5031,7 @@
             <a:prstDash val="solid"/>
           </a:ln>
           <a:effectLst>
-            <a:outerShdw sx="100000" sy="100000" kx="0" ky="0" algn="bl" rotWithShape="0" blurRad="76200" dist="25400" dir="5400000">
+            <a:outerShdw blurRad="76200" dist="25400" dir="5400000" algn="bl" rotWithShape="0">
               <a:srgbClr val="BFB3A0">
                 <a:alpha val="25000"/>
               </a:srgbClr>
@@ -5308,7 +5085,7 @@
           <a:bodyPr wrap="square" lIns="0" tIns="0" rIns="0" bIns="0" rtlCol="0" anchor="ctr"/>
           <a:lstStyle/>
           <a:p>
-            <a:pPr algn="ctr" indent="0" marL="0">
+            <a:pPr marL="0" indent="0" algn="ctr">
               <a:buNone/>
             </a:pPr>
             <a:r>
@@ -5347,7 +5124,7 @@
           <a:bodyPr wrap="square" lIns="0" tIns="0" rIns="0" bIns="0" rtlCol="0" anchor="t"/>
           <a:lstStyle/>
           <a:p>
-            <a:pPr indent="0" marL="0">
+            <a:pPr marL="0" indent="0">
               <a:buNone/>
             </a:pPr>
             <a:r>
@@ -5386,7 +5163,7 @@
           <a:bodyPr wrap="square" lIns="0" tIns="0" rIns="0" bIns="0" rtlCol="0" anchor="t"/>
           <a:lstStyle/>
           <a:p>
-            <a:pPr indent="0" marL="0">
+            <a:pPr marL="0" indent="0">
               <a:buNone/>
             </a:pPr>
             <a:r>
@@ -5430,7 +5207,7 @@
             <a:prstDash val="solid"/>
           </a:ln>
           <a:effectLst>
-            <a:outerShdw sx="100000" sy="100000" kx="0" ky="0" algn="bl" rotWithShape="0" blurRad="76200" dist="25400" dir="5400000">
+            <a:outerShdw blurRad="76200" dist="25400" dir="5400000" algn="bl" rotWithShape="0">
               <a:srgbClr val="BFB3A0">
                 <a:alpha val="25000"/>
               </a:srgbClr>
@@ -5484,7 +5261,7 @@
           <a:bodyPr wrap="square" lIns="0" tIns="0" rIns="0" bIns="0" rtlCol="0" anchor="ctr"/>
           <a:lstStyle/>
           <a:p>
-            <a:pPr algn="ctr" indent="0" marL="0">
+            <a:pPr marL="0" indent="0" algn="ctr">
               <a:buNone/>
             </a:pPr>
             <a:r>
@@ -5523,7 +5300,7 @@
           <a:bodyPr wrap="square" lIns="0" tIns="0" rIns="0" bIns="0" rtlCol="0" anchor="t"/>
           <a:lstStyle/>
           <a:p>
-            <a:pPr indent="0" marL="0">
+            <a:pPr marL="0" indent="0">
               <a:buNone/>
             </a:pPr>
             <a:r>
@@ -5562,7 +5339,7 @@
           <a:bodyPr wrap="square" lIns="0" tIns="0" rIns="0" bIns="0" rtlCol="0" anchor="t"/>
           <a:lstStyle/>
           <a:p>
-            <a:pPr indent="0" marL="0">
+            <a:pPr marL="0" indent="0">
               <a:buNone/>
             </a:pPr>
             <a:r>
@@ -5628,7 +5405,7 @@
           <a:bodyPr wrap="square" lIns="0" tIns="0" rIns="0" bIns="0" rtlCol="0" anchor="t"/>
           <a:lstStyle/>
           <a:p>
-            <a:pPr indent="0" marL="0">
+            <a:pPr marL="0" indent="0">
               <a:buNone/>
             </a:pPr>
             <a:r>
@@ -5667,7 +5444,7 @@
           <a:bodyPr wrap="square" lIns="0" tIns="0" rIns="0" bIns="0" rtlCol="0" anchor="t"/>
           <a:lstStyle/>
           <a:p>
-            <a:pPr indent="0" marL="0">
+            <a:pPr marL="0" indent="0">
               <a:buNone/>
             </a:pPr>
             <a:r>
@@ -5733,7 +5510,7 @@
           <a:bodyPr wrap="square" lIns="0" tIns="0" rIns="0" bIns="0" rtlCol="0" anchor="t"/>
           <a:lstStyle/>
           <a:p>
-            <a:pPr indent="0" marL="0">
+            <a:pPr marL="0" indent="0">
               <a:buNone/>
             </a:pPr>
             <a:r>
@@ -5772,7 +5549,7 @@
           <a:bodyPr wrap="square" lIns="0" tIns="0" rIns="0" bIns="0" rtlCol="0" anchor="t"/>
           <a:lstStyle/>
           <a:p>
-            <a:pPr indent="0" marL="0">
+            <a:pPr marL="0" indent="0">
               <a:buNone/>
             </a:pPr>
             <a:r>
@@ -5838,7 +5615,7 @@
           <a:bodyPr wrap="square" lIns="0" tIns="0" rIns="0" bIns="0" rtlCol="0" anchor="t"/>
           <a:lstStyle/>
           <a:p>
-            <a:pPr indent="0" marL="0">
+            <a:pPr marL="0" indent="0">
               <a:buNone/>
             </a:pPr>
             <a:r>
@@ -5877,7 +5654,7 @@
           <a:bodyPr wrap="square" lIns="0" tIns="0" rIns="0" bIns="0" rtlCol="0" anchor="t"/>
           <a:lstStyle/>
           <a:p>
-            <a:pPr indent="0" marL="0">
+            <a:pPr marL="0" indent="0">
               <a:buNone/>
             </a:pPr>
             <a:r>
@@ -5943,7 +5720,7 @@
           <a:bodyPr wrap="square" lIns="0" tIns="0" rIns="0" bIns="0" rtlCol="0" anchor="t"/>
           <a:lstStyle/>
           <a:p>
-            <a:pPr indent="0" marL="0">
+            <a:pPr marL="0" indent="0">
               <a:buNone/>
             </a:pPr>
             <a:r>
@@ -5982,7 +5759,7 @@
           <a:bodyPr wrap="square" lIns="0" tIns="0" rIns="0" bIns="0" rtlCol="0" anchor="t"/>
           <a:lstStyle/>
           <a:p>
-            <a:pPr indent="0" marL="0">
+            <a:pPr marL="0" indent="0">
               <a:buNone/>
             </a:pPr>
             <a:r>
@@ -6048,7 +5825,7 @@
           <a:bodyPr wrap="square" lIns="0" tIns="0" rIns="0" bIns="0" rtlCol="0" anchor="t"/>
           <a:lstStyle/>
           <a:p>
-            <a:pPr indent="0" marL="0">
+            <a:pPr marL="0" indent="0">
               <a:buNone/>
             </a:pPr>
             <a:r>
@@ -6087,7 +5864,7 @@
           <a:bodyPr wrap="square" lIns="0" tIns="0" rIns="0" bIns="0" rtlCol="0" anchor="t"/>
           <a:lstStyle/>
           <a:p>
-            <a:pPr indent="0" marL="0">
+            <a:pPr marL="0" indent="0">
               <a:buNone/>
             </a:pPr>
             <a:r>
@@ -6153,7 +5930,7 @@
           <a:bodyPr wrap="square" lIns="0" tIns="0" rIns="0" bIns="0" rtlCol="0" anchor="t"/>
           <a:lstStyle/>
           <a:p>
-            <a:pPr indent="0" marL="0">
+            <a:pPr marL="0" indent="0">
               <a:buNone/>
             </a:pPr>
             <a:r>
@@ -6192,7 +5969,7 @@
           <a:bodyPr wrap="square" lIns="0" tIns="0" rIns="0" bIns="0" rtlCol="0" anchor="t"/>
           <a:lstStyle/>
           <a:p>
-            <a:pPr indent="0" marL="0">
+            <a:pPr marL="0" indent="0">
               <a:buNone/>
             </a:pPr>
             <a:r>
@@ -6258,7 +6035,7 @@
           <a:bodyPr wrap="square" lIns="0" tIns="0" rIns="0" bIns="0" rtlCol="0" anchor="t"/>
           <a:lstStyle/>
           <a:p>
-            <a:pPr indent="0" marL="0">
+            <a:pPr marL="0" indent="0">
               <a:buNone/>
             </a:pPr>
             <a:r>
@@ -6297,7 +6074,7 @@
           <a:bodyPr wrap="square" lIns="0" tIns="0" rIns="0" bIns="0" rtlCol="0" anchor="t"/>
           <a:lstStyle/>
           <a:p>
-            <a:pPr indent="0" marL="0">
+            <a:pPr marL="0" indent="0">
               <a:buNone/>
             </a:pPr>
             <a:r>
@@ -6363,7 +6140,7 @@
           <a:bodyPr wrap="square" lIns="0" tIns="0" rIns="0" bIns="0" rtlCol="0" anchor="t"/>
           <a:lstStyle/>
           <a:p>
-            <a:pPr indent="0" marL="0">
+            <a:pPr marL="0" indent="0">
               <a:buNone/>
             </a:pPr>
             <a:r>
@@ -6402,7 +6179,7 @@
           <a:bodyPr wrap="square" lIns="0" tIns="0" rIns="0" bIns="0" rtlCol="0" anchor="t"/>
           <a:lstStyle/>
           <a:p>
-            <a:pPr indent="0" marL="0">
+            <a:pPr marL="0" indent="0">
               <a:buNone/>
             </a:pPr>
             <a:r>
@@ -6422,7 +6199,7 @@
       </p:sp>
       <p:sp>
         <p:nvSpPr>
-          <p:cNvPr id="25" name="Slide Number Placeholder 0"/>
+          <p:cNvPr id="47" name="Slide Number Placeholder 0"/>
           <p:cNvSpPr>
             <a:spLocks noGrp="1"/>
           </p:cNvSpPr>
@@ -6440,7 +6217,7 @@
           </a:prstGeom>
           <a:extLst>
             <a:ext uri="{C572A759-6A51-4108-AA02-DFA0A04FC94B}">
-              <ma14:wrappingTextBoxFlag xmlns:ma14="http://schemas.microsoft.com/office/mac/drawingml/2011/main" val="0"/>
+              <ma14:wrappingTextBoxFlag xmlns:ma14="http://schemas.microsoft.com/office/mac/drawingml/2011/main" xmlns="" val="0"/>
             </a:ext>
           </a:extLst>
         </p:spPr>
@@ -6461,7 +6238,7 @@
           <a:p>
             <a:pPr algn="l"/>
             <a:fld id="{F7021451-1387-4CA6-816F-3879F97B5CBC}" type="slidenum">
-              <a:rPr b="0" lang="en-US"/>
+              <a:rPr lang="en-US" b="0"/>
               <a:t>4</a:t>
             </a:fld>
             <a:endParaRPr lang="en-US"/>
@@ -6496,9 +6273,11 @@
       <p:sp>
         <p:nvSpPr>
           <p:cNvPr id="2" name="Text 3"/>
-          <p:cNvSpPr/>
+          <p:cNvSpPr>
+            <a:spLocks noGrp="1"/>
+          </p:cNvSpPr>
           <p:nvPr>
-            <p:ph idx="103" type="title" hasCustomPrompt="1"/>
+            <p:ph type="title" idx="103" hasCustomPrompt="1"/>
           </p:nvPr>
         </p:nvSpPr>
         <p:spPr>
@@ -6516,7 +6295,7 @@
           <a:bodyPr wrap="square" rtlCol="0" anchor="ctr"/>
           <a:lstStyle/>
           <a:p>
-            <a:pPr algn="l" indent="0" marL="0">
+            <a:pPr marL="0" indent="0" algn="l">
               <a:buNone/>
             </a:pPr>
             <a:r>
@@ -6536,7 +6315,7 @@
       </p:sp>
       <p:graphicFrame>
         <p:nvGraphicFramePr>
-          <p:cNvPr id="3" name="Chart 0" descr=""/>
+          <p:cNvPr id="3" name="Chart 0"/>
           <p:cNvGraphicFramePr/>
           <p:nvPr/>
         </p:nvGraphicFramePr>
@@ -6544,9 +6323,9 @@
           <a:off x="548640" y="1325880"/>
           <a:ext cx="6949440" cy="4846320"/>
         </p:xfrm>
-        <a:graphic xmlns:a="http://schemas.openxmlformats.org/drawingml/2006/main">
+        <a:graphic>
           <a:graphicData uri="http://schemas.openxmlformats.org/drawingml/2006/chart">
-            <c:chart xmlns:c="http://schemas.openxmlformats.org/drawingml/2006/chart" r:id="rId1"/>
+            <c:chart xmlns:c="http://schemas.openxmlformats.org/drawingml/2006/chart" xmlns:r="http://schemas.openxmlformats.org/officeDocument/2006/relationships" r:id="rId3"/>
           </a:graphicData>
         </a:graphic>
       </p:graphicFrame>
@@ -6576,7 +6355,7 @@
             <a:prstDash val="solid"/>
           </a:ln>
           <a:effectLst>
-            <a:outerShdw sx="100000" sy="100000" kx="0" ky="0" algn="bl" rotWithShape="0" blurRad="76200" dist="25400" dir="5400000">
+            <a:outerShdw blurRad="76200" dist="25400" dir="5400000" algn="bl" rotWithShape="0">
               <a:srgbClr val="BFB3A0">
                 <a:alpha val="25000"/>
               </a:srgbClr>
@@ -6605,7 +6384,7 @@
           <a:bodyPr wrap="square" lIns="0" tIns="0" rIns="0" bIns="0" rtlCol="0" anchor="t"/>
           <a:lstStyle/>
           <a:p>
-            <a:pPr indent="0" marL="0">
+            <a:pPr marL="0" indent="0">
               <a:buNone/>
             </a:pPr>
             <a:r>
@@ -6644,7 +6423,7 @@
           <a:bodyPr wrap="square" lIns="0" tIns="0" rIns="0" bIns="0" rtlCol="0" anchor="t"/>
           <a:lstStyle/>
           <a:p>
-            <a:pPr indent="0" marL="0">
+            <a:pPr marL="0" indent="0">
               <a:buNone/>
             </a:pPr>
             <a:r>
@@ -6688,7 +6467,7 @@
             <a:prstDash val="solid"/>
           </a:ln>
           <a:effectLst>
-            <a:outerShdw sx="100000" sy="100000" kx="0" ky="0" algn="bl" rotWithShape="0" blurRad="76200" dist="25400" dir="5400000">
+            <a:outerShdw blurRad="76200" dist="25400" dir="5400000" algn="bl" rotWithShape="0">
               <a:srgbClr val="BFB3A0">
                 <a:alpha val="25000"/>
               </a:srgbClr>
@@ -6717,7 +6496,7 @@
           <a:bodyPr wrap="square" lIns="0" tIns="0" rIns="0" bIns="0" rtlCol="0" anchor="t"/>
           <a:lstStyle/>
           <a:p>
-            <a:pPr indent="0" marL="0">
+            <a:pPr marL="0" indent="0">
               <a:buNone/>
             </a:pPr>
             <a:r>
@@ -6756,7 +6535,7 @@
           <a:bodyPr wrap="square" lIns="0" tIns="0" rIns="0" bIns="0" rtlCol="0" anchor="t"/>
           <a:lstStyle/>
           <a:p>
-            <a:pPr indent="0" marL="0">
+            <a:pPr marL="0" indent="0">
               <a:buNone/>
             </a:pPr>
             <a:r>
@@ -6794,7 +6573,7 @@
           </a:prstGeom>
           <a:extLst>
             <a:ext uri="{C572A759-6A51-4108-AA02-DFA0A04FC94B}">
-              <ma14:wrappingTextBoxFlag xmlns:ma14="http://schemas.microsoft.com/office/mac/drawingml/2011/main" val="0"/>
+              <ma14:wrappingTextBoxFlag xmlns:ma14="http://schemas.microsoft.com/office/mac/drawingml/2011/main" xmlns="" val="0"/>
             </a:ext>
           </a:extLst>
         </p:spPr>
@@ -6815,7 +6594,7 @@
           <a:p>
             <a:pPr algn="l"/>
             <a:fld id="{F7021451-1387-4CA6-816F-3879F97B5CBC}" type="slidenum">
-              <a:rPr b="0" lang="en-US"/>
+              <a:rPr lang="en-US" b="0"/>
               <a:t>5</a:t>
             </a:fld>
             <a:endParaRPr lang="en-US"/>
@@ -6850,9 +6629,11 @@
       <p:sp>
         <p:nvSpPr>
           <p:cNvPr id="2" name="Text 3"/>
-          <p:cNvSpPr/>
+          <p:cNvSpPr>
+            <a:spLocks noGrp="1"/>
+          </p:cNvSpPr>
           <p:nvPr>
-            <p:ph idx="103" type="title" hasCustomPrompt="1"/>
+            <p:ph type="title" idx="103" hasCustomPrompt="1"/>
           </p:nvPr>
         </p:nvSpPr>
         <p:spPr>
@@ -6870,7 +6651,7 @@
           <a:bodyPr wrap="square" rtlCol="0" anchor="ctr"/>
           <a:lstStyle/>
           <a:p>
-            <a:pPr algn="l" indent="0" marL="0">
+            <a:pPr marL="0" indent="0" algn="l">
               <a:buNone/>
             </a:pPr>
             <a:r>
@@ -6914,7 +6695,7 @@
             <a:prstDash val="solid"/>
           </a:ln>
           <a:effectLst>
-            <a:outerShdw sx="100000" sy="100000" kx="0" ky="0" algn="bl" rotWithShape="0" blurRad="76200" dist="25400" dir="5400000">
+            <a:outerShdw blurRad="76200" dist="25400" dir="5400000" algn="bl" rotWithShape="0">
               <a:srgbClr val="BFB3A0">
                 <a:alpha val="25000"/>
               </a:srgbClr>
@@ -6924,14 +6705,14 @@
       </p:sp>
       <p:pic>
         <p:nvPicPr>
-          <p:cNvPr id="4" name="Image 0" descr="/home/user/AI-Collusion-Research-Sprint/Apart Research/figures/fig_trajectories.png">    </p:cNvPr>
+          <p:cNvPr id="4" name="Image 0" descr="/home/user/AI-Collusion-Research-Sprint/Apart Research/figures/fig_trajectories.png"/>
           <p:cNvPicPr>
             <a:picLocks noChangeAspect="1"/>
           </p:cNvPicPr>
           <p:nvPr/>
         </p:nvPicPr>
         <p:blipFill>
-          <a:blip r:embed="rId1"/>
+          <a:blip r:embed="rId3"/>
           <a:stretch>
             <a:fillRect/>
           </a:stretch>
@@ -6967,7 +6748,7 @@
           <a:bodyPr wrap="square" lIns="0" tIns="0" rIns="0" bIns="0" rtlCol="0" anchor="t"/>
           <a:lstStyle/>
           <a:p>
-            <a:pPr indent="0" marL="0">
+            <a:pPr marL="0" indent="0">
               <a:buNone/>
             </a:pPr>
             <a:r>
@@ -7011,7 +6792,7 @@
             <a:prstDash val="solid"/>
           </a:ln>
           <a:effectLst>
-            <a:outerShdw sx="100000" sy="100000" kx="0" ky="0" algn="bl" rotWithShape="0" blurRad="76200" dist="25400" dir="5400000">
+            <a:outerShdw blurRad="76200" dist="25400" dir="5400000" algn="bl" rotWithShape="0">
               <a:srgbClr val="BFB3A0">
                 <a:alpha val="25000"/>
               </a:srgbClr>
@@ -7040,7 +6821,7 @@
           <a:bodyPr wrap="square" lIns="0" tIns="0" rIns="0" bIns="0" rtlCol="0" anchor="t"/>
           <a:lstStyle/>
           <a:p>
-            <a:pPr indent="0" marL="0">
+            <a:pPr marL="0" indent="0">
               <a:buNone/>
             </a:pPr>
             <a:r>
@@ -7079,7 +6860,7 @@
           <a:bodyPr wrap="square" lIns="0" tIns="0" rIns="0" bIns="0" rtlCol="0" anchor="t"/>
           <a:lstStyle/>
           <a:p>
-            <a:pPr indent="0" marL="0">
+            <a:pPr marL="0" indent="0">
               <a:buNone/>
             </a:pPr>
             <a:r>
@@ -7118,7 +6899,7 @@
           <a:bodyPr wrap="square" lIns="0" tIns="0" rIns="0" bIns="0" rtlCol="0" anchor="t"/>
           <a:lstStyle/>
           <a:p>
-            <a:pPr indent="0" marL="0">
+            <a:pPr marL="0" indent="0">
               <a:buNone/>
             </a:pPr>
             <a:r>
@@ -7157,7 +6938,7 @@
           <a:bodyPr wrap="square" lIns="0" tIns="0" rIns="0" bIns="0" rtlCol="0" anchor="t"/>
           <a:lstStyle/>
           <a:p>
-            <a:pPr indent="0" marL="0">
+            <a:pPr marL="0" indent="0">
               <a:buNone/>
             </a:pPr>
             <a:r>
@@ -7195,7 +6976,7 @@
           </a:prstGeom>
           <a:extLst>
             <a:ext uri="{C572A759-6A51-4108-AA02-DFA0A04FC94B}">
-              <ma14:wrappingTextBoxFlag xmlns:ma14="http://schemas.microsoft.com/office/mac/drawingml/2011/main" val="0"/>
+              <ma14:wrappingTextBoxFlag xmlns:ma14="http://schemas.microsoft.com/office/mac/drawingml/2011/main" xmlns="" val="0"/>
             </a:ext>
           </a:extLst>
         </p:spPr>
@@ -7216,7 +6997,7 @@
           <a:p>
             <a:pPr algn="l"/>
             <a:fld id="{F7021451-1387-4CA6-816F-3879F97B5CBC}" type="slidenum">
-              <a:rPr b="0" lang="en-US"/>
+              <a:rPr lang="en-US" b="0"/>
               <a:t>6</a:t>
             </a:fld>
             <a:endParaRPr lang="en-US"/>
@@ -7251,9 +7032,11 @@
       <p:sp>
         <p:nvSpPr>
           <p:cNvPr id="2" name="Text 3"/>
-          <p:cNvSpPr/>
+          <p:cNvSpPr>
+            <a:spLocks noGrp="1"/>
+          </p:cNvSpPr>
           <p:nvPr>
-            <p:ph idx="103" type="title" hasCustomPrompt="1"/>
+            <p:ph type="title" idx="103" hasCustomPrompt="1"/>
           </p:nvPr>
         </p:nvSpPr>
         <p:spPr>
@@ -7271,7 +7054,7 @@
           <a:bodyPr wrap="square" rtlCol="0" anchor="ctr"/>
           <a:lstStyle/>
           <a:p>
-            <a:pPr algn="l" indent="0" marL="0">
+            <a:pPr marL="0" indent="0" algn="l">
               <a:buNone/>
             </a:pPr>
             <a:r>
@@ -7315,7 +7098,7 @@
             <a:prstDash val="solid"/>
           </a:ln>
           <a:effectLst>
-            <a:outerShdw sx="100000" sy="100000" kx="0" ky="0" algn="bl" rotWithShape="0" blurRad="76200" dist="25400" dir="5400000">
+            <a:outerShdw blurRad="76200" dist="25400" dir="5400000" algn="bl" rotWithShape="0">
               <a:srgbClr val="BFB3A0">
                 <a:alpha val="25000"/>
               </a:srgbClr>
@@ -7344,7 +7127,7 @@
           <a:bodyPr wrap="square" lIns="0" tIns="0" rIns="0" bIns="0" rtlCol="0" anchor="t"/>
           <a:lstStyle/>
           <a:p>
-            <a:pPr indent="0" marL="0">
+            <a:pPr marL="0" indent="0">
               <a:buNone/>
             </a:pPr>
             <a:r>
@@ -7383,7 +7166,7 @@
           <a:bodyPr wrap="square" lIns="0" tIns="0" rIns="0" bIns="0" rtlCol="0" anchor="t"/>
           <a:lstStyle/>
           <a:p>
-            <a:pPr indent="0" marL="0">
+            <a:pPr marL="0" indent="0">
               <a:buNone/>
             </a:pPr>
             <a:r>
@@ -7422,7 +7205,7 @@
           <a:bodyPr wrap="square" lIns="0" tIns="0" rIns="0" bIns="0" rtlCol="0" anchor="t"/>
           <a:lstStyle/>
           <a:p>
-            <a:pPr indent="0" marL="0">
+            <a:pPr marL="0" indent="0">
               <a:buNone/>
             </a:pPr>
             <a:r>
@@ -7461,7 +7244,7 @@
           <a:bodyPr wrap="square" lIns="0" tIns="0" rIns="0" bIns="0" rtlCol="0" anchor="t"/>
           <a:lstStyle/>
           <a:p>
-            <a:pPr indent="0" marL="0">
+            <a:pPr marL="0" indent="0">
               <a:buNone/>
             </a:pPr>
             <a:r>
@@ -7505,7 +7288,7 @@
             <a:prstDash val="solid"/>
           </a:ln>
           <a:effectLst>
-            <a:outerShdw sx="100000" sy="100000" kx="0" ky="0" algn="bl" rotWithShape="0" blurRad="76200" dist="25400" dir="5400000">
+            <a:outerShdw blurRad="76200" dist="25400" dir="5400000" algn="bl" rotWithShape="0">
               <a:srgbClr val="BFB3A0">
                 <a:alpha val="25000"/>
               </a:srgbClr>
@@ -7534,7 +7317,7 @@
           <a:bodyPr wrap="square" lIns="0" tIns="0" rIns="0" bIns="0" rtlCol="0" anchor="t"/>
           <a:lstStyle/>
           <a:p>
-            <a:pPr indent="0" marL="0">
+            <a:pPr marL="0" indent="0">
               <a:buNone/>
             </a:pPr>
             <a:r>
@@ -7573,7 +7356,7 @@
           <a:bodyPr wrap="square" lIns="0" tIns="0" rIns="0" bIns="0" rtlCol="0" anchor="t"/>
           <a:lstStyle/>
           <a:p>
-            <a:pPr indent="0" marL="0">
+            <a:pPr marL="0" indent="0">
               <a:buNone/>
             </a:pPr>
             <a:r>
@@ -7612,7 +7395,7 @@
           <a:bodyPr wrap="square" lIns="0" tIns="0" rIns="0" bIns="0" rtlCol="0" anchor="t"/>
           <a:lstStyle/>
           <a:p>
-            <a:pPr indent="0" marL="0">
+            <a:pPr marL="0" indent="0">
               <a:buNone/>
             </a:pPr>
             <a:r>
@@ -7651,7 +7434,7 @@
           <a:bodyPr wrap="square" lIns="0" tIns="0" rIns="0" bIns="0" rtlCol="0" anchor="t"/>
           <a:lstStyle/>
           <a:p>
-            <a:pPr indent="0" marL="0">
+            <a:pPr marL="0" indent="0">
               <a:buNone/>
             </a:pPr>
             <a:r>
@@ -7690,7 +7473,7 @@
           <a:bodyPr wrap="square" lIns="0" tIns="0" rIns="0" bIns="0" rtlCol="0" anchor="t"/>
           <a:lstStyle/>
           <a:p>
-            <a:pPr indent="0" marL="0">
+            <a:pPr marL="0" indent="0">
               <a:buNone/>
             </a:pPr>
             <a:r>
@@ -7728,7 +7511,7 @@
           </a:prstGeom>
           <a:extLst>
             <a:ext uri="{C572A759-6A51-4108-AA02-DFA0A04FC94B}">
-              <ma14:wrappingTextBoxFlag xmlns:ma14="http://schemas.microsoft.com/office/mac/drawingml/2011/main" val="0"/>
+              <ma14:wrappingTextBoxFlag xmlns:ma14="http://schemas.microsoft.com/office/mac/drawingml/2011/main" xmlns="" val="0"/>
             </a:ext>
           </a:extLst>
         </p:spPr>
@@ -7749,7 +7532,7 @@
           <a:p>
             <a:pPr algn="l"/>
             <a:fld id="{F7021451-1387-4CA6-816F-3879F97B5CBC}" type="slidenum">
-              <a:rPr b="0" lang="en-US"/>
+              <a:rPr lang="en-US" b="0"/>
               <a:t>7</a:t>
             </a:fld>
             <a:endParaRPr lang="en-US"/>
@@ -7784,9 +7567,11 @@
       <p:sp>
         <p:nvSpPr>
           <p:cNvPr id="2" name="Text 3"/>
-          <p:cNvSpPr/>
+          <p:cNvSpPr>
+            <a:spLocks noGrp="1"/>
+          </p:cNvSpPr>
           <p:nvPr>
-            <p:ph idx="103" type="title" hasCustomPrompt="1"/>
+            <p:ph type="title" idx="103" hasCustomPrompt="1"/>
           </p:nvPr>
         </p:nvSpPr>
         <p:spPr>
@@ -7804,7 +7589,7 @@
           <a:bodyPr wrap="square" rtlCol="0" anchor="ctr"/>
           <a:lstStyle/>
           <a:p>
-            <a:pPr algn="l" indent="0" marL="0">
+            <a:pPr marL="0" indent="0" algn="l">
               <a:buNone/>
             </a:pPr>
             <a:r>
@@ -7848,7 +7633,7 @@
             <a:prstDash val="solid"/>
           </a:ln>
           <a:effectLst>
-            <a:outerShdw sx="100000" sy="100000" kx="0" ky="0" algn="bl" rotWithShape="0" blurRad="76200" dist="25400" dir="5400000">
+            <a:outerShdw blurRad="76200" dist="25400" dir="5400000" algn="bl" rotWithShape="0">
               <a:srgbClr val="BFB3A0">
                 <a:alpha val="25000"/>
               </a:srgbClr>
@@ -7902,7 +7687,7 @@
           <a:bodyPr wrap="square" lIns="0" tIns="0" rIns="0" bIns="0" rtlCol="0" anchor="ctr"/>
           <a:lstStyle/>
           <a:p>
-            <a:pPr algn="ctr" indent="0" marL="0">
+            <a:pPr marL="0" indent="0" algn="ctr">
               <a:buNone/>
             </a:pPr>
             <a:r>
@@ -7941,7 +7726,7 @@
           <a:bodyPr wrap="square" lIns="0" tIns="0" rIns="0" bIns="0" rtlCol="0" anchor="t"/>
           <a:lstStyle/>
           <a:p>
-            <a:pPr indent="0" marL="0">
+            <a:pPr marL="0" indent="0">
               <a:buNone/>
             </a:pPr>
             <a:r>
@@ -7980,7 +7765,7 @@
           <a:bodyPr wrap="square" lIns="0" tIns="0" rIns="0" bIns="0" rtlCol="0" anchor="t"/>
           <a:lstStyle/>
           <a:p>
-            <a:pPr indent="0" marL="0">
+            <a:pPr marL="0" indent="0">
               <a:buNone/>
             </a:pPr>
             <a:r>
@@ -8024,7 +7809,7 @@
             <a:prstDash val="solid"/>
           </a:ln>
           <a:effectLst>
-            <a:outerShdw sx="100000" sy="100000" kx="0" ky="0" algn="bl" rotWithShape="0" blurRad="76200" dist="25400" dir="5400000">
+            <a:outerShdw blurRad="76200" dist="25400" dir="5400000" algn="bl" rotWithShape="0">
               <a:srgbClr val="BFB3A0">
                 <a:alpha val="25000"/>
               </a:srgbClr>
@@ -8078,7 +7863,7 @@
           <a:bodyPr wrap="square" lIns="0" tIns="0" rIns="0" bIns="0" rtlCol="0" anchor="ctr"/>
           <a:lstStyle/>
           <a:p>
-            <a:pPr algn="ctr" indent="0" marL="0">
+            <a:pPr marL="0" indent="0" algn="ctr">
               <a:buNone/>
             </a:pPr>
             <a:r>
@@ -8117,7 +7902,7 @@
           <a:bodyPr wrap="square" lIns="0" tIns="0" rIns="0" bIns="0" rtlCol="0" anchor="t"/>
           <a:lstStyle/>
           <a:p>
-            <a:pPr indent="0" marL="0">
+            <a:pPr marL="0" indent="0">
               <a:buNone/>
             </a:pPr>
             <a:r>
@@ -8156,7 +7941,7 @@
           <a:bodyPr wrap="square" lIns="0" tIns="0" rIns="0" bIns="0" rtlCol="0" anchor="t"/>
           <a:lstStyle/>
           <a:p>
-            <a:pPr indent="0" marL="0">
+            <a:pPr marL="0" indent="0">
               <a:buNone/>
             </a:pPr>
             <a:r>
@@ -8200,7 +7985,7 @@
             <a:prstDash val="solid"/>
           </a:ln>
           <a:effectLst>
-            <a:outerShdw sx="100000" sy="100000" kx="0" ky="0" algn="bl" rotWithShape="0" blurRad="76200" dist="25400" dir="5400000">
+            <a:outerShdw blurRad="76200" dist="25400" dir="5400000" algn="bl" rotWithShape="0">
               <a:srgbClr val="BFB3A0">
                 <a:alpha val="25000"/>
               </a:srgbClr>
@@ -8254,7 +8039,7 @@
           <a:bodyPr wrap="square" lIns="0" tIns="0" rIns="0" bIns="0" rtlCol="0" anchor="ctr"/>
           <a:lstStyle/>
           <a:p>
-            <a:pPr algn="ctr" indent="0" marL="0">
+            <a:pPr marL="0" indent="0" algn="ctr">
               <a:buNone/>
             </a:pPr>
             <a:r>
@@ -8293,7 +8078,7 @@
           <a:bodyPr wrap="square" lIns="0" tIns="0" rIns="0" bIns="0" rtlCol="0" anchor="t"/>
           <a:lstStyle/>
           <a:p>
-            <a:pPr indent="0" marL="0">
+            <a:pPr marL="0" indent="0">
               <a:buNone/>
             </a:pPr>
             <a:r>
@@ -8332,7 +8117,7 @@
           <a:bodyPr wrap="square" lIns="0" tIns="0" rIns="0" bIns="0" rtlCol="0" anchor="t"/>
           <a:lstStyle/>
           <a:p>
-            <a:pPr indent="0" marL="0">
+            <a:pPr marL="0" indent="0">
               <a:buNone/>
             </a:pPr>
             <a:r>
@@ -8376,7 +8161,7 @@
             <a:prstDash val="solid"/>
           </a:ln>
           <a:effectLst>
-            <a:outerShdw sx="100000" sy="100000" kx="0" ky="0" algn="bl" rotWithShape="0" blurRad="76200" dist="25400" dir="5400000">
+            <a:outerShdw blurRad="76200" dist="25400" dir="5400000" algn="bl" rotWithShape="0">
               <a:srgbClr val="BFB3A0">
                 <a:alpha val="25000"/>
               </a:srgbClr>
@@ -8405,7 +8190,7 @@
           <a:bodyPr wrap="square" lIns="0" tIns="0" rIns="0" bIns="0" rtlCol="0" anchor="t"/>
           <a:lstStyle/>
           <a:p>
-            <a:pPr indent="0" marL="0">
+            <a:pPr marL="0" indent="0">
               <a:buNone/>
             </a:pPr>
             <a:r>
@@ -8444,7 +8229,7 @@
           <a:bodyPr wrap="square" lIns="0" tIns="0" rIns="0" bIns="0" rtlCol="0" anchor="t"/>
           <a:lstStyle/>
           <a:p>
-            <a:pPr indent="0" marL="0">
+            <a:pPr marL="0" indent="0">
               <a:buNone/>
             </a:pPr>
             <a:r>
@@ -8483,7 +8268,7 @@
           <a:bodyPr wrap="square" lIns="0" tIns="0" rIns="0" bIns="0" rtlCol="0" anchor="t"/>
           <a:lstStyle/>
           <a:p>
-            <a:pPr indent="0" marL="0">
+            <a:pPr marL="0" indent="0">
               <a:buNone/>
             </a:pPr>
             <a:r>
@@ -8522,7 +8307,7 @@
           <a:bodyPr wrap="square" lIns="0" tIns="0" rIns="0" bIns="0" rtlCol="0" anchor="t"/>
           <a:lstStyle/>
           <a:p>
-            <a:pPr indent="0" marL="0">
+            <a:pPr marL="0" indent="0">
               <a:buNone/>
             </a:pPr>
             <a:r>
@@ -8561,7 +8346,7 @@
           <a:bodyPr wrap="square" lIns="0" tIns="0" rIns="0" bIns="0" rtlCol="0" anchor="t"/>
           <a:lstStyle/>
           <a:p>
-            <a:pPr indent="0" marL="0">
+            <a:pPr marL="0" indent="0">
               <a:buNone/>
             </a:pPr>
             <a:r>
@@ -8600,7 +8385,7 @@
           <a:bodyPr wrap="square" lIns="0" tIns="0" rIns="0" bIns="0" rtlCol="0" anchor="t"/>
           <a:lstStyle/>
           <a:p>
-            <a:pPr indent="0" marL="0">
+            <a:pPr marL="0" indent="0">
               <a:buNone/>
             </a:pPr>
             <a:r>
@@ -8638,7 +8423,7 @@
           </a:prstGeom>
           <a:extLst>
             <a:ext uri="{C572A759-6A51-4108-AA02-DFA0A04FC94B}">
-              <ma14:wrappingTextBoxFlag xmlns:ma14="http://schemas.microsoft.com/office/mac/drawingml/2011/main" val="0"/>
+              <ma14:wrappingTextBoxFlag xmlns:ma14="http://schemas.microsoft.com/office/mac/drawingml/2011/main" xmlns="" val="0"/>
             </a:ext>
           </a:extLst>
         </p:spPr>
@@ -8659,7 +8444,7 @@
           <a:p>
             <a:pPr algn="l"/>
             <a:fld id="{F7021451-1387-4CA6-816F-3879F97B5CBC}" type="slidenum">
-              <a:rPr b="0" lang="en-US"/>
+              <a:rPr lang="en-US" b="0"/>
               <a:t>8</a:t>
             </a:fld>
             <a:endParaRPr lang="en-US"/>
@@ -8694,9 +8479,11 @@
       <p:sp>
         <p:nvSpPr>
           <p:cNvPr id="2" name="Text 2"/>
-          <p:cNvSpPr/>
+          <p:cNvSpPr>
+            <a:spLocks noGrp="1"/>
+          </p:cNvSpPr>
           <p:nvPr>
-            <p:ph idx="102" type="title" hasCustomPrompt="1"/>
+            <p:ph type="title" idx="102" hasCustomPrompt="1"/>
           </p:nvPr>
         </p:nvSpPr>
         <p:spPr>
@@ -8714,7 +8501,7 @@
           <a:bodyPr wrap="square" rtlCol="0" anchor="ctr"/>
           <a:lstStyle/>
           <a:p>
-            <a:pPr algn="l" indent="0" marL="0">
+            <a:pPr marL="0" indent="0" algn="l">
               <a:buNone/>
             </a:pPr>
             <a:r>
@@ -8758,7 +8545,7 @@
             <a:prstDash val="solid"/>
           </a:ln>
           <a:effectLst>
-            <a:outerShdw sx="100000" sy="100000" kx="0" ky="0" algn="bl" rotWithShape="0" blurRad="76200" dist="25400" dir="5400000">
+            <a:outerShdw blurRad="76200" dist="25400" dir="5400000" algn="bl" rotWithShape="0">
               <a:srgbClr val="BFB3A0">
                 <a:alpha val="25000"/>
               </a:srgbClr>
@@ -8787,7 +8574,7 @@
           <a:bodyPr wrap="square" lIns="0" tIns="0" rIns="0" bIns="0" rtlCol="0" anchor="t"/>
           <a:lstStyle/>
           <a:p>
-            <a:pPr indent="0" marL="0">
+            <a:pPr marL="0" indent="0">
               <a:buNone/>
             </a:pPr>
             <a:r>
@@ -8826,7 +8613,7 @@
           <a:bodyPr wrap="square" lIns="0" tIns="0" rIns="0" bIns="0" rtlCol="0" anchor="t"/>
           <a:lstStyle/>
           <a:p>
-            <a:pPr indent="0" marL="0">
+            <a:pPr marL="0" indent="0">
               <a:buNone/>
             </a:pPr>
             <a:r>
@@ -8870,7 +8657,7 @@
             <a:prstDash val="solid"/>
           </a:ln>
           <a:effectLst>
-            <a:outerShdw sx="100000" sy="100000" kx="0" ky="0" algn="bl" rotWithShape="0" blurRad="76200" dist="25400" dir="5400000">
+            <a:outerShdw blurRad="76200" dist="25400" dir="5400000" algn="bl" rotWithShape="0">
               <a:srgbClr val="BFB3A0">
                 <a:alpha val="25000"/>
               </a:srgbClr>
@@ -8899,7 +8686,7 @@
           <a:bodyPr wrap="square" lIns="0" tIns="0" rIns="0" bIns="0" rtlCol="0" anchor="t"/>
           <a:lstStyle/>
           <a:p>
-            <a:pPr indent="0" marL="0">
+            <a:pPr marL="0" indent="0">
               <a:buNone/>
             </a:pPr>
             <a:r>
@@ -8938,7 +8725,7 @@
           <a:bodyPr wrap="square" lIns="0" tIns="0" rIns="0" bIns="0" rtlCol="0" anchor="t"/>
           <a:lstStyle/>
           <a:p>
-            <a:pPr indent="0" marL="0">
+            <a:pPr marL="0" indent="0">
               <a:buNone/>
             </a:pPr>
             <a:r>
@@ -8982,7 +8769,7 @@
             <a:prstDash val="solid"/>
           </a:ln>
           <a:effectLst>
-            <a:outerShdw sx="100000" sy="100000" kx="0" ky="0" algn="bl" rotWithShape="0" blurRad="76200" dist="25400" dir="5400000">
+            <a:outerShdw blurRad="76200" dist="25400" dir="5400000" algn="bl" rotWithShape="0">
               <a:srgbClr val="BFB3A0">
                 <a:alpha val="25000"/>
               </a:srgbClr>
@@ -9011,7 +8798,7 @@
           <a:bodyPr wrap="square" lIns="0" tIns="0" rIns="0" bIns="0" rtlCol="0" anchor="t"/>
           <a:lstStyle/>
           <a:p>
-            <a:pPr indent="0" marL="0">
+            <a:pPr marL="0" indent="0">
               <a:buNone/>
             </a:pPr>
             <a:r>
@@ -9050,7 +8837,7 @@
           <a:bodyPr wrap="square" lIns="0" tIns="0" rIns="0" bIns="0" rtlCol="0" anchor="t"/>
           <a:lstStyle/>
           <a:p>
-            <a:pPr indent="0" marL="0">
+            <a:pPr marL="0" indent="0">
               <a:buNone/>
             </a:pPr>
             <a:r>
@@ -9094,7 +8881,7 @@
             <a:prstDash val="solid"/>
           </a:ln>
           <a:effectLst>
-            <a:outerShdw sx="100000" sy="100000" kx="0" ky="0" algn="bl" rotWithShape="0" blurRad="76200" dist="25400" dir="5400000">
+            <a:outerShdw blurRad="76200" dist="25400" dir="5400000" algn="bl" rotWithShape="0">
               <a:srgbClr val="BFB3A0">
                 <a:alpha val="25000"/>
               </a:srgbClr>
@@ -9123,7 +8910,7 @@
           <a:bodyPr wrap="square" lIns="0" tIns="0" rIns="0" bIns="0" rtlCol="0" anchor="t"/>
           <a:lstStyle/>
           <a:p>
-            <a:pPr indent="0" marL="0">
+            <a:pPr marL="0" indent="0">
               <a:buNone/>
             </a:pPr>
             <a:r>
@@ -9162,7 +8949,7 @@
           <a:bodyPr wrap="square" lIns="0" tIns="0" rIns="0" bIns="0" rtlCol="0" anchor="t"/>
           <a:lstStyle/>
           <a:p>
-            <a:pPr indent="0" marL="0">
+            <a:pPr marL="0" indent="0">
               <a:buNone/>
             </a:pPr>
             <a:r>
@@ -9200,7 +8987,7 @@
           </a:prstGeom>
           <a:extLst>
             <a:ext uri="{C572A759-6A51-4108-AA02-DFA0A04FC94B}">
-              <ma14:wrappingTextBoxFlag xmlns:ma14="http://schemas.microsoft.com/office/mac/drawingml/2011/main" val="0"/>
+              <ma14:wrappingTextBoxFlag xmlns:ma14="http://schemas.microsoft.com/office/mac/drawingml/2011/main" xmlns="" val="0"/>
             </a:ext>
           </a:extLst>
         </p:spPr>
@@ -9221,7 +9008,7 @@
           <a:p>
             <a:pPr algn="l"/>
             <a:fld id="{F7021451-1387-4CA6-816F-3879F97B5CBC}" type="slidenum">
-              <a:rPr b="0" lang="en-US"/>
+              <a:rPr lang="en-US" b="0"/>
               <a:t>9</a:t>
             </a:fld>
             <a:endParaRPr lang="en-US"/>
@@ -9529,4 +9316,299 @@
     </a:ext>
   </a:extLst>
 </a:theme>
+</file>
+
+<file path=ppt/theme/theme2.xml><?xml version="1.0" encoding="utf-8"?>
+<a:theme xmlns:a="http://schemas.openxmlformats.org/drawingml/2006/main" name="Office Theme">
+  <a:themeElements>
+    <a:clrScheme name="Office">
+      <a:dk1>
+        <a:sysClr val="windowText" lastClr="000000"/>
+      </a:dk1>
+      <a:lt1>
+        <a:sysClr val="window" lastClr="FFFFFF"/>
+      </a:lt1>
+      <a:dk2>
+        <a:srgbClr val="44546A"/>
+      </a:dk2>
+      <a:lt2>
+        <a:srgbClr val="E7E6E6"/>
+      </a:lt2>
+      <a:accent1>
+        <a:srgbClr val="4472C4"/>
+      </a:accent1>
+      <a:accent2>
+        <a:srgbClr val="ED7D31"/>
+      </a:accent2>
+      <a:accent3>
+        <a:srgbClr val="A5A5A5"/>
+      </a:accent3>
+      <a:accent4>
+        <a:srgbClr val="FFC000"/>
+      </a:accent4>
+      <a:accent5>
+        <a:srgbClr val="5B9BD5"/>
+      </a:accent5>
+      <a:accent6>
+        <a:srgbClr val="70AD47"/>
+      </a:accent6>
+      <a:hlink>
+        <a:srgbClr val="0563C1"/>
+      </a:hlink>
+      <a:folHlink>
+        <a:srgbClr val="954F72"/>
+      </a:folHlink>
+    </a:clrScheme>
+    <a:fontScheme name="Office">
+      <a:majorFont>
+        <a:latin typeface="Calibri Light" panose="020F0302020204030204"/>
+        <a:ea typeface=""/>
+        <a:cs typeface=""/>
+        <a:font script="Jpan" typeface="游ゴシック Light"/>
+        <a:font script="Hang" typeface="맑은 고딕"/>
+        <a:font script="Hans" typeface="等线 Light"/>
+        <a:font script="Hant" typeface="新細明體"/>
+        <a:font script="Arab" typeface="Times New Roman"/>
+        <a:font script="Hebr" typeface="Times New Roman"/>
+        <a:font script="Thai" typeface="Angsana New"/>
+        <a:font script="Ethi" typeface="Nyala"/>
+        <a:font script="Beng" typeface="Vrinda"/>
+        <a:font script="Gujr" typeface="Shruti"/>
+        <a:font script="Khmr" typeface="MoolBoran"/>
+        <a:font script="Knda" typeface="Tunga"/>
+        <a:font script="Guru" typeface="Raavi"/>
+        <a:font script="Cans" typeface="Euphemia"/>
+        <a:font script="Cher" typeface="Plantagenet Cherokee"/>
+        <a:font script="Yiii" typeface="Microsoft Yi Baiti"/>
+        <a:font script="Tibt" typeface="Microsoft Himalaya"/>
+        <a:font script="Thaa" typeface="MV Boli"/>
+        <a:font script="Deva" typeface="Mangal"/>
+        <a:font script="Telu" typeface="Gautami"/>
+        <a:font script="Taml" typeface="Latha"/>
+        <a:font script="Syrc" typeface="Estrangelo Edessa"/>
+        <a:font script="Orya" typeface="Kalinga"/>
+        <a:font script="Mlym" typeface="Kartika"/>
+        <a:font script="Laoo" typeface="DokChampa"/>
+        <a:font script="Sinh" typeface="Iskoola Pota"/>
+        <a:font script="Mong" typeface="Mongolian Baiti"/>
+        <a:font script="Viet" typeface="Times New Roman"/>
+        <a:font script="Uigh" typeface="Microsoft Uighur"/>
+        <a:font script="Geor" typeface="Sylfaen"/>
+        <a:font script="Armn" typeface="Arial"/>
+        <a:font script="Bugi" typeface="Leelawadee UI"/>
+        <a:font script="Bopo" typeface="Microsoft JhengHei"/>
+        <a:font script="Java" typeface="Javanese Text"/>
+        <a:font script="Lisu" typeface="Segoe UI"/>
+        <a:font script="Mymr" typeface="Myanmar Text"/>
+        <a:font script="Nkoo" typeface="Ebrima"/>
+        <a:font script="Olck" typeface="Nirmala UI"/>
+        <a:font script="Osma" typeface="Ebrima"/>
+        <a:font script="Phag" typeface="Phagspa"/>
+        <a:font script="Syrn" typeface="Estrangelo Edessa"/>
+        <a:font script="Syrj" typeface="Estrangelo Edessa"/>
+        <a:font script="Syre" typeface="Estrangelo Edessa"/>
+        <a:font script="Sora" typeface="Nirmala UI"/>
+        <a:font script="Tale" typeface="Microsoft Tai Le"/>
+        <a:font script="Talu" typeface="Microsoft New Tai Lue"/>
+        <a:font script="Tfng" typeface="Ebrima"/>
+      </a:majorFont>
+      <a:minorFont>
+        <a:latin typeface="Calibri" panose="020F0502020204030204"/>
+        <a:ea typeface=""/>
+        <a:cs typeface=""/>
+        <a:font script="Jpan" typeface="游ゴシック"/>
+        <a:font script="Hang" typeface="맑은 고딕"/>
+        <a:font script="Hans" typeface="等线"/>
+        <a:font script="Hant" typeface="新細明體"/>
+        <a:font script="Arab" typeface="Arial"/>
+        <a:font script="Hebr" typeface="Arial"/>
+        <a:font script="Thai" typeface="Cordia New"/>
+        <a:font script="Ethi" typeface="Nyala"/>
+        <a:font script="Beng" typeface="Vrinda"/>
+        <a:font script="Gujr" typeface="Shruti"/>
+        <a:font script="Khmr" typeface="DaunPenh"/>
+        <a:font script="Knda" typeface="Tunga"/>
+        <a:font script="Guru" typeface="Raavi"/>
+        <a:font script="Cans" typeface="Euphemia"/>
+        <a:font script="Cher" typeface="Plantagenet Cherokee"/>
+        <a:font script="Yiii" typeface="Microsoft Yi Baiti"/>
+        <a:font script="Tibt" typeface="Microsoft Himalaya"/>
+        <a:font script="Thaa" typeface="MV Boli"/>
+        <a:font script="Deva" typeface="Mangal"/>
+        <a:font script="Telu" typeface="Gautami"/>
+        <a:font script="Taml" typeface="Latha"/>
+        <a:font script="Syrc" typeface="Estrangelo Edessa"/>
+        <a:font script="Orya" typeface="Kalinga"/>
+        <a:font script="Mlym" typeface="Kartika"/>
+        <a:font script="Laoo" typeface="DokChampa"/>
+        <a:font script="Sinh" typeface="Iskoola Pota"/>
+        <a:font script="Mong" typeface="Mongolian Baiti"/>
+        <a:font script="Viet" typeface="Arial"/>
+        <a:font script="Uigh" typeface="Microsoft Uighur"/>
+        <a:font script="Geor" typeface="Sylfaen"/>
+        <a:font script="Armn" typeface="Arial"/>
+        <a:font script="Bugi" typeface="Leelawadee UI"/>
+        <a:font script="Bopo" typeface="Microsoft JhengHei"/>
+        <a:font script="Java" typeface="Javanese Text"/>
+        <a:font script="Lisu" typeface="Segoe UI"/>
+        <a:font script="Mymr" typeface="Myanmar Text"/>
+        <a:font script="Nkoo" typeface="Ebrima"/>
+        <a:font script="Olck" typeface="Nirmala UI"/>
+        <a:font script="Osma" typeface="Ebrima"/>
+        <a:font script="Phag" typeface="Phagspa"/>
+        <a:font script="Syrn" typeface="Estrangelo Edessa"/>
+        <a:font script="Syrj" typeface="Estrangelo Edessa"/>
+        <a:font script="Syre" typeface="Estrangelo Edessa"/>
+        <a:font script="Sora" typeface="Nirmala UI"/>
+        <a:font script="Tale" typeface="Microsoft Tai Le"/>
+        <a:font script="Talu" typeface="Microsoft New Tai Lue"/>
+        <a:font script="Tfng" typeface="Ebrima"/>
+      </a:minorFont>
+    </a:fontScheme>
+    <a:fmtScheme name="Office">
+      <a:fillStyleLst>
+        <a:solidFill>
+          <a:schemeClr val="phClr"/>
+        </a:solidFill>
+        <a:gradFill rotWithShape="1">
+          <a:gsLst>
+            <a:gs pos="0">
+              <a:schemeClr val="phClr">
+                <a:lumMod val="110000"/>
+                <a:satMod val="105000"/>
+                <a:tint val="67000"/>
+              </a:schemeClr>
+            </a:gs>
+            <a:gs pos="50000">
+              <a:schemeClr val="phClr">
+                <a:lumMod val="105000"/>
+                <a:satMod val="103000"/>
+                <a:tint val="73000"/>
+              </a:schemeClr>
+            </a:gs>
+            <a:gs pos="100000">
+              <a:schemeClr val="phClr">
+                <a:lumMod val="105000"/>
+                <a:satMod val="109000"/>
+                <a:tint val="81000"/>
+              </a:schemeClr>
+            </a:gs>
+          </a:gsLst>
+          <a:lin ang="5400000" scaled="0"/>
+        </a:gradFill>
+        <a:gradFill rotWithShape="1">
+          <a:gsLst>
+            <a:gs pos="0">
+              <a:schemeClr val="phClr">
+                <a:satMod val="103000"/>
+                <a:lumMod val="102000"/>
+                <a:tint val="94000"/>
+              </a:schemeClr>
+            </a:gs>
+            <a:gs pos="50000">
+              <a:schemeClr val="phClr">
+                <a:satMod val="110000"/>
+                <a:lumMod val="100000"/>
+                <a:shade val="100000"/>
+              </a:schemeClr>
+            </a:gs>
+            <a:gs pos="100000">
+              <a:schemeClr val="phClr">
+                <a:lumMod val="99000"/>
+                <a:satMod val="120000"/>
+                <a:shade val="78000"/>
+              </a:schemeClr>
+            </a:gs>
+          </a:gsLst>
+          <a:lin ang="5400000" scaled="0"/>
+        </a:gradFill>
+      </a:fillStyleLst>
+      <a:lnStyleLst>
+        <a:ln w="6350" cap="flat" cmpd="sng" algn="ctr">
+          <a:solidFill>
+            <a:schemeClr val="phClr"/>
+          </a:solidFill>
+          <a:prstDash val="solid"/>
+          <a:miter lim="800000"/>
+        </a:ln>
+        <a:ln w="12700" cap="flat" cmpd="sng" algn="ctr">
+          <a:solidFill>
+            <a:schemeClr val="phClr"/>
+          </a:solidFill>
+          <a:prstDash val="solid"/>
+          <a:miter lim="800000"/>
+        </a:ln>
+        <a:ln w="19050" cap="flat" cmpd="sng" algn="ctr">
+          <a:solidFill>
+            <a:schemeClr val="phClr"/>
+          </a:solidFill>
+          <a:prstDash val="solid"/>
+          <a:miter lim="800000"/>
+        </a:ln>
+      </a:lnStyleLst>
+      <a:effectStyleLst>
+        <a:effectStyle>
+          <a:effectLst/>
+        </a:effectStyle>
+        <a:effectStyle>
+          <a:effectLst/>
+        </a:effectStyle>
+        <a:effectStyle>
+          <a:effectLst>
+            <a:outerShdw blurRad="57150" dist="19050" dir="5400000" algn="ctr" rotWithShape="0">
+              <a:srgbClr val="000000">
+                <a:alpha val="63000"/>
+              </a:srgbClr>
+            </a:outerShdw>
+          </a:effectLst>
+        </a:effectStyle>
+      </a:effectStyleLst>
+      <a:bgFillStyleLst>
+        <a:solidFill>
+          <a:schemeClr val="phClr"/>
+        </a:solidFill>
+        <a:solidFill>
+          <a:schemeClr val="phClr">
+            <a:tint val="95000"/>
+            <a:satMod val="170000"/>
+          </a:schemeClr>
+        </a:solidFill>
+        <a:gradFill rotWithShape="1">
+          <a:gsLst>
+            <a:gs pos="0">
+              <a:schemeClr val="phClr">
+                <a:tint val="93000"/>
+                <a:satMod val="150000"/>
+                <a:shade val="98000"/>
+                <a:lumMod val="102000"/>
+              </a:schemeClr>
+            </a:gs>
+            <a:gs pos="50000">
+              <a:schemeClr val="phClr">
+                <a:tint val="98000"/>
+                <a:satMod val="130000"/>
+                <a:shade val="90000"/>
+                <a:lumMod val="103000"/>
+              </a:schemeClr>
+            </a:gs>
+            <a:gs pos="100000">
+              <a:schemeClr val="phClr">
+                <a:shade val="63000"/>
+                <a:satMod val="120000"/>
+              </a:schemeClr>
+            </a:gs>
+          </a:gsLst>
+          <a:lin ang="5400000" scaled="0"/>
+        </a:gradFill>
+      </a:bgFillStyleLst>
+    </a:fmtScheme>
+  </a:themeElements>
+  <a:objectDefaults/>
+  <a:extraClrSchemeLst/>
+  <a:extLst>
+    <a:ext uri="{05A4C25C-085E-4340-85A3-A5531E510DB2}">
+      <thm15:themeFamily xmlns:thm15="http://schemas.microsoft.com/office/thememl/2012/main" name="Office Theme" id="{62F939B6-93AF-4DB8-9C6B-D6C7DFDC589F}" vid="{4A3C46E8-61CC-4603-A589-7422A47A8E4A}"/>
+    </a:ext>
+  </a:extLst>
+</a:theme>
 </file>
</xml_diff>